<commit_message>
Polish AI model comparison slide
Parameter row with disclosure status and estimate range, leader shading
in the specs table, bolded leading figures, release dates in the spec
header, spec rows aligned to the task grid, footnotes renumbered in
reading order.

Co-Authored-By: Claude Opus 5.5 <noreply@anthropic.com>
Claude-Session: https://claude.ai/code/session_01ArvvTMQ47fYQzBZA3Mrxmu
</commit_message>
<xml_diff>
--- a/ai-model-comparison/AI-Model-Comparison-Sep-2026.pptx
+++ b/ai-model-comparison/AI-Model-Comparison-Sep-2026.pptx
@@ -1909,7 +1909,35 @@
                 <a:ea typeface="Arial" pitchFamily="34" charset="-122"/>
                 <a:cs typeface="Arial" pitchFamily="34" charset="-120"/>
               </a:rPr>
-              <a:t>Terminal-Bench 4.0: 66.4% vs. 57.9%</a:t>
+              <a:t>Terminal-Bench 4.0: </a:t>
+            </a:r>
+            <a:pPr indent="0" marL="0">
+              <a:buNone/>
+            </a:pPr>
+            <a:r>
+              <a:rPr lang="en-US" sz="850" b="1" dirty="0">
+                <a:solidFill>
+                  <a:srgbClr val="041E42"/>
+                </a:solidFill>
+                <a:latin typeface="Arial" pitchFamily="34" charset="0"/>
+                <a:ea typeface="Arial" pitchFamily="34" charset="-122"/>
+                <a:cs typeface="Arial" pitchFamily="34" charset="-120"/>
+              </a:rPr>
+              <a:t>66.4%</a:t>
+            </a:r>
+            <a:pPr indent="0" marL="0">
+              <a:buNone/>
+            </a:pPr>
+            <a:r>
+              <a:rPr lang="en-US" sz="850" dirty="0">
+                <a:solidFill>
+                  <a:srgbClr val="1F2A37"/>
+                </a:solidFill>
+                <a:latin typeface="Arial" pitchFamily="34" charset="0"/>
+                <a:ea typeface="Arial" pitchFamily="34" charset="-122"/>
+                <a:cs typeface="Arial" pitchFamily="34" charset="-120"/>
+              </a:rPr>
+              <a:t> vs. 57.9%</a:t>
             </a:r>
             <a:pPr indent="0" marL="0">
               <a:buNone/>
@@ -1937,7 +1965,7 @@
                 <a:ea typeface="Arial" pitchFamily="34" charset="-122"/>
                 <a:cs typeface="Arial" pitchFamily="34" charset="-120"/>
               </a:rPr>
-              <a:t>; customer case: 680K-line migration in &lt;1 day</a:t>
+              <a:t>; customer case: 680K lines migrated in &lt;1 day</a:t>
             </a:r>
             <a:endParaRPr lang="en-US" sz="850" dirty="0"/>
           </a:p>
@@ -2211,7 +2239,63 @@
                 <a:ea typeface="Arial" pitchFamily="34" charset="-122"/>
                 <a:cs typeface="Arial" pitchFamily="34" charset="-120"/>
               </a:rPr>
-              <a:t>GDPval-AA v2.1: 1,846 vs. 1,542 Elo; Humanity's Last Exam: 67.7% vs. 57.2%</a:t>
+              <a:t>GDPval-AA v2.1: </a:t>
+            </a:r>
+            <a:pPr indent="0" marL="0">
+              <a:buNone/>
+            </a:pPr>
+            <a:r>
+              <a:rPr lang="en-US" sz="850" b="1" dirty="0">
+                <a:solidFill>
+                  <a:srgbClr val="041E42"/>
+                </a:solidFill>
+                <a:latin typeface="Arial" pitchFamily="34" charset="0"/>
+                <a:ea typeface="Arial" pitchFamily="34" charset="-122"/>
+                <a:cs typeface="Arial" pitchFamily="34" charset="-120"/>
+              </a:rPr>
+              <a:t>1,846</a:t>
+            </a:r>
+            <a:pPr indent="0" marL="0">
+              <a:buNone/>
+            </a:pPr>
+            <a:r>
+              <a:rPr lang="en-US" sz="850" dirty="0">
+                <a:solidFill>
+                  <a:srgbClr val="1F2A37"/>
+                </a:solidFill>
+                <a:latin typeface="Arial" pitchFamily="34" charset="0"/>
+                <a:ea typeface="Arial" pitchFamily="34" charset="-122"/>
+                <a:cs typeface="Arial" pitchFamily="34" charset="-120"/>
+              </a:rPr>
+              <a:t> vs. 1,542 Elo; Humanity's Last Exam: </a:t>
+            </a:r>
+            <a:pPr indent="0" marL="0">
+              <a:buNone/>
+            </a:pPr>
+            <a:r>
+              <a:rPr lang="en-US" sz="850" b="1" dirty="0">
+                <a:solidFill>
+                  <a:srgbClr val="041E42"/>
+                </a:solidFill>
+                <a:latin typeface="Arial" pitchFamily="34" charset="0"/>
+                <a:ea typeface="Arial" pitchFamily="34" charset="-122"/>
+                <a:cs typeface="Arial" pitchFamily="34" charset="-120"/>
+              </a:rPr>
+              <a:t>67.7%</a:t>
+            </a:r>
+            <a:pPr indent="0" marL="0">
+              <a:buNone/>
+            </a:pPr>
+            <a:r>
+              <a:rPr lang="en-US" sz="850" dirty="0">
+                <a:solidFill>
+                  <a:srgbClr val="1F2A37"/>
+                </a:solidFill>
+                <a:latin typeface="Arial" pitchFamily="34" charset="0"/>
+                <a:ea typeface="Arial" pitchFamily="34" charset="-122"/>
+                <a:cs typeface="Arial" pitchFamily="34" charset="-120"/>
+              </a:rPr>
+              <a:t> vs. 57.2%</a:t>
             </a:r>
             <a:pPr indent="0" marL="0">
               <a:buNone/>
@@ -2524,7 +2608,21 @@
                 <a:ea typeface="Arial" pitchFamily="34" charset="-122"/>
                 <a:cs typeface="Arial" pitchFamily="34" charset="-120"/>
               </a:rPr>
-              <a:t>; AutomationBench: 40.0% vs. 41.4%</a:t>
+              <a:t>; AutomationBench: 40.0% vs. </a:t>
+            </a:r>
+            <a:pPr indent="0" marL="0">
+              <a:buNone/>
+            </a:pPr>
+            <a:r>
+              <a:rPr lang="en-US" sz="850" b="1" dirty="0">
+                <a:solidFill>
+                  <a:srgbClr val="041E42"/>
+                </a:solidFill>
+                <a:latin typeface="Arial" pitchFamily="34" charset="0"/>
+                <a:ea typeface="Arial" pitchFamily="34" charset="-122"/>
+                <a:cs typeface="Arial" pitchFamily="34" charset="-120"/>
+              </a:rPr>
+              <a:t>41.4%</a:t>
             </a:r>
             <a:pPr indent="0" marL="0">
               <a:buNone/>
@@ -3086,7 +3184,21 @@
                 <a:ea typeface="Arial" pitchFamily="34" charset="-122"/>
                 <a:cs typeface="Arial" pitchFamily="34" charset="-120"/>
               </a:rPr>
-              <a:t>Terminal-Bench-Science: 58.7% vs. 64.6%</a:t>
+              <a:t>Terminal-Bench-Science: 58.7% vs. </a:t>
+            </a:r>
+            <a:pPr indent="0" marL="0">
+              <a:buNone/>
+            </a:pPr>
+            <a:r>
+              <a:rPr lang="en-US" sz="850" b="1" dirty="0">
+                <a:solidFill>
+                  <a:srgbClr val="041E42"/>
+                </a:solidFill>
+                <a:latin typeface="Arial" pitchFamily="34" charset="0"/>
+                <a:ea typeface="Arial" pitchFamily="34" charset="-122"/>
+                <a:cs typeface="Arial" pitchFamily="34" charset="-120"/>
+              </a:rPr>
+              <a:t>64.6%</a:t>
             </a:r>
             <a:pPr indent="0" marL="0">
               <a:buNone/>
@@ -3114,7 +3226,21 @@
                 <a:ea typeface="Arial" pitchFamily="34" charset="-122"/>
                 <a:cs typeface="Arial" pitchFamily="34" charset="-120"/>
               </a:rPr>
-              <a:t>; FrontierMath Tier 4: Astra 97.6%</a:t>
+              <a:t>; FrontierMath Tier 4: Astra </a:t>
+            </a:r>
+            <a:pPr indent="0" marL="0">
+              <a:buNone/>
+            </a:pPr>
+            <a:r>
+              <a:rPr lang="en-US" sz="850" b="1" dirty="0">
+                <a:solidFill>
+                  <a:srgbClr val="041E42"/>
+                </a:solidFill>
+                <a:latin typeface="Arial" pitchFamily="34" charset="0"/>
+                <a:ea typeface="Arial" pitchFamily="34" charset="-122"/>
+                <a:cs typeface="Arial" pitchFamily="34" charset="-120"/>
+              </a:rPr>
+              <a:t>97.6%</a:t>
             </a:r>
             <a:endParaRPr lang="en-US" sz="850" dirty="0"/>
           </a:p>
@@ -3388,7 +3514,35 @@
                 <a:ea typeface="Arial" pitchFamily="34" charset="-122"/>
                 <a:cs typeface="Arial" pitchFamily="34" charset="-120"/>
               </a:rPr>
-              <a:t>List price, $/1M tokens in/out: K3 $3/$15; Opus 5.5 $4/$20; Astra $10/$50</a:t>
+              <a:t>List price, $/1M tokens in/out: K3 </a:t>
+            </a:r>
+            <a:pPr indent="0" marL="0">
+              <a:buNone/>
+            </a:pPr>
+            <a:r>
+              <a:rPr lang="en-US" sz="850" b="1" dirty="0">
+                <a:solidFill>
+                  <a:srgbClr val="041E42"/>
+                </a:solidFill>
+                <a:latin typeface="Arial" pitchFamily="34" charset="0"/>
+                <a:ea typeface="Arial" pitchFamily="34" charset="-122"/>
+                <a:cs typeface="Arial" pitchFamily="34" charset="-120"/>
+              </a:rPr>
+              <a:t>$3/$15</a:t>
+            </a:r>
+            <a:pPr indent="0" marL="0">
+              <a:buNone/>
+            </a:pPr>
+            <a:r>
+              <a:rPr lang="en-US" sz="850" dirty="0">
+                <a:solidFill>
+                  <a:srgbClr val="1F2A37"/>
+                </a:solidFill>
+                <a:latin typeface="Arial" pitchFamily="34" charset="0"/>
+                <a:ea typeface="Arial" pitchFamily="34" charset="-122"/>
+                <a:cs typeface="Arial" pitchFamily="34" charset="-120"/>
+              </a:rPr>
+              <a:t>; Opus 5.5 $4/$20; Astra $10/$50</a:t>
             </a:r>
             <a:endParaRPr lang="en-US" sz="850" dirty="0"/>
           </a:p>
@@ -3648,7 +3802,7 @@
                 <a:ea typeface="Arial" pitchFamily="34" charset="-122"/>
                 <a:cs typeface="Arial" pitchFamily="34" charset="-120"/>
               </a:rPr>
-              <a:t>(4)</a:t>
+              <a:t>(3)</a:t>
             </a:r>
             <a:pPr indent="0" marL="0">
               <a:buNone/>
@@ -3762,7 +3916,7 @@
         <p:spPr>
           <a:xfrm>
             <a:off x="9326880" y="1627632"/>
-            <a:ext cx="817778" cy="182880"/>
+            <a:ext cx="817778" cy="347472"/>
           </a:xfrm>
           <a:prstGeom prst="rect">
             <a:avLst/>
@@ -3778,7 +3932,7 @@
               <a:buNone/>
             </a:pPr>
             <a:r>
-              <a:rPr lang="en-US" sz="900" b="1" dirty="0">
+              <a:rPr lang="en-US" sz="950" b="1" dirty="0">
                 <a:solidFill>
                   <a:srgbClr val="041E42"/>
                 </a:solidFill>
@@ -3788,7 +3942,24 @@
               </a:rPr>
               <a:t>Opus 5.5</a:t>
             </a:r>
-            <a:endParaRPr lang="en-US" sz="900" dirty="0"/>
+            <a:endParaRPr lang="en-US" sz="950" dirty="0"/>
+          </a:p>
+          <a:p>
+            <a:pPr algn="ctr" indent="0" marL="0">
+              <a:buNone/>
+            </a:pPr>
+            <a:r>
+              <a:rPr lang="en-US" sz="800" dirty="0">
+                <a:solidFill>
+                  <a:srgbClr val="5F6B7A"/>
+                </a:solidFill>
+                <a:latin typeface="Arial" pitchFamily="34" charset="0"/>
+                <a:ea typeface="Arial" pitchFamily="34" charset="-122"/>
+                <a:cs typeface="Arial" pitchFamily="34" charset="-120"/>
+              </a:rPr>
+              <a:t>22 Sep 2026</a:t>
+            </a:r>
+            <a:endParaRPr lang="en-US" sz="950" dirty="0"/>
           </a:p>
         </p:txBody>
       </p:sp>
@@ -3801,7 +3972,7 @@
         <p:spPr>
           <a:xfrm>
             <a:off x="10144658" y="1627632"/>
-            <a:ext cx="817778" cy="182880"/>
+            <a:ext cx="817778" cy="347472"/>
           </a:xfrm>
           <a:prstGeom prst="rect">
             <a:avLst/>
@@ -3817,7 +3988,7 @@
               <a:buNone/>
             </a:pPr>
             <a:r>
-              <a:rPr lang="en-US" sz="900" b="1" dirty="0">
+              <a:rPr lang="en-US" sz="950" b="1" dirty="0">
                 <a:solidFill>
                   <a:srgbClr val="041E42"/>
                 </a:solidFill>
@@ -3827,7 +3998,24 @@
               </a:rPr>
               <a:t>GPT-6 Astra</a:t>
             </a:r>
-            <a:endParaRPr lang="en-US" sz="900" dirty="0"/>
+            <a:endParaRPr lang="en-US" sz="950" dirty="0"/>
+          </a:p>
+          <a:p>
+            <a:pPr algn="ctr" indent="0" marL="0">
+              <a:buNone/>
+            </a:pPr>
+            <a:r>
+              <a:rPr lang="en-US" sz="800" dirty="0">
+                <a:solidFill>
+                  <a:srgbClr val="5F6B7A"/>
+                </a:solidFill>
+                <a:latin typeface="Arial" pitchFamily="34" charset="0"/>
+                <a:ea typeface="Arial" pitchFamily="34" charset="-122"/>
+                <a:cs typeface="Arial" pitchFamily="34" charset="-120"/>
+              </a:rPr>
+              <a:t>3 Sep 2026</a:t>
+            </a:r>
+            <a:endParaRPr lang="en-US" sz="950" dirty="0"/>
           </a:p>
         </p:txBody>
       </p:sp>
@@ -3840,7 +4028,7 @@
         <p:spPr>
           <a:xfrm>
             <a:off x="10962437" y="1627632"/>
-            <a:ext cx="817778" cy="182880"/>
+            <a:ext cx="817778" cy="347472"/>
           </a:xfrm>
           <a:prstGeom prst="rect">
             <a:avLst/>
@@ -3856,7 +4044,7 @@
               <a:buNone/>
             </a:pPr>
             <a:r>
-              <a:rPr lang="en-US" sz="900" b="1" dirty="0">
+              <a:rPr lang="en-US" sz="950" b="1" dirty="0">
                 <a:solidFill>
                   <a:srgbClr val="041E42"/>
                 </a:solidFill>
@@ -3866,19 +4054,92 @@
               </a:rPr>
               <a:t>Kimi K3</a:t>
             </a:r>
-            <a:endParaRPr lang="en-US" sz="900" dirty="0"/>
-          </a:p>
-        </p:txBody>
-      </p:sp>
-      <p:sp>
-        <p:nvSpPr>
-          <p:cNvPr id="90" name="Shape 88"/>
-          <p:cNvSpPr/>
-          <p:nvPr/>
-        </p:nvSpPr>
-        <p:spPr>
-          <a:xfrm>
-            <a:off x="8229600" y="1865376"/>
+            <a:endParaRPr lang="en-US" sz="950" dirty="0"/>
+          </a:p>
+          <a:p>
+            <a:pPr algn="ctr" indent="0" marL="0">
+              <a:buNone/>
+            </a:pPr>
+            <a:r>
+              <a:rPr lang="en-US" sz="800" dirty="0">
+                <a:solidFill>
+                  <a:srgbClr val="5F6B7A"/>
+                </a:solidFill>
+                <a:latin typeface="Arial" pitchFamily="34" charset="0"/>
+                <a:ea typeface="Arial" pitchFamily="34" charset="-122"/>
+                <a:cs typeface="Arial" pitchFamily="34" charset="-120"/>
+              </a:rPr>
+              <a:t>16 Jul 2026</a:t>
+            </a:r>
+            <a:endParaRPr lang="en-US" sz="950" dirty="0"/>
+          </a:p>
+        </p:txBody>
+      </p:sp>
+      <p:sp>
+        <p:nvSpPr>
+          <p:cNvPr id="90" name="Text 88"/>
+          <p:cNvSpPr txBox="1"/>
+          <p:nvPr/>
+        </p:nvSpPr>
+        <p:spPr>
+          <a:xfrm>
+            <a:off x="8229600" y="1627632"/>
+            <a:ext cx="1097280" cy="347472"/>
+          </a:xfrm>
+          <a:prstGeom prst="rect">
+            <a:avLst/>
+          </a:prstGeom>
+          <a:noFill/>
+          <a:ln/>
+        </p:spPr>
+        <p:txBody>
+          <a:bodyPr wrap="square" lIns="0" tIns="0" rIns="0" bIns="0" rtlCol="0" anchor="t"/>
+          <a:lstStyle/>
+          <a:p>
+            <a:pPr indent="0" marL="0">
+              <a:buNone/>
+            </a:pPr>
+            <a:r>
+              <a:rPr lang="en-US" sz="950" dirty="0">
+                <a:solidFill>
+                  <a:srgbClr val="5F6B7A"/>
+                </a:solidFill>
+                <a:latin typeface="Arial" pitchFamily="34" charset="0"/>
+                <a:ea typeface="Arial" pitchFamily="34" charset="-122"/>
+                <a:cs typeface="Arial" pitchFamily="34" charset="-120"/>
+              </a:rPr>
+              <a:t> </a:t>
+            </a:r>
+            <a:endParaRPr lang="en-US" sz="950" dirty="0"/>
+          </a:p>
+          <a:p>
+            <a:pPr indent="0" marL="0">
+              <a:buNone/>
+            </a:pPr>
+            <a:r>
+              <a:rPr lang="en-US" sz="800" dirty="0">
+                <a:solidFill>
+                  <a:srgbClr val="5F6B7A"/>
+                </a:solidFill>
+                <a:latin typeface="Arial" pitchFamily="34" charset="0"/>
+                <a:ea typeface="Arial" pitchFamily="34" charset="-122"/>
+                <a:cs typeface="Arial" pitchFamily="34" charset="-120"/>
+              </a:rPr>
+              <a:t>Released</a:t>
+            </a:r>
+            <a:endParaRPr lang="en-US" sz="950" dirty="0"/>
+          </a:p>
+        </p:txBody>
+      </p:sp>
+      <p:sp>
+        <p:nvSpPr>
+          <p:cNvPr id="91" name="Shape 89"/>
+          <p:cNvSpPr/>
+          <p:nvPr/>
+        </p:nvSpPr>
+        <p:spPr>
+          <a:xfrm>
+            <a:off x="8229600" y="2011680"/>
             <a:ext cx="3550615" cy="0"/>
           </a:xfrm>
           <a:prstGeom prst="line">
@@ -3895,14 +4156,14 @@
       </p:sp>
       <p:sp>
         <p:nvSpPr>
-          <p:cNvPr id="91" name="Text 89"/>
-          <p:cNvSpPr txBox="1"/>
-          <p:nvPr/>
-        </p:nvSpPr>
-        <p:spPr>
-          <a:xfrm>
-            <a:off x="8229600" y="1865376"/>
-            <a:ext cx="1097280" cy="269748"/>
+          <p:cNvPr id="92" name="Text 90"/>
+          <p:cNvSpPr txBox="1"/>
+          <p:nvPr/>
+        </p:nvSpPr>
+        <p:spPr>
+          <a:xfrm>
+            <a:off x="8229600" y="2011680"/>
+            <a:ext cx="1097280" cy="274320"/>
           </a:xfrm>
           <a:prstGeom prst="rect">
             <a:avLst/>
@@ -3926,7 +4187,7 @@
                 <a:ea typeface="Arial" pitchFamily="34" charset="-122"/>
                 <a:cs typeface="Arial" pitchFamily="34" charset="-120"/>
               </a:rPr>
-              <a:t>Released</a:t>
+              <a:t>Access</a:t>
             </a:r>
             <a:endParaRPr lang="en-US" sz="850" dirty="0"/>
           </a:p>
@@ -3934,14 +4195,14 @@
       </p:sp>
       <p:sp>
         <p:nvSpPr>
-          <p:cNvPr id="92" name="Text 90"/>
-          <p:cNvSpPr txBox="1"/>
-          <p:nvPr/>
-        </p:nvSpPr>
-        <p:spPr>
-          <a:xfrm>
-            <a:off x="9345168" y="1865376"/>
-            <a:ext cx="781202" cy="269748"/>
+          <p:cNvPr id="93" name="Text 91"/>
+          <p:cNvSpPr txBox="1"/>
+          <p:nvPr/>
+        </p:nvSpPr>
+        <p:spPr>
+          <a:xfrm>
+            <a:off x="9345168" y="2011680"/>
+            <a:ext cx="781202" cy="274320"/>
           </a:xfrm>
           <a:prstGeom prst="rect">
             <a:avLst/>
@@ -3965,7 +4226,7 @@
                 <a:ea typeface="Arial" pitchFamily="34" charset="-122"/>
                 <a:cs typeface="Arial" pitchFamily="34" charset="-120"/>
               </a:rPr>
-              <a:t>22 Sep 2026</a:t>
+              <a:t>API</a:t>
             </a:r>
             <a:endParaRPr lang="en-US" sz="850" dirty="0"/>
           </a:p>
@@ -3973,14 +4234,14 @@
       </p:sp>
       <p:sp>
         <p:nvSpPr>
-          <p:cNvPr id="93" name="Text 91"/>
-          <p:cNvSpPr txBox="1"/>
-          <p:nvPr/>
-        </p:nvSpPr>
-        <p:spPr>
-          <a:xfrm>
-            <a:off x="10162946" y="1865376"/>
-            <a:ext cx="781202" cy="269748"/>
+          <p:cNvPr id="94" name="Text 92"/>
+          <p:cNvSpPr txBox="1"/>
+          <p:nvPr/>
+        </p:nvSpPr>
+        <p:spPr>
+          <a:xfrm>
+            <a:off x="10162946" y="2011680"/>
+            <a:ext cx="781202" cy="274320"/>
           </a:xfrm>
           <a:prstGeom prst="rect">
             <a:avLst/>
@@ -4004,7 +4265,7 @@
                 <a:ea typeface="Arial" pitchFamily="34" charset="-122"/>
                 <a:cs typeface="Arial" pitchFamily="34" charset="-120"/>
               </a:rPr>
-              <a:t>3 Sep 2026</a:t>
+              <a:t>API (staged)</a:t>
             </a:r>
             <a:endParaRPr lang="en-US" sz="850" dirty="0"/>
           </a:p>
@@ -4012,14 +4273,14 @@
       </p:sp>
       <p:sp>
         <p:nvSpPr>
-          <p:cNvPr id="94" name="Text 92"/>
-          <p:cNvSpPr txBox="1"/>
-          <p:nvPr/>
-        </p:nvSpPr>
-        <p:spPr>
-          <a:xfrm>
-            <a:off x="10980725" y="1865376"/>
-            <a:ext cx="781202" cy="269748"/>
+          <p:cNvPr id="95" name="Text 93"/>
+          <p:cNvSpPr txBox="1"/>
+          <p:nvPr/>
+        </p:nvSpPr>
+        <p:spPr>
+          <a:xfrm>
+            <a:off x="10980725" y="2011680"/>
+            <a:ext cx="781202" cy="274320"/>
           </a:xfrm>
           <a:prstGeom prst="rect">
             <a:avLst/>
@@ -4043,7 +4304,21 @@
                 <a:ea typeface="Arial" pitchFamily="34" charset="-122"/>
                 <a:cs typeface="Arial" pitchFamily="34" charset="-120"/>
               </a:rPr>
-              <a:t>16 Jul 2026</a:t>
+              <a:t>Open weights</a:t>
+            </a:r>
+            <a:pPr algn="ctr" indent="0" marL="0">
+              <a:buNone/>
+            </a:pPr>
+            <a:r>
+              <a:rPr lang="en-US" sz="850" baseline="30000" dirty="0">
+                <a:solidFill>
+                  <a:srgbClr val="1F2A37"/>
+                </a:solidFill>
+                <a:latin typeface="Arial" pitchFamily="34" charset="0"/>
+                <a:ea typeface="Arial" pitchFamily="34" charset="-122"/>
+                <a:cs typeface="Arial" pitchFamily="34" charset="-120"/>
+              </a:rPr>
+              <a:t>(3)</a:t>
             </a:r>
             <a:endParaRPr lang="en-US" sz="850" dirty="0"/>
           </a:p>
@@ -4051,13 +4326,13 @@
       </p:sp>
       <p:sp>
         <p:nvSpPr>
-          <p:cNvPr id="95" name="Shape 93"/>
-          <p:cNvSpPr/>
-          <p:nvPr/>
-        </p:nvSpPr>
-        <p:spPr>
-          <a:xfrm>
-            <a:off x="8229600" y="2135124"/>
+          <p:cNvPr id="96" name="Shape 94"/>
+          <p:cNvSpPr/>
+          <p:nvPr/>
+        </p:nvSpPr>
+        <p:spPr>
+          <a:xfrm>
+            <a:off x="8229600" y="2286000"/>
             <a:ext cx="3550615" cy="0"/>
           </a:xfrm>
           <a:prstGeom prst="line">
@@ -4074,14 +4349,39 @@
       </p:sp>
       <p:sp>
         <p:nvSpPr>
-          <p:cNvPr id="96" name="Text 94"/>
-          <p:cNvSpPr txBox="1"/>
-          <p:nvPr/>
-        </p:nvSpPr>
-        <p:spPr>
-          <a:xfrm>
-            <a:off x="8229600" y="2135124"/>
-            <a:ext cx="1097280" cy="269748"/>
+          <p:cNvPr id="97" name="Shape 95"/>
+          <p:cNvSpPr/>
+          <p:nvPr/>
+        </p:nvSpPr>
+        <p:spPr>
+          <a:xfrm>
+            <a:off x="11053877" y="2322576"/>
+            <a:ext cx="634898" cy="201168"/>
+          </a:xfrm>
+          <a:prstGeom prst="rect">
+            <a:avLst/>
+          </a:prstGeom>
+          <a:solidFill>
+            <a:srgbClr val="EAF0F7"/>
+          </a:solidFill>
+          <a:ln w="12700">
+            <a:solidFill>
+              <a:srgbClr val="EAF0F7"/>
+            </a:solidFill>
+            <a:prstDash val="solid"/>
+          </a:ln>
+        </p:spPr>
+      </p:sp>
+      <p:sp>
+        <p:nvSpPr>
+          <p:cNvPr id="98" name="Text 96"/>
+          <p:cNvSpPr txBox="1"/>
+          <p:nvPr/>
+        </p:nvSpPr>
+        <p:spPr>
+          <a:xfrm>
+            <a:off x="8229600" y="2286000"/>
+            <a:ext cx="1097280" cy="274320"/>
           </a:xfrm>
           <a:prstGeom prst="rect">
             <a:avLst/>
@@ -4105,7 +4405,7 @@
                 <a:ea typeface="Arial" pitchFamily="34" charset="-122"/>
                 <a:cs typeface="Arial" pitchFamily="34" charset="-120"/>
               </a:rPr>
-              <a:t>Access</a:t>
+              <a:t>Input ($ / 1M tokens)</a:t>
             </a:r>
             <a:endParaRPr lang="en-US" sz="850" dirty="0"/>
           </a:p>
@@ -4113,14 +4413,14 @@
       </p:sp>
       <p:sp>
         <p:nvSpPr>
-          <p:cNvPr id="97" name="Text 95"/>
-          <p:cNvSpPr txBox="1"/>
-          <p:nvPr/>
-        </p:nvSpPr>
-        <p:spPr>
-          <a:xfrm>
-            <a:off x="9345168" y="2135124"/>
-            <a:ext cx="781202" cy="269748"/>
+          <p:cNvPr id="99" name="Text 97"/>
+          <p:cNvSpPr txBox="1"/>
+          <p:nvPr/>
+        </p:nvSpPr>
+        <p:spPr>
+          <a:xfrm>
+            <a:off x="9345168" y="2286000"/>
+            <a:ext cx="781202" cy="274320"/>
           </a:xfrm>
           <a:prstGeom prst="rect">
             <a:avLst/>
@@ -4144,7 +4444,7 @@
                 <a:ea typeface="Arial" pitchFamily="34" charset="-122"/>
                 <a:cs typeface="Arial" pitchFamily="34" charset="-120"/>
               </a:rPr>
-              <a:t>API</a:t>
+              <a:t>$4.00</a:t>
             </a:r>
             <a:endParaRPr lang="en-US" sz="850" dirty="0"/>
           </a:p>
@@ -4152,14 +4452,14 @@
       </p:sp>
       <p:sp>
         <p:nvSpPr>
-          <p:cNvPr id="98" name="Text 96"/>
-          <p:cNvSpPr txBox="1"/>
-          <p:nvPr/>
-        </p:nvSpPr>
-        <p:spPr>
-          <a:xfrm>
-            <a:off x="10162946" y="2135124"/>
-            <a:ext cx="781202" cy="269748"/>
+          <p:cNvPr id="100" name="Text 98"/>
+          <p:cNvSpPr txBox="1"/>
+          <p:nvPr/>
+        </p:nvSpPr>
+        <p:spPr>
+          <a:xfrm>
+            <a:off x="10162946" y="2286000"/>
+            <a:ext cx="781202" cy="274320"/>
           </a:xfrm>
           <a:prstGeom prst="rect">
             <a:avLst/>
@@ -4183,7 +4483,7 @@
                 <a:ea typeface="Arial" pitchFamily="34" charset="-122"/>
                 <a:cs typeface="Arial" pitchFamily="34" charset="-120"/>
               </a:rPr>
-              <a:t>API (staged)</a:t>
+              <a:t>$10.00</a:t>
             </a:r>
             <a:endParaRPr lang="en-US" sz="850" dirty="0"/>
           </a:p>
@@ -4191,14 +4491,14 @@
       </p:sp>
       <p:sp>
         <p:nvSpPr>
-          <p:cNvPr id="99" name="Text 97"/>
-          <p:cNvSpPr txBox="1"/>
-          <p:nvPr/>
-        </p:nvSpPr>
-        <p:spPr>
-          <a:xfrm>
-            <a:off x="10980725" y="2135124"/>
-            <a:ext cx="781202" cy="269748"/>
+          <p:cNvPr id="101" name="Text 99"/>
+          <p:cNvSpPr txBox="1"/>
+          <p:nvPr/>
+        </p:nvSpPr>
+        <p:spPr>
+          <a:xfrm>
+            <a:off x="10980725" y="2286000"/>
+            <a:ext cx="781202" cy="274320"/>
           </a:xfrm>
           <a:prstGeom prst="rect">
             <a:avLst/>
@@ -4214,28 +4514,971 @@
               <a:buNone/>
             </a:pPr>
             <a:r>
+              <a:rPr lang="en-US" sz="850" b="1" dirty="0">
+                <a:solidFill>
+                  <a:srgbClr val="041E42"/>
+                </a:solidFill>
+                <a:latin typeface="Arial" pitchFamily="34" charset="0"/>
+                <a:ea typeface="Arial" pitchFamily="34" charset="-122"/>
+                <a:cs typeface="Arial" pitchFamily="34" charset="-120"/>
+              </a:rPr>
+              <a:t>$3.00</a:t>
+            </a:r>
+            <a:endParaRPr lang="en-US" sz="850" dirty="0"/>
+          </a:p>
+        </p:txBody>
+      </p:sp>
+      <p:sp>
+        <p:nvSpPr>
+          <p:cNvPr id="102" name="Shape 100"/>
+          <p:cNvSpPr/>
+          <p:nvPr/>
+        </p:nvSpPr>
+        <p:spPr>
+          <a:xfrm>
+            <a:off x="8229600" y="2560320"/>
+            <a:ext cx="3550615" cy="0"/>
+          </a:xfrm>
+          <a:prstGeom prst="line">
+            <a:avLst/>
+          </a:prstGeom>
+          <a:noFill/>
+          <a:ln w="6350">
+            <a:solidFill>
+              <a:srgbClr val="E3E7EC"/>
+            </a:solidFill>
+            <a:prstDash val="solid"/>
+          </a:ln>
+        </p:spPr>
+      </p:sp>
+      <p:sp>
+        <p:nvSpPr>
+          <p:cNvPr id="103" name="Shape 101"/>
+          <p:cNvSpPr/>
+          <p:nvPr/>
+        </p:nvSpPr>
+        <p:spPr>
+          <a:xfrm>
+            <a:off x="11053877" y="2596896"/>
+            <a:ext cx="634898" cy="201168"/>
+          </a:xfrm>
+          <a:prstGeom prst="rect">
+            <a:avLst/>
+          </a:prstGeom>
+          <a:solidFill>
+            <a:srgbClr val="EAF0F7"/>
+          </a:solidFill>
+          <a:ln w="12700">
+            <a:solidFill>
+              <a:srgbClr val="EAF0F7"/>
+            </a:solidFill>
+            <a:prstDash val="solid"/>
+          </a:ln>
+        </p:spPr>
+      </p:sp>
+      <p:sp>
+        <p:nvSpPr>
+          <p:cNvPr id="104" name="Text 102"/>
+          <p:cNvSpPr txBox="1"/>
+          <p:nvPr/>
+        </p:nvSpPr>
+        <p:spPr>
+          <a:xfrm>
+            <a:off x="8229600" y="2560320"/>
+            <a:ext cx="1097280" cy="274320"/>
+          </a:xfrm>
+          <a:prstGeom prst="rect">
+            <a:avLst/>
+          </a:prstGeom>
+          <a:noFill/>
+          <a:ln/>
+        </p:spPr>
+        <p:txBody>
+          <a:bodyPr wrap="square" lIns="0" tIns="0" rIns="0" bIns="0" rtlCol="0" anchor="ctr"/>
+          <a:lstStyle/>
+          <a:p>
+            <a:pPr indent="0" marL="0">
+              <a:buNone/>
+            </a:pPr>
+            <a:r>
               <a:rPr lang="en-US" sz="850" dirty="0">
                 <a:solidFill>
+                  <a:srgbClr val="5F6B7A"/>
+                </a:solidFill>
+                <a:latin typeface="Arial" pitchFamily="34" charset="0"/>
+                <a:ea typeface="Arial" pitchFamily="34" charset="-122"/>
+                <a:cs typeface="Arial" pitchFamily="34" charset="-120"/>
+              </a:rPr>
+              <a:t>Output ($ / 1M tokens)</a:t>
+            </a:r>
+            <a:endParaRPr lang="en-US" sz="850" dirty="0"/>
+          </a:p>
+        </p:txBody>
+      </p:sp>
+      <p:sp>
+        <p:nvSpPr>
+          <p:cNvPr id="105" name="Text 103"/>
+          <p:cNvSpPr txBox="1"/>
+          <p:nvPr/>
+        </p:nvSpPr>
+        <p:spPr>
+          <a:xfrm>
+            <a:off x="9345168" y="2560320"/>
+            <a:ext cx="781202" cy="274320"/>
+          </a:xfrm>
+          <a:prstGeom prst="rect">
+            <a:avLst/>
+          </a:prstGeom>
+          <a:noFill/>
+          <a:ln/>
+        </p:spPr>
+        <p:txBody>
+          <a:bodyPr wrap="square" lIns="0" tIns="0" rIns="0" bIns="0" rtlCol="0" anchor="ctr"/>
+          <a:lstStyle/>
+          <a:p>
+            <a:pPr algn="ctr" indent="0" marL="0">
+              <a:buNone/>
+            </a:pPr>
+            <a:r>
+              <a:rPr lang="en-US" sz="850" dirty="0">
+                <a:solidFill>
                   <a:srgbClr val="1F2A37"/>
                 </a:solidFill>
                 <a:latin typeface="Arial" pitchFamily="34" charset="0"/>
                 <a:ea typeface="Arial" pitchFamily="34" charset="-122"/>
                 <a:cs typeface="Arial" pitchFamily="34" charset="-120"/>
               </a:rPr>
-              <a:t>Open weights</a:t>
-            </a:r>
+              <a:t>$20.00</a:t>
+            </a:r>
+            <a:endParaRPr lang="en-US" sz="850" dirty="0"/>
+          </a:p>
+        </p:txBody>
+      </p:sp>
+      <p:sp>
+        <p:nvSpPr>
+          <p:cNvPr id="106" name="Text 104"/>
+          <p:cNvSpPr txBox="1"/>
+          <p:nvPr/>
+        </p:nvSpPr>
+        <p:spPr>
+          <a:xfrm>
+            <a:off x="10162946" y="2560320"/>
+            <a:ext cx="781202" cy="274320"/>
+          </a:xfrm>
+          <a:prstGeom prst="rect">
+            <a:avLst/>
+          </a:prstGeom>
+          <a:noFill/>
+          <a:ln/>
+        </p:spPr>
+        <p:txBody>
+          <a:bodyPr wrap="square" lIns="0" tIns="0" rIns="0" bIns="0" rtlCol="0" anchor="ctr"/>
+          <a:lstStyle/>
+          <a:p>
             <a:pPr algn="ctr" indent="0" marL="0">
               <a:buNone/>
             </a:pPr>
             <a:r>
+              <a:rPr lang="en-US" sz="850" dirty="0">
+                <a:solidFill>
+                  <a:srgbClr val="1F2A37"/>
+                </a:solidFill>
+                <a:latin typeface="Arial" pitchFamily="34" charset="0"/>
+                <a:ea typeface="Arial" pitchFamily="34" charset="-122"/>
+                <a:cs typeface="Arial" pitchFamily="34" charset="-120"/>
+              </a:rPr>
+              <a:t>$50.00</a:t>
+            </a:r>
+            <a:endParaRPr lang="en-US" sz="850" dirty="0"/>
+          </a:p>
+        </p:txBody>
+      </p:sp>
+      <p:sp>
+        <p:nvSpPr>
+          <p:cNvPr id="107" name="Text 105"/>
+          <p:cNvSpPr txBox="1"/>
+          <p:nvPr/>
+        </p:nvSpPr>
+        <p:spPr>
+          <a:xfrm>
+            <a:off x="10980725" y="2560320"/>
+            <a:ext cx="781202" cy="274320"/>
+          </a:xfrm>
+          <a:prstGeom prst="rect">
+            <a:avLst/>
+          </a:prstGeom>
+          <a:noFill/>
+          <a:ln/>
+        </p:spPr>
+        <p:txBody>
+          <a:bodyPr wrap="square" lIns="0" tIns="0" rIns="0" bIns="0" rtlCol="0" anchor="ctr"/>
+          <a:lstStyle/>
+          <a:p>
+            <a:pPr algn="ctr" indent="0" marL="0">
+              <a:buNone/>
+            </a:pPr>
+            <a:r>
+              <a:rPr lang="en-US" sz="850" b="1" dirty="0">
+                <a:solidFill>
+                  <a:srgbClr val="041E42"/>
+                </a:solidFill>
+                <a:latin typeface="Arial" pitchFamily="34" charset="0"/>
+                <a:ea typeface="Arial" pitchFamily="34" charset="-122"/>
+                <a:cs typeface="Arial" pitchFamily="34" charset="-120"/>
+              </a:rPr>
+              <a:t>$15.00</a:t>
+            </a:r>
+            <a:endParaRPr lang="en-US" sz="850" dirty="0"/>
+          </a:p>
+        </p:txBody>
+      </p:sp>
+      <p:sp>
+        <p:nvSpPr>
+          <p:cNvPr id="108" name="Shape 106"/>
+          <p:cNvSpPr/>
+          <p:nvPr/>
+        </p:nvSpPr>
+        <p:spPr>
+          <a:xfrm>
+            <a:off x="8229600" y="2834640"/>
+            <a:ext cx="3550615" cy="0"/>
+          </a:xfrm>
+          <a:prstGeom prst="line">
+            <a:avLst/>
+          </a:prstGeom>
+          <a:noFill/>
+          <a:ln w="6350">
+            <a:solidFill>
+              <a:srgbClr val="E3E7EC"/>
+            </a:solidFill>
+            <a:prstDash val="solid"/>
+          </a:ln>
+        </p:spPr>
+      </p:sp>
+      <p:sp>
+        <p:nvSpPr>
+          <p:cNvPr id="109" name="Shape 107"/>
+          <p:cNvSpPr/>
+          <p:nvPr/>
+        </p:nvSpPr>
+        <p:spPr>
+          <a:xfrm>
+            <a:off x="9418320" y="2871216"/>
+            <a:ext cx="634898" cy="201168"/>
+          </a:xfrm>
+          <a:prstGeom prst="rect">
+            <a:avLst/>
+          </a:prstGeom>
+          <a:solidFill>
+            <a:srgbClr val="EAF0F7"/>
+          </a:solidFill>
+          <a:ln w="12700">
+            <a:solidFill>
+              <a:srgbClr val="EAF0F7"/>
+            </a:solidFill>
+            <a:prstDash val="solid"/>
+          </a:ln>
+        </p:spPr>
+      </p:sp>
+      <p:sp>
+        <p:nvSpPr>
+          <p:cNvPr id="110" name="Text 108"/>
+          <p:cNvSpPr txBox="1"/>
+          <p:nvPr/>
+        </p:nvSpPr>
+        <p:spPr>
+          <a:xfrm>
+            <a:off x="8229600" y="2834640"/>
+            <a:ext cx="1097280" cy="274320"/>
+          </a:xfrm>
+          <a:prstGeom prst="rect">
+            <a:avLst/>
+          </a:prstGeom>
+          <a:noFill/>
+          <a:ln/>
+        </p:spPr>
+        <p:txBody>
+          <a:bodyPr wrap="square" lIns="0" tIns="0" rIns="0" bIns="0" rtlCol="0" anchor="ctr"/>
+          <a:lstStyle/>
+          <a:p>
+            <a:pPr indent="0" marL="0">
+              <a:buNone/>
+            </a:pPr>
+            <a:r>
+              <a:rPr lang="en-US" sz="850" dirty="0">
+                <a:solidFill>
+                  <a:srgbClr val="5F6B7A"/>
+                </a:solidFill>
+                <a:latin typeface="Arial" pitchFamily="34" charset="0"/>
+                <a:ea typeface="Arial" pitchFamily="34" charset="-122"/>
+                <a:cs typeface="Arial" pitchFamily="34" charset="-120"/>
+              </a:rPr>
+              <a:t>Cached input ($ / 1M)</a:t>
+            </a:r>
+            <a:endParaRPr lang="en-US" sz="850" dirty="0"/>
+          </a:p>
+        </p:txBody>
+      </p:sp>
+      <p:sp>
+        <p:nvSpPr>
+          <p:cNvPr id="111" name="Text 109"/>
+          <p:cNvSpPr txBox="1"/>
+          <p:nvPr/>
+        </p:nvSpPr>
+        <p:spPr>
+          <a:xfrm>
+            <a:off x="9345168" y="2834640"/>
+            <a:ext cx="781202" cy="274320"/>
+          </a:xfrm>
+          <a:prstGeom prst="rect">
+            <a:avLst/>
+          </a:prstGeom>
+          <a:noFill/>
+          <a:ln/>
+        </p:spPr>
+        <p:txBody>
+          <a:bodyPr wrap="square" lIns="0" tIns="0" rIns="0" bIns="0" rtlCol="0" anchor="ctr"/>
+          <a:lstStyle/>
+          <a:p>
+            <a:pPr algn="ctr" indent="0" marL="0">
+              <a:buNone/>
+            </a:pPr>
+            <a:r>
+              <a:rPr lang="en-US" sz="850" b="1" dirty="0">
+                <a:solidFill>
+                  <a:srgbClr val="041E42"/>
+                </a:solidFill>
+                <a:latin typeface="Arial" pitchFamily="34" charset="0"/>
+                <a:ea typeface="Arial" pitchFamily="34" charset="-122"/>
+                <a:cs typeface="Arial" pitchFamily="34" charset="-120"/>
+              </a:rPr>
+              <a:t>$0.20</a:t>
+            </a:r>
+            <a:endParaRPr lang="en-US" sz="850" dirty="0"/>
+          </a:p>
+        </p:txBody>
+      </p:sp>
+      <p:sp>
+        <p:nvSpPr>
+          <p:cNvPr id="112" name="Text 110"/>
+          <p:cNvSpPr txBox="1"/>
+          <p:nvPr/>
+        </p:nvSpPr>
+        <p:spPr>
+          <a:xfrm>
+            <a:off x="10162946" y="2834640"/>
+            <a:ext cx="781202" cy="274320"/>
+          </a:xfrm>
+          <a:prstGeom prst="rect">
+            <a:avLst/>
+          </a:prstGeom>
+          <a:noFill/>
+          <a:ln/>
+        </p:spPr>
+        <p:txBody>
+          <a:bodyPr wrap="square" lIns="0" tIns="0" rIns="0" bIns="0" rtlCol="0" anchor="ctr"/>
+          <a:lstStyle/>
+          <a:p>
+            <a:pPr algn="ctr" indent="0" marL="0">
+              <a:buNone/>
+            </a:pPr>
+            <a:r>
+              <a:rPr lang="en-US" sz="850" dirty="0">
+                <a:solidFill>
+                  <a:srgbClr val="1F2A37"/>
+                </a:solidFill>
+                <a:latin typeface="Arial" pitchFamily="34" charset="0"/>
+                <a:ea typeface="Arial" pitchFamily="34" charset="-122"/>
+                <a:cs typeface="Arial" pitchFamily="34" charset="-120"/>
+              </a:rPr>
+              <a:t>$1.00</a:t>
+            </a:r>
+            <a:endParaRPr lang="en-US" sz="850" dirty="0"/>
+          </a:p>
+        </p:txBody>
+      </p:sp>
+      <p:sp>
+        <p:nvSpPr>
+          <p:cNvPr id="113" name="Text 111"/>
+          <p:cNvSpPr txBox="1"/>
+          <p:nvPr/>
+        </p:nvSpPr>
+        <p:spPr>
+          <a:xfrm>
+            <a:off x="10980725" y="2834640"/>
+            <a:ext cx="781202" cy="274320"/>
+          </a:xfrm>
+          <a:prstGeom prst="rect">
+            <a:avLst/>
+          </a:prstGeom>
+          <a:noFill/>
+          <a:ln/>
+        </p:spPr>
+        <p:txBody>
+          <a:bodyPr wrap="square" lIns="0" tIns="0" rIns="0" bIns="0" rtlCol="0" anchor="ctr"/>
+          <a:lstStyle/>
+          <a:p>
+            <a:pPr algn="ctr" indent="0" marL="0">
+              <a:buNone/>
+            </a:pPr>
+            <a:r>
+              <a:rPr lang="en-US" sz="850" dirty="0">
+                <a:solidFill>
+                  <a:srgbClr val="1F2A37"/>
+                </a:solidFill>
+                <a:latin typeface="Arial" pitchFamily="34" charset="0"/>
+                <a:ea typeface="Arial" pitchFamily="34" charset="-122"/>
+                <a:cs typeface="Arial" pitchFamily="34" charset="-120"/>
+              </a:rPr>
+              <a:t>$0.30</a:t>
+            </a:r>
+            <a:endParaRPr lang="en-US" sz="850" dirty="0"/>
+          </a:p>
+        </p:txBody>
+      </p:sp>
+      <p:sp>
+        <p:nvSpPr>
+          <p:cNvPr id="114" name="Shape 112"/>
+          <p:cNvSpPr/>
+          <p:nvPr/>
+        </p:nvSpPr>
+        <p:spPr>
+          <a:xfrm>
+            <a:off x="8229600" y="3108960"/>
+            <a:ext cx="3550615" cy="0"/>
+          </a:xfrm>
+          <a:prstGeom prst="line">
+            <a:avLst/>
+          </a:prstGeom>
+          <a:noFill/>
+          <a:ln w="6350">
+            <a:solidFill>
+              <a:srgbClr val="E3E7EC"/>
+            </a:solidFill>
+            <a:prstDash val="solid"/>
+          </a:ln>
+        </p:spPr>
+      </p:sp>
+      <p:sp>
+        <p:nvSpPr>
+          <p:cNvPr id="115" name="Shape 113"/>
+          <p:cNvSpPr/>
+          <p:nvPr/>
+        </p:nvSpPr>
+        <p:spPr>
+          <a:xfrm>
+            <a:off x="10236098" y="3145536"/>
+            <a:ext cx="634898" cy="201168"/>
+          </a:xfrm>
+          <a:prstGeom prst="rect">
+            <a:avLst/>
+          </a:prstGeom>
+          <a:solidFill>
+            <a:srgbClr val="EAF0F7"/>
+          </a:solidFill>
+          <a:ln w="12700">
+            <a:solidFill>
+              <a:srgbClr val="EAF0F7"/>
+            </a:solidFill>
+            <a:prstDash val="solid"/>
+          </a:ln>
+        </p:spPr>
+      </p:sp>
+      <p:sp>
+        <p:nvSpPr>
+          <p:cNvPr id="116" name="Text 114"/>
+          <p:cNvSpPr txBox="1"/>
+          <p:nvPr/>
+        </p:nvSpPr>
+        <p:spPr>
+          <a:xfrm>
+            <a:off x="8229600" y="3108960"/>
+            <a:ext cx="1097280" cy="274320"/>
+          </a:xfrm>
+          <a:prstGeom prst="rect">
+            <a:avLst/>
+          </a:prstGeom>
+          <a:noFill/>
+          <a:ln/>
+        </p:spPr>
+        <p:txBody>
+          <a:bodyPr wrap="square" lIns="0" tIns="0" rIns="0" bIns="0" rtlCol="0" anchor="ctr"/>
+          <a:lstStyle/>
+          <a:p>
+            <a:pPr indent="0" marL="0">
+              <a:buNone/>
+            </a:pPr>
+            <a:r>
+              <a:rPr lang="en-US" sz="850" dirty="0">
+                <a:solidFill>
+                  <a:srgbClr val="5F6B7A"/>
+                </a:solidFill>
+                <a:latin typeface="Arial" pitchFamily="34" charset="0"/>
+                <a:ea typeface="Arial" pitchFamily="34" charset="-122"/>
+                <a:cs typeface="Arial" pitchFamily="34" charset="-120"/>
+              </a:rPr>
+              <a:t>Context (tokens)</a:t>
+            </a:r>
+            <a:endParaRPr lang="en-US" sz="850" dirty="0"/>
+          </a:p>
+        </p:txBody>
+      </p:sp>
+      <p:sp>
+        <p:nvSpPr>
+          <p:cNvPr id="117" name="Text 115"/>
+          <p:cNvSpPr txBox="1"/>
+          <p:nvPr/>
+        </p:nvSpPr>
+        <p:spPr>
+          <a:xfrm>
+            <a:off x="9345168" y="3108960"/>
+            <a:ext cx="781202" cy="274320"/>
+          </a:xfrm>
+          <a:prstGeom prst="rect">
+            <a:avLst/>
+          </a:prstGeom>
+          <a:noFill/>
+          <a:ln/>
+        </p:spPr>
+        <p:txBody>
+          <a:bodyPr wrap="square" lIns="0" tIns="0" rIns="0" bIns="0" rtlCol="0" anchor="ctr"/>
+          <a:lstStyle/>
+          <a:p>
+            <a:pPr algn="ctr" indent="0" marL="0">
+              <a:buNone/>
+            </a:pPr>
+            <a:r>
+              <a:rPr lang="en-US" sz="850" dirty="0">
+                <a:solidFill>
+                  <a:srgbClr val="1F2A37"/>
+                </a:solidFill>
+                <a:latin typeface="Arial" pitchFamily="34" charset="0"/>
+                <a:ea typeface="Arial" pitchFamily="34" charset="-122"/>
+                <a:cs typeface="Arial" pitchFamily="34" charset="-120"/>
+              </a:rPr>
+              <a:t>1.0M</a:t>
+            </a:r>
+            <a:endParaRPr lang="en-US" sz="850" dirty="0"/>
+          </a:p>
+        </p:txBody>
+      </p:sp>
+      <p:sp>
+        <p:nvSpPr>
+          <p:cNvPr id="118" name="Text 116"/>
+          <p:cNvSpPr txBox="1"/>
+          <p:nvPr/>
+        </p:nvSpPr>
+        <p:spPr>
+          <a:xfrm>
+            <a:off x="10162946" y="3108960"/>
+            <a:ext cx="781202" cy="274320"/>
+          </a:xfrm>
+          <a:prstGeom prst="rect">
+            <a:avLst/>
+          </a:prstGeom>
+          <a:noFill/>
+          <a:ln/>
+        </p:spPr>
+        <p:txBody>
+          <a:bodyPr wrap="square" lIns="0" tIns="0" rIns="0" bIns="0" rtlCol="0" anchor="ctr"/>
+          <a:lstStyle/>
+          <a:p>
+            <a:pPr algn="ctr" indent="0" marL="0">
+              <a:buNone/>
+            </a:pPr>
+            <a:r>
+              <a:rPr lang="en-US" sz="850" b="1" dirty="0">
+                <a:solidFill>
+                  <a:srgbClr val="041E42"/>
+                </a:solidFill>
+                <a:latin typeface="Arial" pitchFamily="34" charset="0"/>
+                <a:ea typeface="Arial" pitchFamily="34" charset="-122"/>
+                <a:cs typeface="Arial" pitchFamily="34" charset="-120"/>
+              </a:rPr>
+              <a:t>1.05M</a:t>
+            </a:r>
+            <a:endParaRPr lang="en-US" sz="850" dirty="0"/>
+          </a:p>
+        </p:txBody>
+      </p:sp>
+      <p:sp>
+        <p:nvSpPr>
+          <p:cNvPr id="119" name="Text 117"/>
+          <p:cNvSpPr txBox="1"/>
+          <p:nvPr/>
+        </p:nvSpPr>
+        <p:spPr>
+          <a:xfrm>
+            <a:off x="10980725" y="3108960"/>
+            <a:ext cx="781202" cy="274320"/>
+          </a:xfrm>
+          <a:prstGeom prst="rect">
+            <a:avLst/>
+          </a:prstGeom>
+          <a:noFill/>
+          <a:ln/>
+        </p:spPr>
+        <p:txBody>
+          <a:bodyPr wrap="square" lIns="0" tIns="0" rIns="0" bIns="0" rtlCol="0" anchor="ctr"/>
+          <a:lstStyle/>
+          <a:p>
+            <a:pPr algn="ctr" indent="0" marL="0">
+              <a:buNone/>
+            </a:pPr>
+            <a:r>
+              <a:rPr lang="en-US" sz="850" dirty="0">
+                <a:solidFill>
+                  <a:srgbClr val="1F2A37"/>
+                </a:solidFill>
+                <a:latin typeface="Arial" pitchFamily="34" charset="0"/>
+                <a:ea typeface="Arial" pitchFamily="34" charset="-122"/>
+                <a:cs typeface="Arial" pitchFamily="34" charset="-120"/>
+              </a:rPr>
+              <a:t>1.0M</a:t>
+            </a:r>
+            <a:endParaRPr lang="en-US" sz="850" dirty="0"/>
+          </a:p>
+        </p:txBody>
+      </p:sp>
+      <p:sp>
+        <p:nvSpPr>
+          <p:cNvPr id="120" name="Shape 118"/>
+          <p:cNvSpPr/>
+          <p:nvPr/>
+        </p:nvSpPr>
+        <p:spPr>
+          <a:xfrm>
+            <a:off x="8229600" y="3383280"/>
+            <a:ext cx="3550615" cy="0"/>
+          </a:xfrm>
+          <a:prstGeom prst="line">
+            <a:avLst/>
+          </a:prstGeom>
+          <a:noFill/>
+          <a:ln w="6350">
+            <a:solidFill>
+              <a:srgbClr val="E3E7EC"/>
+            </a:solidFill>
+            <a:prstDash val="solid"/>
+          </a:ln>
+        </p:spPr>
+      </p:sp>
+      <p:sp>
+        <p:nvSpPr>
+          <p:cNvPr id="121" name="Text 119"/>
+          <p:cNvSpPr txBox="1"/>
+          <p:nvPr/>
+        </p:nvSpPr>
+        <p:spPr>
+          <a:xfrm>
+            <a:off x="8229600" y="3383280"/>
+            <a:ext cx="1097280" cy="548640"/>
+          </a:xfrm>
+          <a:prstGeom prst="rect">
+            <a:avLst/>
+          </a:prstGeom>
+          <a:noFill/>
+          <a:ln/>
+        </p:spPr>
+        <p:txBody>
+          <a:bodyPr wrap="square" lIns="0" tIns="0" rIns="0" bIns="0" rtlCol="0" anchor="ctr"/>
+          <a:lstStyle/>
+          <a:p>
+            <a:pPr indent="0" marL="0">
+              <a:buNone/>
+            </a:pPr>
+            <a:r>
+              <a:rPr lang="en-US" sz="850" dirty="0">
+                <a:solidFill>
+                  <a:srgbClr val="5F6B7A"/>
+                </a:solidFill>
+                <a:latin typeface="Arial" pitchFamily="34" charset="0"/>
+                <a:ea typeface="Arial" pitchFamily="34" charset="-122"/>
+                <a:cs typeface="Arial" pitchFamily="34" charset="-120"/>
+              </a:rPr>
+              <a:t>Parameters</a:t>
+            </a:r>
+            <a:pPr indent="0" marL="0">
+              <a:buNone/>
+            </a:pPr>
+            <a:r>
               <a:rPr lang="en-US" sz="850" baseline="30000" dirty="0">
                 <a:solidFill>
+                  <a:srgbClr val="5F6B7A"/>
+                </a:solidFill>
+                <a:latin typeface="Arial" pitchFamily="34" charset="0"/>
+                <a:ea typeface="Arial" pitchFamily="34" charset="-122"/>
+                <a:cs typeface="Arial" pitchFamily="34" charset="-120"/>
+              </a:rPr>
+              <a:t>(5)</a:t>
+            </a:r>
+            <a:endParaRPr lang="en-US" sz="850" dirty="0"/>
+          </a:p>
+        </p:txBody>
+      </p:sp>
+      <p:sp>
+        <p:nvSpPr>
+          <p:cNvPr id="122" name="Text 120"/>
+          <p:cNvSpPr txBox="1"/>
+          <p:nvPr/>
+        </p:nvSpPr>
+        <p:spPr>
+          <a:xfrm>
+            <a:off x="9345168" y="3383280"/>
+            <a:ext cx="781202" cy="548640"/>
+          </a:xfrm>
+          <a:prstGeom prst="rect">
+            <a:avLst/>
+          </a:prstGeom>
+          <a:noFill/>
+          <a:ln/>
+        </p:spPr>
+        <p:txBody>
+          <a:bodyPr wrap="square" lIns="0" tIns="0" rIns="0" bIns="0" rtlCol="0" anchor="ctr"/>
+          <a:lstStyle/>
+          <a:p>
+            <a:pPr algn="ctr" indent="0" marL="0">
+              <a:buNone/>
+            </a:pPr>
+            <a:r>
+              <a:rPr lang="en-US" sz="850" dirty="0">
+                <a:solidFill>
                   <a:srgbClr val="1F2A37"/>
                 </a:solidFill>
                 <a:latin typeface="Arial" pitchFamily="34" charset="0"/>
                 <a:ea typeface="Arial" pitchFamily="34" charset="-122"/>
                 <a:cs typeface="Arial" pitchFamily="34" charset="-120"/>
               </a:rPr>
+              <a:t>Undisclosed</a:t>
+            </a:r>
+            <a:endParaRPr lang="en-US" sz="850" dirty="0"/>
+          </a:p>
+          <a:p>
+            <a:pPr algn="ctr" indent="0" marL="0">
+              <a:buNone/>
+            </a:pPr>
+            <a:r>
+              <a:rPr lang="en-US" sz="750" dirty="0">
+                <a:solidFill>
+                  <a:srgbClr val="5F6B7A"/>
+                </a:solidFill>
+                <a:latin typeface="Arial" pitchFamily="34" charset="0"/>
+                <a:ea typeface="Arial" pitchFamily="34" charset="-122"/>
+                <a:cs typeface="Arial" pitchFamily="34" charset="-120"/>
+              </a:rPr>
+              <a:t>No estimate</a:t>
+            </a:r>
+            <a:endParaRPr lang="en-US" sz="850" dirty="0"/>
+          </a:p>
+        </p:txBody>
+      </p:sp>
+      <p:sp>
+        <p:nvSpPr>
+          <p:cNvPr id="123" name="Text 121"/>
+          <p:cNvSpPr txBox="1"/>
+          <p:nvPr/>
+        </p:nvSpPr>
+        <p:spPr>
+          <a:xfrm>
+            <a:off x="10162946" y="3383280"/>
+            <a:ext cx="781202" cy="548640"/>
+          </a:xfrm>
+          <a:prstGeom prst="rect">
+            <a:avLst/>
+          </a:prstGeom>
+          <a:noFill/>
+          <a:ln/>
+        </p:spPr>
+        <p:txBody>
+          <a:bodyPr wrap="square" lIns="0" tIns="0" rIns="0" bIns="0" rtlCol="0" anchor="ctr"/>
+          <a:lstStyle/>
+          <a:p>
+            <a:pPr algn="ctr" indent="0" marL="0">
+              <a:buNone/>
+            </a:pPr>
+            <a:r>
+              <a:rPr lang="en-US" sz="850" dirty="0">
+                <a:solidFill>
+                  <a:srgbClr val="1F2A37"/>
+                </a:solidFill>
+                <a:latin typeface="Arial" pitchFamily="34" charset="0"/>
+                <a:ea typeface="Arial" pitchFamily="34" charset="-122"/>
+                <a:cs typeface="Arial" pitchFamily="34" charset="-120"/>
+              </a:rPr>
+              <a:t>Undisclosed</a:t>
+            </a:r>
+            <a:endParaRPr lang="en-US" sz="850" dirty="0"/>
+          </a:p>
+          <a:p>
+            <a:pPr algn="ctr" indent="0" marL="0">
+              <a:buNone/>
+            </a:pPr>
+            <a:r>
+              <a:rPr lang="en-US" sz="750" dirty="0">
+                <a:solidFill>
+                  <a:srgbClr val="5F6B7A"/>
+                </a:solidFill>
+                <a:latin typeface="Arial" pitchFamily="34" charset="0"/>
+                <a:ea typeface="Arial" pitchFamily="34" charset="-122"/>
+                <a:cs typeface="Arial" pitchFamily="34" charset="-120"/>
+              </a:rPr>
+              <a:t>Est. c.5–10T</a:t>
+            </a:r>
+            <a:endParaRPr lang="en-US" sz="850" dirty="0"/>
+          </a:p>
+        </p:txBody>
+      </p:sp>
+      <p:sp>
+        <p:nvSpPr>
+          <p:cNvPr id="124" name="Text 122"/>
+          <p:cNvSpPr txBox="1"/>
+          <p:nvPr/>
+        </p:nvSpPr>
+        <p:spPr>
+          <a:xfrm>
+            <a:off x="10980725" y="3383280"/>
+            <a:ext cx="781202" cy="548640"/>
+          </a:xfrm>
+          <a:prstGeom prst="rect">
+            <a:avLst/>
+          </a:prstGeom>
+          <a:noFill/>
+          <a:ln/>
+        </p:spPr>
+        <p:txBody>
+          <a:bodyPr wrap="square" lIns="0" tIns="0" rIns="0" bIns="0" rtlCol="0" anchor="ctr"/>
+          <a:lstStyle/>
+          <a:p>
+            <a:pPr algn="ctr" indent="0" marL="0">
+              <a:buNone/>
+            </a:pPr>
+            <a:r>
+              <a:rPr lang="en-US" sz="850" dirty="0">
+                <a:solidFill>
+                  <a:srgbClr val="1F2A37"/>
+                </a:solidFill>
+                <a:latin typeface="Arial" pitchFamily="34" charset="0"/>
+                <a:ea typeface="Arial" pitchFamily="34" charset="-122"/>
+                <a:cs typeface="Arial" pitchFamily="34" charset="-120"/>
+              </a:rPr>
+              <a:t>2.8T MoE</a:t>
+            </a:r>
+            <a:endParaRPr lang="en-US" sz="850" dirty="0"/>
+          </a:p>
+          <a:p>
+            <a:pPr algn="ctr" indent="0" marL="0">
+              <a:buNone/>
+            </a:pPr>
+            <a:r>
+              <a:rPr lang="en-US" sz="750" dirty="0">
+                <a:solidFill>
+                  <a:srgbClr val="5F6B7A"/>
+                </a:solidFill>
+                <a:latin typeface="Arial" pitchFamily="34" charset="0"/>
+                <a:ea typeface="Arial" pitchFamily="34" charset="-122"/>
+                <a:cs typeface="Arial" pitchFamily="34" charset="-120"/>
+              </a:rPr>
+              <a:t>104B active</a:t>
+            </a:r>
+            <a:endParaRPr lang="en-US" sz="850" dirty="0"/>
+          </a:p>
+        </p:txBody>
+      </p:sp>
+      <p:sp>
+        <p:nvSpPr>
+          <p:cNvPr id="125" name="Shape 123"/>
+          <p:cNvSpPr/>
+          <p:nvPr/>
+        </p:nvSpPr>
+        <p:spPr>
+          <a:xfrm>
+            <a:off x="8229600" y="3931920"/>
+            <a:ext cx="3550615" cy="0"/>
+          </a:xfrm>
+          <a:prstGeom prst="line">
+            <a:avLst/>
+          </a:prstGeom>
+          <a:noFill/>
+          <a:ln w="6350">
+            <a:solidFill>
+              <a:srgbClr val="E3E7EC"/>
+            </a:solidFill>
+            <a:prstDash val="solid"/>
+          </a:ln>
+        </p:spPr>
+      </p:sp>
+      <p:sp>
+        <p:nvSpPr>
+          <p:cNvPr id="126" name="Shape 124"/>
+          <p:cNvSpPr/>
+          <p:nvPr/>
+        </p:nvSpPr>
+        <p:spPr>
+          <a:xfrm>
+            <a:off x="9418320" y="3968496"/>
+            <a:ext cx="634898" cy="201168"/>
+          </a:xfrm>
+          <a:prstGeom prst="rect">
+            <a:avLst/>
+          </a:prstGeom>
+          <a:solidFill>
+            <a:srgbClr val="EAF0F7"/>
+          </a:solidFill>
+          <a:ln w="12700">
+            <a:solidFill>
+              <a:srgbClr val="EAF0F7"/>
+            </a:solidFill>
+            <a:prstDash val="solid"/>
+          </a:ln>
+        </p:spPr>
+      </p:sp>
+      <p:sp>
+        <p:nvSpPr>
+          <p:cNvPr id="127" name="Text 125"/>
+          <p:cNvSpPr txBox="1"/>
+          <p:nvPr/>
+        </p:nvSpPr>
+        <p:spPr>
+          <a:xfrm>
+            <a:off x="8229600" y="3931920"/>
+            <a:ext cx="1097280" cy="274320"/>
+          </a:xfrm>
+          <a:prstGeom prst="rect">
+            <a:avLst/>
+          </a:prstGeom>
+          <a:noFill/>
+          <a:ln/>
+        </p:spPr>
+        <p:txBody>
+          <a:bodyPr wrap="square" lIns="0" tIns="0" rIns="0" bIns="0" rtlCol="0" anchor="ctr"/>
+          <a:lstStyle/>
+          <a:p>
+            <a:pPr indent="0" marL="0">
+              <a:buNone/>
+            </a:pPr>
+            <a:r>
+              <a:rPr lang="en-US" sz="850" dirty="0">
+                <a:solidFill>
+                  <a:srgbClr val="5F6B7A"/>
+                </a:solidFill>
+                <a:latin typeface="Arial" pitchFamily="34" charset="0"/>
+                <a:ea typeface="Arial" pitchFamily="34" charset="-122"/>
+                <a:cs typeface="Arial" pitchFamily="34" charset="-120"/>
+              </a:rPr>
+              <a:t>AA Intelligence Index</a:t>
+            </a:r>
+            <a:pPr indent="0" marL="0">
+              <a:buNone/>
+            </a:pPr>
+            <a:r>
+              <a:rPr lang="en-US" sz="850" baseline="30000" dirty="0">
+                <a:solidFill>
+                  <a:srgbClr val="5F6B7A"/>
+                </a:solidFill>
+                <a:latin typeface="Arial" pitchFamily="34" charset="0"/>
+                <a:ea typeface="Arial" pitchFamily="34" charset="-122"/>
+                <a:cs typeface="Arial" pitchFamily="34" charset="-120"/>
+              </a:rPr>
               <a:t>(4)</a:t>
             </a:r>
             <a:endParaRPr lang="en-US" sz="850" dirty="0"/>
@@ -4244,37 +5487,218 @@
       </p:sp>
       <p:sp>
         <p:nvSpPr>
-          <p:cNvPr id="100" name="Shape 98"/>
-          <p:cNvSpPr/>
-          <p:nvPr/>
-        </p:nvSpPr>
-        <p:spPr>
-          <a:xfrm>
-            <a:off x="8229600" y="2404872"/>
+          <p:cNvPr id="128" name="Text 126"/>
+          <p:cNvSpPr txBox="1"/>
+          <p:nvPr/>
+        </p:nvSpPr>
+        <p:spPr>
+          <a:xfrm>
+            <a:off x="9345168" y="3931920"/>
+            <a:ext cx="781202" cy="274320"/>
+          </a:xfrm>
+          <a:prstGeom prst="rect">
+            <a:avLst/>
+          </a:prstGeom>
+          <a:noFill/>
+          <a:ln/>
+        </p:spPr>
+        <p:txBody>
+          <a:bodyPr wrap="square" lIns="0" tIns="0" rIns="0" bIns="0" rtlCol="0" anchor="ctr"/>
+          <a:lstStyle/>
+          <a:p>
+            <a:pPr algn="ctr" indent="0" marL="0">
+              <a:buNone/>
+            </a:pPr>
+            <a:r>
+              <a:rPr lang="en-US" sz="850" b="1" dirty="0">
+                <a:solidFill>
+                  <a:srgbClr val="041E42"/>
+                </a:solidFill>
+                <a:latin typeface="Arial" pitchFamily="34" charset="0"/>
+                <a:ea typeface="Arial" pitchFamily="34" charset="-122"/>
+                <a:cs typeface="Arial" pitchFamily="34" charset="-120"/>
+              </a:rPr>
+              <a:t>58</a:t>
+            </a:r>
+            <a:endParaRPr lang="en-US" sz="850" dirty="0"/>
+          </a:p>
+        </p:txBody>
+      </p:sp>
+      <p:sp>
+        <p:nvSpPr>
+          <p:cNvPr id="129" name="Text 127"/>
+          <p:cNvSpPr txBox="1"/>
+          <p:nvPr/>
+        </p:nvSpPr>
+        <p:spPr>
+          <a:xfrm>
+            <a:off x="10162946" y="3931920"/>
+            <a:ext cx="781202" cy="274320"/>
+          </a:xfrm>
+          <a:prstGeom prst="rect">
+            <a:avLst/>
+          </a:prstGeom>
+          <a:noFill/>
+          <a:ln/>
+        </p:spPr>
+        <p:txBody>
+          <a:bodyPr wrap="square" lIns="0" tIns="0" rIns="0" bIns="0" rtlCol="0" anchor="ctr"/>
+          <a:lstStyle/>
+          <a:p>
+            <a:pPr algn="ctr" indent="0" marL="0">
+              <a:buNone/>
+            </a:pPr>
+            <a:r>
+              <a:rPr lang="en-US" sz="850" dirty="0">
+                <a:solidFill>
+                  <a:srgbClr val="1F2A37"/>
+                </a:solidFill>
+                <a:latin typeface="Arial" pitchFamily="34" charset="0"/>
+                <a:ea typeface="Arial" pitchFamily="34" charset="-122"/>
+                <a:cs typeface="Arial" pitchFamily="34" charset="-120"/>
+              </a:rPr>
+              <a:t>53</a:t>
+            </a:r>
+            <a:endParaRPr lang="en-US" sz="850" dirty="0"/>
+          </a:p>
+        </p:txBody>
+      </p:sp>
+      <p:sp>
+        <p:nvSpPr>
+          <p:cNvPr id="130" name="Text 128"/>
+          <p:cNvSpPr txBox="1"/>
+          <p:nvPr/>
+        </p:nvSpPr>
+        <p:spPr>
+          <a:xfrm>
+            <a:off x="10980725" y="3931920"/>
+            <a:ext cx="781202" cy="274320"/>
+          </a:xfrm>
+          <a:prstGeom prst="rect">
+            <a:avLst/>
+          </a:prstGeom>
+          <a:noFill/>
+          <a:ln/>
+        </p:spPr>
+        <p:txBody>
+          <a:bodyPr wrap="square" lIns="0" tIns="0" rIns="0" bIns="0" rtlCol="0" anchor="ctr"/>
+          <a:lstStyle/>
+          <a:p>
+            <a:pPr algn="ctr" indent="0" marL="0">
+              <a:buNone/>
+            </a:pPr>
+            <a:r>
+              <a:rPr lang="en-US" sz="850" dirty="0">
+                <a:solidFill>
+                  <a:srgbClr val="1F2A37"/>
+                </a:solidFill>
+                <a:latin typeface="Arial" pitchFamily="34" charset="0"/>
+                <a:ea typeface="Arial" pitchFamily="34" charset="-122"/>
+                <a:cs typeface="Arial" pitchFamily="34" charset="-120"/>
+              </a:rPr>
+              <a:t>44</a:t>
+            </a:r>
+            <a:endParaRPr lang="en-US" sz="850" dirty="0"/>
+          </a:p>
+        </p:txBody>
+      </p:sp>
+      <p:sp>
+        <p:nvSpPr>
+          <p:cNvPr id="131" name="Shape 129"/>
+          <p:cNvSpPr/>
+          <p:nvPr/>
+        </p:nvSpPr>
+        <p:spPr>
+          <a:xfrm>
+            <a:off x="8229600" y="4206240"/>
             <a:ext cx="3550615" cy="0"/>
           </a:xfrm>
           <a:prstGeom prst="line">
             <a:avLst/>
           </a:prstGeom>
           <a:noFill/>
-          <a:ln w="6350">
-            <a:solidFill>
-              <a:srgbClr val="E3E7EC"/>
-            </a:solidFill>
-            <a:prstDash val="solid"/>
-          </a:ln>
-        </p:spPr>
-      </p:sp>
-      <p:sp>
-        <p:nvSpPr>
-          <p:cNvPr id="101" name="Text 99"/>
-          <p:cNvSpPr txBox="1"/>
-          <p:nvPr/>
-        </p:nvSpPr>
-        <p:spPr>
-          <a:xfrm>
-            <a:off x="8229600" y="2404872"/>
-            <a:ext cx="1097280" cy="269748"/>
+          <a:ln w="9525">
+            <a:solidFill>
+              <a:srgbClr val="041E42"/>
+            </a:solidFill>
+            <a:prstDash val="solid"/>
+          </a:ln>
+        </p:spPr>
+      </p:sp>
+      <p:sp>
+        <p:nvSpPr>
+          <p:cNvPr id="132" name="Text 130"/>
+          <p:cNvSpPr txBox="1"/>
+          <p:nvPr/>
+        </p:nvSpPr>
+        <p:spPr>
+          <a:xfrm>
+            <a:off x="8229600" y="4425696"/>
+            <a:ext cx="3550615" cy="201168"/>
+          </a:xfrm>
+          <a:prstGeom prst="rect">
+            <a:avLst/>
+          </a:prstGeom>
+          <a:noFill/>
+          <a:ln/>
+        </p:spPr>
+        <p:txBody>
+          <a:bodyPr wrap="square" lIns="0" tIns="0" rIns="0" bIns="0" rtlCol="0" anchor="t"/>
+          <a:lstStyle/>
+          <a:p>
+            <a:pPr indent="0" marL="0">
+              <a:buNone/>
+            </a:pPr>
+            <a:r>
+              <a:rPr lang="en-US" sz="1100" b="1" dirty="0">
+                <a:solidFill>
+                  <a:srgbClr val="041E42"/>
+                </a:solidFill>
+                <a:latin typeface="Arial" pitchFamily="34" charset="0"/>
+                <a:ea typeface="Arial" pitchFamily="34" charset="-122"/>
+                <a:cs typeface="Arial" pitchFamily="34" charset="-120"/>
+              </a:rPr>
+              <a:t>Recommended use</a:t>
+            </a:r>
+            <a:endParaRPr lang="en-US" sz="1100" dirty="0"/>
+          </a:p>
+        </p:txBody>
+      </p:sp>
+      <p:sp>
+        <p:nvSpPr>
+          <p:cNvPr id="133" name="Shape 131"/>
+          <p:cNvSpPr/>
+          <p:nvPr/>
+        </p:nvSpPr>
+        <p:spPr>
+          <a:xfrm>
+            <a:off x="8229600" y="4736592"/>
+            <a:ext cx="3550615" cy="1115568"/>
+          </a:xfrm>
+          <a:prstGeom prst="rect">
+            <a:avLst/>
+          </a:prstGeom>
+          <a:solidFill>
+            <a:srgbClr val="EAF0F7"/>
+          </a:solidFill>
+          <a:ln w="12700">
+            <a:solidFill>
+              <a:srgbClr val="EAF0F7"/>
+            </a:solidFill>
+            <a:prstDash val="solid"/>
+          </a:ln>
+        </p:spPr>
+      </p:sp>
+      <p:sp>
+        <p:nvSpPr>
+          <p:cNvPr id="134" name="Text 132"/>
+          <p:cNvSpPr txBox="1"/>
+          <p:nvPr/>
+        </p:nvSpPr>
+        <p:spPr>
+          <a:xfrm>
+            <a:off x="8357616" y="4864608"/>
+            <a:ext cx="658368" cy="286512"/>
           </a:xfrm>
           <a:prstGeom prst="rect">
             <a:avLst/>
@@ -4290,186 +5714,258 @@
               <a:buNone/>
             </a:pPr>
             <a:r>
+              <a:rPr lang="en-US" sz="850" b="1" dirty="0">
+                <a:solidFill>
+                  <a:srgbClr val="041E42"/>
+                </a:solidFill>
+                <a:latin typeface="Arial" pitchFamily="34" charset="0"/>
+                <a:ea typeface="Arial" pitchFamily="34" charset="-122"/>
+                <a:cs typeface="Arial" pitchFamily="34" charset="-120"/>
+              </a:rPr>
+              <a:t>Opus 5.5</a:t>
+            </a:r>
+            <a:endParaRPr lang="en-US" sz="850" dirty="0"/>
+          </a:p>
+        </p:txBody>
+      </p:sp>
+      <p:sp>
+        <p:nvSpPr>
+          <p:cNvPr id="135" name="Text 133"/>
+          <p:cNvSpPr txBox="1"/>
+          <p:nvPr/>
+        </p:nvSpPr>
+        <p:spPr>
+          <a:xfrm>
+            <a:off x="9015984" y="4864608"/>
+            <a:ext cx="2636215" cy="286512"/>
+          </a:xfrm>
+          <a:prstGeom prst="rect">
+            <a:avLst/>
+          </a:prstGeom>
+          <a:noFill/>
+          <a:ln/>
+        </p:spPr>
+        <p:txBody>
+          <a:bodyPr wrap="square" lIns="0" tIns="0" rIns="0" bIns="0" rtlCol="0" anchor="ctr"/>
+          <a:lstStyle/>
+          <a:p>
+            <a:pPr indent="0" marL="0">
+              <a:buNone/>
+            </a:pPr>
+            <a:r>
               <a:rPr lang="en-US" sz="850" dirty="0">
                 <a:solidFill>
+                  <a:srgbClr val="1F2A37"/>
+                </a:solidFill>
+                <a:latin typeface="Arial" pitchFamily="34" charset="0"/>
+                <a:ea typeface="Arial" pitchFamily="34" charset="-122"/>
+                <a:cs typeface="Arial" pitchFamily="34" charset="-120"/>
+              </a:rPr>
+              <a:t>Default for coding, agents and analyst work. List price c.60% below Astra.</a:t>
+            </a:r>
+            <a:endParaRPr lang="en-US" sz="850" dirty="0"/>
+          </a:p>
+        </p:txBody>
+      </p:sp>
+      <p:sp>
+        <p:nvSpPr>
+          <p:cNvPr id="136" name="Text 134"/>
+          <p:cNvSpPr txBox="1"/>
+          <p:nvPr/>
+        </p:nvSpPr>
+        <p:spPr>
+          <a:xfrm>
+            <a:off x="8357616" y="5151120"/>
+            <a:ext cx="658368" cy="286512"/>
+          </a:xfrm>
+          <a:prstGeom prst="rect">
+            <a:avLst/>
+          </a:prstGeom>
+          <a:noFill/>
+          <a:ln/>
+        </p:spPr>
+        <p:txBody>
+          <a:bodyPr wrap="square" lIns="0" tIns="0" rIns="0" bIns="0" rtlCol="0" anchor="ctr"/>
+          <a:lstStyle/>
+          <a:p>
+            <a:pPr indent="0" marL="0">
+              <a:buNone/>
+            </a:pPr>
+            <a:r>
+              <a:rPr lang="en-US" sz="850" b="1" dirty="0">
+                <a:solidFill>
+                  <a:srgbClr val="041E42"/>
+                </a:solidFill>
+                <a:latin typeface="Arial" pitchFamily="34" charset="0"/>
+                <a:ea typeface="Arial" pitchFamily="34" charset="-122"/>
+                <a:cs typeface="Arial" pitchFamily="34" charset="-120"/>
+              </a:rPr>
+              <a:t>Astra</a:t>
+            </a:r>
+            <a:endParaRPr lang="en-US" sz="850" dirty="0"/>
+          </a:p>
+        </p:txBody>
+      </p:sp>
+      <p:sp>
+        <p:nvSpPr>
+          <p:cNvPr id="137" name="Text 135"/>
+          <p:cNvSpPr txBox="1"/>
+          <p:nvPr/>
+        </p:nvSpPr>
+        <p:spPr>
+          <a:xfrm>
+            <a:off x="9015984" y="5151120"/>
+            <a:ext cx="2636215" cy="286512"/>
+          </a:xfrm>
+          <a:prstGeom prst="rect">
+            <a:avLst/>
+          </a:prstGeom>
+          <a:noFill/>
+          <a:ln/>
+        </p:spPr>
+        <p:txBody>
+          <a:bodyPr wrap="square" lIns="0" tIns="0" rIns="0" bIns="0" rtlCol="0" anchor="ctr"/>
+          <a:lstStyle/>
+          <a:p>
+            <a:pPr indent="0" marL="0">
+              <a:buNone/>
+            </a:pPr>
+            <a:r>
+              <a:rPr lang="en-US" sz="850" dirty="0">
+                <a:solidFill>
+                  <a:srgbClr val="1F2A37"/>
+                </a:solidFill>
+                <a:latin typeface="Arial" pitchFamily="34" charset="0"/>
+                <a:ea typeface="Arial" pitchFamily="34" charset="-122"/>
+                <a:cs typeface="Arial" pitchFamily="34" charset="-120"/>
+              </a:rPr>
+              <a:t>Computer use, 3D tools and frontier math. Staged access; OpenAI rates its cyber capability "Critical".</a:t>
+            </a:r>
+            <a:endParaRPr lang="en-US" sz="850" dirty="0"/>
+          </a:p>
+        </p:txBody>
+      </p:sp>
+      <p:sp>
+        <p:nvSpPr>
+          <p:cNvPr id="138" name="Text 136"/>
+          <p:cNvSpPr txBox="1"/>
+          <p:nvPr/>
+        </p:nvSpPr>
+        <p:spPr>
+          <a:xfrm>
+            <a:off x="8357616" y="5437632"/>
+            <a:ext cx="658368" cy="286512"/>
+          </a:xfrm>
+          <a:prstGeom prst="rect">
+            <a:avLst/>
+          </a:prstGeom>
+          <a:noFill/>
+          <a:ln/>
+        </p:spPr>
+        <p:txBody>
+          <a:bodyPr wrap="square" lIns="0" tIns="0" rIns="0" bIns="0" rtlCol="0" anchor="ctr"/>
+          <a:lstStyle/>
+          <a:p>
+            <a:pPr indent="0" marL="0">
+              <a:buNone/>
+            </a:pPr>
+            <a:r>
+              <a:rPr lang="en-US" sz="850" b="1" dirty="0">
+                <a:solidFill>
+                  <a:srgbClr val="041E42"/>
+                </a:solidFill>
+                <a:latin typeface="Arial" pitchFamily="34" charset="0"/>
+                <a:ea typeface="Arial" pitchFamily="34" charset="-122"/>
+                <a:cs typeface="Arial" pitchFamily="34" charset="-120"/>
+              </a:rPr>
+              <a:t>K3</a:t>
+            </a:r>
+            <a:endParaRPr lang="en-US" sz="850" dirty="0"/>
+          </a:p>
+        </p:txBody>
+      </p:sp>
+      <p:sp>
+        <p:nvSpPr>
+          <p:cNvPr id="139" name="Text 137"/>
+          <p:cNvSpPr txBox="1"/>
+          <p:nvPr/>
+        </p:nvSpPr>
+        <p:spPr>
+          <a:xfrm>
+            <a:off x="9015984" y="5437632"/>
+            <a:ext cx="2636215" cy="286512"/>
+          </a:xfrm>
+          <a:prstGeom prst="rect">
+            <a:avLst/>
+          </a:prstGeom>
+          <a:noFill/>
+          <a:ln/>
+        </p:spPr>
+        <p:txBody>
+          <a:bodyPr wrap="square" lIns="0" tIns="0" rIns="0" bIns="0" rtlCol="0" anchor="ctr"/>
+          <a:lstStyle/>
+          <a:p>
+            <a:pPr indent="0" marL="0">
+              <a:buNone/>
+            </a:pPr>
+            <a:r>
+              <a:rPr lang="en-US" sz="850" dirty="0">
+                <a:solidFill>
+                  <a:srgbClr val="1F2A37"/>
+                </a:solidFill>
+                <a:latin typeface="Arial" pitchFamily="34" charset="0"/>
+                <a:ea typeface="Arial" pitchFamily="34" charset="-122"/>
+                <a:cs typeface="Arial" pitchFamily="34" charset="-120"/>
+              </a:rPr>
+              <a:t>Self-hosted and high-volume work. Avoid Moonshot's own API for regulated data.</a:t>
+            </a:r>
+            <a:endParaRPr lang="en-US" sz="850" dirty="0"/>
+          </a:p>
+        </p:txBody>
+      </p:sp>
+      <p:sp>
+        <p:nvSpPr>
+          <p:cNvPr id="140" name="Text 138"/>
+          <p:cNvSpPr txBox="1"/>
+          <p:nvPr/>
+        </p:nvSpPr>
+        <p:spPr>
+          <a:xfrm>
+            <a:off x="411480" y="5961888"/>
+            <a:ext cx="11002975" cy="658368"/>
+          </a:xfrm>
+          <a:prstGeom prst="rect">
+            <a:avLst/>
+          </a:prstGeom>
+          <a:noFill/>
+          <a:ln/>
+        </p:spPr>
+        <p:txBody>
+          <a:bodyPr wrap="square" lIns="0" tIns="0" rIns="0" bIns="0" rtlCol="0" anchor="t"/>
+          <a:lstStyle/>
+          <a:p>
+            <a:pPr indent="0" marL="0">
+              <a:buNone/>
+            </a:pPr>
+            <a:r>
+              <a:rPr lang="en-US" sz="700" dirty="0">
+                <a:solidFill>
                   <a:srgbClr val="5F6B7A"/>
                 </a:solidFill>
                 <a:latin typeface="Arial" pitchFamily="34" charset="0"/>
                 <a:ea typeface="Arial" pitchFamily="34" charset="-122"/>
                 <a:cs typeface="Arial" pitchFamily="34" charset="-120"/>
               </a:rPr>
-              <a:t>Input ($ / 1M tokens)</a:t>
-            </a:r>
-            <a:endParaRPr lang="en-US" sz="850" dirty="0"/>
-          </a:p>
-        </p:txBody>
-      </p:sp>
-      <p:sp>
-        <p:nvSpPr>
-          <p:cNvPr id="102" name="Text 100"/>
-          <p:cNvSpPr txBox="1"/>
-          <p:nvPr/>
-        </p:nvSpPr>
-        <p:spPr>
-          <a:xfrm>
-            <a:off x="9345168" y="2404872"/>
-            <a:ext cx="781202" cy="269748"/>
-          </a:xfrm>
-          <a:prstGeom prst="rect">
-            <a:avLst/>
-          </a:prstGeom>
-          <a:noFill/>
-          <a:ln/>
-        </p:spPr>
-        <p:txBody>
-          <a:bodyPr wrap="square" lIns="0" tIns="0" rIns="0" bIns="0" rtlCol="0" anchor="ctr"/>
-          <a:lstStyle/>
-          <a:p>
-            <a:pPr algn="ctr" indent="0" marL="0">
-              <a:buNone/>
-            </a:pPr>
-            <a:r>
-              <a:rPr lang="en-US" sz="850" dirty="0">
-                <a:solidFill>
-                  <a:srgbClr val="1F2A37"/>
-                </a:solidFill>
-                <a:latin typeface="Arial" pitchFamily="34" charset="0"/>
-                <a:ea typeface="Arial" pitchFamily="34" charset="-122"/>
-                <a:cs typeface="Arial" pitchFamily="34" charset="-120"/>
-              </a:rPr>
-              <a:t>$4.00</a:t>
-            </a:r>
-            <a:endParaRPr lang="en-US" sz="850" dirty="0"/>
-          </a:p>
-        </p:txBody>
-      </p:sp>
-      <p:sp>
-        <p:nvSpPr>
-          <p:cNvPr id="103" name="Text 101"/>
-          <p:cNvSpPr txBox="1"/>
-          <p:nvPr/>
-        </p:nvSpPr>
-        <p:spPr>
-          <a:xfrm>
-            <a:off x="10162946" y="2404872"/>
-            <a:ext cx="781202" cy="269748"/>
-          </a:xfrm>
-          <a:prstGeom prst="rect">
-            <a:avLst/>
-          </a:prstGeom>
-          <a:noFill/>
-          <a:ln/>
-        </p:spPr>
-        <p:txBody>
-          <a:bodyPr wrap="square" lIns="0" tIns="0" rIns="0" bIns="0" rtlCol="0" anchor="ctr"/>
-          <a:lstStyle/>
-          <a:p>
-            <a:pPr algn="ctr" indent="0" marL="0">
-              <a:buNone/>
-            </a:pPr>
-            <a:r>
-              <a:rPr lang="en-US" sz="850" dirty="0">
-                <a:solidFill>
-                  <a:srgbClr val="1F2A37"/>
-                </a:solidFill>
-                <a:latin typeface="Arial" pitchFamily="34" charset="0"/>
-                <a:ea typeface="Arial" pitchFamily="34" charset="-122"/>
-                <a:cs typeface="Arial" pitchFamily="34" charset="-120"/>
-              </a:rPr>
-              <a:t>$10.00</a:t>
-            </a:r>
-            <a:endParaRPr lang="en-US" sz="850" dirty="0"/>
-          </a:p>
-        </p:txBody>
-      </p:sp>
-      <p:sp>
-        <p:nvSpPr>
-          <p:cNvPr id="104" name="Text 102"/>
-          <p:cNvSpPr txBox="1"/>
-          <p:nvPr/>
-        </p:nvSpPr>
-        <p:spPr>
-          <a:xfrm>
-            <a:off x="10980725" y="2404872"/>
-            <a:ext cx="781202" cy="269748"/>
-          </a:xfrm>
-          <a:prstGeom prst="rect">
-            <a:avLst/>
-          </a:prstGeom>
-          <a:noFill/>
-          <a:ln/>
-        </p:spPr>
-        <p:txBody>
-          <a:bodyPr wrap="square" lIns="0" tIns="0" rIns="0" bIns="0" rtlCol="0" anchor="ctr"/>
-          <a:lstStyle/>
-          <a:p>
-            <a:pPr algn="ctr" indent="0" marL="0">
-              <a:buNone/>
-            </a:pPr>
-            <a:r>
-              <a:rPr lang="en-US" sz="850" dirty="0">
-                <a:solidFill>
-                  <a:srgbClr val="1F2A37"/>
-                </a:solidFill>
-                <a:latin typeface="Arial" pitchFamily="34" charset="0"/>
-                <a:ea typeface="Arial" pitchFamily="34" charset="-122"/>
-                <a:cs typeface="Arial" pitchFamily="34" charset="-120"/>
-              </a:rPr>
-              <a:t>$3.00</a:t>
-            </a:r>
-            <a:endParaRPr lang="en-US" sz="850" dirty="0"/>
-          </a:p>
-        </p:txBody>
-      </p:sp>
-      <p:sp>
-        <p:nvSpPr>
-          <p:cNvPr id="105" name="Shape 103"/>
-          <p:cNvSpPr/>
-          <p:nvPr/>
-        </p:nvSpPr>
-        <p:spPr>
-          <a:xfrm>
-            <a:off x="8229600" y="2674620"/>
-            <a:ext cx="3550615" cy="0"/>
-          </a:xfrm>
-          <a:prstGeom prst="line">
-            <a:avLst/>
-          </a:prstGeom>
-          <a:noFill/>
-          <a:ln w="6350">
-            <a:solidFill>
-              <a:srgbClr val="E3E7EC"/>
-            </a:solidFill>
-            <a:prstDash val="solid"/>
-          </a:ln>
-        </p:spPr>
-      </p:sp>
-      <p:sp>
-        <p:nvSpPr>
-          <p:cNvPr id="106" name="Text 104"/>
-          <p:cNvSpPr txBox="1"/>
-          <p:nvPr/>
-        </p:nvSpPr>
-        <p:spPr>
-          <a:xfrm>
-            <a:off x="8229600" y="2674620"/>
-            <a:ext cx="1097280" cy="269748"/>
-          </a:xfrm>
-          <a:prstGeom prst="rect">
-            <a:avLst/>
-          </a:prstGeom>
-          <a:noFill/>
-          <a:ln/>
-        </p:spPr>
-        <p:txBody>
-          <a:bodyPr wrap="square" lIns="0" tIns="0" rIns="0" bIns="0" rtlCol="0" anchor="ctr"/>
-          <a:lstStyle/>
-          <a:p>
-            <a:pPr indent="0" marL="0">
-              <a:buNone/>
-            </a:pPr>
-            <a:r>
-              <a:rPr lang="en-US" sz="850" dirty="0">
+              <a:t>Note: Ratings are analyst judgment based on the data shown; scores reported by different vendors are not always like-for-like. Shading marks the leader in each row. Prices are list API rates.</a:t>
+            </a:r>
+            <a:endParaRPr lang="en-US" sz="700" dirty="0"/>
+          </a:p>
+          <a:p>
+            <a:pPr indent="0" marL="0">
+              <a:buNone/>
+            </a:pPr>
+            <a:r>
+              <a:rPr lang="en-US" sz="700" baseline="30000" dirty="0">
                 <a:solidFill>
                   <a:srgbClr val="5F6B7A"/>
                 </a:solidFill>
@@ -4477,178 +5973,13 @@
                 <a:ea typeface="Arial" pitchFamily="34" charset="-122"/>
                 <a:cs typeface="Arial" pitchFamily="34" charset="-120"/>
               </a:rPr>
-              <a:t>Output ($ / 1M tokens)</a:t>
-            </a:r>
-            <a:endParaRPr lang="en-US" sz="850" dirty="0"/>
-          </a:p>
-        </p:txBody>
-      </p:sp>
-      <p:sp>
-        <p:nvSpPr>
-          <p:cNvPr id="107" name="Text 105"/>
-          <p:cNvSpPr txBox="1"/>
-          <p:nvPr/>
-        </p:nvSpPr>
-        <p:spPr>
-          <a:xfrm>
-            <a:off x="9345168" y="2674620"/>
-            <a:ext cx="781202" cy="269748"/>
-          </a:xfrm>
-          <a:prstGeom prst="rect">
-            <a:avLst/>
-          </a:prstGeom>
-          <a:noFill/>
-          <a:ln/>
-        </p:spPr>
-        <p:txBody>
-          <a:bodyPr wrap="square" lIns="0" tIns="0" rIns="0" bIns="0" rtlCol="0" anchor="ctr"/>
-          <a:lstStyle/>
-          <a:p>
-            <a:pPr algn="ctr" indent="0" marL="0">
-              <a:buNone/>
-            </a:pPr>
-            <a:r>
-              <a:rPr lang="en-US" sz="850" dirty="0">
-                <a:solidFill>
-                  <a:srgbClr val="1F2A37"/>
-                </a:solidFill>
-                <a:latin typeface="Arial" pitchFamily="34" charset="0"/>
-                <a:ea typeface="Arial" pitchFamily="34" charset="-122"/>
-                <a:cs typeface="Arial" pitchFamily="34" charset="-120"/>
-              </a:rPr>
-              <a:t>$20.00</a:t>
-            </a:r>
-            <a:endParaRPr lang="en-US" sz="850" dirty="0"/>
-          </a:p>
-        </p:txBody>
-      </p:sp>
-      <p:sp>
-        <p:nvSpPr>
-          <p:cNvPr id="108" name="Text 106"/>
-          <p:cNvSpPr txBox="1"/>
-          <p:nvPr/>
-        </p:nvSpPr>
-        <p:spPr>
-          <a:xfrm>
-            <a:off x="10162946" y="2674620"/>
-            <a:ext cx="781202" cy="269748"/>
-          </a:xfrm>
-          <a:prstGeom prst="rect">
-            <a:avLst/>
-          </a:prstGeom>
-          <a:noFill/>
-          <a:ln/>
-        </p:spPr>
-        <p:txBody>
-          <a:bodyPr wrap="square" lIns="0" tIns="0" rIns="0" bIns="0" rtlCol="0" anchor="ctr"/>
-          <a:lstStyle/>
-          <a:p>
-            <a:pPr algn="ctr" indent="0" marL="0">
-              <a:buNone/>
-            </a:pPr>
-            <a:r>
-              <a:rPr lang="en-US" sz="850" dirty="0">
-                <a:solidFill>
-                  <a:srgbClr val="1F2A37"/>
-                </a:solidFill>
-                <a:latin typeface="Arial" pitchFamily="34" charset="0"/>
-                <a:ea typeface="Arial" pitchFamily="34" charset="-122"/>
-                <a:cs typeface="Arial" pitchFamily="34" charset="-120"/>
-              </a:rPr>
-              <a:t>$50.00</a:t>
-            </a:r>
-            <a:endParaRPr lang="en-US" sz="850" dirty="0"/>
-          </a:p>
-        </p:txBody>
-      </p:sp>
-      <p:sp>
-        <p:nvSpPr>
-          <p:cNvPr id="109" name="Text 107"/>
-          <p:cNvSpPr txBox="1"/>
-          <p:nvPr/>
-        </p:nvSpPr>
-        <p:spPr>
-          <a:xfrm>
-            <a:off x="10980725" y="2674620"/>
-            <a:ext cx="781202" cy="269748"/>
-          </a:xfrm>
-          <a:prstGeom prst="rect">
-            <a:avLst/>
-          </a:prstGeom>
-          <a:noFill/>
-          <a:ln/>
-        </p:spPr>
-        <p:txBody>
-          <a:bodyPr wrap="square" lIns="0" tIns="0" rIns="0" bIns="0" rtlCol="0" anchor="ctr"/>
-          <a:lstStyle/>
-          <a:p>
-            <a:pPr algn="ctr" indent="0" marL="0">
-              <a:buNone/>
-            </a:pPr>
-            <a:r>
-              <a:rPr lang="en-US" sz="850" dirty="0">
-                <a:solidFill>
-                  <a:srgbClr val="1F2A37"/>
-                </a:solidFill>
-                <a:latin typeface="Arial" pitchFamily="34" charset="0"/>
-                <a:ea typeface="Arial" pitchFamily="34" charset="-122"/>
-                <a:cs typeface="Arial" pitchFamily="34" charset="-120"/>
-              </a:rPr>
-              <a:t>$15.00</a:t>
-            </a:r>
-            <a:endParaRPr lang="en-US" sz="850" dirty="0"/>
-          </a:p>
-        </p:txBody>
-      </p:sp>
-      <p:sp>
-        <p:nvSpPr>
-          <p:cNvPr id="110" name="Shape 108"/>
-          <p:cNvSpPr/>
-          <p:nvPr/>
-        </p:nvSpPr>
-        <p:spPr>
-          <a:xfrm>
-            <a:off x="8229600" y="2944368"/>
-            <a:ext cx="3550615" cy="0"/>
-          </a:xfrm>
-          <a:prstGeom prst="line">
-            <a:avLst/>
-          </a:prstGeom>
-          <a:noFill/>
-          <a:ln w="6350">
-            <a:solidFill>
-              <a:srgbClr val="E3E7EC"/>
-            </a:solidFill>
-            <a:prstDash val="solid"/>
-          </a:ln>
-        </p:spPr>
-      </p:sp>
-      <p:sp>
-        <p:nvSpPr>
-          <p:cNvPr id="111" name="Text 109"/>
-          <p:cNvSpPr txBox="1"/>
-          <p:nvPr/>
-        </p:nvSpPr>
-        <p:spPr>
-          <a:xfrm>
-            <a:off x="8229600" y="2944368"/>
-            <a:ext cx="1097280" cy="269748"/>
-          </a:xfrm>
-          <a:prstGeom prst="rect">
-            <a:avLst/>
-          </a:prstGeom>
-          <a:noFill/>
-          <a:ln/>
-        </p:spPr>
-        <p:txBody>
-          <a:bodyPr wrap="square" lIns="0" tIns="0" rIns="0" bIns="0" rtlCol="0" anchor="ctr"/>
-          <a:lstStyle/>
-          <a:p>
-            <a:pPr indent="0" marL="0">
-              <a:buNone/>
-            </a:pPr>
-            <a:r>
-              <a:rPr lang="en-US" sz="850" dirty="0">
+              <a:t>(1)</a:t>
+            </a:r>
+            <a:pPr indent="0" marL="0">
+              <a:buNone/>
+            </a:pPr>
+            <a:r>
+              <a:rPr lang="en-US" sz="700" dirty="0">
                 <a:solidFill>
                   <a:srgbClr val="5F6B7A"/>
                 </a:solidFill>
@@ -4656,178 +5987,13 @@
                 <a:ea typeface="Arial" pitchFamily="34" charset="-122"/>
                 <a:cs typeface="Arial" pitchFamily="34" charset="-120"/>
               </a:rPr>
-              <a:t>Cached input ($ / 1M)</a:t>
-            </a:r>
-            <a:endParaRPr lang="en-US" sz="850" dirty="0"/>
-          </a:p>
-        </p:txBody>
-      </p:sp>
-      <p:sp>
-        <p:nvSpPr>
-          <p:cNvPr id="112" name="Text 110"/>
-          <p:cNvSpPr txBox="1"/>
-          <p:nvPr/>
-        </p:nvSpPr>
-        <p:spPr>
-          <a:xfrm>
-            <a:off x="9345168" y="2944368"/>
-            <a:ext cx="781202" cy="269748"/>
-          </a:xfrm>
-          <a:prstGeom prst="rect">
-            <a:avLst/>
-          </a:prstGeom>
-          <a:noFill/>
-          <a:ln/>
-        </p:spPr>
-        <p:txBody>
-          <a:bodyPr wrap="square" lIns="0" tIns="0" rIns="0" bIns="0" rtlCol="0" anchor="ctr"/>
-          <a:lstStyle/>
-          <a:p>
-            <a:pPr algn="ctr" indent="0" marL="0">
-              <a:buNone/>
-            </a:pPr>
-            <a:r>
-              <a:rPr lang="en-US" sz="850" dirty="0">
-                <a:solidFill>
-                  <a:srgbClr val="1F2A37"/>
-                </a:solidFill>
-                <a:latin typeface="Arial" pitchFamily="34" charset="0"/>
-                <a:ea typeface="Arial" pitchFamily="34" charset="-122"/>
-                <a:cs typeface="Arial" pitchFamily="34" charset="-120"/>
-              </a:rPr>
-              <a:t>$0.20</a:t>
-            </a:r>
-            <a:endParaRPr lang="en-US" sz="850" dirty="0"/>
-          </a:p>
-        </p:txBody>
-      </p:sp>
-      <p:sp>
-        <p:nvSpPr>
-          <p:cNvPr id="113" name="Text 111"/>
-          <p:cNvSpPr txBox="1"/>
-          <p:nvPr/>
-        </p:nvSpPr>
-        <p:spPr>
-          <a:xfrm>
-            <a:off x="10162946" y="2944368"/>
-            <a:ext cx="781202" cy="269748"/>
-          </a:xfrm>
-          <a:prstGeom prst="rect">
-            <a:avLst/>
-          </a:prstGeom>
-          <a:noFill/>
-          <a:ln/>
-        </p:spPr>
-        <p:txBody>
-          <a:bodyPr wrap="square" lIns="0" tIns="0" rIns="0" bIns="0" rtlCol="0" anchor="ctr"/>
-          <a:lstStyle/>
-          <a:p>
-            <a:pPr algn="ctr" indent="0" marL="0">
-              <a:buNone/>
-            </a:pPr>
-            <a:r>
-              <a:rPr lang="en-US" sz="850" dirty="0">
-                <a:solidFill>
-                  <a:srgbClr val="1F2A37"/>
-                </a:solidFill>
-                <a:latin typeface="Arial" pitchFamily="34" charset="0"/>
-                <a:ea typeface="Arial" pitchFamily="34" charset="-122"/>
-                <a:cs typeface="Arial" pitchFamily="34" charset="-120"/>
-              </a:rPr>
-              <a:t>$1.00</a:t>
-            </a:r>
-            <a:endParaRPr lang="en-US" sz="850" dirty="0"/>
-          </a:p>
-        </p:txBody>
-      </p:sp>
-      <p:sp>
-        <p:nvSpPr>
-          <p:cNvPr id="114" name="Text 112"/>
-          <p:cNvSpPr txBox="1"/>
-          <p:nvPr/>
-        </p:nvSpPr>
-        <p:spPr>
-          <a:xfrm>
-            <a:off x="10980725" y="2944368"/>
-            <a:ext cx="781202" cy="269748"/>
-          </a:xfrm>
-          <a:prstGeom prst="rect">
-            <a:avLst/>
-          </a:prstGeom>
-          <a:noFill/>
-          <a:ln/>
-        </p:spPr>
-        <p:txBody>
-          <a:bodyPr wrap="square" lIns="0" tIns="0" rIns="0" bIns="0" rtlCol="0" anchor="ctr"/>
-          <a:lstStyle/>
-          <a:p>
-            <a:pPr algn="ctr" indent="0" marL="0">
-              <a:buNone/>
-            </a:pPr>
-            <a:r>
-              <a:rPr lang="en-US" sz="850" dirty="0">
-                <a:solidFill>
-                  <a:srgbClr val="1F2A37"/>
-                </a:solidFill>
-                <a:latin typeface="Arial" pitchFamily="34" charset="0"/>
-                <a:ea typeface="Arial" pitchFamily="34" charset="-122"/>
-                <a:cs typeface="Arial" pitchFamily="34" charset="-120"/>
-              </a:rPr>
-              <a:t>$0.30</a:t>
-            </a:r>
-            <a:endParaRPr lang="en-US" sz="850" dirty="0"/>
-          </a:p>
-        </p:txBody>
-      </p:sp>
-      <p:sp>
-        <p:nvSpPr>
-          <p:cNvPr id="115" name="Shape 113"/>
-          <p:cNvSpPr/>
-          <p:nvPr/>
-        </p:nvSpPr>
-        <p:spPr>
-          <a:xfrm>
-            <a:off x="8229600" y="3214116"/>
-            <a:ext cx="3550615" cy="0"/>
-          </a:xfrm>
-          <a:prstGeom prst="line">
-            <a:avLst/>
-          </a:prstGeom>
-          <a:noFill/>
-          <a:ln w="6350">
-            <a:solidFill>
-              <a:srgbClr val="E3E7EC"/>
-            </a:solidFill>
-            <a:prstDash val="solid"/>
-          </a:ln>
-        </p:spPr>
-      </p:sp>
-      <p:sp>
-        <p:nvSpPr>
-          <p:cNvPr id="116" name="Text 114"/>
-          <p:cNvSpPr txBox="1"/>
-          <p:nvPr/>
-        </p:nvSpPr>
-        <p:spPr>
-          <a:xfrm>
-            <a:off x="8229600" y="3214116"/>
-            <a:ext cx="1097280" cy="269748"/>
-          </a:xfrm>
-          <a:prstGeom prst="rect">
-            <a:avLst/>
-          </a:prstGeom>
-          <a:noFill/>
-          <a:ln/>
-        </p:spPr>
-        <p:txBody>
-          <a:bodyPr wrap="square" lIns="0" tIns="0" rIns="0" bIns="0" rtlCol="0" anchor="ctr"/>
-          <a:lstStyle/>
-          <a:p>
-            <a:pPr indent="0" marL="0">
-              <a:buNone/>
-            </a:pPr>
-            <a:r>
-              <a:rPr lang="en-US" sz="850" dirty="0">
+              <a:t> Opus 5.5 vs. Astra figures as reported by Anthropic (22 Sep 2026); not independently replicated.  </a:t>
+            </a:r>
+            <a:pPr indent="0" marL="0">
+              <a:buNone/>
+            </a:pPr>
+            <a:r>
+              <a:rPr lang="en-US" sz="700" baseline="30000" dirty="0">
                 <a:solidFill>
                   <a:srgbClr val="5F6B7A"/>
                 </a:solidFill>
@@ -4835,178 +6001,13 @@
                 <a:ea typeface="Arial" pitchFamily="34" charset="-122"/>
                 <a:cs typeface="Arial" pitchFamily="34" charset="-120"/>
               </a:rPr>
-              <a:t>Context (tokens)</a:t>
-            </a:r>
-            <a:endParaRPr lang="en-US" sz="850" dirty="0"/>
-          </a:p>
-        </p:txBody>
-      </p:sp>
-      <p:sp>
-        <p:nvSpPr>
-          <p:cNvPr id="117" name="Text 115"/>
-          <p:cNvSpPr txBox="1"/>
-          <p:nvPr/>
-        </p:nvSpPr>
-        <p:spPr>
-          <a:xfrm>
-            <a:off x="9345168" y="3214116"/>
-            <a:ext cx="781202" cy="269748"/>
-          </a:xfrm>
-          <a:prstGeom prst="rect">
-            <a:avLst/>
-          </a:prstGeom>
-          <a:noFill/>
-          <a:ln/>
-        </p:spPr>
-        <p:txBody>
-          <a:bodyPr wrap="square" lIns="0" tIns="0" rIns="0" bIns="0" rtlCol="0" anchor="ctr"/>
-          <a:lstStyle/>
-          <a:p>
-            <a:pPr algn="ctr" indent="0" marL="0">
-              <a:buNone/>
-            </a:pPr>
-            <a:r>
-              <a:rPr lang="en-US" sz="850" dirty="0">
-                <a:solidFill>
-                  <a:srgbClr val="1F2A37"/>
-                </a:solidFill>
-                <a:latin typeface="Arial" pitchFamily="34" charset="0"/>
-                <a:ea typeface="Arial" pitchFamily="34" charset="-122"/>
-                <a:cs typeface="Arial" pitchFamily="34" charset="-120"/>
-              </a:rPr>
-              <a:t>1.0M</a:t>
-            </a:r>
-            <a:endParaRPr lang="en-US" sz="850" dirty="0"/>
-          </a:p>
-        </p:txBody>
-      </p:sp>
-      <p:sp>
-        <p:nvSpPr>
-          <p:cNvPr id="118" name="Text 116"/>
-          <p:cNvSpPr txBox="1"/>
-          <p:nvPr/>
-        </p:nvSpPr>
-        <p:spPr>
-          <a:xfrm>
-            <a:off x="10162946" y="3214116"/>
-            <a:ext cx="781202" cy="269748"/>
-          </a:xfrm>
-          <a:prstGeom prst="rect">
-            <a:avLst/>
-          </a:prstGeom>
-          <a:noFill/>
-          <a:ln/>
-        </p:spPr>
-        <p:txBody>
-          <a:bodyPr wrap="square" lIns="0" tIns="0" rIns="0" bIns="0" rtlCol="0" anchor="ctr"/>
-          <a:lstStyle/>
-          <a:p>
-            <a:pPr algn="ctr" indent="0" marL="0">
-              <a:buNone/>
-            </a:pPr>
-            <a:r>
-              <a:rPr lang="en-US" sz="850" dirty="0">
-                <a:solidFill>
-                  <a:srgbClr val="1F2A37"/>
-                </a:solidFill>
-                <a:latin typeface="Arial" pitchFamily="34" charset="0"/>
-                <a:ea typeface="Arial" pitchFamily="34" charset="-122"/>
-                <a:cs typeface="Arial" pitchFamily="34" charset="-120"/>
-              </a:rPr>
-              <a:t>1.05M</a:t>
-            </a:r>
-            <a:endParaRPr lang="en-US" sz="850" dirty="0"/>
-          </a:p>
-        </p:txBody>
-      </p:sp>
-      <p:sp>
-        <p:nvSpPr>
-          <p:cNvPr id="119" name="Text 117"/>
-          <p:cNvSpPr txBox="1"/>
-          <p:nvPr/>
-        </p:nvSpPr>
-        <p:spPr>
-          <a:xfrm>
-            <a:off x="10980725" y="3214116"/>
-            <a:ext cx="781202" cy="269748"/>
-          </a:xfrm>
-          <a:prstGeom prst="rect">
-            <a:avLst/>
-          </a:prstGeom>
-          <a:noFill/>
-          <a:ln/>
-        </p:spPr>
-        <p:txBody>
-          <a:bodyPr wrap="square" lIns="0" tIns="0" rIns="0" bIns="0" rtlCol="0" anchor="ctr"/>
-          <a:lstStyle/>
-          <a:p>
-            <a:pPr algn="ctr" indent="0" marL="0">
-              <a:buNone/>
-            </a:pPr>
-            <a:r>
-              <a:rPr lang="en-US" sz="850" dirty="0">
-                <a:solidFill>
-                  <a:srgbClr val="1F2A37"/>
-                </a:solidFill>
-                <a:latin typeface="Arial" pitchFamily="34" charset="0"/>
-                <a:ea typeface="Arial" pitchFamily="34" charset="-122"/>
-                <a:cs typeface="Arial" pitchFamily="34" charset="-120"/>
-              </a:rPr>
-              <a:t>1.0M</a:t>
-            </a:r>
-            <a:endParaRPr lang="en-US" sz="850" dirty="0"/>
-          </a:p>
-        </p:txBody>
-      </p:sp>
-      <p:sp>
-        <p:nvSpPr>
-          <p:cNvPr id="120" name="Shape 118"/>
-          <p:cNvSpPr/>
-          <p:nvPr/>
-        </p:nvSpPr>
-        <p:spPr>
-          <a:xfrm>
-            <a:off x="8229600" y="3483864"/>
-            <a:ext cx="3550615" cy="0"/>
-          </a:xfrm>
-          <a:prstGeom prst="line">
-            <a:avLst/>
-          </a:prstGeom>
-          <a:noFill/>
-          <a:ln w="6350">
-            <a:solidFill>
-              <a:srgbClr val="E3E7EC"/>
-            </a:solidFill>
-            <a:prstDash val="solid"/>
-          </a:ln>
-        </p:spPr>
-      </p:sp>
-      <p:sp>
-        <p:nvSpPr>
-          <p:cNvPr id="121" name="Text 119"/>
-          <p:cNvSpPr txBox="1"/>
-          <p:nvPr/>
-        </p:nvSpPr>
-        <p:spPr>
-          <a:xfrm>
-            <a:off x="8229600" y="3483864"/>
-            <a:ext cx="1097280" cy="269748"/>
-          </a:xfrm>
-          <a:prstGeom prst="rect">
-            <a:avLst/>
-          </a:prstGeom>
-          <a:noFill/>
-          <a:ln/>
-        </p:spPr>
-        <p:txBody>
-          <a:bodyPr wrap="square" lIns="0" tIns="0" rIns="0" bIns="0" rtlCol="0" anchor="ctr"/>
-          <a:lstStyle/>
-          <a:p>
-            <a:pPr indent="0" marL="0">
-              <a:buNone/>
-            </a:pPr>
-            <a:r>
-              <a:rPr lang="en-US" sz="850" dirty="0">
+              <a:t>(2)</a:t>
+            </a:r>
+            <a:pPr indent="0" marL="0">
+              <a:buNone/>
+            </a:pPr>
+            <a:r>
+              <a:rPr lang="en-US" sz="700" dirty="0">
                 <a:solidFill>
                   <a:srgbClr val="5F6B7A"/>
                 </a:solidFill>
@@ -5014,178 +6015,19 @@
                 <a:ea typeface="Arial" pitchFamily="34" charset="-122"/>
                 <a:cs typeface="Arial" pitchFamily="34" charset="-120"/>
               </a:rPr>
-              <a:t>Parameters</a:t>
-            </a:r>
-            <a:endParaRPr lang="en-US" sz="850" dirty="0"/>
-          </a:p>
-        </p:txBody>
-      </p:sp>
-      <p:sp>
-        <p:nvSpPr>
-          <p:cNvPr id="122" name="Text 120"/>
-          <p:cNvSpPr txBox="1"/>
-          <p:nvPr/>
-        </p:nvSpPr>
-        <p:spPr>
-          <a:xfrm>
-            <a:off x="9345168" y="3483864"/>
-            <a:ext cx="781202" cy="269748"/>
-          </a:xfrm>
-          <a:prstGeom prst="rect">
-            <a:avLst/>
-          </a:prstGeom>
-          <a:noFill/>
-          <a:ln/>
-        </p:spPr>
-        <p:txBody>
-          <a:bodyPr wrap="square" lIns="0" tIns="0" rIns="0" bIns="0" rtlCol="0" anchor="ctr"/>
-          <a:lstStyle/>
-          <a:p>
-            <a:pPr algn="ctr" indent="0" marL="0">
-              <a:buNone/>
-            </a:pPr>
-            <a:r>
-              <a:rPr lang="en-US" sz="850" dirty="0">
-                <a:solidFill>
-                  <a:srgbClr val="1F2A37"/>
-                </a:solidFill>
-                <a:latin typeface="Arial" pitchFamily="34" charset="0"/>
-                <a:ea typeface="Arial" pitchFamily="34" charset="-122"/>
-                <a:cs typeface="Arial" pitchFamily="34" charset="-120"/>
-              </a:rPr>
-              <a:t>n/a</a:t>
-            </a:r>
-            <a:endParaRPr lang="en-US" sz="850" dirty="0"/>
-          </a:p>
-        </p:txBody>
-      </p:sp>
-      <p:sp>
-        <p:nvSpPr>
-          <p:cNvPr id="123" name="Text 121"/>
-          <p:cNvSpPr txBox="1"/>
-          <p:nvPr/>
-        </p:nvSpPr>
-        <p:spPr>
-          <a:xfrm>
-            <a:off x="10162946" y="3483864"/>
-            <a:ext cx="781202" cy="269748"/>
-          </a:xfrm>
-          <a:prstGeom prst="rect">
-            <a:avLst/>
-          </a:prstGeom>
-          <a:noFill/>
-          <a:ln/>
-        </p:spPr>
-        <p:txBody>
-          <a:bodyPr wrap="square" lIns="0" tIns="0" rIns="0" bIns="0" rtlCol="0" anchor="ctr"/>
-          <a:lstStyle/>
-          <a:p>
-            <a:pPr algn="ctr" indent="0" marL="0">
-              <a:buNone/>
-            </a:pPr>
-            <a:r>
-              <a:rPr lang="en-US" sz="850" dirty="0">
-                <a:solidFill>
-                  <a:srgbClr val="1F2A37"/>
-                </a:solidFill>
-                <a:latin typeface="Arial" pitchFamily="34" charset="0"/>
-                <a:ea typeface="Arial" pitchFamily="34" charset="-122"/>
-                <a:cs typeface="Arial" pitchFamily="34" charset="-120"/>
-              </a:rPr>
-              <a:t>n/a</a:t>
-            </a:r>
-            <a:endParaRPr lang="en-US" sz="850" dirty="0"/>
-          </a:p>
-        </p:txBody>
-      </p:sp>
-      <p:sp>
-        <p:nvSpPr>
-          <p:cNvPr id="124" name="Text 122"/>
-          <p:cNvSpPr txBox="1"/>
-          <p:nvPr/>
-        </p:nvSpPr>
-        <p:spPr>
-          <a:xfrm>
-            <a:off x="10980725" y="3483864"/>
-            <a:ext cx="781202" cy="269748"/>
-          </a:xfrm>
-          <a:prstGeom prst="rect">
-            <a:avLst/>
-          </a:prstGeom>
-          <a:noFill/>
-          <a:ln/>
-        </p:spPr>
-        <p:txBody>
-          <a:bodyPr wrap="square" lIns="0" tIns="0" rIns="0" bIns="0" rtlCol="0" anchor="ctr"/>
-          <a:lstStyle/>
-          <a:p>
-            <a:pPr algn="ctr" indent="0" marL="0">
-              <a:buNone/>
-            </a:pPr>
-            <a:r>
-              <a:rPr lang="en-US" sz="850" dirty="0">
-                <a:solidFill>
-                  <a:srgbClr val="1F2A37"/>
-                </a:solidFill>
-                <a:latin typeface="Arial" pitchFamily="34" charset="0"/>
-                <a:ea typeface="Arial" pitchFamily="34" charset="-122"/>
-                <a:cs typeface="Arial" pitchFamily="34" charset="-120"/>
-              </a:rPr>
-              <a:t>2.8T MoE</a:t>
-            </a:r>
-            <a:endParaRPr lang="en-US" sz="850" dirty="0"/>
-          </a:p>
-        </p:txBody>
-      </p:sp>
-      <p:sp>
-        <p:nvSpPr>
-          <p:cNvPr id="125" name="Shape 123"/>
-          <p:cNvSpPr/>
-          <p:nvPr/>
-        </p:nvSpPr>
-        <p:spPr>
-          <a:xfrm>
-            <a:off x="8229600" y="3753612"/>
-            <a:ext cx="3550615" cy="0"/>
-          </a:xfrm>
-          <a:prstGeom prst="line">
-            <a:avLst/>
-          </a:prstGeom>
-          <a:noFill/>
-          <a:ln w="6350">
-            <a:solidFill>
-              <a:srgbClr val="E3E7EC"/>
-            </a:solidFill>
-            <a:prstDash val="solid"/>
-          </a:ln>
-        </p:spPr>
-      </p:sp>
-      <p:sp>
-        <p:nvSpPr>
-          <p:cNvPr id="126" name="Text 124"/>
-          <p:cNvSpPr txBox="1"/>
-          <p:nvPr/>
-        </p:nvSpPr>
-        <p:spPr>
-          <a:xfrm>
-            <a:off x="8229600" y="3753612"/>
-            <a:ext cx="1097280" cy="269748"/>
-          </a:xfrm>
-          <a:prstGeom prst="rect">
-            <a:avLst/>
-          </a:prstGeom>
-          <a:noFill/>
-          <a:ln/>
-        </p:spPr>
-        <p:txBody>
-          <a:bodyPr wrap="square" lIns="0" tIns="0" rIns="0" bIns="0" rtlCol="0" anchor="ctr"/>
-          <a:lstStyle/>
-          <a:p>
-            <a:pPr indent="0" marL="0">
-              <a:buNone/>
-            </a:pPr>
-            <a:r>
-              <a:rPr lang="en-US" sz="850" dirty="0">
+              <a:t> Anthropic and OpenAI report OSWorld 2.0 under different test settings.</a:t>
+            </a:r>
+            <a:pPr indent="0" marL="0">
+              <a:buNone/>
+            </a:pPr>
+            <a:endParaRPr lang="en-US" sz="700" dirty="0"/>
+          </a:p>
+          <a:p>
+            <a:pPr indent="0" marL="0">
+              <a:buNone/>
+            </a:pPr>
+            <a:r>
+              <a:rPr lang="en-US" sz="700" baseline="30000" dirty="0">
                 <a:solidFill>
                   <a:srgbClr val="5F6B7A"/>
                 </a:solidFill>
@@ -5193,13 +6035,13 @@
                 <a:ea typeface="Arial" pitchFamily="34" charset="-122"/>
                 <a:cs typeface="Arial" pitchFamily="34" charset="-120"/>
               </a:rPr>
-              <a:t>AA Intelligence Index</a:t>
-            </a:r>
-            <a:pPr indent="0" marL="0">
-              <a:buNone/>
-            </a:pPr>
-            <a:r>
-              <a:rPr lang="en-US" sz="850" baseline="30000" dirty="0">
+              <a:t>(3)</a:t>
+            </a:r>
+            <a:pPr indent="0" marL="0">
+              <a:buNone/>
+            </a:pPr>
+            <a:r>
+              <a:rPr lang="en-US" sz="700" dirty="0">
                 <a:solidFill>
                   <a:srgbClr val="5F6B7A"/>
                 </a:solidFill>
@@ -5207,475 +6049,29 @@
                 <a:ea typeface="Arial" pitchFamily="34" charset="-122"/>
                 <a:cs typeface="Arial" pitchFamily="34" charset="-120"/>
               </a:rPr>
-              <a:t>(3)</a:t>
-            </a:r>
-            <a:endParaRPr lang="en-US" sz="850" dirty="0"/>
-          </a:p>
-        </p:txBody>
-      </p:sp>
-      <p:sp>
-        <p:nvSpPr>
-          <p:cNvPr id="127" name="Text 125"/>
-          <p:cNvSpPr txBox="1"/>
-          <p:nvPr/>
-        </p:nvSpPr>
-        <p:spPr>
-          <a:xfrm>
-            <a:off x="9345168" y="3753612"/>
-            <a:ext cx="781202" cy="269748"/>
-          </a:xfrm>
-          <a:prstGeom prst="rect">
-            <a:avLst/>
-          </a:prstGeom>
-          <a:noFill/>
-          <a:ln/>
-        </p:spPr>
-        <p:txBody>
-          <a:bodyPr wrap="square" lIns="0" tIns="0" rIns="0" bIns="0" rtlCol="0" anchor="ctr"/>
-          <a:lstStyle/>
-          <a:p>
-            <a:pPr algn="ctr" indent="0" marL="0">
-              <a:buNone/>
-            </a:pPr>
-            <a:r>
-              <a:rPr lang="en-US" sz="850" b="1" dirty="0">
-                <a:solidFill>
-                  <a:srgbClr val="1F2A37"/>
-                </a:solidFill>
-                <a:latin typeface="Arial" pitchFamily="34" charset="0"/>
-                <a:ea typeface="Arial" pitchFamily="34" charset="-122"/>
-                <a:cs typeface="Arial" pitchFamily="34" charset="-120"/>
-              </a:rPr>
-              <a:t>58</a:t>
-            </a:r>
-            <a:endParaRPr lang="en-US" sz="850" dirty="0"/>
-          </a:p>
-        </p:txBody>
-      </p:sp>
-      <p:sp>
-        <p:nvSpPr>
-          <p:cNvPr id="128" name="Text 126"/>
-          <p:cNvSpPr txBox="1"/>
-          <p:nvPr/>
-        </p:nvSpPr>
-        <p:spPr>
-          <a:xfrm>
-            <a:off x="10162946" y="3753612"/>
-            <a:ext cx="781202" cy="269748"/>
-          </a:xfrm>
-          <a:prstGeom prst="rect">
-            <a:avLst/>
-          </a:prstGeom>
-          <a:noFill/>
-          <a:ln/>
-        </p:spPr>
-        <p:txBody>
-          <a:bodyPr wrap="square" lIns="0" tIns="0" rIns="0" bIns="0" rtlCol="0" anchor="ctr"/>
-          <a:lstStyle/>
-          <a:p>
-            <a:pPr algn="ctr" indent="0" marL="0">
-              <a:buNone/>
-            </a:pPr>
-            <a:r>
-              <a:rPr lang="en-US" sz="850" b="1" dirty="0">
-                <a:solidFill>
-                  <a:srgbClr val="1F2A37"/>
-                </a:solidFill>
-                <a:latin typeface="Arial" pitchFamily="34" charset="0"/>
-                <a:ea typeface="Arial" pitchFamily="34" charset="-122"/>
-                <a:cs typeface="Arial" pitchFamily="34" charset="-120"/>
-              </a:rPr>
-              <a:t>53</a:t>
-            </a:r>
-            <a:endParaRPr lang="en-US" sz="850" dirty="0"/>
-          </a:p>
-        </p:txBody>
-      </p:sp>
-      <p:sp>
-        <p:nvSpPr>
-          <p:cNvPr id="129" name="Text 127"/>
-          <p:cNvSpPr txBox="1"/>
-          <p:nvPr/>
-        </p:nvSpPr>
-        <p:spPr>
-          <a:xfrm>
-            <a:off x="10980725" y="3753612"/>
-            <a:ext cx="781202" cy="269748"/>
-          </a:xfrm>
-          <a:prstGeom prst="rect">
-            <a:avLst/>
-          </a:prstGeom>
-          <a:noFill/>
-          <a:ln/>
-        </p:spPr>
-        <p:txBody>
-          <a:bodyPr wrap="square" lIns="0" tIns="0" rIns="0" bIns="0" rtlCol="0" anchor="ctr"/>
-          <a:lstStyle/>
-          <a:p>
-            <a:pPr algn="ctr" indent="0" marL="0">
-              <a:buNone/>
-            </a:pPr>
-            <a:r>
-              <a:rPr lang="en-US" sz="850" b="1" dirty="0">
-                <a:solidFill>
-                  <a:srgbClr val="1F2A37"/>
-                </a:solidFill>
-                <a:latin typeface="Arial" pitchFamily="34" charset="0"/>
-                <a:ea typeface="Arial" pitchFamily="34" charset="-122"/>
-                <a:cs typeface="Arial" pitchFamily="34" charset="-120"/>
-              </a:rPr>
-              <a:t>44</a:t>
-            </a:r>
-            <a:endParaRPr lang="en-US" sz="850" dirty="0"/>
-          </a:p>
-        </p:txBody>
-      </p:sp>
-      <p:sp>
-        <p:nvSpPr>
-          <p:cNvPr id="130" name="Shape 128"/>
-          <p:cNvSpPr/>
-          <p:nvPr/>
-        </p:nvSpPr>
-        <p:spPr>
-          <a:xfrm>
-            <a:off x="8229600" y="4023360"/>
-            <a:ext cx="3550615" cy="0"/>
-          </a:xfrm>
-          <a:prstGeom prst="line">
-            <a:avLst/>
-          </a:prstGeom>
-          <a:noFill/>
-          <a:ln w="9525">
-            <a:solidFill>
-              <a:srgbClr val="041E42"/>
-            </a:solidFill>
-            <a:prstDash val="solid"/>
-          </a:ln>
-        </p:spPr>
-      </p:sp>
-      <p:sp>
-        <p:nvSpPr>
-          <p:cNvPr id="131" name="Text 129"/>
-          <p:cNvSpPr txBox="1"/>
-          <p:nvPr/>
-        </p:nvSpPr>
-        <p:spPr>
-          <a:xfrm>
-            <a:off x="8229600" y="4261104"/>
-            <a:ext cx="3550615" cy="201168"/>
-          </a:xfrm>
-          <a:prstGeom prst="rect">
-            <a:avLst/>
-          </a:prstGeom>
-          <a:noFill/>
-          <a:ln/>
-        </p:spPr>
-        <p:txBody>
-          <a:bodyPr wrap="square" lIns="0" tIns="0" rIns="0" bIns="0" rtlCol="0" anchor="t"/>
-          <a:lstStyle/>
-          <a:p>
-            <a:pPr indent="0" marL="0">
-              <a:buNone/>
-            </a:pPr>
-            <a:r>
-              <a:rPr lang="en-US" sz="1100" b="1" dirty="0">
-                <a:solidFill>
-                  <a:srgbClr val="041E42"/>
-                </a:solidFill>
-                <a:latin typeface="Arial" pitchFamily="34" charset="0"/>
-                <a:ea typeface="Arial" pitchFamily="34" charset="-122"/>
-                <a:cs typeface="Arial" pitchFamily="34" charset="-120"/>
-              </a:rPr>
-              <a:t>Recommended use</a:t>
-            </a:r>
-            <a:endParaRPr lang="en-US" sz="1100" dirty="0"/>
-          </a:p>
-        </p:txBody>
-      </p:sp>
-      <p:sp>
-        <p:nvSpPr>
-          <p:cNvPr id="132" name="Shape 130"/>
-          <p:cNvSpPr/>
-          <p:nvPr/>
-        </p:nvSpPr>
-        <p:spPr>
-          <a:xfrm>
-            <a:off x="8229600" y="4572000"/>
-            <a:ext cx="3550615" cy="1280160"/>
-          </a:xfrm>
-          <a:prstGeom prst="rect">
-            <a:avLst/>
-          </a:prstGeom>
-          <a:solidFill>
-            <a:srgbClr val="EAF0F7"/>
-          </a:solidFill>
-          <a:ln w="12700">
-            <a:solidFill>
-              <a:srgbClr val="EAF0F7"/>
-            </a:solidFill>
-            <a:prstDash val="solid"/>
-          </a:ln>
-        </p:spPr>
-      </p:sp>
-      <p:sp>
-        <p:nvSpPr>
-          <p:cNvPr id="133" name="Text 131"/>
-          <p:cNvSpPr txBox="1"/>
-          <p:nvPr/>
-        </p:nvSpPr>
-        <p:spPr>
-          <a:xfrm>
-            <a:off x="8366760" y="4709160"/>
-            <a:ext cx="658368" cy="335280"/>
-          </a:xfrm>
-          <a:prstGeom prst="rect">
-            <a:avLst/>
-          </a:prstGeom>
-          <a:noFill/>
-          <a:ln/>
-        </p:spPr>
-        <p:txBody>
-          <a:bodyPr wrap="square" lIns="0" tIns="0" rIns="0" bIns="0" rtlCol="0" anchor="ctr"/>
-          <a:lstStyle/>
-          <a:p>
-            <a:pPr indent="0" marL="0">
-              <a:buNone/>
-            </a:pPr>
-            <a:r>
-              <a:rPr lang="en-US" sz="850" b="1" dirty="0">
-                <a:solidFill>
-                  <a:srgbClr val="041E42"/>
-                </a:solidFill>
-                <a:latin typeface="Arial" pitchFamily="34" charset="0"/>
-                <a:ea typeface="Arial" pitchFamily="34" charset="-122"/>
-                <a:cs typeface="Arial" pitchFamily="34" charset="-120"/>
-              </a:rPr>
-              <a:t>Opus 5.5</a:t>
-            </a:r>
-            <a:endParaRPr lang="en-US" sz="850" dirty="0"/>
-          </a:p>
-        </p:txBody>
-      </p:sp>
-      <p:sp>
-        <p:nvSpPr>
-          <p:cNvPr id="134" name="Text 132"/>
-          <p:cNvSpPr txBox="1"/>
-          <p:nvPr/>
-        </p:nvSpPr>
-        <p:spPr>
-          <a:xfrm>
-            <a:off x="9025128" y="4709160"/>
-            <a:ext cx="2617927" cy="335280"/>
-          </a:xfrm>
-          <a:prstGeom prst="rect">
-            <a:avLst/>
-          </a:prstGeom>
-          <a:noFill/>
-          <a:ln/>
-        </p:spPr>
-        <p:txBody>
-          <a:bodyPr wrap="square" lIns="0" tIns="0" rIns="0" bIns="0" rtlCol="0" anchor="ctr"/>
-          <a:lstStyle/>
-          <a:p>
-            <a:pPr indent="0" marL="0">
-              <a:buNone/>
-            </a:pPr>
-            <a:r>
-              <a:rPr lang="en-US" sz="850" dirty="0">
-                <a:solidFill>
-                  <a:srgbClr val="1F2A37"/>
-                </a:solidFill>
-                <a:latin typeface="Arial" pitchFamily="34" charset="0"/>
-                <a:ea typeface="Arial" pitchFamily="34" charset="-122"/>
-                <a:cs typeface="Arial" pitchFamily="34" charset="-120"/>
-              </a:rPr>
-              <a:t>Default for coding, agents and analyst work. List price c.60% below Astra.</a:t>
-            </a:r>
-            <a:endParaRPr lang="en-US" sz="850" dirty="0"/>
-          </a:p>
-        </p:txBody>
-      </p:sp>
-      <p:sp>
-        <p:nvSpPr>
-          <p:cNvPr id="135" name="Text 133"/>
-          <p:cNvSpPr txBox="1"/>
-          <p:nvPr/>
-        </p:nvSpPr>
-        <p:spPr>
-          <a:xfrm>
-            <a:off x="8366760" y="5044440"/>
-            <a:ext cx="658368" cy="335280"/>
-          </a:xfrm>
-          <a:prstGeom prst="rect">
-            <a:avLst/>
-          </a:prstGeom>
-          <a:noFill/>
-          <a:ln/>
-        </p:spPr>
-        <p:txBody>
-          <a:bodyPr wrap="square" lIns="0" tIns="0" rIns="0" bIns="0" rtlCol="0" anchor="ctr"/>
-          <a:lstStyle/>
-          <a:p>
-            <a:pPr indent="0" marL="0">
-              <a:buNone/>
-            </a:pPr>
-            <a:r>
-              <a:rPr lang="en-US" sz="850" b="1" dirty="0">
-                <a:solidFill>
-                  <a:srgbClr val="041E42"/>
-                </a:solidFill>
-                <a:latin typeface="Arial" pitchFamily="34" charset="0"/>
-                <a:ea typeface="Arial" pitchFamily="34" charset="-122"/>
-                <a:cs typeface="Arial" pitchFamily="34" charset="-120"/>
-              </a:rPr>
-              <a:t>Astra</a:t>
-            </a:r>
-            <a:endParaRPr lang="en-US" sz="850" dirty="0"/>
-          </a:p>
-        </p:txBody>
-      </p:sp>
-      <p:sp>
-        <p:nvSpPr>
-          <p:cNvPr id="136" name="Text 134"/>
-          <p:cNvSpPr txBox="1"/>
-          <p:nvPr/>
-        </p:nvSpPr>
-        <p:spPr>
-          <a:xfrm>
-            <a:off x="9025128" y="5044440"/>
-            <a:ext cx="2617927" cy="335280"/>
-          </a:xfrm>
-          <a:prstGeom prst="rect">
-            <a:avLst/>
-          </a:prstGeom>
-          <a:noFill/>
-          <a:ln/>
-        </p:spPr>
-        <p:txBody>
-          <a:bodyPr wrap="square" lIns="0" tIns="0" rIns="0" bIns="0" rtlCol="0" anchor="ctr"/>
-          <a:lstStyle/>
-          <a:p>
-            <a:pPr indent="0" marL="0">
-              <a:buNone/>
-            </a:pPr>
-            <a:r>
-              <a:rPr lang="en-US" sz="850" dirty="0">
-                <a:solidFill>
-                  <a:srgbClr val="1F2A37"/>
-                </a:solidFill>
-                <a:latin typeface="Arial" pitchFamily="34" charset="0"/>
-                <a:ea typeface="Arial" pitchFamily="34" charset="-122"/>
-                <a:cs typeface="Arial" pitchFamily="34" charset="-120"/>
-              </a:rPr>
-              <a:t>Computer use, 3D tools and frontier math. Staged access; OpenAI rates its cyber capability "Critical".</a:t>
-            </a:r>
-            <a:endParaRPr lang="en-US" sz="850" dirty="0"/>
-          </a:p>
-        </p:txBody>
-      </p:sp>
-      <p:sp>
-        <p:nvSpPr>
-          <p:cNvPr id="137" name="Text 135"/>
-          <p:cNvSpPr txBox="1"/>
-          <p:nvPr/>
-        </p:nvSpPr>
-        <p:spPr>
-          <a:xfrm>
-            <a:off x="8366760" y="5379720"/>
-            <a:ext cx="658368" cy="335280"/>
-          </a:xfrm>
-          <a:prstGeom prst="rect">
-            <a:avLst/>
-          </a:prstGeom>
-          <a:noFill/>
-          <a:ln/>
-        </p:spPr>
-        <p:txBody>
-          <a:bodyPr wrap="square" lIns="0" tIns="0" rIns="0" bIns="0" rtlCol="0" anchor="ctr"/>
-          <a:lstStyle/>
-          <a:p>
-            <a:pPr indent="0" marL="0">
-              <a:buNone/>
-            </a:pPr>
-            <a:r>
-              <a:rPr lang="en-US" sz="850" b="1" dirty="0">
-                <a:solidFill>
-                  <a:srgbClr val="041E42"/>
-                </a:solidFill>
-                <a:latin typeface="Arial" pitchFamily="34" charset="0"/>
-                <a:ea typeface="Arial" pitchFamily="34" charset="-122"/>
-                <a:cs typeface="Arial" pitchFamily="34" charset="-120"/>
-              </a:rPr>
-              <a:t>K3</a:t>
-            </a:r>
-            <a:endParaRPr lang="en-US" sz="850" dirty="0"/>
-          </a:p>
-        </p:txBody>
-      </p:sp>
-      <p:sp>
-        <p:nvSpPr>
-          <p:cNvPr id="138" name="Text 136"/>
-          <p:cNvSpPr txBox="1"/>
-          <p:nvPr/>
-        </p:nvSpPr>
-        <p:spPr>
-          <a:xfrm>
-            <a:off x="9025128" y="5379720"/>
-            <a:ext cx="2617927" cy="335280"/>
-          </a:xfrm>
-          <a:prstGeom prst="rect">
-            <a:avLst/>
-          </a:prstGeom>
-          <a:noFill/>
-          <a:ln/>
-        </p:spPr>
-        <p:txBody>
-          <a:bodyPr wrap="square" lIns="0" tIns="0" rIns="0" bIns="0" rtlCol="0" anchor="ctr"/>
-          <a:lstStyle/>
-          <a:p>
-            <a:pPr indent="0" marL="0">
-              <a:buNone/>
-            </a:pPr>
-            <a:r>
-              <a:rPr lang="en-US" sz="850" dirty="0">
-                <a:solidFill>
-                  <a:srgbClr val="1F2A37"/>
-                </a:solidFill>
-                <a:latin typeface="Arial" pitchFamily="34" charset="0"/>
-                <a:ea typeface="Arial" pitchFamily="34" charset="-122"/>
-                <a:cs typeface="Arial" pitchFamily="34" charset="-120"/>
-              </a:rPr>
-              <a:t>Self-hosted and high-volume work. Avoid Moonshot's own API for regulated data.</a:t>
-            </a:r>
-            <a:endParaRPr lang="en-US" sz="850" dirty="0"/>
-          </a:p>
-        </p:txBody>
-      </p:sp>
-      <p:sp>
-        <p:nvSpPr>
-          <p:cNvPr id="139" name="Text 137"/>
-          <p:cNvSpPr txBox="1"/>
-          <p:nvPr/>
-        </p:nvSpPr>
-        <p:spPr>
-          <a:xfrm>
-            <a:off x="411480" y="5980176"/>
-            <a:ext cx="11002975" cy="566928"/>
-          </a:xfrm>
-          <a:prstGeom prst="rect">
-            <a:avLst/>
-          </a:prstGeom>
-          <a:noFill/>
-          <a:ln/>
-        </p:spPr>
-        <p:txBody>
-          <a:bodyPr wrap="square" lIns="0" tIns="0" rIns="0" bIns="0" rtlCol="0" anchor="t"/>
-          <a:lstStyle/>
-          <a:p>
-            <a:pPr indent="0" marL="0">
-              <a:lnSpc>
-                <a:spcPct val="100000"/>
-              </a:lnSpc>
+              <a:t> Weights released 27 Jul 2026 under the Kimi K3 License (modified open license; model-as-a-service businesses above $20M annual revenue need a separate agreement).</a:t>
+            </a:r>
+            <a:pPr indent="0" marL="0">
+              <a:buNone/>
+            </a:pPr>
+            <a:endParaRPr lang="en-US" sz="700" dirty="0"/>
+          </a:p>
+          <a:p>
+            <a:pPr indent="0" marL="0">
+              <a:buNone/>
+            </a:pPr>
+            <a:r>
+              <a:rPr lang="en-US" sz="700" baseline="30000" dirty="0">
+                <a:solidFill>
+                  <a:srgbClr val="5F6B7A"/>
+                </a:solidFill>
+                <a:latin typeface="Arial" pitchFamily="34" charset="0"/>
+                <a:ea typeface="Arial" pitchFamily="34" charset="-122"/>
+                <a:cs typeface="Arial" pitchFamily="34" charset="-120"/>
+              </a:rPr>
+              <a:t>(4)</a:t>
+            </a:r>
+            <a:pPr indent="0" marL="0">
               <a:buNone/>
             </a:pPr>
             <a:r>
@@ -5687,15 +6083,15 @@
                 <a:ea typeface="Arial" pitchFamily="34" charset="-122"/>
                 <a:cs typeface="Arial" pitchFamily="34" charset="-120"/>
               </a:rPr>
-              <a:t>Note: Ratings are analyst judgment based on the data shown; scores reported by different vendors are not always like-for-like. Prices are list API rates.</a:t>
-            </a:r>
+              <a:t> Artificial Analysis Intelligence Index v4.3 (Sep 2026). No like-for-like K3 scores are published for most tasks above, so K3 ratings rely mainly on this index.</a:t>
+            </a:r>
+            <a:pPr indent="0" marL="0">
+              <a:buNone/>
+            </a:pPr>
             <a:endParaRPr lang="en-US" sz="700" dirty="0"/>
           </a:p>
           <a:p>
             <a:pPr indent="0" marL="0">
-              <a:lnSpc>
-                <a:spcPct val="100000"/>
-              </a:lnSpc>
               <a:buNone/>
             </a:pPr>
             <a:r>
@@ -5707,12 +6103,9 @@
                 <a:ea typeface="Arial" pitchFamily="34" charset="-122"/>
                 <a:cs typeface="Arial" pitchFamily="34" charset="-120"/>
               </a:rPr>
-              <a:t>(1)</a:t>
-            </a:r>
-            <a:pPr indent="0" marL="0">
-              <a:lnSpc>
-                <a:spcPct val="100000"/>
-              </a:lnSpc>
+              <a:t>(5)</a:t>
+            </a:r>
+            <a:pPr indent="0" marL="0">
               <a:buNone/>
             </a:pPr>
             <a:r>
@@ -5724,16 +6117,19 @@
                 <a:ea typeface="Arial" pitchFamily="34" charset="-122"/>
                 <a:cs typeface="Arial" pitchFamily="34" charset="-120"/>
               </a:rPr>
-              <a:t> Opus 5.5 vs. Astra figures as reported by Anthropic (22 Sep 2026); not independently replicated.  </a:t>
-            </a:r>
-            <a:pPr indent="0" marL="0">
-              <a:lnSpc>
-                <a:spcPct val="100000"/>
-              </a:lnSpc>
-              <a:buNone/>
-            </a:pPr>
-            <a:r>
-              <a:rPr lang="en-US" sz="700" baseline="30000" dirty="0">
+              <a:t> Anthropic and OpenAI do not disclose model size. Third-party estimates for Astra range from c.5T to 10T total parameters and are unverified.</a:t>
+            </a:r>
+            <a:pPr indent="0" marL="0">
+              <a:buNone/>
+            </a:pPr>
+            <a:endParaRPr lang="en-US" sz="700" dirty="0"/>
+          </a:p>
+          <a:p>
+            <a:pPr indent="0" marL="0">
+              <a:buNone/>
+            </a:pPr>
+            <a:r>
+              <a:rPr lang="en-US" sz="700" dirty="0">
                 <a:solidFill>
                   <a:srgbClr val="5F6B7A"/>
                 </a:solidFill>
@@ -5741,151 +6137,22 @@
                 <a:ea typeface="Arial" pitchFamily="34" charset="-122"/>
                 <a:cs typeface="Arial" pitchFamily="34" charset="-120"/>
               </a:rPr>
-              <a:t>(2)</a:t>
-            </a:r>
-            <a:pPr indent="0" marL="0">
-              <a:lnSpc>
-                <a:spcPct val="100000"/>
-              </a:lnSpc>
-              <a:buNone/>
-            </a:pPr>
-            <a:r>
-              <a:rPr lang="en-US" sz="700" dirty="0">
-                <a:solidFill>
-                  <a:srgbClr val="5F6B7A"/>
-                </a:solidFill>
-                <a:latin typeface="Arial" pitchFamily="34" charset="0"/>
-                <a:ea typeface="Arial" pitchFamily="34" charset="-122"/>
-                <a:cs typeface="Arial" pitchFamily="34" charset="-120"/>
-              </a:rPr>
-              <a:t> Anthropic and OpenAI report OSWorld 2.0 under different test settings.</a:t>
-            </a:r>
-            <a:pPr indent="0" marL="0">
-              <a:lnSpc>
-                <a:spcPct val="100000"/>
-              </a:lnSpc>
-              <a:buNone/>
-            </a:pPr>
+              <a:t>Source: Anthropic, "Introducing Claude Opus 5.5" (22 Sep 2026); OpenAI, "GPT-6 Astra" (3 Sep 2026); Moonshot AI, "Kimi K3 Tech Blog" (16 Jul 2026); Artificial Analysis; Databricks; Fireworks AI.</a:t>
+            </a:r>
             <a:endParaRPr lang="en-US" sz="700" dirty="0"/>
           </a:p>
-          <a:p>
-            <a:pPr indent="0" marL="0">
-              <a:lnSpc>
-                <a:spcPct val="100000"/>
-              </a:lnSpc>
-              <a:buNone/>
-            </a:pPr>
-            <a:r>
-              <a:rPr lang="en-US" sz="700" baseline="30000" dirty="0">
-                <a:solidFill>
-                  <a:srgbClr val="5F6B7A"/>
-                </a:solidFill>
-                <a:latin typeface="Arial" pitchFamily="34" charset="0"/>
-                <a:ea typeface="Arial" pitchFamily="34" charset="-122"/>
-                <a:cs typeface="Arial" pitchFamily="34" charset="-120"/>
-              </a:rPr>
-              <a:t>(3)</a:t>
-            </a:r>
-            <a:pPr indent="0" marL="0">
-              <a:lnSpc>
-                <a:spcPct val="100000"/>
-              </a:lnSpc>
-              <a:buNone/>
-            </a:pPr>
-            <a:r>
-              <a:rPr lang="en-US" sz="700" dirty="0">
-                <a:solidFill>
-                  <a:srgbClr val="5F6B7A"/>
-                </a:solidFill>
-                <a:latin typeface="Arial" pitchFamily="34" charset="0"/>
-                <a:ea typeface="Arial" pitchFamily="34" charset="-122"/>
-                <a:cs typeface="Arial" pitchFamily="34" charset="-120"/>
-              </a:rPr>
-              <a:t> Artificial Analysis Intelligence Index v4.3 (Sep 2026). No like-for-like K3 scores are published for most tasks above, so K3 ratings rely mainly on this index.</a:t>
-            </a:r>
-            <a:pPr indent="0" marL="0">
-              <a:lnSpc>
-                <a:spcPct val="100000"/>
-              </a:lnSpc>
-              <a:buNone/>
-            </a:pPr>
-            <a:endParaRPr lang="en-US" sz="700" dirty="0"/>
-          </a:p>
-          <a:p>
-            <a:pPr indent="0" marL="0">
-              <a:lnSpc>
-                <a:spcPct val="100000"/>
-              </a:lnSpc>
-              <a:buNone/>
-            </a:pPr>
-            <a:r>
-              <a:rPr lang="en-US" sz="700" baseline="30000" dirty="0">
-                <a:solidFill>
-                  <a:srgbClr val="5F6B7A"/>
-                </a:solidFill>
-                <a:latin typeface="Arial" pitchFamily="34" charset="0"/>
-                <a:ea typeface="Arial" pitchFamily="34" charset="-122"/>
-                <a:cs typeface="Arial" pitchFamily="34" charset="-120"/>
-              </a:rPr>
-              <a:t>(4)</a:t>
-            </a:r>
-            <a:pPr indent="0" marL="0">
-              <a:lnSpc>
-                <a:spcPct val="100000"/>
-              </a:lnSpc>
-              <a:buNone/>
-            </a:pPr>
-            <a:r>
-              <a:rPr lang="en-US" sz="700" dirty="0">
-                <a:solidFill>
-                  <a:srgbClr val="5F6B7A"/>
-                </a:solidFill>
-                <a:latin typeface="Arial" pitchFamily="34" charset="0"/>
-                <a:ea typeface="Arial" pitchFamily="34" charset="-122"/>
-                <a:cs typeface="Arial" pitchFamily="34" charset="-120"/>
-              </a:rPr>
-              <a:t> 104B active parameters. Weights released 27 Jul 2026 under the Kimi K3 License (modified open license; model-as-a-service businesses above $20M annual revenue need a separate agreement).</a:t>
-            </a:r>
-            <a:pPr indent="0" marL="0">
-              <a:lnSpc>
-                <a:spcPct val="100000"/>
-              </a:lnSpc>
-              <a:buNone/>
-            </a:pPr>
-            <a:endParaRPr lang="en-US" sz="700" dirty="0"/>
-          </a:p>
-          <a:p>
-            <a:pPr indent="0" marL="0">
-              <a:lnSpc>
-                <a:spcPct val="100000"/>
-              </a:lnSpc>
-              <a:buNone/>
-            </a:pPr>
-            <a:r>
-              <a:rPr lang="en-US" sz="700" dirty="0">
-                <a:solidFill>
-                  <a:srgbClr val="5F6B7A"/>
-                </a:solidFill>
-                <a:latin typeface="Arial" pitchFamily="34" charset="0"/>
-                <a:ea typeface="Arial" pitchFamily="34" charset="-122"/>
-                <a:cs typeface="Arial" pitchFamily="34" charset="-120"/>
-              </a:rPr>
-              <a:t>Source: Anthropic, "Introducing Claude Opus 5.5" (22 Sep 2026); OpenAI, "GPT-6 Astra" (3 Sep 2026); Moonshot AI, "Kimi K3 Tech Blog" (16 Jul 2026); Artificial Analysis; Databricks; Fireworks AI.</a:t>
-            </a:r>
-            <a:endParaRPr lang="en-US" sz="700" dirty="0"/>
-          </a:p>
-        </p:txBody>
-      </p:sp>
-      <p:sp>
-        <p:nvSpPr>
-          <p:cNvPr id="140" name="Text 138"/>
-          <p:cNvSpPr txBox="1"/>
-          <p:nvPr/>
-        </p:nvSpPr>
-        <p:spPr>
-          <a:xfrm>
-            <a:off x="11505895" y="6473952"/>
-            <a:ext cx="274320" cy="146304"/>
+        </p:txBody>
+      </p:sp>
+      <p:sp>
+        <p:nvSpPr>
+          <p:cNvPr id="141" name="Text 139"/>
+          <p:cNvSpPr txBox="1"/>
+          <p:nvPr/>
+        </p:nvSpPr>
+        <p:spPr>
+          <a:xfrm>
+            <a:off x="11505895" y="6492240"/>
+            <a:ext cx="274320" cy="128016"/>
           </a:xfrm>
           <a:prstGeom prst="rect">
             <a:avLst/>

</xml_diff>

<commit_message>
Plain table for recommended use; Arial theme; clean file metadata
Replace the dark recommendation panel with a table matching the specs
table, set theme fonts to Arial, and strip generator metadata and
default shape names from the file.

Co-Authored-By: Claude Opus 5.5 <noreply@anthropic.com>
Claude-Session: https://claude.ai/code/session_01ArvvTMQ47fYQzBZA3Mrxmu
</commit_message>
<xml_diff>
--- a/ai-model-comparison/AI-Model-Comparison-Sep-2026.pptx
+++ b/ai-model-comparison/AI-Model-Comparison-Sep-2026.pptx
@@ -877,7 +877,7 @@
       </p:grpSpPr>
       <p:sp>
         <p:nvSpPr>
-          <p:cNvPr id="2" name="Text 0"/>
+          <p:cNvPr id="2" name="TextBox 1"/>
           <p:cNvSpPr txBox="1"/>
           <p:nvPr/>
         </p:nvSpPr>
@@ -916,7 +916,7 @@
       </p:sp>
       <p:sp>
         <p:nvSpPr>
-          <p:cNvPr id="3" name="Text 1"/>
+          <p:cNvPr id="3" name="TextBox 2"/>
           <p:cNvSpPr txBox="1"/>
           <p:nvPr/>
         </p:nvSpPr>
@@ -955,7 +955,7 @@
       </p:sp>
       <p:sp>
         <p:nvSpPr>
-          <p:cNvPr id="4" name="Shape 2"/>
+          <p:cNvPr id="4" name="Straight Connector 3"/>
           <p:cNvSpPr/>
           <p:nvPr/>
         </p:nvSpPr>
@@ -978,7 +978,7 @@
       </p:sp>
       <p:sp>
         <p:nvSpPr>
-          <p:cNvPr id="5" name="Text 3"/>
+          <p:cNvPr id="5" name="TextBox 4"/>
           <p:cNvSpPr txBox="1"/>
           <p:nvPr/>
         </p:nvSpPr>
@@ -1017,7 +1017,7 @@
       </p:sp>
       <p:sp>
         <p:nvSpPr>
-          <p:cNvPr id="6" name="Shape 4"/>
+          <p:cNvPr id="6" name="Oval 5"/>
           <p:cNvSpPr/>
           <p:nvPr/>
         </p:nvSpPr>
@@ -1042,7 +1042,7 @@
       </p:sp>
       <p:sp>
         <p:nvSpPr>
-          <p:cNvPr id="7" name="Text 5"/>
+          <p:cNvPr id="7" name="TextBox 6"/>
           <p:cNvSpPr txBox="1"/>
           <p:nvPr/>
         </p:nvSpPr>
@@ -1081,7 +1081,7 @@
       </p:sp>
       <p:sp>
         <p:nvSpPr>
-          <p:cNvPr id="8" name="Shape 6"/>
+          <p:cNvPr id="8" name="Oval 7"/>
           <p:cNvSpPr/>
           <p:nvPr/>
         </p:nvSpPr>
@@ -1106,7 +1106,7 @@
       </p:sp>
       <p:sp>
         <p:nvSpPr>
-          <p:cNvPr id="9" name="Shape 7"/>
+          <p:cNvPr id="9" name="Partial Circle 8"/>
           <p:cNvSpPr/>
           <p:nvPr/>
         </p:nvSpPr>
@@ -1134,7 +1134,7 @@
       </p:sp>
       <p:sp>
         <p:nvSpPr>
-          <p:cNvPr id="10" name="Text 8"/>
+          <p:cNvPr id="10" name="TextBox 9"/>
           <p:cNvSpPr txBox="1"/>
           <p:nvPr/>
         </p:nvSpPr>
@@ -1173,7 +1173,7 @@
       </p:sp>
       <p:sp>
         <p:nvSpPr>
-          <p:cNvPr id="11" name="Shape 9"/>
+          <p:cNvPr id="11" name="Oval 10"/>
           <p:cNvSpPr/>
           <p:nvPr/>
         </p:nvSpPr>
@@ -1198,7 +1198,7 @@
       </p:sp>
       <p:sp>
         <p:nvSpPr>
-          <p:cNvPr id="12" name="Shape 10"/>
+          <p:cNvPr id="12" name="Partial Circle 11"/>
           <p:cNvSpPr/>
           <p:nvPr/>
         </p:nvSpPr>
@@ -1226,7 +1226,7 @@
       </p:sp>
       <p:sp>
         <p:nvSpPr>
-          <p:cNvPr id="13" name="Text 11"/>
+          <p:cNvPr id="13" name="TextBox 12"/>
           <p:cNvSpPr txBox="1"/>
           <p:nvPr/>
         </p:nvSpPr>
@@ -1265,7 +1265,7 @@
       </p:sp>
       <p:sp>
         <p:nvSpPr>
-          <p:cNvPr id="14" name="Shape 12"/>
+          <p:cNvPr id="14" name="Oval 13"/>
           <p:cNvSpPr/>
           <p:nvPr/>
         </p:nvSpPr>
@@ -1290,7 +1290,7 @@
       </p:sp>
       <p:sp>
         <p:nvSpPr>
-          <p:cNvPr id="15" name="Shape 13"/>
+          <p:cNvPr id="15" name="Partial Circle 14"/>
           <p:cNvSpPr/>
           <p:nvPr/>
         </p:nvSpPr>
@@ -1318,7 +1318,7 @@
       </p:sp>
       <p:sp>
         <p:nvSpPr>
-          <p:cNvPr id="16" name="Text 14"/>
+          <p:cNvPr id="16" name="TextBox 15"/>
           <p:cNvSpPr txBox="1"/>
           <p:nvPr/>
         </p:nvSpPr>
@@ -1357,7 +1357,7 @@
       </p:sp>
       <p:sp>
         <p:nvSpPr>
-          <p:cNvPr id="17" name="Shape 15"/>
+          <p:cNvPr id="17" name="Straight Connector 16"/>
           <p:cNvSpPr/>
           <p:nvPr/>
         </p:nvSpPr>
@@ -1380,7 +1380,7 @@
       </p:sp>
       <p:sp>
         <p:nvSpPr>
-          <p:cNvPr id="18" name="Text 16"/>
+          <p:cNvPr id="18" name="TextBox 17"/>
           <p:cNvSpPr txBox="1"/>
           <p:nvPr/>
         </p:nvSpPr>
@@ -1436,7 +1436,7 @@
       </p:sp>
       <p:sp>
         <p:nvSpPr>
-          <p:cNvPr id="19" name="Text 17"/>
+          <p:cNvPr id="19" name="TextBox 18"/>
           <p:cNvSpPr txBox="1"/>
           <p:nvPr/>
         </p:nvSpPr>
@@ -1492,7 +1492,7 @@
       </p:sp>
       <p:sp>
         <p:nvSpPr>
-          <p:cNvPr id="20" name="Text 18"/>
+          <p:cNvPr id="20" name="TextBox 19"/>
           <p:cNvSpPr txBox="1"/>
           <p:nvPr/>
         </p:nvSpPr>
@@ -1548,7 +1548,7 @@
       </p:sp>
       <p:sp>
         <p:nvSpPr>
-          <p:cNvPr id="21" name="Text 19"/>
+          <p:cNvPr id="21" name="TextBox 20"/>
           <p:cNvSpPr txBox="1"/>
           <p:nvPr/>
         </p:nvSpPr>
@@ -1604,7 +1604,7 @@
       </p:sp>
       <p:sp>
         <p:nvSpPr>
-          <p:cNvPr id="22" name="Text 20"/>
+          <p:cNvPr id="22" name="TextBox 21"/>
           <p:cNvSpPr txBox="1"/>
           <p:nvPr/>
         </p:nvSpPr>
@@ -1660,7 +1660,7 @@
       </p:sp>
       <p:sp>
         <p:nvSpPr>
-          <p:cNvPr id="23" name="Shape 21"/>
+          <p:cNvPr id="23" name="Straight Connector 22"/>
           <p:cNvSpPr/>
           <p:nvPr/>
         </p:nvSpPr>
@@ -1683,7 +1683,7 @@
       </p:sp>
       <p:sp>
         <p:nvSpPr>
-          <p:cNvPr id="24" name="Shape 22"/>
+          <p:cNvPr id="24" name="Rectangle 23"/>
           <p:cNvSpPr/>
           <p:nvPr/>
         </p:nvSpPr>
@@ -1708,7 +1708,7 @@
       </p:sp>
       <p:sp>
         <p:nvSpPr>
-          <p:cNvPr id="25" name="Text 23"/>
+          <p:cNvPr id="25" name="TextBox 24"/>
           <p:cNvSpPr txBox="1"/>
           <p:nvPr/>
         </p:nvSpPr>
@@ -1764,7 +1764,7 @@
       </p:sp>
       <p:sp>
         <p:nvSpPr>
-          <p:cNvPr id="26" name="Shape 24"/>
+          <p:cNvPr id="26" name="Oval 25"/>
           <p:cNvSpPr/>
           <p:nvPr/>
         </p:nvSpPr>
@@ -1789,7 +1789,7 @@
       </p:sp>
       <p:sp>
         <p:nvSpPr>
-          <p:cNvPr id="27" name="Shape 25"/>
+          <p:cNvPr id="27" name="Oval 26"/>
           <p:cNvSpPr/>
           <p:nvPr/>
         </p:nvSpPr>
@@ -1814,7 +1814,7 @@
       </p:sp>
       <p:sp>
         <p:nvSpPr>
-          <p:cNvPr id="28" name="Shape 26"/>
+          <p:cNvPr id="28" name="Partial Circle 27"/>
           <p:cNvSpPr/>
           <p:nvPr/>
         </p:nvSpPr>
@@ -1842,7 +1842,7 @@
       </p:sp>
       <p:sp>
         <p:nvSpPr>
-          <p:cNvPr id="29" name="Shape 27"/>
+          <p:cNvPr id="29" name="Oval 28"/>
           <p:cNvSpPr/>
           <p:nvPr/>
         </p:nvSpPr>
@@ -1867,7 +1867,7 @@
       </p:sp>
       <p:sp>
         <p:nvSpPr>
-          <p:cNvPr id="30" name="Shape 28"/>
+          <p:cNvPr id="30" name="Partial Circle 29"/>
           <p:cNvSpPr/>
           <p:nvPr/>
         </p:nvSpPr>
@@ -1895,7 +1895,7 @@
       </p:sp>
       <p:sp>
         <p:nvSpPr>
-          <p:cNvPr id="31" name="Text 29"/>
+          <p:cNvPr id="31" name="TextBox 30"/>
           <p:cNvSpPr txBox="1"/>
           <p:nvPr/>
         </p:nvSpPr>
@@ -1990,7 +1990,7 @@
       </p:sp>
       <p:sp>
         <p:nvSpPr>
-          <p:cNvPr id="32" name="Shape 30"/>
+          <p:cNvPr id="32" name="Straight Connector 31"/>
           <p:cNvSpPr/>
           <p:nvPr/>
         </p:nvSpPr>
@@ -2013,7 +2013,7 @@
       </p:sp>
       <p:sp>
         <p:nvSpPr>
-          <p:cNvPr id="33" name="Shape 31"/>
+          <p:cNvPr id="33" name="Rectangle 32"/>
           <p:cNvSpPr/>
           <p:nvPr/>
         </p:nvSpPr>
@@ -2038,7 +2038,7 @@
       </p:sp>
       <p:sp>
         <p:nvSpPr>
-          <p:cNvPr id="34" name="Text 32"/>
+          <p:cNvPr id="34" name="TextBox 33"/>
           <p:cNvSpPr txBox="1"/>
           <p:nvPr/>
         </p:nvSpPr>
@@ -2094,7 +2094,7 @@
       </p:sp>
       <p:sp>
         <p:nvSpPr>
-          <p:cNvPr id="35" name="Shape 33"/>
+          <p:cNvPr id="35" name="Oval 34"/>
           <p:cNvSpPr/>
           <p:nvPr/>
         </p:nvSpPr>
@@ -2119,7 +2119,7 @@
       </p:sp>
       <p:sp>
         <p:nvSpPr>
-          <p:cNvPr id="36" name="Shape 34"/>
+          <p:cNvPr id="36" name="Oval 35"/>
           <p:cNvSpPr/>
           <p:nvPr/>
         </p:nvSpPr>
@@ -2144,7 +2144,7 @@
       </p:sp>
       <p:sp>
         <p:nvSpPr>
-          <p:cNvPr id="37" name="Shape 35"/>
+          <p:cNvPr id="37" name="Partial Circle 36"/>
           <p:cNvSpPr/>
           <p:nvPr/>
         </p:nvSpPr>
@@ -2172,7 +2172,7 @@
       </p:sp>
       <p:sp>
         <p:nvSpPr>
-          <p:cNvPr id="38" name="Shape 36"/>
+          <p:cNvPr id="38" name="Oval 37"/>
           <p:cNvSpPr/>
           <p:nvPr/>
         </p:nvSpPr>
@@ -2197,7 +2197,7 @@
       </p:sp>
       <p:sp>
         <p:nvSpPr>
-          <p:cNvPr id="39" name="Shape 37"/>
+          <p:cNvPr id="39" name="Partial Circle 38"/>
           <p:cNvSpPr/>
           <p:nvPr/>
         </p:nvSpPr>
@@ -2225,7 +2225,7 @@
       </p:sp>
       <p:sp>
         <p:nvSpPr>
-          <p:cNvPr id="40" name="Text 38"/>
+          <p:cNvPr id="40" name="TextBox 39"/>
           <p:cNvSpPr txBox="1"/>
           <p:nvPr/>
         </p:nvSpPr>
@@ -2334,7 +2334,7 @@
       </p:sp>
       <p:sp>
         <p:nvSpPr>
-          <p:cNvPr id="41" name="Shape 39"/>
+          <p:cNvPr id="41" name="Straight Connector 40"/>
           <p:cNvSpPr/>
           <p:nvPr/>
         </p:nvSpPr>
@@ -2357,7 +2357,7 @@
       </p:sp>
       <p:sp>
         <p:nvSpPr>
-          <p:cNvPr id="42" name="Shape 40"/>
+          <p:cNvPr id="42" name="Rectangle 41"/>
           <p:cNvSpPr/>
           <p:nvPr/>
         </p:nvSpPr>
@@ -2382,7 +2382,7 @@
       </p:sp>
       <p:sp>
         <p:nvSpPr>
-          <p:cNvPr id="43" name="Shape 41"/>
+          <p:cNvPr id="43" name="Rectangle 42"/>
           <p:cNvSpPr/>
           <p:nvPr/>
         </p:nvSpPr>
@@ -2407,7 +2407,7 @@
       </p:sp>
       <p:sp>
         <p:nvSpPr>
-          <p:cNvPr id="44" name="Text 42"/>
+          <p:cNvPr id="44" name="TextBox 43"/>
           <p:cNvSpPr txBox="1"/>
           <p:nvPr/>
         </p:nvSpPr>
@@ -2463,7 +2463,7 @@
       </p:sp>
       <p:sp>
         <p:nvSpPr>
-          <p:cNvPr id="45" name="Shape 43"/>
+          <p:cNvPr id="45" name="Oval 44"/>
           <p:cNvSpPr/>
           <p:nvPr/>
         </p:nvSpPr>
@@ -2488,7 +2488,7 @@
       </p:sp>
       <p:sp>
         <p:nvSpPr>
-          <p:cNvPr id="46" name="Shape 44"/>
+          <p:cNvPr id="46" name="Oval 45"/>
           <p:cNvSpPr/>
           <p:nvPr/>
         </p:nvSpPr>
@@ -2513,7 +2513,7 @@
       </p:sp>
       <p:sp>
         <p:nvSpPr>
-          <p:cNvPr id="47" name="Shape 45"/>
+          <p:cNvPr id="47" name="Oval 46"/>
           <p:cNvSpPr/>
           <p:nvPr/>
         </p:nvSpPr>
@@ -2538,7 +2538,7 @@
       </p:sp>
       <p:sp>
         <p:nvSpPr>
-          <p:cNvPr id="48" name="Shape 46"/>
+          <p:cNvPr id="48" name="Partial Circle 47"/>
           <p:cNvSpPr/>
           <p:nvPr/>
         </p:nvSpPr>
@@ -2566,7 +2566,7 @@
       </p:sp>
       <p:sp>
         <p:nvSpPr>
-          <p:cNvPr id="49" name="Text 47"/>
+          <p:cNvPr id="49" name="TextBox 48"/>
           <p:cNvSpPr txBox="1"/>
           <p:nvPr/>
         </p:nvSpPr>
@@ -2661,7 +2661,7 @@
       </p:sp>
       <p:sp>
         <p:nvSpPr>
-          <p:cNvPr id="50" name="Shape 48"/>
+          <p:cNvPr id="50" name="Straight Connector 49"/>
           <p:cNvSpPr/>
           <p:nvPr/>
         </p:nvSpPr>
@@ -2684,7 +2684,7 @@
       </p:sp>
       <p:sp>
         <p:nvSpPr>
-          <p:cNvPr id="51" name="Shape 49"/>
+          <p:cNvPr id="51" name="Rectangle 50"/>
           <p:cNvSpPr/>
           <p:nvPr/>
         </p:nvSpPr>
@@ -2709,7 +2709,7 @@
       </p:sp>
       <p:sp>
         <p:nvSpPr>
-          <p:cNvPr id="52" name="Text 50"/>
+          <p:cNvPr id="52" name="TextBox 51"/>
           <p:cNvSpPr txBox="1"/>
           <p:nvPr/>
         </p:nvSpPr>
@@ -2765,7 +2765,7 @@
       </p:sp>
       <p:sp>
         <p:nvSpPr>
-          <p:cNvPr id="53" name="Shape 51"/>
+          <p:cNvPr id="53" name="Oval 52"/>
           <p:cNvSpPr/>
           <p:nvPr/>
         </p:nvSpPr>
@@ -2790,7 +2790,7 @@
       </p:sp>
       <p:sp>
         <p:nvSpPr>
-          <p:cNvPr id="54" name="Shape 52"/>
+          <p:cNvPr id="54" name="Partial Circle 53"/>
           <p:cNvSpPr/>
           <p:nvPr/>
         </p:nvSpPr>
@@ -2818,7 +2818,7 @@
       </p:sp>
       <p:sp>
         <p:nvSpPr>
-          <p:cNvPr id="55" name="Shape 53"/>
+          <p:cNvPr id="55" name="Oval 54"/>
           <p:cNvSpPr/>
           <p:nvPr/>
         </p:nvSpPr>
@@ -2843,7 +2843,7 @@
       </p:sp>
       <p:sp>
         <p:nvSpPr>
-          <p:cNvPr id="56" name="Shape 54"/>
+          <p:cNvPr id="56" name="Oval 55"/>
           <p:cNvSpPr/>
           <p:nvPr/>
         </p:nvSpPr>
@@ -2868,7 +2868,7 @@
       </p:sp>
       <p:sp>
         <p:nvSpPr>
-          <p:cNvPr id="57" name="Shape 55"/>
+          <p:cNvPr id="57" name="Partial Circle 56"/>
           <p:cNvSpPr/>
           <p:nvPr/>
         </p:nvSpPr>
@@ -2896,7 +2896,7 @@
       </p:sp>
       <p:sp>
         <p:nvSpPr>
-          <p:cNvPr id="58" name="Text 56"/>
+          <p:cNvPr id="58" name="TextBox 57"/>
           <p:cNvSpPr txBox="1"/>
           <p:nvPr/>
         </p:nvSpPr>
@@ -2935,7 +2935,7 @@
       </p:sp>
       <p:sp>
         <p:nvSpPr>
-          <p:cNvPr id="59" name="Shape 57"/>
+          <p:cNvPr id="59" name="Straight Connector 58"/>
           <p:cNvSpPr/>
           <p:nvPr/>
         </p:nvSpPr>
@@ -2958,7 +2958,7 @@
       </p:sp>
       <p:sp>
         <p:nvSpPr>
-          <p:cNvPr id="60" name="Shape 58"/>
+          <p:cNvPr id="60" name="Rectangle 59"/>
           <p:cNvSpPr/>
           <p:nvPr/>
         </p:nvSpPr>
@@ -2983,7 +2983,7 @@
       </p:sp>
       <p:sp>
         <p:nvSpPr>
-          <p:cNvPr id="61" name="Text 59"/>
+          <p:cNvPr id="61" name="TextBox 60"/>
           <p:cNvSpPr txBox="1"/>
           <p:nvPr/>
         </p:nvSpPr>
@@ -3039,7 +3039,7 @@
       </p:sp>
       <p:sp>
         <p:nvSpPr>
-          <p:cNvPr id="62" name="Shape 60"/>
+          <p:cNvPr id="62" name="Oval 61"/>
           <p:cNvSpPr/>
           <p:nvPr/>
         </p:nvSpPr>
@@ -3064,7 +3064,7 @@
       </p:sp>
       <p:sp>
         <p:nvSpPr>
-          <p:cNvPr id="63" name="Shape 61"/>
+          <p:cNvPr id="63" name="Partial Circle 62"/>
           <p:cNvSpPr/>
           <p:nvPr/>
         </p:nvSpPr>
@@ -3092,7 +3092,7 @@
       </p:sp>
       <p:sp>
         <p:nvSpPr>
-          <p:cNvPr id="64" name="Shape 62"/>
+          <p:cNvPr id="64" name="Oval 63"/>
           <p:cNvSpPr/>
           <p:nvPr/>
         </p:nvSpPr>
@@ -3117,7 +3117,7 @@
       </p:sp>
       <p:sp>
         <p:nvSpPr>
-          <p:cNvPr id="65" name="Shape 63"/>
+          <p:cNvPr id="65" name="Oval 64"/>
           <p:cNvSpPr/>
           <p:nvPr/>
         </p:nvSpPr>
@@ -3142,7 +3142,7 @@
       </p:sp>
       <p:sp>
         <p:nvSpPr>
-          <p:cNvPr id="66" name="Shape 64"/>
+          <p:cNvPr id="66" name="Partial Circle 65"/>
           <p:cNvSpPr/>
           <p:nvPr/>
         </p:nvSpPr>
@@ -3170,7 +3170,7 @@
       </p:sp>
       <p:sp>
         <p:nvSpPr>
-          <p:cNvPr id="67" name="Text 65"/>
+          <p:cNvPr id="67" name="TextBox 66"/>
           <p:cNvSpPr txBox="1"/>
           <p:nvPr/>
         </p:nvSpPr>
@@ -3265,7 +3265,7 @@
       </p:sp>
       <p:sp>
         <p:nvSpPr>
-          <p:cNvPr id="68" name="Shape 66"/>
+          <p:cNvPr id="68" name="Straight Connector 67"/>
           <p:cNvSpPr/>
           <p:nvPr/>
         </p:nvSpPr>
@@ -3288,7 +3288,7 @@
       </p:sp>
       <p:sp>
         <p:nvSpPr>
-          <p:cNvPr id="69" name="Shape 67"/>
+          <p:cNvPr id="69" name="Rectangle 68"/>
           <p:cNvSpPr/>
           <p:nvPr/>
         </p:nvSpPr>
@@ -3313,7 +3313,7 @@
       </p:sp>
       <p:sp>
         <p:nvSpPr>
-          <p:cNvPr id="70" name="Text 68"/>
+          <p:cNvPr id="70" name="TextBox 69"/>
           <p:cNvSpPr txBox="1"/>
           <p:nvPr/>
         </p:nvSpPr>
@@ -3369,7 +3369,7 @@
       </p:sp>
       <p:sp>
         <p:nvSpPr>
-          <p:cNvPr id="71" name="Shape 69"/>
+          <p:cNvPr id="71" name="Oval 70"/>
           <p:cNvSpPr/>
           <p:nvPr/>
         </p:nvSpPr>
@@ -3394,7 +3394,7 @@
       </p:sp>
       <p:sp>
         <p:nvSpPr>
-          <p:cNvPr id="72" name="Shape 70"/>
+          <p:cNvPr id="72" name="Partial Circle 71"/>
           <p:cNvSpPr/>
           <p:nvPr/>
         </p:nvSpPr>
@@ -3422,7 +3422,7 @@
       </p:sp>
       <p:sp>
         <p:nvSpPr>
-          <p:cNvPr id="73" name="Shape 71"/>
+          <p:cNvPr id="73" name="Oval 72"/>
           <p:cNvSpPr/>
           <p:nvPr/>
         </p:nvSpPr>
@@ -3447,7 +3447,7 @@
       </p:sp>
       <p:sp>
         <p:nvSpPr>
-          <p:cNvPr id="74" name="Shape 72"/>
+          <p:cNvPr id="74" name="Partial Circle 73"/>
           <p:cNvSpPr/>
           <p:nvPr/>
         </p:nvSpPr>
@@ -3475,7 +3475,7 @@
       </p:sp>
       <p:sp>
         <p:nvSpPr>
-          <p:cNvPr id="75" name="Shape 73"/>
+          <p:cNvPr id="75" name="Oval 74"/>
           <p:cNvSpPr/>
           <p:nvPr/>
         </p:nvSpPr>
@@ -3500,7 +3500,7 @@
       </p:sp>
       <p:sp>
         <p:nvSpPr>
-          <p:cNvPr id="76" name="Text 74"/>
+          <p:cNvPr id="76" name="TextBox 75"/>
           <p:cNvSpPr txBox="1"/>
           <p:nvPr/>
         </p:nvSpPr>
@@ -3531,7 +3531,7 @@
                 <a:ea typeface="Arial" pitchFamily="34" charset="-122"/>
                 <a:cs typeface="Arial" pitchFamily="34" charset="-120"/>
               </a:rPr>
-              <a:t>In/out $/1M: K3 </a:t>
+              <a:t>K3 </a:t>
             </a:r>
             <a:pPr indent="0" marL="0">
               <a:buNone/>
@@ -3563,11 +3563,28 @@
             </a:r>
             <a:endParaRPr lang="en-US" sz="900" dirty="0"/>
           </a:p>
-        </p:txBody>
-      </p:sp>
-      <p:sp>
-        <p:nvSpPr>
-          <p:cNvPr id="77" name="Shape 75"/>
+          <a:p>
+            <a:pPr indent="0" marL="0">
+              <a:buNone/>
+            </a:pPr>
+            <a:r>
+              <a:rPr lang="en-US" sz="900" dirty="0">
+                <a:solidFill>
+                  <a:srgbClr val="1F2A37"/>
+                </a:solidFill>
+                <a:latin typeface="Arial" pitchFamily="34" charset="0"/>
+                <a:ea typeface="Arial" pitchFamily="34" charset="-122"/>
+                <a:cs typeface="Arial" pitchFamily="34" charset="-120"/>
+              </a:rPr>
+              <a:t>List price per 1M tokens, input/output</a:t>
+            </a:r>
+            <a:endParaRPr lang="en-US" sz="900" dirty="0"/>
+          </a:p>
+        </p:txBody>
+      </p:sp>
+      <p:sp>
+        <p:nvSpPr>
+          <p:cNvPr id="77" name="Straight Connector 76"/>
           <p:cNvSpPr/>
           <p:nvPr/>
         </p:nvSpPr>
@@ -3590,7 +3607,7 @@
       </p:sp>
       <p:sp>
         <p:nvSpPr>
-          <p:cNvPr id="78" name="Shape 76"/>
+          <p:cNvPr id="78" name="Rectangle 77"/>
           <p:cNvSpPr/>
           <p:nvPr/>
         </p:nvSpPr>
@@ -3615,7 +3632,7 @@
       </p:sp>
       <p:sp>
         <p:nvSpPr>
-          <p:cNvPr id="79" name="Text 77"/>
+          <p:cNvPr id="79" name="TextBox 78"/>
           <p:cNvSpPr txBox="1"/>
           <p:nvPr/>
         </p:nvSpPr>
@@ -3671,7 +3688,7 @@
       </p:sp>
       <p:sp>
         <p:nvSpPr>
-          <p:cNvPr id="80" name="Text 78"/>
+          <p:cNvPr id="80" name="TextBox 79"/>
           <p:cNvSpPr txBox="1"/>
           <p:nvPr/>
         </p:nvSpPr>
@@ -3710,7 +3727,7 @@
       </p:sp>
       <p:sp>
         <p:nvSpPr>
-          <p:cNvPr id="81" name="Text 79"/>
+          <p:cNvPr id="81" name="TextBox 80"/>
           <p:cNvSpPr txBox="1"/>
           <p:nvPr/>
         </p:nvSpPr>
@@ -3749,7 +3766,7 @@
       </p:sp>
       <p:sp>
         <p:nvSpPr>
-          <p:cNvPr id="82" name="Shape 80"/>
+          <p:cNvPr id="82" name="Oval 81"/>
           <p:cNvSpPr/>
           <p:nvPr/>
         </p:nvSpPr>
@@ -3774,7 +3791,7 @@
       </p:sp>
       <p:sp>
         <p:nvSpPr>
-          <p:cNvPr id="83" name="Text 81"/>
+          <p:cNvPr id="83" name="TextBox 82"/>
           <p:cNvSpPr txBox="1"/>
           <p:nvPr/>
         </p:nvSpPr>
@@ -3813,7 +3830,7 @@
       </p:sp>
       <p:sp>
         <p:nvSpPr>
-          <p:cNvPr id="84" name="Shape 82"/>
+          <p:cNvPr id="84" name="Straight Connector 83"/>
           <p:cNvSpPr/>
           <p:nvPr/>
         </p:nvSpPr>
@@ -3836,7 +3853,7 @@
       </p:sp>
       <p:sp>
         <p:nvSpPr>
-          <p:cNvPr id="85" name="Text 83"/>
+          <p:cNvPr id="85" name="TextBox 84"/>
           <p:cNvSpPr txBox="1"/>
           <p:nvPr/>
         </p:nvSpPr>
@@ -3875,7 +3892,7 @@
       </p:sp>
       <p:sp>
         <p:nvSpPr>
-          <p:cNvPr id="86" name="Shape 84"/>
+          <p:cNvPr id="86" name="Straight Connector 85"/>
           <p:cNvSpPr/>
           <p:nvPr/>
         </p:nvSpPr>
@@ -3898,7 +3915,7 @@
       </p:sp>
       <p:sp>
         <p:nvSpPr>
-          <p:cNvPr id="87" name="Text 85"/>
+          <p:cNvPr id="87" name="TextBox 86"/>
           <p:cNvSpPr txBox="1"/>
           <p:nvPr/>
         </p:nvSpPr>
@@ -3954,7 +3971,7 @@
       </p:sp>
       <p:sp>
         <p:nvSpPr>
-          <p:cNvPr id="88" name="Text 86"/>
+          <p:cNvPr id="88" name="TextBox 87"/>
           <p:cNvSpPr txBox="1"/>
           <p:nvPr/>
         </p:nvSpPr>
@@ -4010,7 +4027,7 @@
       </p:sp>
       <p:sp>
         <p:nvSpPr>
-          <p:cNvPr id="89" name="Text 87"/>
+          <p:cNvPr id="89" name="TextBox 88"/>
           <p:cNvSpPr txBox="1"/>
           <p:nvPr/>
         </p:nvSpPr>
@@ -4066,7 +4083,7 @@
       </p:sp>
       <p:sp>
         <p:nvSpPr>
-          <p:cNvPr id="90" name="Text 88"/>
+          <p:cNvPr id="90" name="TextBox 89"/>
           <p:cNvSpPr txBox="1"/>
           <p:nvPr/>
         </p:nvSpPr>
@@ -4122,7 +4139,7 @@
       </p:sp>
       <p:sp>
         <p:nvSpPr>
-          <p:cNvPr id="91" name="Shape 89"/>
+          <p:cNvPr id="91" name="Straight Connector 90"/>
           <p:cNvSpPr/>
           <p:nvPr/>
         </p:nvSpPr>
@@ -4145,7 +4162,7 @@
       </p:sp>
       <p:sp>
         <p:nvSpPr>
-          <p:cNvPr id="92" name="Text 90"/>
+          <p:cNvPr id="92" name="TextBox 91"/>
           <p:cNvSpPr txBox="1"/>
           <p:nvPr/>
         </p:nvSpPr>
@@ -4184,7 +4201,7 @@
       </p:sp>
       <p:sp>
         <p:nvSpPr>
-          <p:cNvPr id="93" name="Text 91"/>
+          <p:cNvPr id="93" name="TextBox 92"/>
           <p:cNvSpPr txBox="1"/>
           <p:nvPr/>
         </p:nvSpPr>
@@ -4223,7 +4240,7 @@
       </p:sp>
       <p:sp>
         <p:nvSpPr>
-          <p:cNvPr id="94" name="Text 92"/>
+          <p:cNvPr id="94" name="TextBox 93"/>
           <p:cNvSpPr txBox="1"/>
           <p:nvPr/>
         </p:nvSpPr>
@@ -4262,7 +4279,7 @@
       </p:sp>
       <p:sp>
         <p:nvSpPr>
-          <p:cNvPr id="95" name="Text 93"/>
+          <p:cNvPr id="95" name="TextBox 94"/>
           <p:cNvSpPr txBox="1"/>
           <p:nvPr/>
         </p:nvSpPr>
@@ -4301,7 +4318,7 @@
       </p:sp>
       <p:sp>
         <p:nvSpPr>
-          <p:cNvPr id="96" name="Shape 94"/>
+          <p:cNvPr id="96" name="Straight Connector 95"/>
           <p:cNvSpPr/>
           <p:nvPr/>
         </p:nvSpPr>
@@ -4324,7 +4341,7 @@
       </p:sp>
       <p:sp>
         <p:nvSpPr>
-          <p:cNvPr id="97" name="Shape 95"/>
+          <p:cNvPr id="97" name="Rectangle 96"/>
           <p:cNvSpPr/>
           <p:nvPr/>
         </p:nvSpPr>
@@ -4349,7 +4366,7 @@
       </p:sp>
       <p:sp>
         <p:nvSpPr>
-          <p:cNvPr id="98" name="Text 96"/>
+          <p:cNvPr id="98" name="TextBox 97"/>
           <p:cNvSpPr txBox="1"/>
           <p:nvPr/>
         </p:nvSpPr>
@@ -4388,7 +4405,7 @@
       </p:sp>
       <p:sp>
         <p:nvSpPr>
-          <p:cNvPr id="99" name="Text 97"/>
+          <p:cNvPr id="99" name="TextBox 98"/>
           <p:cNvSpPr txBox="1"/>
           <p:nvPr/>
         </p:nvSpPr>
@@ -4427,7 +4444,7 @@
       </p:sp>
       <p:sp>
         <p:nvSpPr>
-          <p:cNvPr id="100" name="Text 98"/>
+          <p:cNvPr id="100" name="TextBox 99"/>
           <p:cNvSpPr txBox="1"/>
           <p:nvPr/>
         </p:nvSpPr>
@@ -4466,7 +4483,7 @@
       </p:sp>
       <p:sp>
         <p:nvSpPr>
-          <p:cNvPr id="101" name="Text 99"/>
+          <p:cNvPr id="101" name="TextBox 100"/>
           <p:cNvSpPr txBox="1"/>
           <p:nvPr/>
         </p:nvSpPr>
@@ -4505,7 +4522,7 @@
       </p:sp>
       <p:sp>
         <p:nvSpPr>
-          <p:cNvPr id="102" name="Shape 100"/>
+          <p:cNvPr id="102" name="Straight Connector 101"/>
           <p:cNvSpPr/>
           <p:nvPr/>
         </p:nvSpPr>
@@ -4528,7 +4545,7 @@
       </p:sp>
       <p:sp>
         <p:nvSpPr>
-          <p:cNvPr id="103" name="Shape 101"/>
+          <p:cNvPr id="103" name="Rectangle 102"/>
           <p:cNvSpPr/>
           <p:nvPr/>
         </p:nvSpPr>
@@ -4553,7 +4570,7 @@
       </p:sp>
       <p:sp>
         <p:nvSpPr>
-          <p:cNvPr id="104" name="Text 102"/>
+          <p:cNvPr id="104" name="TextBox 103"/>
           <p:cNvSpPr txBox="1"/>
           <p:nvPr/>
         </p:nvSpPr>
@@ -4592,7 +4609,7 @@
       </p:sp>
       <p:sp>
         <p:nvSpPr>
-          <p:cNvPr id="105" name="Text 103"/>
+          <p:cNvPr id="105" name="TextBox 104"/>
           <p:cNvSpPr txBox="1"/>
           <p:nvPr/>
         </p:nvSpPr>
@@ -4631,7 +4648,7 @@
       </p:sp>
       <p:sp>
         <p:nvSpPr>
-          <p:cNvPr id="106" name="Text 104"/>
+          <p:cNvPr id="106" name="TextBox 105"/>
           <p:cNvSpPr txBox="1"/>
           <p:nvPr/>
         </p:nvSpPr>
@@ -4670,7 +4687,7 @@
       </p:sp>
       <p:sp>
         <p:nvSpPr>
-          <p:cNvPr id="107" name="Text 105"/>
+          <p:cNvPr id="107" name="TextBox 106"/>
           <p:cNvSpPr txBox="1"/>
           <p:nvPr/>
         </p:nvSpPr>
@@ -4709,7 +4726,7 @@
       </p:sp>
       <p:sp>
         <p:nvSpPr>
-          <p:cNvPr id="108" name="Shape 106"/>
+          <p:cNvPr id="108" name="Straight Connector 107"/>
           <p:cNvSpPr/>
           <p:nvPr/>
         </p:nvSpPr>
@@ -4732,7 +4749,7 @@
       </p:sp>
       <p:sp>
         <p:nvSpPr>
-          <p:cNvPr id="109" name="Shape 107"/>
+          <p:cNvPr id="109" name="Rectangle 108"/>
           <p:cNvSpPr/>
           <p:nvPr/>
         </p:nvSpPr>
@@ -4757,7 +4774,7 @@
       </p:sp>
       <p:sp>
         <p:nvSpPr>
-          <p:cNvPr id="110" name="Text 108"/>
+          <p:cNvPr id="110" name="TextBox 109"/>
           <p:cNvSpPr txBox="1"/>
           <p:nvPr/>
         </p:nvSpPr>
@@ -4796,7 +4813,7 @@
       </p:sp>
       <p:sp>
         <p:nvSpPr>
-          <p:cNvPr id="111" name="Text 109"/>
+          <p:cNvPr id="111" name="TextBox 110"/>
           <p:cNvSpPr txBox="1"/>
           <p:nvPr/>
         </p:nvSpPr>
@@ -4835,7 +4852,7 @@
       </p:sp>
       <p:sp>
         <p:nvSpPr>
-          <p:cNvPr id="112" name="Text 110"/>
+          <p:cNvPr id="112" name="TextBox 111"/>
           <p:cNvSpPr txBox="1"/>
           <p:nvPr/>
         </p:nvSpPr>
@@ -4874,7 +4891,7 @@
       </p:sp>
       <p:sp>
         <p:nvSpPr>
-          <p:cNvPr id="113" name="Text 111"/>
+          <p:cNvPr id="113" name="TextBox 112"/>
           <p:cNvSpPr txBox="1"/>
           <p:nvPr/>
         </p:nvSpPr>
@@ -4913,7 +4930,7 @@
       </p:sp>
       <p:sp>
         <p:nvSpPr>
-          <p:cNvPr id="114" name="Shape 112"/>
+          <p:cNvPr id="114" name="Straight Connector 113"/>
           <p:cNvSpPr/>
           <p:nvPr/>
         </p:nvSpPr>
@@ -4936,7 +4953,7 @@
       </p:sp>
       <p:sp>
         <p:nvSpPr>
-          <p:cNvPr id="115" name="Text 113"/>
+          <p:cNvPr id="115" name="TextBox 114"/>
           <p:cNvSpPr txBox="1"/>
           <p:nvPr/>
         </p:nvSpPr>
@@ -4975,7 +4992,7 @@
       </p:sp>
       <p:sp>
         <p:nvSpPr>
-          <p:cNvPr id="116" name="Text 114"/>
+          <p:cNvPr id="116" name="TextBox 115"/>
           <p:cNvSpPr txBox="1"/>
           <p:nvPr/>
         </p:nvSpPr>
@@ -5014,7 +5031,7 @@
       </p:sp>
       <p:sp>
         <p:nvSpPr>
-          <p:cNvPr id="117" name="Text 115"/>
+          <p:cNvPr id="117" name="TextBox 116"/>
           <p:cNvSpPr txBox="1"/>
           <p:nvPr/>
         </p:nvSpPr>
@@ -5053,7 +5070,7 @@
       </p:sp>
       <p:sp>
         <p:nvSpPr>
-          <p:cNvPr id="118" name="Text 116"/>
+          <p:cNvPr id="118" name="TextBox 117"/>
           <p:cNvSpPr txBox="1"/>
           <p:nvPr/>
         </p:nvSpPr>
@@ -5092,7 +5109,7 @@
       </p:sp>
       <p:sp>
         <p:nvSpPr>
-          <p:cNvPr id="119" name="Shape 117"/>
+          <p:cNvPr id="119" name="Straight Connector 118"/>
           <p:cNvSpPr/>
           <p:nvPr/>
         </p:nvSpPr>
@@ -5115,7 +5132,7 @@
       </p:sp>
       <p:sp>
         <p:nvSpPr>
-          <p:cNvPr id="120" name="Text 118"/>
+          <p:cNvPr id="120" name="TextBox 119"/>
           <p:cNvSpPr txBox="1"/>
           <p:nvPr/>
         </p:nvSpPr>
@@ -5154,7 +5171,7 @@
       </p:sp>
       <p:sp>
         <p:nvSpPr>
-          <p:cNvPr id="121" name="Text 119"/>
+          <p:cNvPr id="121" name="TextBox 120"/>
           <p:cNvSpPr txBox="1"/>
           <p:nvPr/>
         </p:nvSpPr>
@@ -5193,7 +5210,7 @@
       </p:sp>
       <p:sp>
         <p:nvSpPr>
-          <p:cNvPr id="122" name="Text 120"/>
+          <p:cNvPr id="122" name="TextBox 121"/>
           <p:cNvSpPr txBox="1"/>
           <p:nvPr/>
         </p:nvSpPr>
@@ -5232,7 +5249,7 @@
       </p:sp>
       <p:sp>
         <p:nvSpPr>
-          <p:cNvPr id="123" name="Text 121"/>
+          <p:cNvPr id="123" name="TextBox 122"/>
           <p:cNvSpPr txBox="1"/>
           <p:nvPr/>
         </p:nvSpPr>
@@ -5271,7 +5288,7 @@
       </p:sp>
       <p:sp>
         <p:nvSpPr>
-          <p:cNvPr id="124" name="Shape 122"/>
+          <p:cNvPr id="124" name="Straight Connector 123"/>
           <p:cNvSpPr/>
           <p:nvPr/>
         </p:nvSpPr>
@@ -5294,7 +5311,7 @@
       </p:sp>
       <p:sp>
         <p:nvSpPr>
-          <p:cNvPr id="125" name="Shape 123"/>
+          <p:cNvPr id="125" name="Rectangle 124"/>
           <p:cNvSpPr/>
           <p:nvPr/>
         </p:nvSpPr>
@@ -5319,7 +5336,7 @@
       </p:sp>
       <p:sp>
         <p:nvSpPr>
-          <p:cNvPr id="126" name="Text 124"/>
+          <p:cNvPr id="126" name="TextBox 125"/>
           <p:cNvSpPr txBox="1"/>
           <p:nvPr/>
         </p:nvSpPr>
@@ -5372,7 +5389,7 @@
       </p:sp>
       <p:sp>
         <p:nvSpPr>
-          <p:cNvPr id="127" name="Text 125"/>
+          <p:cNvPr id="127" name="TextBox 126"/>
           <p:cNvSpPr txBox="1"/>
           <p:nvPr/>
         </p:nvSpPr>
@@ -5411,7 +5428,7 @@
       </p:sp>
       <p:sp>
         <p:nvSpPr>
-          <p:cNvPr id="128" name="Text 126"/>
+          <p:cNvPr id="128" name="TextBox 127"/>
           <p:cNvSpPr txBox="1"/>
           <p:nvPr/>
         </p:nvSpPr>
@@ -5450,7 +5467,7 @@
       </p:sp>
       <p:sp>
         <p:nvSpPr>
-          <p:cNvPr id="129" name="Text 127"/>
+          <p:cNvPr id="129" name="TextBox 128"/>
           <p:cNvSpPr txBox="1"/>
           <p:nvPr/>
         </p:nvSpPr>
@@ -5489,7 +5506,7 @@
       </p:sp>
       <p:sp>
         <p:nvSpPr>
-          <p:cNvPr id="130" name="Shape 128"/>
+          <p:cNvPr id="130" name="Straight Connector 129"/>
           <p:cNvSpPr/>
           <p:nvPr/>
         </p:nvSpPr>
@@ -5512,7 +5529,7 @@
       </p:sp>
       <p:sp>
         <p:nvSpPr>
-          <p:cNvPr id="131" name="Text 129"/>
+          <p:cNvPr id="131" name="TextBox 130"/>
           <p:cNvSpPr txBox="1"/>
           <p:nvPr/>
         </p:nvSpPr>
@@ -5551,22 +5568,20 @@
       </p:sp>
       <p:sp>
         <p:nvSpPr>
-          <p:cNvPr id="132" name="Shape 130"/>
+          <p:cNvPr id="132" name="Straight Connector 131"/>
           <p:cNvSpPr/>
           <p:nvPr/>
         </p:nvSpPr>
         <p:spPr>
           <a:xfrm>
             <a:off x="8229600" y="4663440"/>
-            <a:ext cx="3550615" cy="1463040"/>
-          </a:xfrm>
-          <a:prstGeom prst="rect">
-            <a:avLst/>
-          </a:prstGeom>
-          <a:solidFill>
-            <a:srgbClr val="041E42"/>
-          </a:solidFill>
-          <a:ln w="12700">
+            <a:ext cx="3550615" cy="0"/>
+          </a:xfrm>
+          <a:prstGeom prst="line">
+            <a:avLst/>
+          </a:prstGeom>
+          <a:noFill/>
+          <a:ln w="9525">
             <a:solidFill>
               <a:srgbClr val="041E42"/>
             </a:solidFill>
@@ -5576,32 +5591,133 @@
       </p:sp>
       <p:sp>
         <p:nvSpPr>
-          <p:cNvPr id="133" name="Text 131"/>
-          <p:cNvSpPr txBox="1"/>
-          <p:nvPr/>
-        </p:nvSpPr>
-        <p:spPr>
-          <a:xfrm>
-            <a:off x="8394192" y="4791456"/>
-            <a:ext cx="1828800" cy="182880"/>
-          </a:xfrm>
-          <a:prstGeom prst="rect">
-            <a:avLst/>
-          </a:prstGeom>
-          <a:noFill/>
-          <a:ln/>
-        </p:spPr>
-        <p:txBody>
-          <a:bodyPr wrap="square" lIns="0" tIns="0" rIns="0" bIns="0" rtlCol="0" anchor="t"/>
-          <a:lstStyle/>
-          <a:p>
-            <a:pPr indent="0" marL="0">
-              <a:buNone/>
-            </a:pPr>
-            <a:r>
-              <a:rPr lang="en-US" sz="1050" b="1" dirty="0">
-                <a:solidFill>
-                  <a:srgbClr val="FFFFFF"/>
+          <p:cNvPr id="133" name="TextBox 132"/>
+          <p:cNvSpPr txBox="1"/>
+          <p:nvPr/>
+        </p:nvSpPr>
+        <p:spPr>
+          <a:xfrm>
+            <a:off x="8229600" y="4663440"/>
+            <a:ext cx="1024128" cy="292608"/>
+          </a:xfrm>
+          <a:prstGeom prst="rect">
+            <a:avLst/>
+          </a:prstGeom>
+          <a:noFill/>
+          <a:ln/>
+        </p:spPr>
+        <p:txBody>
+          <a:bodyPr wrap="square" lIns="0" tIns="0" rIns="0" bIns="0" rtlCol="0" anchor="ctr"/>
+          <a:lstStyle/>
+          <a:p>
+            <a:pPr indent="0" marL="0">
+              <a:buNone/>
+            </a:pPr>
+            <a:r>
+              <a:rPr lang="en-US" sz="1000" b="1" dirty="0">
+                <a:solidFill>
+                  <a:srgbClr val="041E42"/>
+                </a:solidFill>
+                <a:latin typeface="Arial" pitchFamily="34" charset="0"/>
+                <a:ea typeface="Arial" pitchFamily="34" charset="-122"/>
+                <a:cs typeface="Arial" pitchFamily="34" charset="-120"/>
+              </a:rPr>
+              <a:t>Model</a:t>
+            </a:r>
+            <a:endParaRPr lang="en-US" sz="1000" dirty="0"/>
+          </a:p>
+        </p:txBody>
+      </p:sp>
+      <p:sp>
+        <p:nvSpPr>
+          <p:cNvPr id="134" name="TextBox 133"/>
+          <p:cNvSpPr txBox="1"/>
+          <p:nvPr/>
+        </p:nvSpPr>
+        <p:spPr>
+          <a:xfrm>
+            <a:off x="9253728" y="4663440"/>
+            <a:ext cx="2526487" cy="292608"/>
+          </a:xfrm>
+          <a:prstGeom prst="rect">
+            <a:avLst/>
+          </a:prstGeom>
+          <a:noFill/>
+          <a:ln/>
+        </p:spPr>
+        <p:txBody>
+          <a:bodyPr wrap="square" lIns="0" tIns="0" rIns="0" bIns="0" rtlCol="0" anchor="ctr"/>
+          <a:lstStyle/>
+          <a:p>
+            <a:pPr indent="0" marL="0">
+              <a:buNone/>
+            </a:pPr>
+            <a:r>
+              <a:rPr lang="en-US" sz="1000" b="1" dirty="0">
+                <a:solidFill>
+                  <a:srgbClr val="041E42"/>
+                </a:solidFill>
+                <a:latin typeface="Arial" pitchFamily="34" charset="0"/>
+                <a:ea typeface="Arial" pitchFamily="34" charset="-122"/>
+                <a:cs typeface="Arial" pitchFamily="34" charset="-120"/>
+              </a:rPr>
+              <a:t>Use for</a:t>
+            </a:r>
+            <a:endParaRPr lang="en-US" sz="1000" dirty="0"/>
+          </a:p>
+        </p:txBody>
+      </p:sp>
+      <p:sp>
+        <p:nvSpPr>
+          <p:cNvPr id="135" name="Straight Connector 134"/>
+          <p:cNvSpPr/>
+          <p:nvPr/>
+        </p:nvSpPr>
+        <p:spPr>
+          <a:xfrm>
+            <a:off x="8229600" y="4956048"/>
+            <a:ext cx="3550615" cy="0"/>
+          </a:xfrm>
+          <a:prstGeom prst="line">
+            <a:avLst/>
+          </a:prstGeom>
+          <a:noFill/>
+          <a:ln w="9525">
+            <a:solidFill>
+              <a:srgbClr val="C9D0D9"/>
+            </a:solidFill>
+            <a:prstDash val="solid"/>
+          </a:ln>
+        </p:spPr>
+      </p:sp>
+      <p:sp>
+        <p:nvSpPr>
+          <p:cNvPr id="136" name="TextBox 135"/>
+          <p:cNvSpPr txBox="1"/>
+          <p:nvPr/>
+        </p:nvSpPr>
+        <p:spPr>
+          <a:xfrm>
+            <a:off x="8229600" y="4956048"/>
+            <a:ext cx="1024128" cy="390144"/>
+          </a:xfrm>
+          <a:prstGeom prst="rect">
+            <a:avLst/>
+          </a:prstGeom>
+          <a:noFill/>
+          <a:ln/>
+        </p:spPr>
+        <p:txBody>
+          <a:bodyPr wrap="square" lIns="0" tIns="0" rIns="0" bIns="0" rtlCol="0" anchor="ctr"/>
+          <a:lstStyle/>
+          <a:p>
+            <a:pPr indent="0" marL="0">
+              <a:buNone/>
+            </a:pPr>
+            <a:r>
+              <a:rPr lang="en-US" sz="900" b="1" dirty="0">
+                <a:solidFill>
+                  <a:srgbClr val="1F2A37"/>
                 </a:solidFill>
                 <a:latin typeface="Arial" pitchFamily="34" charset="0"/>
                 <a:ea typeface="Arial" pitchFamily="34" charset="-122"/>
@@ -5609,68 +5725,29 @@
               </a:rPr>
               <a:t>Opus 5.5</a:t>
             </a:r>
-            <a:endParaRPr lang="en-US" sz="1050" dirty="0"/>
-          </a:p>
-        </p:txBody>
-      </p:sp>
-      <p:sp>
-        <p:nvSpPr>
-          <p:cNvPr id="134" name="Text 132"/>
-          <p:cNvSpPr txBox="1"/>
-          <p:nvPr/>
-        </p:nvSpPr>
-        <p:spPr>
-          <a:xfrm>
-            <a:off x="10335463" y="4809744"/>
-            <a:ext cx="1280160" cy="164592"/>
-          </a:xfrm>
-          <a:prstGeom prst="rect">
-            <a:avLst/>
-          </a:prstGeom>
-          <a:noFill/>
-          <a:ln/>
-        </p:spPr>
-        <p:txBody>
-          <a:bodyPr wrap="square" lIns="0" tIns="0" rIns="0" bIns="0" rtlCol="0" anchor="t"/>
-          <a:lstStyle/>
-          <a:p>
-            <a:pPr algn="r" indent="0" marL="0">
-              <a:buNone/>
-            </a:pPr>
-            <a:r>
-              <a:rPr lang="en-US" sz="750" b="1" spc="100" kern="0" dirty="0">
-                <a:solidFill>
-                  <a:srgbClr val="A9BBD3"/>
-                </a:solidFill>
-                <a:latin typeface="Arial" pitchFamily="34" charset="0"/>
-                <a:ea typeface="Arial" pitchFamily="34" charset="-122"/>
-                <a:cs typeface="Arial" pitchFamily="34" charset="-120"/>
-              </a:rPr>
-              <a:t>DEFAULT</a:t>
-            </a:r>
-            <a:endParaRPr lang="en-US" sz="750" dirty="0"/>
-          </a:p>
-        </p:txBody>
-      </p:sp>
-      <p:sp>
-        <p:nvSpPr>
-          <p:cNvPr id="135" name="Text 133"/>
-          <p:cNvSpPr txBox="1"/>
-          <p:nvPr/>
-        </p:nvSpPr>
-        <p:spPr>
-          <a:xfrm>
-            <a:off x="8394192" y="4992624"/>
-            <a:ext cx="3221431" cy="164592"/>
-          </a:xfrm>
-          <a:prstGeom prst="rect">
-            <a:avLst/>
-          </a:prstGeom>
-          <a:noFill/>
-          <a:ln/>
-        </p:spPr>
-        <p:txBody>
-          <a:bodyPr wrap="square" lIns="0" tIns="0" rIns="0" bIns="0" rtlCol="0" anchor="t"/>
+            <a:endParaRPr lang="en-US" sz="900" dirty="0"/>
+          </a:p>
+        </p:txBody>
+      </p:sp>
+      <p:sp>
+        <p:nvSpPr>
+          <p:cNvPr id="137" name="TextBox 136"/>
+          <p:cNvSpPr txBox="1"/>
+          <p:nvPr/>
+        </p:nvSpPr>
+        <p:spPr>
+          <a:xfrm>
+            <a:off x="9253728" y="4956048"/>
+            <a:ext cx="2526487" cy="390144"/>
+          </a:xfrm>
+          <a:prstGeom prst="rect">
+            <a:avLst/>
+          </a:prstGeom>
+          <a:noFill/>
+          <a:ln/>
+        </p:spPr>
+        <p:txBody>
+          <a:bodyPr wrap="square" lIns="0" tIns="0" rIns="0" bIns="0" rtlCol="0" anchor="ctr"/>
           <a:lstStyle/>
           <a:p>
             <a:pPr indent="0" marL="0">
@@ -5679,13 +5756,13 @@
             <a:r>
               <a:rPr lang="en-US" sz="900" dirty="0">
                 <a:solidFill>
-                  <a:srgbClr val="DCE4EE"/>
-                </a:solidFill>
-                <a:latin typeface="Arial" pitchFamily="34" charset="0"/>
-                <a:ea typeface="Arial" pitchFamily="34" charset="-122"/>
-                <a:cs typeface="Arial" pitchFamily="34" charset="-120"/>
-              </a:rPr>
-              <a:t>Coding, agents and analysis at c.60% below Astra's price</a:t>
+                  <a:srgbClr val="1F2A37"/>
+                </a:solidFill>
+                <a:latin typeface="Arial" pitchFamily="34" charset="0"/>
+                <a:ea typeface="Arial" pitchFamily="34" charset="-122"/>
+                <a:cs typeface="Arial" pitchFamily="34" charset="-120"/>
+              </a:rPr>
+              <a:t>Default for coding, agents and analyst work; c.60% below Astra at list price</a:t>
             </a:r>
             <a:endParaRPr lang="en-US" sz="900" dirty="0"/>
           </a:p>
@@ -5693,14 +5770,14 @@
       </p:sp>
       <p:sp>
         <p:nvSpPr>
-          <p:cNvPr id="136" name="Shape 134"/>
-          <p:cNvSpPr/>
-          <p:nvPr/>
-        </p:nvSpPr>
-        <p:spPr>
-          <a:xfrm>
-            <a:off x="8394192" y="5169408"/>
-            <a:ext cx="3221431" cy="0"/>
+          <p:cNvPr id="138" name="Straight Connector 137"/>
+          <p:cNvSpPr/>
+          <p:nvPr/>
+        </p:nvSpPr>
+        <p:spPr>
+          <a:xfrm>
+            <a:off x="8229600" y="5346192"/>
+            <a:ext cx="3550615" cy="0"/>
           </a:xfrm>
           <a:prstGeom prst="line">
             <a:avLst/>
@@ -5708,40 +5785,40 @@
           <a:noFill/>
           <a:ln w="6350">
             <a:solidFill>
-              <a:srgbClr val="2A4570"/>
-            </a:solidFill>
-            <a:prstDash val="solid"/>
-          </a:ln>
-        </p:spPr>
-      </p:sp>
-      <p:sp>
-        <p:nvSpPr>
-          <p:cNvPr id="137" name="Text 135"/>
-          <p:cNvSpPr txBox="1"/>
-          <p:nvPr/>
-        </p:nvSpPr>
-        <p:spPr>
-          <a:xfrm>
-            <a:off x="8394192" y="5242560"/>
-            <a:ext cx="1828800" cy="182880"/>
-          </a:xfrm>
-          <a:prstGeom prst="rect">
-            <a:avLst/>
-          </a:prstGeom>
-          <a:noFill/>
-          <a:ln/>
-        </p:spPr>
-        <p:txBody>
-          <a:bodyPr wrap="square" lIns="0" tIns="0" rIns="0" bIns="0" rtlCol="0" anchor="t"/>
-          <a:lstStyle/>
-          <a:p>
-            <a:pPr indent="0" marL="0">
-              <a:buNone/>
-            </a:pPr>
-            <a:r>
-              <a:rPr lang="en-US" sz="1050" b="1" dirty="0">
-                <a:solidFill>
-                  <a:srgbClr val="FFFFFF"/>
+              <a:srgbClr val="E3E7EC"/>
+            </a:solidFill>
+            <a:prstDash val="solid"/>
+          </a:ln>
+        </p:spPr>
+      </p:sp>
+      <p:sp>
+        <p:nvSpPr>
+          <p:cNvPr id="139" name="TextBox 138"/>
+          <p:cNvSpPr txBox="1"/>
+          <p:nvPr/>
+        </p:nvSpPr>
+        <p:spPr>
+          <a:xfrm>
+            <a:off x="8229600" y="5346192"/>
+            <a:ext cx="1024128" cy="390144"/>
+          </a:xfrm>
+          <a:prstGeom prst="rect">
+            <a:avLst/>
+          </a:prstGeom>
+          <a:noFill/>
+          <a:ln/>
+        </p:spPr>
+        <p:txBody>
+          <a:bodyPr wrap="square" lIns="0" tIns="0" rIns="0" bIns="0" rtlCol="0" anchor="ctr"/>
+          <a:lstStyle/>
+          <a:p>
+            <a:pPr indent="0" marL="0">
+              <a:buNone/>
+            </a:pPr>
+            <a:r>
+              <a:rPr lang="en-US" sz="900" b="1" dirty="0">
+                <a:solidFill>
+                  <a:srgbClr val="1F2A37"/>
                 </a:solidFill>
                 <a:latin typeface="Arial" pitchFamily="34" charset="0"/>
                 <a:ea typeface="Arial" pitchFamily="34" charset="-122"/>
@@ -5749,68 +5826,29 @@
               </a:rPr>
               <a:t>GPT-6 Astra</a:t>
             </a:r>
-            <a:endParaRPr lang="en-US" sz="1050" dirty="0"/>
-          </a:p>
-        </p:txBody>
-      </p:sp>
-      <p:sp>
-        <p:nvSpPr>
-          <p:cNvPr id="138" name="Text 136"/>
-          <p:cNvSpPr txBox="1"/>
-          <p:nvPr/>
-        </p:nvSpPr>
-        <p:spPr>
-          <a:xfrm>
-            <a:off x="10335463" y="5260848"/>
-            <a:ext cx="1280160" cy="164592"/>
-          </a:xfrm>
-          <a:prstGeom prst="rect">
-            <a:avLst/>
-          </a:prstGeom>
-          <a:noFill/>
-          <a:ln/>
-        </p:spPr>
-        <p:txBody>
-          <a:bodyPr wrap="square" lIns="0" tIns="0" rIns="0" bIns="0" rtlCol="0" anchor="t"/>
-          <a:lstStyle/>
-          <a:p>
-            <a:pPr algn="r" indent="0" marL="0">
-              <a:buNone/>
-            </a:pPr>
-            <a:r>
-              <a:rPr lang="en-US" sz="750" b="1" spc="100" kern="0" dirty="0">
-                <a:solidFill>
-                  <a:srgbClr val="A9BBD3"/>
-                </a:solidFill>
-                <a:latin typeface="Arial" pitchFamily="34" charset="0"/>
-                <a:ea typeface="Arial" pitchFamily="34" charset="-122"/>
-                <a:cs typeface="Arial" pitchFamily="34" charset="-120"/>
-              </a:rPr>
-              <a:t>SPECIALIST</a:t>
-            </a:r>
-            <a:endParaRPr lang="en-US" sz="750" dirty="0"/>
-          </a:p>
-        </p:txBody>
-      </p:sp>
-      <p:sp>
-        <p:nvSpPr>
-          <p:cNvPr id="139" name="Text 137"/>
-          <p:cNvSpPr txBox="1"/>
-          <p:nvPr/>
-        </p:nvSpPr>
-        <p:spPr>
-          <a:xfrm>
-            <a:off x="8394192" y="5443728"/>
-            <a:ext cx="3221431" cy="164592"/>
-          </a:xfrm>
-          <a:prstGeom prst="rect">
-            <a:avLst/>
-          </a:prstGeom>
-          <a:noFill/>
-          <a:ln/>
-        </p:spPr>
-        <p:txBody>
-          <a:bodyPr wrap="square" lIns="0" tIns="0" rIns="0" bIns="0" rtlCol="0" anchor="t"/>
+            <a:endParaRPr lang="en-US" sz="900" dirty="0"/>
+          </a:p>
+        </p:txBody>
+      </p:sp>
+      <p:sp>
+        <p:nvSpPr>
+          <p:cNvPr id="140" name="TextBox 139"/>
+          <p:cNvSpPr txBox="1"/>
+          <p:nvPr/>
+        </p:nvSpPr>
+        <p:spPr>
+          <a:xfrm>
+            <a:off x="9253728" y="5346192"/>
+            <a:ext cx="2526487" cy="390144"/>
+          </a:xfrm>
+          <a:prstGeom prst="rect">
+            <a:avLst/>
+          </a:prstGeom>
+          <a:noFill/>
+          <a:ln/>
+        </p:spPr>
+        <p:txBody>
+          <a:bodyPr wrap="square" lIns="0" tIns="0" rIns="0" bIns="0" rtlCol="0" anchor="ctr"/>
           <a:lstStyle/>
           <a:p>
             <a:pPr indent="0" marL="0">
@@ -5819,7 +5857,7 @@
             <a:r>
               <a:rPr lang="en-US" sz="900" dirty="0">
                 <a:solidFill>
-                  <a:srgbClr val="DCE4EE"/>
+                  <a:srgbClr val="1F2A37"/>
                 </a:solidFill>
                 <a:latin typeface="Arial" pitchFamily="34" charset="0"/>
                 <a:ea typeface="Arial" pitchFamily="34" charset="-122"/>
@@ -5833,14 +5871,14 @@
       </p:sp>
       <p:sp>
         <p:nvSpPr>
-          <p:cNvPr id="140" name="Shape 138"/>
-          <p:cNvSpPr/>
-          <p:nvPr/>
-        </p:nvSpPr>
-        <p:spPr>
-          <a:xfrm>
-            <a:off x="8394192" y="5620512"/>
-            <a:ext cx="3221431" cy="0"/>
+          <p:cNvPr id="141" name="Straight Connector 140"/>
+          <p:cNvSpPr/>
+          <p:nvPr/>
+        </p:nvSpPr>
+        <p:spPr>
+          <a:xfrm>
+            <a:off x="8229600" y="5736336"/>
+            <a:ext cx="3550615" cy="0"/>
           </a:xfrm>
           <a:prstGeom prst="line">
             <a:avLst/>
@@ -5848,40 +5886,40 @@
           <a:noFill/>
           <a:ln w="6350">
             <a:solidFill>
-              <a:srgbClr val="2A4570"/>
-            </a:solidFill>
-            <a:prstDash val="solid"/>
-          </a:ln>
-        </p:spPr>
-      </p:sp>
-      <p:sp>
-        <p:nvSpPr>
-          <p:cNvPr id="141" name="Text 139"/>
-          <p:cNvSpPr txBox="1"/>
-          <p:nvPr/>
-        </p:nvSpPr>
-        <p:spPr>
-          <a:xfrm>
-            <a:off x="8394192" y="5693664"/>
-            <a:ext cx="1828800" cy="182880"/>
-          </a:xfrm>
-          <a:prstGeom prst="rect">
-            <a:avLst/>
-          </a:prstGeom>
-          <a:noFill/>
-          <a:ln/>
-        </p:spPr>
-        <p:txBody>
-          <a:bodyPr wrap="square" lIns="0" tIns="0" rIns="0" bIns="0" rtlCol="0" anchor="t"/>
-          <a:lstStyle/>
-          <a:p>
-            <a:pPr indent="0" marL="0">
-              <a:buNone/>
-            </a:pPr>
-            <a:r>
-              <a:rPr lang="en-US" sz="1050" b="1" dirty="0">
-                <a:solidFill>
-                  <a:srgbClr val="FFFFFF"/>
+              <a:srgbClr val="E3E7EC"/>
+            </a:solidFill>
+            <a:prstDash val="solid"/>
+          </a:ln>
+        </p:spPr>
+      </p:sp>
+      <p:sp>
+        <p:nvSpPr>
+          <p:cNvPr id="142" name="TextBox 141"/>
+          <p:cNvSpPr txBox="1"/>
+          <p:nvPr/>
+        </p:nvSpPr>
+        <p:spPr>
+          <a:xfrm>
+            <a:off x="8229600" y="5736336"/>
+            <a:ext cx="1024128" cy="390144"/>
+          </a:xfrm>
+          <a:prstGeom prst="rect">
+            <a:avLst/>
+          </a:prstGeom>
+          <a:noFill/>
+          <a:ln/>
+        </p:spPr>
+        <p:txBody>
+          <a:bodyPr wrap="square" lIns="0" tIns="0" rIns="0" bIns="0" rtlCol="0" anchor="ctr"/>
+          <a:lstStyle/>
+          <a:p>
+            <a:pPr indent="0" marL="0">
+              <a:buNone/>
+            </a:pPr>
+            <a:r>
+              <a:rPr lang="en-US" sz="900" b="1" dirty="0">
+                <a:solidFill>
+                  <a:srgbClr val="1F2A37"/>
                 </a:solidFill>
                 <a:latin typeface="Arial" pitchFamily="34" charset="0"/>
                 <a:ea typeface="Arial" pitchFamily="34" charset="-122"/>
@@ -5889,68 +5927,29 @@
               </a:rPr>
               <a:t>Kimi K3</a:t>
             </a:r>
-            <a:endParaRPr lang="en-US" sz="1050" dirty="0"/>
-          </a:p>
-        </p:txBody>
-      </p:sp>
-      <p:sp>
-        <p:nvSpPr>
-          <p:cNvPr id="142" name="Text 140"/>
-          <p:cNvSpPr txBox="1"/>
-          <p:nvPr/>
-        </p:nvSpPr>
-        <p:spPr>
-          <a:xfrm>
-            <a:off x="10335463" y="5711952"/>
-            <a:ext cx="1280160" cy="164592"/>
-          </a:xfrm>
-          <a:prstGeom prst="rect">
-            <a:avLst/>
-          </a:prstGeom>
-          <a:noFill/>
-          <a:ln/>
-        </p:spPr>
-        <p:txBody>
-          <a:bodyPr wrap="square" lIns="0" tIns="0" rIns="0" bIns="0" rtlCol="0" anchor="t"/>
-          <a:lstStyle/>
-          <a:p>
-            <a:pPr algn="r" indent="0" marL="0">
-              <a:buNone/>
-            </a:pPr>
-            <a:r>
-              <a:rPr lang="en-US" sz="750" b="1" spc="100" kern="0" dirty="0">
-                <a:solidFill>
-                  <a:srgbClr val="A9BBD3"/>
-                </a:solidFill>
-                <a:latin typeface="Arial" pitchFamily="34" charset="0"/>
-                <a:ea typeface="Arial" pitchFamily="34" charset="-122"/>
-                <a:cs typeface="Arial" pitchFamily="34" charset="-120"/>
-              </a:rPr>
-              <a:t>SELF-HOSTED</a:t>
-            </a:r>
-            <a:endParaRPr lang="en-US" sz="750" dirty="0"/>
-          </a:p>
-        </p:txBody>
-      </p:sp>
-      <p:sp>
-        <p:nvSpPr>
-          <p:cNvPr id="143" name="Text 141"/>
-          <p:cNvSpPr txBox="1"/>
-          <p:nvPr/>
-        </p:nvSpPr>
-        <p:spPr>
-          <a:xfrm>
-            <a:off x="8394192" y="5894832"/>
-            <a:ext cx="3221431" cy="164592"/>
-          </a:xfrm>
-          <a:prstGeom prst="rect">
-            <a:avLst/>
-          </a:prstGeom>
-          <a:noFill/>
-          <a:ln/>
-        </p:spPr>
-        <p:txBody>
-          <a:bodyPr wrap="square" lIns="0" tIns="0" rIns="0" bIns="0" rtlCol="0" anchor="t"/>
+            <a:endParaRPr lang="en-US" sz="900" dirty="0"/>
+          </a:p>
+        </p:txBody>
+      </p:sp>
+      <p:sp>
+        <p:nvSpPr>
+          <p:cNvPr id="143" name="TextBox 142"/>
+          <p:cNvSpPr txBox="1"/>
+          <p:nvPr/>
+        </p:nvSpPr>
+        <p:spPr>
+          <a:xfrm>
+            <a:off x="9253728" y="5736336"/>
+            <a:ext cx="2526487" cy="390144"/>
+          </a:xfrm>
+          <a:prstGeom prst="rect">
+            <a:avLst/>
+          </a:prstGeom>
+          <a:noFill/>
+          <a:ln/>
+        </p:spPr>
+        <p:txBody>
+          <a:bodyPr wrap="square" lIns="0" tIns="0" rIns="0" bIns="0" rtlCol="0" anchor="ctr"/>
           <a:lstStyle/>
           <a:p>
             <a:pPr indent="0" marL="0">
@@ -5959,13 +5958,13 @@
             <a:r>
               <a:rPr lang="en-US" sz="900" dirty="0">
                 <a:solidFill>
-                  <a:srgbClr val="DCE4EE"/>
-                </a:solidFill>
-                <a:latin typeface="Arial" pitchFamily="34" charset="0"/>
-                <a:ea typeface="Arial" pitchFamily="34" charset="-122"/>
-                <a:cs typeface="Arial" pitchFamily="34" charset="-120"/>
-              </a:rPr>
-              <a:t>Regulated data and high-volume, low-cost workloads</a:t>
+                  <a:srgbClr val="1F2A37"/>
+                </a:solidFill>
+                <a:latin typeface="Arial" pitchFamily="34" charset="0"/>
+                <a:ea typeface="Arial" pitchFamily="34" charset="-122"/>
+                <a:cs typeface="Arial" pitchFamily="34" charset="-120"/>
+              </a:rPr>
+              <a:t>Regulated data (self-hosted) and high-volume, low-cost work</a:t>
             </a:r>
             <a:endParaRPr lang="en-US" sz="900" dirty="0"/>
           </a:p>
@@ -5973,7 +5972,30 @@
       </p:sp>
       <p:sp>
         <p:nvSpPr>
-          <p:cNvPr id="144" name="Text 142"/>
+          <p:cNvPr id="144" name="Straight Connector 143"/>
+          <p:cNvSpPr/>
+          <p:nvPr/>
+        </p:nvSpPr>
+        <p:spPr>
+          <a:xfrm>
+            <a:off x="8229600" y="6126480"/>
+            <a:ext cx="3550615" cy="0"/>
+          </a:xfrm>
+          <a:prstGeom prst="line">
+            <a:avLst/>
+          </a:prstGeom>
+          <a:noFill/>
+          <a:ln w="9525">
+            <a:solidFill>
+              <a:srgbClr val="041E42"/>
+            </a:solidFill>
+            <a:prstDash val="solid"/>
+          </a:ln>
+        </p:spPr>
+      </p:sp>
+      <p:sp>
+        <p:nvSpPr>
+          <p:cNvPr id="145" name="TextBox 144"/>
           <p:cNvSpPr txBox="1"/>
           <p:nvPr/>
         </p:nvSpPr>
@@ -6116,7 +6138,7 @@
       </p:sp>
       <p:sp>
         <p:nvSpPr>
-          <p:cNvPr id="145" name="Text 143"/>
+          <p:cNvPr id="146" name="TextBox 145"/>
           <p:cNvSpPr txBox="1"/>
           <p:nvPr/>
         </p:nvSpPr>
@@ -6204,7 +6226,7 @@
     </a:clrScheme>
     <a:fontScheme name="Office">
       <a:majorFont>
-        <a:latin typeface="Calibri Light" panose="020F0302020204030204"/>
+        <a:latin typeface="Arial"/>
         <a:ea typeface=""/>
         <a:cs typeface=""/>
         <a:font script="Jpan" typeface="游ゴシック Light"/>
@@ -6256,7 +6278,7 @@
         <a:font script="Tfng" typeface="Ebrima"/>
       </a:majorFont>
       <a:minorFont>
-        <a:latin typeface="Calibri" panose="020F0502020204030204"/>
+        <a:latin typeface="Arial"/>
         <a:ea typeface=""/>
         <a:cs typeface=""/>
         <a:font script="Jpan" typeface="游ゴシック"/>

</xml_diff>

<commit_message>
Poppins, company logo badges and fading double borders
Switch type to Poppins, add Anthropic/OpenAI/Moonshot marks in ringed
badges on each card, and draw overlapping gradient outlines that fade
out around the card numbers and the Key Takeaways label.

Co-Authored-By: Claude Opus 5.5 <noreply@anthropic.com>
Claude-Session: https://claude.ai/code/session_01ArvvTMQ47fYQzBZA3Mrxmu
</commit_message>
<xml_diff>
--- a/ai-model-comparison/AI-Model-Comparison-Sep-2026.pptx
+++ b/ai-model-comparison/AI-Model-Comparison-Sep-2026.pptx
@@ -883,8 +883,8 @@
         </p:nvSpPr>
         <p:spPr>
           <a:xfrm>
-            <a:off x="530352" y="420624"/>
-            <a:ext cx="0" cy="749808"/>
+            <a:off x="530352" y="402336"/>
+            <a:ext cx="0" cy="731520"/>
           </a:xfrm>
           <a:prstGeom prst="line">
             <a:avLst/>
@@ -906,8 +906,8 @@
         </p:nvSpPr>
         <p:spPr>
           <a:xfrm>
-            <a:off x="795528" y="329184"/>
-            <a:ext cx="10332720" cy="566928"/>
+            <a:off x="795528" y="310896"/>
+            <a:ext cx="10515600" cy="530352"/>
           </a:xfrm>
           <a:prstGeom prst="rect">
             <a:avLst/>
@@ -923,17 +923,17 @@
               <a:buNone/>
             </a:pPr>
             <a:r>
-              <a:rPr lang="en-US" sz="3600" dirty="0">
-                <a:solidFill>
-                  <a:srgbClr val="FFFFFF"/>
-                </a:solidFill>
-                <a:latin typeface="Avenir Book" pitchFamily="34" charset="0"/>
-                <a:ea typeface="Avenir Book" pitchFamily="34" charset="-122"/>
-                <a:cs typeface="Avenir Book" pitchFamily="34" charset="-120"/>
+              <a:rPr lang="en-US" sz="3000" dirty="0">
+                <a:solidFill>
+                  <a:srgbClr val="FFFFFF"/>
+                </a:solidFill>
+                <a:latin typeface="Poppins" pitchFamily="34" charset="0"/>
+                <a:ea typeface="Poppins" pitchFamily="34" charset="-122"/>
+                <a:cs typeface="Poppins" pitchFamily="34" charset="-120"/>
               </a:rPr>
               <a:t>Analysis of the Top Three Frontier AI Models</a:t>
             </a:r>
-            <a:endParaRPr lang="en-US" sz="3600" dirty="0"/>
+            <a:endParaRPr lang="en-US" sz="3000" dirty="0"/>
           </a:p>
         </p:txBody>
       </p:sp>
@@ -945,8 +945,8 @@
         </p:nvSpPr>
         <p:spPr>
           <a:xfrm>
-            <a:off x="795528" y="868680"/>
-            <a:ext cx="10789920" cy="329184"/>
+            <a:off x="795528" y="850392"/>
+            <a:ext cx="11064240" cy="292608"/>
           </a:xfrm>
           <a:prstGeom prst="rect">
             <a:avLst/>
@@ -962,57 +962,102 @@
               <a:buNone/>
             </a:pPr>
             <a:r>
-              <a:rPr lang="en-US" sz="1600" i="1" dirty="0">
-                <a:solidFill>
-                  <a:srgbClr val="FFFFFF"/>
-                </a:solidFill>
-                <a:latin typeface="Avenir Light" pitchFamily="34" charset="0"/>
-                <a:ea typeface="Avenir Light" pitchFamily="34" charset="-122"/>
-                <a:cs typeface="Avenir Light" pitchFamily="34" charset="-120"/>
+              <a:rPr lang="en-US" sz="1350" i="1" dirty="0">
+                <a:solidFill>
+                  <a:srgbClr val="FFFFFF"/>
+                </a:solidFill>
+                <a:latin typeface="Poppins Light" pitchFamily="34" charset="0"/>
+                <a:ea typeface="Poppins Light" pitchFamily="34" charset="-122"/>
+                <a:cs typeface="Poppins Light" pitchFamily="34" charset="-120"/>
               </a:rPr>
               <a:t>Opus 5.5 leads on coding and analyst work, Astra on 3D tools and hard science, and Kimi K3 on cost and self-hosting</a:t>
             </a:r>
-            <a:endParaRPr lang="en-US" sz="1600" dirty="0"/>
+            <a:endParaRPr lang="en-US" sz="1350" dirty="0"/>
           </a:p>
         </p:txBody>
       </p:sp>
-      <p:sp>
-        <p:nvSpPr>
-          <p:cNvPr id="5" name="Shape 4"/>
-          <p:cNvSpPr/>
-          <p:nvPr/>
-        </p:nvSpPr>
-        <p:spPr>
-          <a:xfrm>
-            <a:off x="365760" y="1444752"/>
-            <a:ext cx="3611880" cy="3383280"/>
-          </a:xfrm>
-          <a:prstGeom prst="roundRect">
-            <a:avLst>
-              <a:gd name="adj" fmla="val 3784"/>
-            </a:avLst>
-          </a:prstGeom>
-          <a:solidFill>
-            <a:srgbClr val="001D3B"/>
-          </a:solidFill>
-          <a:ln w="15875">
-            <a:solidFill>
-              <a:srgbClr val="1C5EDD"/>
-            </a:solidFill>
-            <a:prstDash val="solid"/>
-          </a:ln>
-        </p:spPr>
-      </p:sp>
-      <p:sp>
-        <p:nvSpPr>
-          <p:cNvPr id="6" name="TextBox 5"/>
+      <p:pic>
+        <p:nvPicPr>
+          <p:cNvPr id="5" name="Image 0" descr="preencoded.png">    </p:cNvPr>
+          <p:cNvPicPr>
+            <a:picLocks noChangeAspect="1"/>
+          </p:cNvPicPr>
+          <p:nvPr/>
+        </p:nvPicPr>
+        <p:blipFill>
+          <a:blip r:embed="rId1"/>
+          <a:stretch>
+            <a:fillRect/>
+          </a:stretch>
+        </p:blipFill>
+        <p:spPr>
+          <a:xfrm>
+            <a:off x="320040" y="1673352"/>
+            <a:ext cx="3767328" cy="3264408"/>
+          </a:xfrm>
+          <a:prstGeom prst="rect">
+            <a:avLst/>
+          </a:prstGeom>
+        </p:spPr>
+      </p:pic>
+      <p:pic>
+        <p:nvPicPr>
+          <p:cNvPr id="6" name="Image 1" descr="preencoded.png">    </p:cNvPr>
+          <p:cNvPicPr>
+            <a:picLocks noChangeAspect="1"/>
+          </p:cNvPicPr>
+          <p:nvPr/>
+        </p:nvPicPr>
+        <p:blipFill>
+          <a:blip r:embed="rId2"/>
+          <a:stretch>
+            <a:fillRect/>
+          </a:stretch>
+        </p:blipFill>
+        <p:spPr>
+          <a:xfrm>
+            <a:off x="1805940" y="1353312"/>
+            <a:ext cx="731520" cy="731520"/>
+          </a:xfrm>
+          <a:prstGeom prst="rect">
+            <a:avLst/>
+          </a:prstGeom>
+        </p:spPr>
+      </p:pic>
+      <p:pic>
+        <p:nvPicPr>
+          <p:cNvPr id="7" name="Image 2" descr="preencoded.png">    </p:cNvPr>
+          <p:cNvPicPr>
+            <a:picLocks noChangeAspect="1"/>
+          </p:cNvPicPr>
+          <p:nvPr/>
+        </p:nvPicPr>
+        <p:blipFill>
+          <a:blip r:embed="rId3"/>
+          <a:stretch>
+            <a:fillRect/>
+          </a:stretch>
+        </p:blipFill>
+        <p:spPr>
+          <a:xfrm>
+            <a:off x="1988820" y="1536192"/>
+            <a:ext cx="365760" cy="365760"/>
+          </a:xfrm>
+          <a:prstGeom prst="rect">
+            <a:avLst/>
+          </a:prstGeom>
+        </p:spPr>
+      </p:pic>
+      <p:sp>
+        <p:nvSpPr>
+          <p:cNvPr id="8" name="TextBox 7"/>
           <p:cNvSpPr txBox="1"/>
           <p:nvPr/>
         </p:nvSpPr>
         <p:spPr>
           <a:xfrm>
-            <a:off x="640080" y="1627632"/>
-            <a:ext cx="3063240" cy="384048"/>
+            <a:off x="640080" y="2176272"/>
+            <a:ext cx="3063240" cy="347472"/>
           </a:xfrm>
           <a:prstGeom prst="rect">
             <a:avLst/>
@@ -1028,30 +1073,30 @@
               <a:buNone/>
             </a:pPr>
             <a:r>
-              <a:rPr lang="en-US" sz="2200" dirty="0">
-                <a:solidFill>
-                  <a:srgbClr val="FFFFFF"/>
-                </a:solidFill>
-                <a:latin typeface="Avenir Book" pitchFamily="34" charset="0"/>
-                <a:ea typeface="Avenir Book" pitchFamily="34" charset="-122"/>
-                <a:cs typeface="Avenir Book" pitchFamily="34" charset="-120"/>
+              <a:rPr lang="en-US" sz="1800" dirty="0">
+                <a:solidFill>
+                  <a:srgbClr val="FFFFFF"/>
+                </a:solidFill>
+                <a:latin typeface="Poppins Medium" pitchFamily="34" charset="0"/>
+                <a:ea typeface="Poppins Medium" pitchFamily="34" charset="-122"/>
+                <a:cs typeface="Poppins Medium" pitchFamily="34" charset="-120"/>
               </a:rPr>
               <a:t>Claude Opus 5.5</a:t>
             </a:r>
-            <a:endParaRPr lang="en-US" sz="2200" dirty="0"/>
+            <a:endParaRPr lang="en-US" sz="1800" dirty="0"/>
           </a:p>
         </p:txBody>
       </p:sp>
       <p:sp>
         <p:nvSpPr>
-          <p:cNvPr id="7" name="Straight Connector 6"/>
+          <p:cNvPr id="9" name="Straight Connector 8"/>
           <p:cNvSpPr/>
           <p:nvPr/>
         </p:nvSpPr>
         <p:spPr>
           <a:xfrm>
-            <a:off x="868680" y="2066544"/>
-            <a:ext cx="2606040" cy="0"/>
+            <a:off x="914400" y="2569464"/>
+            <a:ext cx="2514600" cy="0"/>
           </a:xfrm>
           <a:prstGeom prst="line">
             <a:avLst/>
@@ -1067,14 +1112,14 @@
       </p:sp>
       <p:sp>
         <p:nvSpPr>
-          <p:cNvPr id="8" name="TextBox 7"/>
+          <p:cNvPr id="10" name="TextBox 9"/>
           <p:cNvSpPr txBox="1"/>
           <p:nvPr/>
         </p:nvSpPr>
         <p:spPr>
           <a:xfrm>
-            <a:off x="640080" y="2139696"/>
-            <a:ext cx="3063240" cy="237744"/>
+            <a:off x="640080" y="2633472"/>
+            <a:ext cx="3063240" cy="219456"/>
           </a:xfrm>
           <a:prstGeom prst="rect">
             <a:avLst/>
@@ -1090,30 +1135,30 @@
               <a:buNone/>
             </a:pPr>
             <a:r>
-              <a:rPr lang="en-US" sz="1150" i="1" dirty="0">
+              <a:rPr lang="en-US" sz="1000" i="1" dirty="0">
                 <a:solidFill>
                   <a:srgbClr val="C9D3E0"/>
                 </a:solidFill>
-                <a:latin typeface="Avenir Light" pitchFamily="34" charset="0"/>
-                <a:ea typeface="Avenir Light" pitchFamily="34" charset="-122"/>
-                <a:cs typeface="Avenir Light" pitchFamily="34" charset="-120"/>
+                <a:latin typeface="Poppins Light" pitchFamily="34" charset="0"/>
+                <a:ea typeface="Poppins Light" pitchFamily="34" charset="-122"/>
+                <a:cs typeface="Poppins Light" pitchFamily="34" charset="-120"/>
               </a:rPr>
               <a:t>Anthropic  |  Released Sep 22, 2026</a:t>
             </a:r>
-            <a:endParaRPr lang="en-US" sz="1150" dirty="0"/>
+            <a:endParaRPr lang="en-US" sz="1000" dirty="0"/>
           </a:p>
         </p:txBody>
       </p:sp>
       <p:sp>
         <p:nvSpPr>
-          <p:cNvPr id="9" name="TextBox 8"/>
+          <p:cNvPr id="11" name="TextBox 10"/>
           <p:cNvSpPr txBox="1"/>
           <p:nvPr/>
         </p:nvSpPr>
         <p:spPr>
           <a:xfrm>
-            <a:off x="621792" y="2487168"/>
-            <a:ext cx="3154680" cy="2057400"/>
+            <a:off x="603504" y="2944368"/>
+            <a:ext cx="3191256" cy="1645920"/>
           </a:xfrm>
           <a:prstGeom prst="rect">
             <a:avLst/>
@@ -1125,9 +1170,9 @@
           <a:bodyPr wrap="square" lIns="0" tIns="0" rIns="0" bIns="0" rtlCol="0" anchor="t"/>
           <a:lstStyle/>
           <a:p>
-            <a:pPr marL="203200" indent="-203200">
+            <a:pPr marL="190500" indent="-190500">
               <a:spcAft>
-                <a:spcPts val="900"/>
+                <a:spcPts val="700"/>
               </a:spcAft>
               <a:buClr>
                 <a:srgbClr val="FFFFFF"/>
@@ -1136,44 +1181,44 @@
               <a:buChar char="•"/>
             </a:pPr>
             <a:r>
-              <a:rPr lang="en-US" sz="1300" dirty="0">
-                <a:solidFill>
-                  <a:srgbClr val="FFFFFF"/>
-                </a:solidFill>
-                <a:latin typeface="Avenir Book" pitchFamily="34" charset="0"/>
-                <a:ea typeface="Avenir Book" pitchFamily="34" charset="-122"/>
-                <a:cs typeface="Avenir Book" pitchFamily="34" charset="-120"/>
+              <a:rPr lang="en-US" sz="1150" dirty="0">
+                <a:solidFill>
+                  <a:srgbClr val="FFFFFF"/>
+                </a:solidFill>
+                <a:latin typeface="Poppins" pitchFamily="34" charset="0"/>
+                <a:ea typeface="Poppins" pitchFamily="34" charset="-122"/>
+                <a:cs typeface="Poppins" pitchFamily="34" charset="-120"/>
               </a:rPr>
               <a:t>Best for </a:t>
             </a:r>
             <a:r>
-              <a:rPr lang="en-US" sz="1300" dirty="0">
+              <a:rPr lang="en-US" sz="1150" dirty="0">
                 <a:solidFill>
                   <a:srgbClr val="5DAAFF"/>
                 </a:solidFill>
-                <a:latin typeface="Avenir Book" pitchFamily="34" charset="0"/>
-                <a:ea typeface="Avenir Book" pitchFamily="34" charset="-122"/>
-                <a:cs typeface="Avenir Book" pitchFamily="34" charset="-120"/>
+                <a:latin typeface="Poppins" pitchFamily="34" charset="0"/>
+                <a:ea typeface="Poppins" pitchFamily="34" charset="-122"/>
+                <a:cs typeface="Poppins" pitchFamily="34" charset="-120"/>
               </a:rPr>
               <a:t>coding, agent workflows and analyst work</a:t>
             </a:r>
             <a:r>
-              <a:rPr lang="en-US" sz="1300" dirty="0">
-                <a:solidFill>
-                  <a:srgbClr val="FFFFFF"/>
-                </a:solidFill>
-                <a:latin typeface="Avenir Book" pitchFamily="34" charset="0"/>
-                <a:ea typeface="Avenir Book" pitchFamily="34" charset="-122"/>
-                <a:cs typeface="Avenir Book" pitchFamily="34" charset="-120"/>
+              <a:rPr lang="en-US" sz="1150" dirty="0">
+                <a:solidFill>
+                  <a:srgbClr val="FFFFFF"/>
+                </a:solidFill>
+                <a:latin typeface="Poppins" pitchFamily="34" charset="0"/>
+                <a:ea typeface="Poppins" pitchFamily="34" charset="-122"/>
+                <a:cs typeface="Poppins" pitchFamily="34" charset="-120"/>
               </a:rPr>
               <a:t> like research and modeling</a:t>
             </a:r>
-            <a:endParaRPr lang="en-US" sz="1300" dirty="0"/>
-          </a:p>
-          <a:p>
-            <a:pPr marL="203200" indent="-203200">
+            <a:endParaRPr lang="en-US" sz="1150" dirty="0"/>
+          </a:p>
+          <a:p>
+            <a:pPr marL="190500" indent="-190500">
               <a:spcAft>
-                <a:spcPts val="900"/>
+                <a:spcPts val="700"/>
               </a:spcAft>
               <a:buClr>
                 <a:srgbClr val="FFFFFF"/>
@@ -1182,55 +1227,55 @@
               <a:buChar char="•"/>
             </a:pPr>
             <a:r>
-              <a:rPr lang="en-US" sz="1300" dirty="0">
-                <a:solidFill>
-                  <a:srgbClr val="FFFFFF"/>
-                </a:solidFill>
-                <a:latin typeface="Avenir Book" pitchFamily="34" charset="0"/>
-                <a:ea typeface="Avenir Book" pitchFamily="34" charset="-122"/>
-                <a:cs typeface="Avenir Book" pitchFamily="34" charset="-120"/>
+              <a:rPr lang="en-US" sz="1150" dirty="0">
+                <a:solidFill>
+                  <a:srgbClr val="FFFFFF"/>
+                </a:solidFill>
+                <a:latin typeface="Poppins" pitchFamily="34" charset="0"/>
+                <a:ea typeface="Poppins" pitchFamily="34" charset="-122"/>
+                <a:cs typeface="Poppins" pitchFamily="34" charset="-120"/>
               </a:rPr>
               <a:t>Scored </a:t>
             </a:r>
             <a:r>
-              <a:rPr lang="en-US" sz="1300" dirty="0">
+              <a:rPr lang="en-US" sz="1150" dirty="0">
                 <a:solidFill>
                   <a:srgbClr val="5DAAFF"/>
                 </a:solidFill>
-                <a:latin typeface="Avenir Book" pitchFamily="34" charset="0"/>
-                <a:ea typeface="Avenir Book" pitchFamily="34" charset="-122"/>
-                <a:cs typeface="Avenir Book" pitchFamily="34" charset="-120"/>
+                <a:latin typeface="Poppins" pitchFamily="34" charset="0"/>
+                <a:ea typeface="Poppins" pitchFamily="34" charset="-122"/>
+                <a:cs typeface="Poppins" pitchFamily="34" charset="-120"/>
               </a:rPr>
               <a:t>66.4% on Terminal-Bench 4.0</a:t>
             </a:r>
             <a:r>
-              <a:rPr lang="en-US" sz="1300" dirty="0">
-                <a:solidFill>
-                  <a:srgbClr val="FFFFFF"/>
-                </a:solidFill>
-                <a:latin typeface="Avenir Book" pitchFamily="34" charset="0"/>
-                <a:ea typeface="Avenir Book" pitchFamily="34" charset="-122"/>
-                <a:cs typeface="Avenir Book" pitchFamily="34" charset="-120"/>
+              <a:rPr lang="en-US" sz="1150" dirty="0">
+                <a:solidFill>
+                  <a:srgbClr val="FFFFFF"/>
+                </a:solidFill>
+                <a:latin typeface="Poppins" pitchFamily="34" charset="0"/>
+                <a:ea typeface="Poppins" pitchFamily="34" charset="-122"/>
+                <a:cs typeface="Poppins" pitchFamily="34" charset="-120"/>
               </a:rPr>
               <a:t> vs. 57.9% for Astra; one customer migrated </a:t>
             </a:r>
             <a:r>
-              <a:rPr lang="en-US" sz="1300" dirty="0">
+              <a:rPr lang="en-US" sz="1150" dirty="0">
                 <a:solidFill>
                   <a:srgbClr val="5DAAFF"/>
                 </a:solidFill>
-                <a:latin typeface="Avenir Book" pitchFamily="34" charset="0"/>
-                <a:ea typeface="Avenir Book" pitchFamily="34" charset="-122"/>
-                <a:cs typeface="Avenir Book" pitchFamily="34" charset="-120"/>
+                <a:latin typeface="Poppins" pitchFamily="34" charset="0"/>
+                <a:ea typeface="Poppins" pitchFamily="34" charset="-122"/>
+                <a:cs typeface="Poppins" pitchFamily="34" charset="-120"/>
               </a:rPr>
               <a:t>680K lines of code in a day</a:t>
             </a:r>
-            <a:endParaRPr lang="en-US" sz="1300" dirty="0"/>
-          </a:p>
-          <a:p>
-            <a:pPr marL="203200" indent="-203200">
+            <a:endParaRPr lang="en-US" sz="1150" dirty="0"/>
+          </a:p>
+          <a:p>
+            <a:pPr marL="190500" indent="-190500">
               <a:spcAft>
-                <a:spcPts val="900"/>
+                <a:spcPts val="700"/>
               </a:spcAft>
               <a:buClr>
                 <a:srgbClr val="FFFFFF"/>
@@ -1239,77 +1284,52 @@
               <a:buChar char="•"/>
             </a:pPr>
             <a:r>
-              <a:rPr lang="en-US" sz="1300" dirty="0">
-                <a:solidFill>
-                  <a:srgbClr val="FFFFFF"/>
-                </a:solidFill>
-                <a:latin typeface="Avenir Book" pitchFamily="34" charset="0"/>
-                <a:ea typeface="Avenir Book" pitchFamily="34" charset="-122"/>
-                <a:cs typeface="Avenir Book" pitchFamily="34" charset="-120"/>
+              <a:rPr lang="en-US" sz="1150" dirty="0">
+                <a:solidFill>
+                  <a:srgbClr val="FFFFFF"/>
+                </a:solidFill>
+                <a:latin typeface="Poppins" pitchFamily="34" charset="0"/>
+                <a:ea typeface="Poppins" pitchFamily="34" charset="-122"/>
+                <a:cs typeface="Poppins" pitchFamily="34" charset="-120"/>
               </a:rPr>
               <a:t>Costs </a:t>
             </a:r>
             <a:r>
-              <a:rPr lang="en-US" sz="1300" dirty="0">
+              <a:rPr lang="en-US" sz="1150" dirty="0">
                 <a:solidFill>
                   <a:srgbClr val="5DAAFF"/>
                 </a:solidFill>
-                <a:latin typeface="Avenir Book" pitchFamily="34" charset="0"/>
-                <a:ea typeface="Avenir Book" pitchFamily="34" charset="-122"/>
-                <a:cs typeface="Avenir Book" pitchFamily="34" charset="-120"/>
+                <a:latin typeface="Poppins" pitchFamily="34" charset="0"/>
+                <a:ea typeface="Poppins" pitchFamily="34" charset="-122"/>
+                <a:cs typeface="Poppins" pitchFamily="34" charset="-120"/>
               </a:rPr>
               <a:t>$4 / $20 per 1M tokens</a:t>
             </a:r>
             <a:r>
-              <a:rPr lang="en-US" sz="1300" dirty="0">
-                <a:solidFill>
-                  <a:srgbClr val="FFFFFF"/>
-                </a:solidFill>
-                <a:latin typeface="Avenir Book" pitchFamily="34" charset="0"/>
-                <a:ea typeface="Avenir Book" pitchFamily="34" charset="-122"/>
-                <a:cs typeface="Avenir Book" pitchFamily="34" charset="-120"/>
+              <a:rPr lang="en-US" sz="1150" dirty="0">
+                <a:solidFill>
+                  <a:srgbClr val="FFFFFF"/>
+                </a:solidFill>
+                <a:latin typeface="Poppins" pitchFamily="34" charset="0"/>
+                <a:ea typeface="Poppins" pitchFamily="34" charset="-122"/>
+                <a:cs typeface="Poppins" pitchFamily="34" charset="-120"/>
               </a:rPr>
               <a:t>, about 60% less than Astra</a:t>
             </a:r>
-            <a:endParaRPr lang="en-US" sz="1300" dirty="0"/>
+            <a:endParaRPr lang="en-US" sz="1150" dirty="0"/>
           </a:p>
         </p:txBody>
       </p:sp>
       <p:sp>
         <p:nvSpPr>
-          <p:cNvPr id="10" name="Rectangle 9"/>
-          <p:cNvSpPr/>
-          <p:nvPr/>
-        </p:nvSpPr>
-        <p:spPr>
-          <a:xfrm>
-            <a:off x="3319272" y="4645152"/>
-            <a:ext cx="566928" cy="365760"/>
-          </a:xfrm>
-          <a:prstGeom prst="rect">
-            <a:avLst/>
-          </a:prstGeom>
-          <a:solidFill>
-            <a:srgbClr val="001D3B"/>
-          </a:solidFill>
-          <a:ln w="12700">
-            <a:solidFill>
-              <a:srgbClr val="001D3B"/>
-            </a:solidFill>
-            <a:prstDash val="solid"/>
-          </a:ln>
-        </p:spPr>
-      </p:sp>
-      <p:sp>
-        <p:nvSpPr>
-          <p:cNvPr id="11" name="TextBox 10"/>
+          <p:cNvPr id="12" name="TextBox 11"/>
           <p:cNvSpPr txBox="1"/>
           <p:nvPr/>
         </p:nvSpPr>
         <p:spPr>
           <a:xfrm>
-            <a:off x="3319272" y="4590288"/>
-            <a:ext cx="566928" cy="438912"/>
+            <a:off x="3264408" y="4599432"/>
+            <a:ext cx="658368" cy="420624"/>
           </a:xfrm>
           <a:prstGeom prst="rect">
             <a:avLst/>
@@ -1325,57 +1345,102 @@
               <a:buNone/>
             </a:pPr>
             <a:r>
-              <a:rPr lang="en-US" sz="2800" dirty="0">
-                <a:solidFill>
-                  <a:srgbClr val="FFFFFF"/>
-                </a:solidFill>
-                <a:latin typeface="Avenir Book" pitchFamily="34" charset="0"/>
-                <a:ea typeface="Avenir Book" pitchFamily="34" charset="-122"/>
-                <a:cs typeface="Avenir Book" pitchFamily="34" charset="-120"/>
+              <a:rPr lang="en-US" sz="2400" dirty="0">
+                <a:solidFill>
+                  <a:srgbClr val="FFFFFF"/>
+                </a:solidFill>
+                <a:latin typeface="Poppins" pitchFamily="34" charset="0"/>
+                <a:ea typeface="Poppins" pitchFamily="34" charset="-122"/>
+                <a:cs typeface="Poppins" pitchFamily="34" charset="-120"/>
               </a:rPr>
               <a:t>01</a:t>
             </a:r>
-            <a:endParaRPr lang="en-US" sz="2800" dirty="0"/>
+            <a:endParaRPr lang="en-US" sz="2400" dirty="0"/>
           </a:p>
         </p:txBody>
       </p:sp>
-      <p:sp>
-        <p:nvSpPr>
-          <p:cNvPr id="12" name="Shape 11"/>
-          <p:cNvSpPr/>
-          <p:nvPr/>
-        </p:nvSpPr>
-        <p:spPr>
-          <a:xfrm>
-            <a:off x="4270248" y="1444752"/>
-            <a:ext cx="3611880" cy="3383280"/>
-          </a:xfrm>
-          <a:prstGeom prst="roundRect">
-            <a:avLst>
-              <a:gd name="adj" fmla="val 3784"/>
-            </a:avLst>
-          </a:prstGeom>
-          <a:solidFill>
-            <a:srgbClr val="001D3B"/>
-          </a:solidFill>
-          <a:ln w="15875">
-            <a:solidFill>
-              <a:srgbClr val="1C5EDD"/>
-            </a:solidFill>
-            <a:prstDash val="solid"/>
-          </a:ln>
-        </p:spPr>
-      </p:sp>
-      <p:sp>
-        <p:nvSpPr>
-          <p:cNvPr id="13" name="TextBox 12"/>
+      <p:pic>
+        <p:nvPicPr>
+          <p:cNvPr id="13" name="Image 3" descr="preencoded.png">    </p:cNvPr>
+          <p:cNvPicPr>
+            <a:picLocks noChangeAspect="1"/>
+          </p:cNvPicPr>
+          <p:nvPr/>
+        </p:nvPicPr>
+        <p:blipFill>
+          <a:blip r:embed="rId4"/>
+          <a:stretch>
+            <a:fillRect/>
+          </a:stretch>
+        </p:blipFill>
+        <p:spPr>
+          <a:xfrm>
+            <a:off x="4224528" y="1673352"/>
+            <a:ext cx="3767328" cy="3264408"/>
+          </a:xfrm>
+          <a:prstGeom prst="rect">
+            <a:avLst/>
+          </a:prstGeom>
+        </p:spPr>
+      </p:pic>
+      <p:pic>
+        <p:nvPicPr>
+          <p:cNvPr id="14" name="Image 4" descr="preencoded.png">    </p:cNvPr>
+          <p:cNvPicPr>
+            <a:picLocks noChangeAspect="1"/>
+          </p:cNvPicPr>
+          <p:nvPr/>
+        </p:nvPicPr>
+        <p:blipFill>
+          <a:blip r:embed="rId5"/>
+          <a:stretch>
+            <a:fillRect/>
+          </a:stretch>
+        </p:blipFill>
+        <p:spPr>
+          <a:xfrm>
+            <a:off x="5710428" y="1353312"/>
+            <a:ext cx="731520" cy="731520"/>
+          </a:xfrm>
+          <a:prstGeom prst="rect">
+            <a:avLst/>
+          </a:prstGeom>
+        </p:spPr>
+      </p:pic>
+      <p:pic>
+        <p:nvPicPr>
+          <p:cNvPr id="15" name="Image 5" descr="preencoded.png">    </p:cNvPr>
+          <p:cNvPicPr>
+            <a:picLocks noChangeAspect="1"/>
+          </p:cNvPicPr>
+          <p:nvPr/>
+        </p:nvPicPr>
+        <p:blipFill>
+          <a:blip r:embed="rId6"/>
+          <a:stretch>
+            <a:fillRect/>
+          </a:stretch>
+        </p:blipFill>
+        <p:spPr>
+          <a:xfrm>
+            <a:off x="5893308" y="1536192"/>
+            <a:ext cx="365760" cy="365760"/>
+          </a:xfrm>
+          <a:prstGeom prst="rect">
+            <a:avLst/>
+          </a:prstGeom>
+        </p:spPr>
+      </p:pic>
+      <p:sp>
+        <p:nvSpPr>
+          <p:cNvPr id="16" name="TextBox 15"/>
           <p:cNvSpPr txBox="1"/>
           <p:nvPr/>
         </p:nvSpPr>
         <p:spPr>
           <a:xfrm>
-            <a:off x="4544568" y="1627632"/>
-            <a:ext cx="3063240" cy="384048"/>
+            <a:off x="4544568" y="2176272"/>
+            <a:ext cx="3063240" cy="347472"/>
           </a:xfrm>
           <a:prstGeom prst="rect">
             <a:avLst/>
@@ -1391,30 +1456,30 @@
               <a:buNone/>
             </a:pPr>
             <a:r>
-              <a:rPr lang="en-US" sz="2200" dirty="0">
-                <a:solidFill>
-                  <a:srgbClr val="FFFFFF"/>
-                </a:solidFill>
-                <a:latin typeface="Avenir Book" pitchFamily="34" charset="0"/>
-                <a:ea typeface="Avenir Book" pitchFamily="34" charset="-122"/>
-                <a:cs typeface="Avenir Book" pitchFamily="34" charset="-120"/>
+              <a:rPr lang="en-US" sz="1800" dirty="0">
+                <a:solidFill>
+                  <a:srgbClr val="FFFFFF"/>
+                </a:solidFill>
+                <a:latin typeface="Poppins Medium" pitchFamily="34" charset="0"/>
+                <a:ea typeface="Poppins Medium" pitchFamily="34" charset="-122"/>
+                <a:cs typeface="Poppins Medium" pitchFamily="34" charset="-120"/>
               </a:rPr>
               <a:t>GPT-6 Astra</a:t>
             </a:r>
-            <a:endParaRPr lang="en-US" sz="2200" dirty="0"/>
+            <a:endParaRPr lang="en-US" sz="1800" dirty="0"/>
           </a:p>
         </p:txBody>
       </p:sp>
       <p:sp>
         <p:nvSpPr>
-          <p:cNvPr id="14" name="Straight Connector 13"/>
+          <p:cNvPr id="17" name="Straight Connector 16"/>
           <p:cNvSpPr/>
           <p:nvPr/>
         </p:nvSpPr>
         <p:spPr>
           <a:xfrm>
-            <a:off x="4773168" y="2066544"/>
-            <a:ext cx="2606040" cy="0"/>
+            <a:off x="4818888" y="2569464"/>
+            <a:ext cx="2514600" cy="0"/>
           </a:xfrm>
           <a:prstGeom prst="line">
             <a:avLst/>
@@ -1430,14 +1495,14 @@
       </p:sp>
       <p:sp>
         <p:nvSpPr>
-          <p:cNvPr id="15" name="TextBox 14"/>
+          <p:cNvPr id="18" name="TextBox 17"/>
           <p:cNvSpPr txBox="1"/>
           <p:nvPr/>
         </p:nvSpPr>
         <p:spPr>
           <a:xfrm>
-            <a:off x="4544568" y="2139696"/>
-            <a:ext cx="3063240" cy="237744"/>
+            <a:off x="4544568" y="2633472"/>
+            <a:ext cx="3063240" cy="219456"/>
           </a:xfrm>
           <a:prstGeom prst="rect">
             <a:avLst/>
@@ -1453,30 +1518,30 @@
               <a:buNone/>
             </a:pPr>
             <a:r>
-              <a:rPr lang="en-US" sz="1150" i="1" dirty="0">
+              <a:rPr lang="en-US" sz="1000" i="1" dirty="0">
                 <a:solidFill>
                   <a:srgbClr val="C9D3E0"/>
                 </a:solidFill>
-                <a:latin typeface="Avenir Light" pitchFamily="34" charset="0"/>
-                <a:ea typeface="Avenir Light" pitchFamily="34" charset="-122"/>
-                <a:cs typeface="Avenir Light" pitchFamily="34" charset="-120"/>
+                <a:latin typeface="Poppins Light" pitchFamily="34" charset="0"/>
+                <a:ea typeface="Poppins Light" pitchFamily="34" charset="-122"/>
+                <a:cs typeface="Poppins Light" pitchFamily="34" charset="-120"/>
               </a:rPr>
               <a:t>OpenAI  |  Released Sep 3, 2026</a:t>
             </a:r>
-            <a:endParaRPr lang="en-US" sz="1150" dirty="0"/>
+            <a:endParaRPr lang="en-US" sz="1000" dirty="0"/>
           </a:p>
         </p:txBody>
       </p:sp>
       <p:sp>
         <p:nvSpPr>
-          <p:cNvPr id="16" name="TextBox 15"/>
+          <p:cNvPr id="19" name="TextBox 18"/>
           <p:cNvSpPr txBox="1"/>
           <p:nvPr/>
         </p:nvSpPr>
         <p:spPr>
           <a:xfrm>
-            <a:off x="4526280" y="2487168"/>
-            <a:ext cx="3154680" cy="2057400"/>
+            <a:off x="4507992" y="2944368"/>
+            <a:ext cx="3191256" cy="1645920"/>
           </a:xfrm>
           <a:prstGeom prst="rect">
             <a:avLst/>
@@ -1488,9 +1553,9 @@
           <a:bodyPr wrap="square" lIns="0" tIns="0" rIns="0" bIns="0" rtlCol="0" anchor="t"/>
           <a:lstStyle/>
           <a:p>
-            <a:pPr marL="203200" indent="-203200">
+            <a:pPr marL="190500" indent="-190500">
               <a:spcAft>
-                <a:spcPts val="900"/>
+                <a:spcPts val="700"/>
               </a:spcAft>
               <a:buClr>
                 <a:srgbClr val="FFFFFF"/>
@@ -1499,66 +1564,66 @@
               <a:buChar char="•"/>
             </a:pPr>
             <a:r>
-              <a:rPr lang="en-US" sz="1300" dirty="0">
-                <a:solidFill>
-                  <a:srgbClr val="FFFFFF"/>
-                </a:solidFill>
-                <a:latin typeface="Avenir Book" pitchFamily="34" charset="0"/>
-                <a:ea typeface="Avenir Book" pitchFamily="34" charset="-122"/>
-                <a:cs typeface="Avenir Book" pitchFamily="34" charset="-120"/>
+              <a:rPr lang="en-US" sz="1150" dirty="0">
+                <a:solidFill>
+                  <a:srgbClr val="FFFFFF"/>
+                </a:solidFill>
+                <a:latin typeface="Poppins" pitchFamily="34" charset="0"/>
+                <a:ea typeface="Poppins" pitchFamily="34" charset="-122"/>
+                <a:cs typeface="Poppins" pitchFamily="34" charset="-120"/>
               </a:rPr>
               <a:t>Best for </a:t>
             </a:r>
             <a:r>
-              <a:rPr lang="en-US" sz="1300" dirty="0">
+              <a:rPr lang="en-US" sz="1150" dirty="0">
                 <a:solidFill>
                   <a:srgbClr val="5DAAFF"/>
                 </a:solidFill>
-                <a:latin typeface="Avenir Book" pitchFamily="34" charset="0"/>
-                <a:ea typeface="Avenir Book" pitchFamily="34" charset="-122"/>
-                <a:cs typeface="Avenir Book" pitchFamily="34" charset="-120"/>
+                <a:latin typeface="Poppins" pitchFamily="34" charset="0"/>
+                <a:ea typeface="Poppins" pitchFamily="34" charset="-122"/>
+                <a:cs typeface="Poppins" pitchFamily="34" charset="-120"/>
               </a:rPr>
               <a:t>operating desktop software</a:t>
             </a:r>
             <a:r>
-              <a:rPr lang="en-US" sz="1300" dirty="0">
-                <a:solidFill>
-                  <a:srgbClr val="FFFFFF"/>
-                </a:solidFill>
-                <a:latin typeface="Avenir Book" pitchFamily="34" charset="0"/>
-                <a:ea typeface="Avenir Book" pitchFamily="34" charset="-122"/>
-                <a:cs typeface="Avenir Book" pitchFamily="34" charset="-120"/>
+              <a:rPr lang="en-US" sz="1150" dirty="0">
+                <a:solidFill>
+                  <a:srgbClr val="FFFFFF"/>
+                </a:solidFill>
+                <a:latin typeface="Poppins" pitchFamily="34" charset="0"/>
+                <a:ea typeface="Poppins" pitchFamily="34" charset="-122"/>
+                <a:cs typeface="Poppins" pitchFamily="34" charset="-120"/>
               </a:rPr>
               <a:t>, 3D tools like </a:t>
             </a:r>
             <a:r>
-              <a:rPr lang="en-US" sz="1300" dirty="0">
+              <a:rPr lang="en-US" sz="1150" dirty="0">
                 <a:solidFill>
                   <a:srgbClr val="5DAAFF"/>
                 </a:solidFill>
-                <a:latin typeface="Avenir Book" pitchFamily="34" charset="0"/>
-                <a:ea typeface="Avenir Book" pitchFamily="34" charset="-122"/>
-                <a:cs typeface="Avenir Book" pitchFamily="34" charset="-120"/>
+                <a:latin typeface="Poppins" pitchFamily="34" charset="0"/>
+                <a:ea typeface="Poppins" pitchFamily="34" charset="-122"/>
+                <a:cs typeface="Poppins" pitchFamily="34" charset="-120"/>
               </a:rPr>
               <a:t>Blender and Unreal Engine 5</a:t>
             </a:r>
             <a:r>
-              <a:rPr lang="en-US" sz="1300" dirty="0">
-                <a:solidFill>
-                  <a:srgbClr val="FFFFFF"/>
-                </a:solidFill>
-                <a:latin typeface="Avenir Book" pitchFamily="34" charset="0"/>
-                <a:ea typeface="Avenir Book" pitchFamily="34" charset="-122"/>
-                <a:cs typeface="Avenir Book" pitchFamily="34" charset="-120"/>
+              <a:rPr lang="en-US" sz="1150" dirty="0">
+                <a:solidFill>
+                  <a:srgbClr val="FFFFFF"/>
+                </a:solidFill>
+                <a:latin typeface="Poppins" pitchFamily="34" charset="0"/>
+                <a:ea typeface="Poppins" pitchFamily="34" charset="-122"/>
+                <a:cs typeface="Poppins" pitchFamily="34" charset="-120"/>
               </a:rPr>
               <a:t>, and hard math and science</a:t>
             </a:r>
-            <a:endParaRPr lang="en-US" sz="1300" dirty="0"/>
-          </a:p>
-          <a:p>
-            <a:pPr marL="203200" indent="-203200">
+            <a:endParaRPr lang="en-US" sz="1150" dirty="0"/>
+          </a:p>
+          <a:p>
+            <a:pPr marL="190500" indent="-190500">
               <a:spcAft>
-                <a:spcPts val="900"/>
+                <a:spcPts val="700"/>
               </a:spcAft>
               <a:buClr>
                 <a:srgbClr val="FFFFFF"/>
@@ -1567,44 +1632,44 @@
               <a:buChar char="•"/>
             </a:pPr>
             <a:r>
-              <a:rPr lang="en-US" sz="1300" dirty="0">
-                <a:solidFill>
-                  <a:srgbClr val="FFFFFF"/>
-                </a:solidFill>
-                <a:latin typeface="Avenir Book" pitchFamily="34" charset="0"/>
-                <a:ea typeface="Avenir Book" pitchFamily="34" charset="-122"/>
-                <a:cs typeface="Avenir Book" pitchFamily="34" charset="-120"/>
+              <a:rPr lang="en-US" sz="1150" dirty="0">
+                <a:solidFill>
+                  <a:srgbClr val="FFFFFF"/>
+                </a:solidFill>
+                <a:latin typeface="Poppins" pitchFamily="34" charset="0"/>
+                <a:ea typeface="Poppins" pitchFamily="34" charset="-122"/>
+                <a:cs typeface="Poppins" pitchFamily="34" charset="-120"/>
               </a:rPr>
               <a:t>Scored </a:t>
             </a:r>
             <a:r>
-              <a:rPr lang="en-US" sz="1300" dirty="0">
+              <a:rPr lang="en-US" sz="1150" dirty="0">
                 <a:solidFill>
                   <a:srgbClr val="5DAAFF"/>
                 </a:solidFill>
-                <a:latin typeface="Avenir Book" pitchFamily="34" charset="0"/>
-                <a:ea typeface="Avenir Book" pitchFamily="34" charset="-122"/>
-                <a:cs typeface="Avenir Book" pitchFamily="34" charset="-120"/>
+                <a:latin typeface="Poppins" pitchFamily="34" charset="0"/>
+                <a:ea typeface="Poppins" pitchFamily="34" charset="-122"/>
+                <a:cs typeface="Poppins" pitchFamily="34" charset="-120"/>
               </a:rPr>
               <a:t>97.6% on FrontierMath Tier 4</a:t>
             </a:r>
             <a:r>
-              <a:rPr lang="en-US" sz="1300" dirty="0">
-                <a:solidFill>
-                  <a:srgbClr val="FFFFFF"/>
-                </a:solidFill>
-                <a:latin typeface="Avenir Book" pitchFamily="34" charset="0"/>
-                <a:ea typeface="Avenir Book" pitchFamily="34" charset="-122"/>
-                <a:cs typeface="Avenir Book" pitchFamily="34" charset="-120"/>
+              <a:rPr lang="en-US" sz="1150" dirty="0">
+                <a:solidFill>
+                  <a:srgbClr val="FFFFFF"/>
+                </a:solidFill>
+                <a:latin typeface="Poppins" pitchFamily="34" charset="0"/>
+                <a:ea typeface="Poppins" pitchFamily="34" charset="-122"/>
+                <a:cs typeface="Poppins" pitchFamily="34" charset="-120"/>
               </a:rPr>
               <a:t> and 72.6% on OSWorld 2.0</a:t>
             </a:r>
-            <a:endParaRPr lang="en-US" sz="1300" dirty="0"/>
-          </a:p>
-          <a:p>
-            <a:pPr marL="203200" indent="-203200">
+            <a:endParaRPr lang="en-US" sz="1150" dirty="0"/>
+          </a:p>
+          <a:p>
+            <a:pPr marL="190500" indent="-190500">
               <a:spcAft>
-                <a:spcPts val="900"/>
+                <a:spcPts val="700"/>
               </a:spcAft>
               <a:buClr>
                 <a:srgbClr val="FFFFFF"/>
@@ -1613,77 +1678,52 @@
               <a:buChar char="•"/>
             </a:pPr>
             <a:r>
-              <a:rPr lang="en-US" sz="1300" dirty="0">
-                <a:solidFill>
-                  <a:srgbClr val="FFFFFF"/>
-                </a:solidFill>
-                <a:latin typeface="Avenir Book" pitchFamily="34" charset="0"/>
-                <a:ea typeface="Avenir Book" pitchFamily="34" charset="-122"/>
-                <a:cs typeface="Avenir Book" pitchFamily="34" charset="-120"/>
+              <a:rPr lang="en-US" sz="1150" dirty="0">
+                <a:solidFill>
+                  <a:srgbClr val="FFFFFF"/>
+                </a:solidFill>
+                <a:latin typeface="Poppins" pitchFamily="34" charset="0"/>
+                <a:ea typeface="Poppins" pitchFamily="34" charset="-122"/>
+                <a:cs typeface="Poppins" pitchFamily="34" charset="-120"/>
               </a:rPr>
               <a:t>Most expensive at </a:t>
             </a:r>
             <a:r>
-              <a:rPr lang="en-US" sz="1300" dirty="0">
+              <a:rPr lang="en-US" sz="1150" dirty="0">
                 <a:solidFill>
                   <a:srgbClr val="5DAAFF"/>
                 </a:solidFill>
-                <a:latin typeface="Avenir Book" pitchFamily="34" charset="0"/>
-                <a:ea typeface="Avenir Book" pitchFamily="34" charset="-122"/>
-                <a:cs typeface="Avenir Book" pitchFamily="34" charset="-120"/>
+                <a:latin typeface="Poppins" pitchFamily="34" charset="0"/>
+                <a:ea typeface="Poppins" pitchFamily="34" charset="-122"/>
+                <a:cs typeface="Poppins" pitchFamily="34" charset="-120"/>
               </a:rPr>
               <a:t>$10 / $50 per 1M tokens</a:t>
             </a:r>
             <a:r>
-              <a:rPr lang="en-US" sz="1300" dirty="0">
-                <a:solidFill>
-                  <a:srgbClr val="FFFFFF"/>
-                </a:solidFill>
-                <a:latin typeface="Avenir Book" pitchFamily="34" charset="0"/>
-                <a:ea typeface="Avenir Book" pitchFamily="34" charset="-122"/>
-                <a:cs typeface="Avenir Book" pitchFamily="34" charset="-120"/>
+              <a:rPr lang="en-US" sz="1150" dirty="0">
+                <a:solidFill>
+                  <a:srgbClr val="FFFFFF"/>
+                </a:solidFill>
+                <a:latin typeface="Poppins" pitchFamily="34" charset="0"/>
+                <a:ea typeface="Poppins" pitchFamily="34" charset="-122"/>
+                <a:cs typeface="Poppins" pitchFamily="34" charset="-120"/>
               </a:rPr>
               <a:t>, with access still rolling out in stages</a:t>
             </a:r>
-            <a:endParaRPr lang="en-US" sz="1300" dirty="0"/>
+            <a:endParaRPr lang="en-US" sz="1150" dirty="0"/>
           </a:p>
         </p:txBody>
       </p:sp>
       <p:sp>
         <p:nvSpPr>
-          <p:cNvPr id="17" name="Rectangle 16"/>
-          <p:cNvSpPr/>
-          <p:nvPr/>
-        </p:nvSpPr>
-        <p:spPr>
-          <a:xfrm>
-            <a:off x="7223760" y="4645152"/>
-            <a:ext cx="566928" cy="365760"/>
-          </a:xfrm>
-          <a:prstGeom prst="rect">
-            <a:avLst/>
-          </a:prstGeom>
-          <a:solidFill>
-            <a:srgbClr val="001D3B"/>
-          </a:solidFill>
-          <a:ln w="12700">
-            <a:solidFill>
-              <a:srgbClr val="001D3B"/>
-            </a:solidFill>
-            <a:prstDash val="solid"/>
-          </a:ln>
-        </p:spPr>
-      </p:sp>
-      <p:sp>
-        <p:nvSpPr>
-          <p:cNvPr id="18" name="TextBox 17"/>
+          <p:cNvPr id="20" name="TextBox 19"/>
           <p:cNvSpPr txBox="1"/>
           <p:nvPr/>
         </p:nvSpPr>
         <p:spPr>
           <a:xfrm>
-            <a:off x="7223760" y="4590288"/>
-            <a:ext cx="566928" cy="438912"/>
+            <a:off x="7168896" y="4599432"/>
+            <a:ext cx="658368" cy="420624"/>
           </a:xfrm>
           <a:prstGeom prst="rect">
             <a:avLst/>
@@ -1699,57 +1739,102 @@
               <a:buNone/>
             </a:pPr>
             <a:r>
-              <a:rPr lang="en-US" sz="2800" dirty="0">
-                <a:solidFill>
-                  <a:srgbClr val="FFFFFF"/>
-                </a:solidFill>
-                <a:latin typeface="Avenir Book" pitchFamily="34" charset="0"/>
-                <a:ea typeface="Avenir Book" pitchFamily="34" charset="-122"/>
-                <a:cs typeface="Avenir Book" pitchFamily="34" charset="-120"/>
+              <a:rPr lang="en-US" sz="2400" dirty="0">
+                <a:solidFill>
+                  <a:srgbClr val="FFFFFF"/>
+                </a:solidFill>
+                <a:latin typeface="Poppins" pitchFamily="34" charset="0"/>
+                <a:ea typeface="Poppins" pitchFamily="34" charset="-122"/>
+                <a:cs typeface="Poppins" pitchFamily="34" charset="-120"/>
               </a:rPr>
               <a:t>02</a:t>
             </a:r>
-            <a:endParaRPr lang="en-US" sz="2800" dirty="0"/>
+            <a:endParaRPr lang="en-US" sz="2400" dirty="0"/>
           </a:p>
         </p:txBody>
       </p:sp>
-      <p:sp>
-        <p:nvSpPr>
-          <p:cNvPr id="19" name="Shape 18"/>
-          <p:cNvSpPr/>
-          <p:nvPr/>
-        </p:nvSpPr>
-        <p:spPr>
-          <a:xfrm>
-            <a:off x="8174736" y="1444752"/>
-            <a:ext cx="3611880" cy="3383280"/>
-          </a:xfrm>
-          <a:prstGeom prst="roundRect">
-            <a:avLst>
-              <a:gd name="adj" fmla="val 3784"/>
-            </a:avLst>
-          </a:prstGeom>
-          <a:solidFill>
-            <a:srgbClr val="001D3B"/>
-          </a:solidFill>
-          <a:ln w="15875">
-            <a:solidFill>
-              <a:srgbClr val="1C5EDD"/>
-            </a:solidFill>
-            <a:prstDash val="solid"/>
-          </a:ln>
-        </p:spPr>
-      </p:sp>
-      <p:sp>
-        <p:nvSpPr>
-          <p:cNvPr id="20" name="TextBox 19"/>
+      <p:pic>
+        <p:nvPicPr>
+          <p:cNvPr id="21" name="Image 6" descr="preencoded.png">    </p:cNvPr>
+          <p:cNvPicPr>
+            <a:picLocks noChangeAspect="1"/>
+          </p:cNvPicPr>
+          <p:nvPr/>
+        </p:nvPicPr>
+        <p:blipFill>
+          <a:blip r:embed="rId7"/>
+          <a:stretch>
+            <a:fillRect/>
+          </a:stretch>
+        </p:blipFill>
+        <p:spPr>
+          <a:xfrm>
+            <a:off x="8129016" y="1673352"/>
+            <a:ext cx="3767328" cy="3264408"/>
+          </a:xfrm>
+          <a:prstGeom prst="rect">
+            <a:avLst/>
+          </a:prstGeom>
+        </p:spPr>
+      </p:pic>
+      <p:pic>
+        <p:nvPicPr>
+          <p:cNvPr id="22" name="Image 7" descr="preencoded.png">    </p:cNvPr>
+          <p:cNvPicPr>
+            <a:picLocks noChangeAspect="1"/>
+          </p:cNvPicPr>
+          <p:nvPr/>
+        </p:nvPicPr>
+        <p:blipFill>
+          <a:blip r:embed="rId8"/>
+          <a:stretch>
+            <a:fillRect/>
+          </a:stretch>
+        </p:blipFill>
+        <p:spPr>
+          <a:xfrm>
+            <a:off x="9614916" y="1353312"/>
+            <a:ext cx="731520" cy="731520"/>
+          </a:xfrm>
+          <a:prstGeom prst="rect">
+            <a:avLst/>
+          </a:prstGeom>
+        </p:spPr>
+      </p:pic>
+      <p:pic>
+        <p:nvPicPr>
+          <p:cNvPr id="23" name="Image 8" descr="preencoded.png">    </p:cNvPr>
+          <p:cNvPicPr>
+            <a:picLocks noChangeAspect="1"/>
+          </p:cNvPicPr>
+          <p:nvPr/>
+        </p:nvPicPr>
+        <p:blipFill>
+          <a:blip r:embed="rId9"/>
+          <a:stretch>
+            <a:fillRect/>
+          </a:stretch>
+        </p:blipFill>
+        <p:spPr>
+          <a:xfrm>
+            <a:off x="9797796" y="1536192"/>
+            <a:ext cx="365760" cy="365760"/>
+          </a:xfrm>
+          <a:prstGeom prst="rect">
+            <a:avLst/>
+          </a:prstGeom>
+        </p:spPr>
+      </p:pic>
+      <p:sp>
+        <p:nvSpPr>
+          <p:cNvPr id="24" name="TextBox 23"/>
           <p:cNvSpPr txBox="1"/>
           <p:nvPr/>
         </p:nvSpPr>
         <p:spPr>
           <a:xfrm>
-            <a:off x="8449056" y="1627632"/>
-            <a:ext cx="3063240" cy="384048"/>
+            <a:off x="8449056" y="2176272"/>
+            <a:ext cx="3063240" cy="347472"/>
           </a:xfrm>
           <a:prstGeom prst="rect">
             <a:avLst/>
@@ -1765,30 +1850,30 @@
               <a:buNone/>
             </a:pPr>
             <a:r>
-              <a:rPr lang="en-US" sz="2200" dirty="0">
-                <a:solidFill>
-                  <a:srgbClr val="FFFFFF"/>
-                </a:solidFill>
-                <a:latin typeface="Avenir Book" pitchFamily="34" charset="0"/>
-                <a:ea typeface="Avenir Book" pitchFamily="34" charset="-122"/>
-                <a:cs typeface="Avenir Book" pitchFamily="34" charset="-120"/>
+              <a:rPr lang="en-US" sz="1800" dirty="0">
+                <a:solidFill>
+                  <a:srgbClr val="FFFFFF"/>
+                </a:solidFill>
+                <a:latin typeface="Poppins Medium" pitchFamily="34" charset="0"/>
+                <a:ea typeface="Poppins Medium" pitchFamily="34" charset="-122"/>
+                <a:cs typeface="Poppins Medium" pitchFamily="34" charset="-120"/>
               </a:rPr>
               <a:t>Kimi K3</a:t>
             </a:r>
-            <a:endParaRPr lang="en-US" sz="2200" dirty="0"/>
+            <a:endParaRPr lang="en-US" sz="1800" dirty="0"/>
           </a:p>
         </p:txBody>
       </p:sp>
       <p:sp>
         <p:nvSpPr>
-          <p:cNvPr id="21" name="Straight Connector 20"/>
+          <p:cNvPr id="25" name="Straight Connector 24"/>
           <p:cNvSpPr/>
           <p:nvPr/>
         </p:nvSpPr>
         <p:spPr>
           <a:xfrm>
-            <a:off x="8677656" y="2066544"/>
-            <a:ext cx="2606040" cy="0"/>
+            <a:off x="8723376" y="2569464"/>
+            <a:ext cx="2514600" cy="0"/>
           </a:xfrm>
           <a:prstGeom prst="line">
             <a:avLst/>
@@ -1804,14 +1889,14 @@
       </p:sp>
       <p:sp>
         <p:nvSpPr>
-          <p:cNvPr id="22" name="TextBox 21"/>
+          <p:cNvPr id="26" name="TextBox 25"/>
           <p:cNvSpPr txBox="1"/>
           <p:nvPr/>
         </p:nvSpPr>
         <p:spPr>
           <a:xfrm>
-            <a:off x="8449056" y="2139696"/>
-            <a:ext cx="3063240" cy="237744"/>
+            <a:off x="8449056" y="2633472"/>
+            <a:ext cx="3063240" cy="219456"/>
           </a:xfrm>
           <a:prstGeom prst="rect">
             <a:avLst/>
@@ -1827,30 +1912,30 @@
               <a:buNone/>
             </a:pPr>
             <a:r>
-              <a:rPr lang="en-US" sz="1150" i="1" dirty="0">
+              <a:rPr lang="en-US" sz="1000" i="1" dirty="0">
                 <a:solidFill>
                   <a:srgbClr val="C9D3E0"/>
                 </a:solidFill>
-                <a:latin typeface="Avenir Light" pitchFamily="34" charset="0"/>
-                <a:ea typeface="Avenir Light" pitchFamily="34" charset="-122"/>
-                <a:cs typeface="Avenir Light" pitchFamily="34" charset="-120"/>
+                <a:latin typeface="Poppins Light" pitchFamily="34" charset="0"/>
+                <a:ea typeface="Poppins Light" pitchFamily="34" charset="-122"/>
+                <a:cs typeface="Poppins Light" pitchFamily="34" charset="-120"/>
               </a:rPr>
               <a:t>Moonshot AI  |  Released Jul 16, 2026</a:t>
             </a:r>
-            <a:endParaRPr lang="en-US" sz="1150" dirty="0"/>
+            <a:endParaRPr lang="en-US" sz="1000" dirty="0"/>
           </a:p>
         </p:txBody>
       </p:sp>
       <p:sp>
         <p:nvSpPr>
-          <p:cNvPr id="23" name="TextBox 22"/>
+          <p:cNvPr id="27" name="TextBox 26"/>
           <p:cNvSpPr txBox="1"/>
           <p:nvPr/>
         </p:nvSpPr>
         <p:spPr>
           <a:xfrm>
-            <a:off x="8430768" y="2487168"/>
-            <a:ext cx="3154680" cy="2057400"/>
+            <a:off x="8412480" y="2944368"/>
+            <a:ext cx="3191256" cy="1645920"/>
           </a:xfrm>
           <a:prstGeom prst="rect">
             <a:avLst/>
@@ -1862,9 +1947,9 @@
           <a:bodyPr wrap="square" lIns="0" tIns="0" rIns="0" bIns="0" rtlCol="0" anchor="t"/>
           <a:lstStyle/>
           <a:p>
-            <a:pPr marL="203200" indent="-203200">
+            <a:pPr marL="190500" indent="-190500">
               <a:spcAft>
-                <a:spcPts val="900"/>
+                <a:spcPts val="700"/>
               </a:spcAft>
               <a:buClr>
                 <a:srgbClr val="FFFFFF"/>
@@ -1873,55 +1958,55 @@
               <a:buChar char="•"/>
             </a:pPr>
             <a:r>
-              <a:rPr lang="en-US" sz="1300" dirty="0">
-                <a:solidFill>
-                  <a:srgbClr val="FFFFFF"/>
-                </a:solidFill>
-                <a:latin typeface="Avenir Book" pitchFamily="34" charset="0"/>
-                <a:ea typeface="Avenir Book" pitchFamily="34" charset="-122"/>
-                <a:cs typeface="Avenir Book" pitchFamily="34" charset="-120"/>
+              <a:rPr lang="en-US" sz="1150" dirty="0">
+                <a:solidFill>
+                  <a:srgbClr val="FFFFFF"/>
+                </a:solidFill>
+                <a:latin typeface="Poppins" pitchFamily="34" charset="0"/>
+                <a:ea typeface="Poppins" pitchFamily="34" charset="-122"/>
+                <a:cs typeface="Poppins" pitchFamily="34" charset="-120"/>
               </a:rPr>
               <a:t>Best for </a:t>
             </a:r>
             <a:r>
-              <a:rPr lang="en-US" sz="1300" dirty="0">
+              <a:rPr lang="en-US" sz="1150" dirty="0">
                 <a:solidFill>
                   <a:srgbClr val="5DAAFF"/>
                 </a:solidFill>
-                <a:latin typeface="Avenir Book" pitchFamily="34" charset="0"/>
-                <a:ea typeface="Avenir Book" pitchFamily="34" charset="-122"/>
-                <a:cs typeface="Avenir Book" pitchFamily="34" charset="-120"/>
+                <a:latin typeface="Poppins" pitchFamily="34" charset="0"/>
+                <a:ea typeface="Poppins" pitchFamily="34" charset="-122"/>
+                <a:cs typeface="Poppins" pitchFamily="34" charset="-120"/>
               </a:rPr>
               <a:t>high-volume, low-cost work</a:t>
             </a:r>
             <a:r>
-              <a:rPr lang="en-US" sz="1300" dirty="0">
-                <a:solidFill>
-                  <a:srgbClr val="FFFFFF"/>
-                </a:solidFill>
-                <a:latin typeface="Avenir Book" pitchFamily="34" charset="0"/>
-                <a:ea typeface="Avenir Book" pitchFamily="34" charset="-122"/>
-                <a:cs typeface="Avenir Book" pitchFamily="34" charset="-120"/>
+              <a:rPr lang="en-US" sz="1150" dirty="0">
+                <a:solidFill>
+                  <a:srgbClr val="FFFFFF"/>
+                </a:solidFill>
+                <a:latin typeface="Poppins" pitchFamily="34" charset="0"/>
+                <a:ea typeface="Poppins" pitchFamily="34" charset="-122"/>
+                <a:cs typeface="Poppins" pitchFamily="34" charset="-120"/>
               </a:rPr>
               <a:t> and anything that has to be </a:t>
             </a:r>
             <a:r>
-              <a:rPr lang="en-US" sz="1300" dirty="0">
+              <a:rPr lang="en-US" sz="1150" dirty="0">
                 <a:solidFill>
                   <a:srgbClr val="5DAAFF"/>
                 </a:solidFill>
-                <a:latin typeface="Avenir Book" pitchFamily="34" charset="0"/>
-                <a:ea typeface="Avenir Book" pitchFamily="34" charset="-122"/>
-                <a:cs typeface="Avenir Book" pitchFamily="34" charset="-120"/>
+                <a:latin typeface="Poppins" pitchFamily="34" charset="0"/>
+                <a:ea typeface="Poppins" pitchFamily="34" charset="-122"/>
+                <a:cs typeface="Poppins" pitchFamily="34" charset="-120"/>
               </a:rPr>
               <a:t>self-hosted</a:t>
             </a:r>
-            <a:endParaRPr lang="en-US" sz="1300" dirty="0"/>
-          </a:p>
-          <a:p>
-            <a:pPr marL="203200" indent="-203200">
+            <a:endParaRPr lang="en-US" sz="1150" dirty="0"/>
+          </a:p>
+          <a:p>
+            <a:pPr marL="190500" indent="-190500">
               <a:spcAft>
-                <a:spcPts val="900"/>
+                <a:spcPts val="700"/>
               </a:spcAft>
               <a:buClr>
                 <a:srgbClr val="FFFFFF"/>
@@ -1930,44 +2015,44 @@
               <a:buChar char="•"/>
             </a:pPr>
             <a:r>
-              <a:rPr lang="en-US" sz="1300" dirty="0">
-                <a:solidFill>
-                  <a:srgbClr val="FFFFFF"/>
-                </a:solidFill>
-                <a:latin typeface="Avenir Book" pitchFamily="34" charset="0"/>
-                <a:ea typeface="Avenir Book" pitchFamily="34" charset="-122"/>
-                <a:cs typeface="Avenir Book" pitchFamily="34" charset="-120"/>
+              <a:rPr lang="en-US" sz="1150" dirty="0">
+                <a:solidFill>
+                  <a:srgbClr val="FFFFFF"/>
+                </a:solidFill>
+                <a:latin typeface="Poppins" pitchFamily="34" charset="0"/>
+                <a:ea typeface="Poppins" pitchFamily="34" charset="-122"/>
+                <a:cs typeface="Poppins" pitchFamily="34" charset="-120"/>
               </a:rPr>
               <a:t>The </a:t>
             </a:r>
             <a:r>
-              <a:rPr lang="en-US" sz="1300" dirty="0">
+              <a:rPr lang="en-US" sz="1150" dirty="0">
                 <a:solidFill>
                   <a:srgbClr val="5DAAFF"/>
                 </a:solidFill>
-                <a:latin typeface="Avenir Book" pitchFamily="34" charset="0"/>
-                <a:ea typeface="Avenir Book" pitchFamily="34" charset="-122"/>
-                <a:cs typeface="Avenir Book" pitchFamily="34" charset="-120"/>
+                <a:latin typeface="Poppins" pitchFamily="34" charset="0"/>
+                <a:ea typeface="Poppins" pitchFamily="34" charset="-122"/>
+                <a:cs typeface="Poppins" pitchFamily="34" charset="-120"/>
               </a:rPr>
               <a:t>only open-weight model</a:t>
             </a:r>
             <a:r>
-              <a:rPr lang="en-US" sz="1300" dirty="0">
-                <a:solidFill>
-                  <a:srgbClr val="FFFFFF"/>
-                </a:solidFill>
-                <a:latin typeface="Avenir Book" pitchFamily="34" charset="0"/>
-                <a:ea typeface="Avenir Book" pitchFamily="34" charset="-122"/>
-                <a:cs typeface="Avenir Book" pitchFamily="34" charset="-120"/>
+              <a:rPr lang="en-US" sz="1150" dirty="0">
+                <a:solidFill>
+                  <a:srgbClr val="FFFFFF"/>
+                </a:solidFill>
+                <a:latin typeface="Poppins" pitchFamily="34" charset="0"/>
+                <a:ea typeface="Poppins" pitchFamily="34" charset="-122"/>
+                <a:cs typeface="Poppins" pitchFamily="34" charset="-120"/>
               </a:rPr>
               <a:t> of the three, with 2.8T parameters</a:t>
             </a:r>
-            <a:endParaRPr lang="en-US" sz="1300" dirty="0"/>
-          </a:p>
-          <a:p>
-            <a:pPr marL="203200" indent="-203200">
+            <a:endParaRPr lang="en-US" sz="1150" dirty="0"/>
+          </a:p>
+          <a:p>
+            <a:pPr marL="190500" indent="-190500">
               <a:spcAft>
-                <a:spcPts val="900"/>
+                <a:spcPts val="700"/>
               </a:spcAft>
               <a:buClr>
                 <a:srgbClr val="FFFFFF"/>
@@ -1976,77 +2061,52 @@
               <a:buChar char="•"/>
             </a:pPr>
             <a:r>
-              <a:rPr lang="en-US" sz="1300" dirty="0">
-                <a:solidFill>
-                  <a:srgbClr val="FFFFFF"/>
-                </a:solidFill>
-                <a:latin typeface="Avenir Book" pitchFamily="34" charset="0"/>
-                <a:ea typeface="Avenir Book" pitchFamily="34" charset="-122"/>
-                <a:cs typeface="Avenir Book" pitchFamily="34" charset="-120"/>
+              <a:rPr lang="en-US" sz="1150" dirty="0">
+                <a:solidFill>
+                  <a:srgbClr val="FFFFFF"/>
+                </a:solidFill>
+                <a:latin typeface="Poppins" pitchFamily="34" charset="0"/>
+                <a:ea typeface="Poppins" pitchFamily="34" charset="-122"/>
+                <a:cs typeface="Poppins" pitchFamily="34" charset="-120"/>
               </a:rPr>
               <a:t>Cheapest at </a:t>
             </a:r>
             <a:r>
-              <a:rPr lang="en-US" sz="1300" dirty="0">
+              <a:rPr lang="en-US" sz="1150" dirty="0">
                 <a:solidFill>
                   <a:srgbClr val="5DAAFF"/>
                 </a:solidFill>
-                <a:latin typeface="Avenir Book" pitchFamily="34" charset="0"/>
-                <a:ea typeface="Avenir Book" pitchFamily="34" charset="-122"/>
-                <a:cs typeface="Avenir Book" pitchFamily="34" charset="-120"/>
+                <a:latin typeface="Poppins" pitchFamily="34" charset="0"/>
+                <a:ea typeface="Poppins" pitchFamily="34" charset="-122"/>
+                <a:cs typeface="Poppins" pitchFamily="34" charset="-120"/>
               </a:rPr>
               <a:t>$3 / $15 per 1M tokens</a:t>
             </a:r>
             <a:r>
-              <a:rPr lang="en-US" sz="1300" dirty="0">
-                <a:solidFill>
-                  <a:srgbClr val="FFFFFF"/>
-                </a:solidFill>
-                <a:latin typeface="Avenir Book" pitchFamily="34" charset="0"/>
-                <a:ea typeface="Avenir Book" pitchFamily="34" charset="-122"/>
-                <a:cs typeface="Avenir Book" pitchFamily="34" charset="-120"/>
+              <a:rPr lang="en-US" sz="1150" dirty="0">
+                <a:solidFill>
+                  <a:srgbClr val="FFFFFF"/>
+                </a:solidFill>
+                <a:latin typeface="Poppins" pitchFamily="34" charset="0"/>
+                <a:ea typeface="Poppins" pitchFamily="34" charset="-122"/>
+                <a:cs typeface="Poppins" pitchFamily="34" charset="-120"/>
               </a:rPr>
               <a:t>, but scores 44 vs. 58 for Opus on the Artificial Analysis index</a:t>
             </a:r>
-            <a:endParaRPr lang="en-US" sz="1300" dirty="0"/>
+            <a:endParaRPr lang="en-US" sz="1150" dirty="0"/>
           </a:p>
         </p:txBody>
       </p:sp>
       <p:sp>
         <p:nvSpPr>
-          <p:cNvPr id="24" name="Rectangle 23"/>
-          <p:cNvSpPr/>
-          <p:nvPr/>
-        </p:nvSpPr>
-        <p:spPr>
-          <a:xfrm>
-            <a:off x="11128248" y="4645152"/>
-            <a:ext cx="566928" cy="365760"/>
-          </a:xfrm>
-          <a:prstGeom prst="rect">
-            <a:avLst/>
-          </a:prstGeom>
-          <a:solidFill>
-            <a:srgbClr val="001D3B"/>
-          </a:solidFill>
-          <a:ln w="12700">
-            <a:solidFill>
-              <a:srgbClr val="001D3B"/>
-            </a:solidFill>
-            <a:prstDash val="solid"/>
-          </a:ln>
-        </p:spPr>
-      </p:sp>
-      <p:sp>
-        <p:nvSpPr>
-          <p:cNvPr id="25" name="TextBox 24"/>
+          <p:cNvPr id="28" name="TextBox 27"/>
           <p:cNvSpPr txBox="1"/>
           <p:nvPr/>
         </p:nvSpPr>
         <p:spPr>
           <a:xfrm>
-            <a:off x="11128248" y="4590288"/>
-            <a:ext cx="566928" cy="438912"/>
+            <a:off x="11073384" y="4599432"/>
+            <a:ext cx="658368" cy="420624"/>
           </a:xfrm>
           <a:prstGeom prst="rect">
             <a:avLst/>
@@ -2062,109 +2122,54 @@
               <a:buNone/>
             </a:pPr>
             <a:r>
-              <a:rPr lang="en-US" sz="2800" dirty="0">
-                <a:solidFill>
-                  <a:srgbClr val="FFFFFF"/>
-                </a:solidFill>
-                <a:latin typeface="Avenir Book" pitchFamily="34" charset="0"/>
-                <a:ea typeface="Avenir Book" pitchFamily="34" charset="-122"/>
-                <a:cs typeface="Avenir Book" pitchFamily="34" charset="-120"/>
+              <a:rPr lang="en-US" sz="2400" dirty="0">
+                <a:solidFill>
+                  <a:srgbClr val="FFFFFF"/>
+                </a:solidFill>
+                <a:latin typeface="Poppins" pitchFamily="34" charset="0"/>
+                <a:ea typeface="Poppins" pitchFamily="34" charset="-122"/>
+                <a:cs typeface="Poppins" pitchFamily="34" charset="-120"/>
               </a:rPr>
               <a:t>03</a:t>
             </a:r>
-            <a:endParaRPr lang="en-US" sz="2800" dirty="0"/>
+            <a:endParaRPr lang="en-US" sz="2400" dirty="0"/>
           </a:p>
         </p:txBody>
       </p:sp>
-      <p:sp>
-        <p:nvSpPr>
-          <p:cNvPr id="26" name="Shape 25"/>
-          <p:cNvSpPr/>
-          <p:nvPr/>
-        </p:nvSpPr>
-        <p:spPr>
-          <a:xfrm>
-            <a:off x="320040" y="5010912"/>
-            <a:ext cx="11548872" cy="1078992"/>
-          </a:xfrm>
-          <a:prstGeom prst="roundRect">
-            <a:avLst>
-              <a:gd name="adj" fmla="val 13559"/>
-            </a:avLst>
-          </a:prstGeom>
-          <a:solidFill>
-            <a:srgbClr val="001D3B"/>
-          </a:solidFill>
-          <a:ln w="12700">
-            <a:solidFill>
-              <a:srgbClr val="5B7495"/>
-            </a:solidFill>
-            <a:prstDash val="solid"/>
-          </a:ln>
-        </p:spPr>
-      </p:sp>
-      <p:sp>
-        <p:nvSpPr>
-          <p:cNvPr id="27" name="Shape 26"/>
-          <p:cNvSpPr/>
-          <p:nvPr/>
-        </p:nvSpPr>
-        <p:spPr>
-          <a:xfrm>
-            <a:off x="365760" y="5047488"/>
-            <a:ext cx="11457432" cy="1005840"/>
-          </a:xfrm>
-          <a:prstGeom prst="roundRect">
-            <a:avLst>
-              <a:gd name="adj" fmla="val 12727"/>
-            </a:avLst>
-          </a:prstGeom>
-          <a:solidFill>
-            <a:srgbClr val="001D3B"/>
-          </a:solidFill>
-          <a:ln w="12700">
-            <a:solidFill>
-              <a:srgbClr val="5DAAFF"/>
-            </a:solidFill>
-            <a:prstDash val="solid"/>
-          </a:ln>
-        </p:spPr>
-      </p:sp>
-      <p:sp>
-        <p:nvSpPr>
-          <p:cNvPr id="28" name="Rectangle 27"/>
-          <p:cNvSpPr/>
-          <p:nvPr/>
-        </p:nvSpPr>
-        <p:spPr>
-          <a:xfrm>
-            <a:off x="1234440" y="4864608"/>
-            <a:ext cx="2148840" cy="310896"/>
-          </a:xfrm>
-          <a:prstGeom prst="rect">
-            <a:avLst/>
-          </a:prstGeom>
-          <a:solidFill>
-            <a:srgbClr val="001D3B"/>
-          </a:solidFill>
-          <a:ln w="12700">
-            <a:solidFill>
-              <a:srgbClr val="001D3B"/>
-            </a:solidFill>
-            <a:prstDash val="solid"/>
-          </a:ln>
-        </p:spPr>
-      </p:sp>
-      <p:sp>
-        <p:nvSpPr>
-          <p:cNvPr id="29" name="TextBox 28"/>
+      <p:pic>
+        <p:nvPicPr>
+          <p:cNvPr id="29" name="Image 9" descr="preencoded.png">    </p:cNvPr>
+          <p:cNvPicPr>
+            <a:picLocks noChangeAspect="1"/>
+          </p:cNvPicPr>
+          <p:nvPr/>
+        </p:nvPicPr>
+        <p:blipFill>
+          <a:blip r:embed="rId10"/>
+          <a:stretch>
+            <a:fillRect/>
+          </a:stretch>
+        </p:blipFill>
+        <p:spPr>
+          <a:xfrm>
+            <a:off x="320040" y="5184648"/>
+            <a:ext cx="11612880" cy="1069848"/>
+          </a:xfrm>
+          <a:prstGeom prst="rect">
+            <a:avLst/>
+          </a:prstGeom>
+        </p:spPr>
+      </p:pic>
+      <p:sp>
+        <p:nvSpPr>
+          <p:cNvPr id="30" name="TextBox 29"/>
           <p:cNvSpPr txBox="1"/>
           <p:nvPr/>
         </p:nvSpPr>
         <p:spPr>
           <a:xfrm>
-            <a:off x="1234440" y="4846320"/>
-            <a:ext cx="2148840" cy="347472"/>
+            <a:off x="822960" y="5047488"/>
+            <a:ext cx="2331720" cy="365760"/>
           </a:xfrm>
           <a:prstGeom prst="rect">
             <a:avLst/>
@@ -2180,30 +2185,30 @@
               <a:buNone/>
             </a:pPr>
             <a:r>
-              <a:rPr lang="en-US" sz="1800" dirty="0">
-                <a:solidFill>
-                  <a:srgbClr val="FFFFFF"/>
-                </a:solidFill>
-                <a:latin typeface="Avenir Book" pitchFamily="34" charset="0"/>
-                <a:ea typeface="Avenir Book" pitchFamily="34" charset="-122"/>
-                <a:cs typeface="Avenir Book" pitchFamily="34" charset="-120"/>
+              <a:rPr lang="en-US" sz="1600" dirty="0">
+                <a:solidFill>
+                  <a:srgbClr val="FFFFFF"/>
+                </a:solidFill>
+                <a:latin typeface="Poppins" pitchFamily="34" charset="0"/>
+                <a:ea typeface="Poppins" pitchFamily="34" charset="-122"/>
+                <a:cs typeface="Poppins" pitchFamily="34" charset="-120"/>
               </a:rPr>
               <a:t>Key Takeaways</a:t>
             </a:r>
-            <a:endParaRPr lang="en-US" sz="1800" dirty="0"/>
+            <a:endParaRPr lang="en-US" sz="1600" dirty="0"/>
           </a:p>
         </p:txBody>
       </p:sp>
       <p:sp>
         <p:nvSpPr>
-          <p:cNvPr id="30" name="TextBox 29"/>
+          <p:cNvPr id="31" name="TextBox 30"/>
           <p:cNvSpPr txBox="1"/>
           <p:nvPr/>
         </p:nvSpPr>
         <p:spPr>
           <a:xfrm>
-            <a:off x="640080" y="5230368"/>
-            <a:ext cx="10908792" cy="731520"/>
+            <a:off x="640080" y="5413248"/>
+            <a:ext cx="10908792" cy="658368"/>
           </a:xfrm>
           <a:prstGeom prst="rect">
             <a:avLst/>
@@ -2215,9 +2220,9 @@
           <a:bodyPr wrap="square" lIns="0" tIns="0" rIns="0" bIns="0" rtlCol="0" anchor="ctr"/>
           <a:lstStyle/>
           <a:p>
-            <a:pPr marL="203200" indent="-203200">
+            <a:pPr marL="190500" indent="-190500">
               <a:spcAft>
-                <a:spcPts val="600"/>
+                <a:spcPts val="500"/>
               </a:spcAft>
               <a:buClr>
                 <a:srgbClr val="FFFFFF"/>
@@ -2226,44 +2231,44 @@
               <a:buChar char="•"/>
             </a:pPr>
             <a:r>
-              <a:rPr lang="en-US" sz="1400" dirty="0">
+              <a:rPr lang="en-US" sz="1200" dirty="0">
                 <a:solidFill>
                   <a:srgbClr val="5DAAFF"/>
                 </a:solidFill>
-                <a:latin typeface="Avenir Book" pitchFamily="34" charset="0"/>
-                <a:ea typeface="Avenir Book" pitchFamily="34" charset="-122"/>
-                <a:cs typeface="Avenir Book" pitchFamily="34" charset="-120"/>
+                <a:latin typeface="Poppins" pitchFamily="34" charset="0"/>
+                <a:ea typeface="Poppins" pitchFamily="34" charset="-122"/>
+                <a:cs typeface="Poppins" pitchFamily="34" charset="-120"/>
               </a:rPr>
               <a:t>Opus 5.5</a:t>
             </a:r>
             <a:r>
-              <a:rPr lang="en-US" sz="1400" dirty="0">
-                <a:solidFill>
-                  <a:srgbClr val="FFFFFF"/>
-                </a:solidFill>
-                <a:latin typeface="Avenir Book" pitchFamily="34" charset="0"/>
-                <a:ea typeface="Avenir Book" pitchFamily="34" charset="-122"/>
-                <a:cs typeface="Avenir Book" pitchFamily="34" charset="-120"/>
+              <a:rPr lang="en-US" sz="1200" dirty="0">
+                <a:solidFill>
+                  <a:srgbClr val="FFFFFF"/>
+                </a:solidFill>
+                <a:latin typeface="Poppins" pitchFamily="34" charset="0"/>
+                <a:ea typeface="Poppins" pitchFamily="34" charset="-122"/>
+                <a:cs typeface="Poppins" pitchFamily="34" charset="-120"/>
               </a:rPr>
               <a:t> should be the default for most work, given its lead on coding and knowledge-work benchmarks and its </a:t>
             </a:r>
             <a:r>
-              <a:rPr lang="en-US" sz="1400" dirty="0">
+              <a:rPr lang="en-US" sz="1200" dirty="0">
                 <a:solidFill>
                   <a:srgbClr val="5DAAFF"/>
                 </a:solidFill>
-                <a:latin typeface="Avenir Book" pitchFamily="34" charset="0"/>
-                <a:ea typeface="Avenir Book" pitchFamily="34" charset="-122"/>
-                <a:cs typeface="Avenir Book" pitchFamily="34" charset="-120"/>
+                <a:latin typeface="Poppins" pitchFamily="34" charset="0"/>
+                <a:ea typeface="Poppins" pitchFamily="34" charset="-122"/>
+                <a:cs typeface="Poppins" pitchFamily="34" charset="-120"/>
               </a:rPr>
               <a:t>lower price than Astra</a:t>
             </a:r>
-            <a:endParaRPr lang="en-US" sz="1400" dirty="0"/>
-          </a:p>
-          <a:p>
-            <a:pPr marL="203200" indent="-203200">
+            <a:endParaRPr lang="en-US" sz="1200" dirty="0"/>
+          </a:p>
+          <a:p>
+            <a:pPr marL="190500" indent="-190500">
               <a:spcAft>
-                <a:spcPts val="600"/>
+                <a:spcPts val="500"/>
               </a:spcAft>
               <a:buClr>
                 <a:srgbClr val="FFFFFF"/>
@@ -2272,63 +2277,63 @@
               <a:buChar char="•"/>
             </a:pPr>
             <a:r>
-              <a:rPr lang="en-US" sz="1400" dirty="0">
+              <a:rPr lang="en-US" sz="1200" dirty="0">
                 <a:solidFill>
                   <a:srgbClr val="5DAAFF"/>
                 </a:solidFill>
-                <a:latin typeface="Avenir Book" pitchFamily="34" charset="0"/>
-                <a:ea typeface="Avenir Book" pitchFamily="34" charset="-122"/>
-                <a:cs typeface="Avenir Book" pitchFamily="34" charset="-120"/>
+                <a:latin typeface="Poppins" pitchFamily="34" charset="0"/>
+                <a:ea typeface="Poppins" pitchFamily="34" charset="-122"/>
+                <a:cs typeface="Poppins" pitchFamily="34" charset="-120"/>
               </a:rPr>
               <a:t>Astra</a:t>
             </a:r>
             <a:r>
-              <a:rPr lang="en-US" sz="1400" dirty="0">
-                <a:solidFill>
-                  <a:srgbClr val="FFFFFF"/>
-                </a:solidFill>
-                <a:latin typeface="Avenir Book" pitchFamily="34" charset="0"/>
-                <a:ea typeface="Avenir Book" pitchFamily="34" charset="-122"/>
-                <a:cs typeface="Avenir Book" pitchFamily="34" charset="-120"/>
+              <a:rPr lang="en-US" sz="1200" dirty="0">
+                <a:solidFill>
+                  <a:srgbClr val="FFFFFF"/>
+                </a:solidFill>
+                <a:latin typeface="Poppins" pitchFamily="34" charset="0"/>
+                <a:ea typeface="Poppins" pitchFamily="34" charset="-122"/>
+                <a:cs typeface="Poppins" pitchFamily="34" charset="-120"/>
               </a:rPr>
               <a:t> is worth the premium for specialist work, while </a:t>
             </a:r>
             <a:r>
-              <a:rPr lang="en-US" sz="1400" dirty="0">
+              <a:rPr lang="en-US" sz="1200" dirty="0">
                 <a:solidFill>
                   <a:srgbClr val="5DAAFF"/>
                 </a:solidFill>
-                <a:latin typeface="Avenir Book" pitchFamily="34" charset="0"/>
-                <a:ea typeface="Avenir Book" pitchFamily="34" charset="-122"/>
-                <a:cs typeface="Avenir Book" pitchFamily="34" charset="-120"/>
+                <a:latin typeface="Poppins" pitchFamily="34" charset="0"/>
+                <a:ea typeface="Poppins" pitchFamily="34" charset="-122"/>
+                <a:cs typeface="Poppins" pitchFamily="34" charset="-120"/>
               </a:rPr>
               <a:t>Kimi K3</a:t>
             </a:r>
             <a:r>
-              <a:rPr lang="en-US" sz="1400" dirty="0">
-                <a:solidFill>
-                  <a:srgbClr val="FFFFFF"/>
-                </a:solidFill>
-                <a:latin typeface="Avenir Book" pitchFamily="34" charset="0"/>
-                <a:ea typeface="Avenir Book" pitchFamily="34" charset="-122"/>
-                <a:cs typeface="Avenir Book" pitchFamily="34" charset="-120"/>
+              <a:rPr lang="en-US" sz="1200" dirty="0">
+                <a:solidFill>
+                  <a:srgbClr val="FFFFFF"/>
+                </a:solidFill>
+                <a:latin typeface="Poppins" pitchFamily="34" charset="0"/>
+                <a:ea typeface="Poppins" pitchFamily="34" charset="-122"/>
+                <a:cs typeface="Poppins" pitchFamily="34" charset="-120"/>
               </a:rPr>
               <a:t> fits teams that need to keep data in-house or cut costs</a:t>
             </a:r>
-            <a:endParaRPr lang="en-US" sz="1400" dirty="0"/>
+            <a:endParaRPr lang="en-US" sz="1200" dirty="0"/>
           </a:p>
         </p:txBody>
       </p:sp>
       <p:sp>
         <p:nvSpPr>
-          <p:cNvPr id="31" name="TextBox 30"/>
+          <p:cNvPr id="32" name="TextBox 31"/>
           <p:cNvSpPr txBox="1"/>
           <p:nvPr/>
         </p:nvSpPr>
         <p:spPr>
           <a:xfrm>
-            <a:off x="365760" y="6400800"/>
-            <a:ext cx="11430000" cy="228600"/>
+            <a:off x="365760" y="6428232"/>
+            <a:ext cx="11430000" cy="201168"/>
           </a:xfrm>
           <a:prstGeom prst="rect">
             <a:avLst/>
@@ -2344,17 +2349,17 @@
               <a:buNone/>
             </a:pPr>
             <a:r>
-              <a:rPr lang="en-US" sz="1000" dirty="0">
+              <a:rPr lang="en-US" sz="850" dirty="0">
                 <a:solidFill>
                   <a:srgbClr val="7F8FA6"/>
                 </a:solidFill>
-                <a:latin typeface="Avenir Book" pitchFamily="34" charset="0"/>
-                <a:ea typeface="Avenir Book" pitchFamily="34" charset="-122"/>
-                <a:cs typeface="Avenir Book" pitchFamily="34" charset="-120"/>
+                <a:latin typeface="Poppins" pitchFamily="34" charset="0"/>
+                <a:ea typeface="Poppins" pitchFamily="34" charset="-122"/>
+                <a:cs typeface="Poppins" pitchFamily="34" charset="-120"/>
               </a:rPr>
               <a:t>Sources: Anthropic, OpenAI, Moonshot AI, Artificial Analysis (Sep 2026). Opus vs. Astra benchmarks as reported by Anthropic.</a:t>
             </a:r>
-            <a:endParaRPr lang="en-US" sz="1000" dirty="0"/>
+            <a:endParaRPr lang="en-US" sz="850" dirty="0"/>
           </a:p>
         </p:txBody>
       </p:sp>
@@ -2409,7 +2414,7 @@
     </a:clrScheme>
     <a:fontScheme name="Office">
       <a:majorFont>
-        <a:latin typeface="Avenir Book"/>
+        <a:latin typeface="Poppins"/>
         <a:ea typeface=""/>
         <a:cs typeface=""/>
         <a:font script="Jpan" typeface="游ゴシック Light"/>
@@ -2461,7 +2466,7 @@
         <a:font script="Tfng" typeface="Ebrima"/>
       </a:majorFont>
       <a:minorFont>
-        <a:latin typeface="Avenir Book"/>
+        <a:latin typeface="Poppins"/>
         <a:ea typeface=""/>
         <a:cs typeface=""/>
         <a:font script="Jpan" typeface="游ゴシック"/>

</xml_diff>

<commit_message>
New indigo palette, corner-bracket frames and full-colour logos
Move off the reference deck's navy and doubled borders: indigo glow
background, frosted cards with violet-to-cyan corner brackets, and
brand-colour logo tiles next to each model name.

Co-Authored-By: Claude Opus 5.5 <noreply@anthropic.com>
Claude-Session: https://claude.ai/code/session_01ArvvTMQ47fYQzBZA3Mrxmu
</commit_message>
<xml_diff>
--- a/ai-model-comparison/AI-Model-Comparison-Sep-2026.pptx
+++ b/ai-model-comparison/AI-Model-Comparison-Sep-2026.pptx
@@ -856,9 +856,16 @@
   <p:cSld name="Slide 1">
     <p:bg>
       <p:bgPr>
-        <a:solidFill>
-          <a:srgbClr val="001D3B"/>
-        </a:solidFill>
+        <a:blipFill dpi="0" rotWithShape="1">
+          <a:blip r:embed="rId1">
+            <a:lum/>
+          </a:blip>
+          <a:srcRect/>
+          <a:stretch>
+            <a:fillRect/>
+          </a:stretch>
+        </a:blipFill>
+        <a:effectLst/>
       </p:bgPr>
     </p:bg>
     <p:spTree>
@@ -877,132 +884,116 @@
       </p:grpSpPr>
       <p:sp>
         <p:nvSpPr>
-          <p:cNvPr id="2" name="Straight Connector 1"/>
+          <p:cNvPr id="2" name="TextBox 1"/>
+          <p:cNvSpPr txBox="1"/>
+          <p:nvPr/>
+        </p:nvSpPr>
+        <p:spPr>
+          <a:xfrm>
+            <a:off x="411480" y="329184"/>
+            <a:ext cx="10972800" cy="530352"/>
+          </a:xfrm>
+          <a:prstGeom prst="rect">
+            <a:avLst/>
+          </a:prstGeom>
+          <a:noFill/>
+          <a:ln/>
+        </p:spPr>
+        <p:txBody>
+          <a:bodyPr wrap="square" lIns="0" tIns="0" rIns="0" bIns="0" rtlCol="0" anchor="t"/>
+          <a:lstStyle/>
+          <a:p>
+            <a:pPr indent="0" marL="0">
+              <a:buNone/>
+            </a:pPr>
+            <a:r>
+              <a:rPr lang="en-US" sz="3000" dirty="0">
+                <a:solidFill>
+                  <a:srgbClr val="FFFFFF"/>
+                </a:solidFill>
+                <a:latin typeface="Poppins" pitchFamily="34" charset="0"/>
+                <a:ea typeface="Poppins" pitchFamily="34" charset="-122"/>
+                <a:cs typeface="Poppins" pitchFamily="34" charset="-120"/>
+              </a:rPr>
+              <a:t>Analysis of the Top Three Frontier AI Models</a:t>
+            </a:r>
+            <a:endParaRPr lang="en-US" sz="3000" dirty="0"/>
+          </a:p>
+        </p:txBody>
+      </p:sp>
+      <p:sp>
+        <p:nvSpPr>
+          <p:cNvPr id="3" name="TextBox 2"/>
+          <p:cNvSpPr txBox="1"/>
+          <p:nvPr/>
+        </p:nvSpPr>
+        <p:spPr>
+          <a:xfrm>
+            <a:off x="411480" y="868680"/>
+            <a:ext cx="11338560" cy="292608"/>
+          </a:xfrm>
+          <a:prstGeom prst="rect">
+            <a:avLst/>
+          </a:prstGeom>
+          <a:noFill/>
+          <a:ln/>
+        </p:spPr>
+        <p:txBody>
+          <a:bodyPr wrap="square" lIns="0" tIns="0" rIns="0" bIns="0" rtlCol="0" anchor="t"/>
+          <a:lstStyle/>
+          <a:p>
+            <a:pPr indent="0" marL="0">
+              <a:buNone/>
+            </a:pPr>
+            <a:r>
+              <a:rPr lang="en-US" sz="1350" i="1" dirty="0">
+                <a:solidFill>
+                  <a:srgbClr val="AEB6DA"/>
+                </a:solidFill>
+                <a:latin typeface="Poppins Light" pitchFamily="34" charset="0"/>
+                <a:ea typeface="Poppins Light" pitchFamily="34" charset="-122"/>
+                <a:cs typeface="Poppins Light" pitchFamily="34" charset="-120"/>
+              </a:rPr>
+              <a:t>Opus 5.5 leads on coding and analyst work, Astra on 3D tools and hard science, and Kimi K3 on cost and self-hosting</a:t>
+            </a:r>
+            <a:endParaRPr lang="en-US" sz="1350" dirty="0"/>
+          </a:p>
+        </p:txBody>
+      </p:sp>
+      <p:sp>
+        <p:nvSpPr>
+          <p:cNvPr id="4" name="Shape 3"/>
           <p:cNvSpPr/>
           <p:nvPr/>
         </p:nvSpPr>
         <p:spPr>
           <a:xfrm>
-            <a:off x="530352" y="402336"/>
-            <a:ext cx="0" cy="731520"/>
-          </a:xfrm>
-          <a:prstGeom prst="line">
-            <a:avLst/>
-          </a:prstGeom>
-          <a:noFill/>
-          <a:ln w="12700">
+            <a:off x="365760" y="1481328"/>
+            <a:ext cx="3611880" cy="3291840"/>
+          </a:xfrm>
+          <a:prstGeom prst="roundRect">
+            <a:avLst>
+              <a:gd name="adj" fmla="val 5000"/>
+            </a:avLst>
+          </a:prstGeom>
+          <a:solidFill>
+            <a:srgbClr val="FFFFFF">
+              <a:alpha val="6000"/>
+            </a:srgbClr>
+          </a:solidFill>
+          <a:ln w="6350">
             <a:solidFill>
-              <a:srgbClr val="FFFFFF"/>
+              <a:srgbClr val="FFFFFF">
+                <a:alpha val="10000"/>
+              </a:srgbClr>
             </a:solidFill>
             <a:prstDash val="solid"/>
           </a:ln>
         </p:spPr>
       </p:sp>
-      <p:sp>
-        <p:nvSpPr>
-          <p:cNvPr id="3" name="TextBox 2"/>
-          <p:cNvSpPr txBox="1"/>
-          <p:nvPr/>
-        </p:nvSpPr>
-        <p:spPr>
-          <a:xfrm>
-            <a:off x="795528" y="310896"/>
-            <a:ext cx="10515600" cy="530352"/>
-          </a:xfrm>
-          <a:prstGeom prst="rect">
-            <a:avLst/>
-          </a:prstGeom>
-          <a:noFill/>
-          <a:ln/>
-        </p:spPr>
-        <p:txBody>
-          <a:bodyPr wrap="square" lIns="0" tIns="0" rIns="0" bIns="0" rtlCol="0" anchor="t"/>
-          <a:lstStyle/>
-          <a:p>
-            <a:pPr indent="0" marL="0">
-              <a:buNone/>
-            </a:pPr>
-            <a:r>
-              <a:rPr lang="en-US" sz="3000" dirty="0">
-                <a:solidFill>
-                  <a:srgbClr val="FFFFFF"/>
-                </a:solidFill>
-                <a:latin typeface="Poppins" pitchFamily="34" charset="0"/>
-                <a:ea typeface="Poppins" pitchFamily="34" charset="-122"/>
-                <a:cs typeface="Poppins" pitchFamily="34" charset="-120"/>
-              </a:rPr>
-              <a:t>Analysis of the Top Three Frontier AI Models</a:t>
-            </a:r>
-            <a:endParaRPr lang="en-US" sz="3000" dirty="0"/>
-          </a:p>
-        </p:txBody>
-      </p:sp>
-      <p:sp>
-        <p:nvSpPr>
-          <p:cNvPr id="4" name="TextBox 3"/>
-          <p:cNvSpPr txBox="1"/>
-          <p:nvPr/>
-        </p:nvSpPr>
-        <p:spPr>
-          <a:xfrm>
-            <a:off x="795528" y="850392"/>
-            <a:ext cx="11064240" cy="292608"/>
-          </a:xfrm>
-          <a:prstGeom prst="rect">
-            <a:avLst/>
-          </a:prstGeom>
-          <a:noFill/>
-          <a:ln/>
-        </p:spPr>
-        <p:txBody>
-          <a:bodyPr wrap="square" lIns="0" tIns="0" rIns="0" bIns="0" rtlCol="0" anchor="t"/>
-          <a:lstStyle/>
-          <a:p>
-            <a:pPr indent="0" marL="0">
-              <a:buNone/>
-            </a:pPr>
-            <a:r>
-              <a:rPr lang="en-US" sz="1350" i="1" dirty="0">
-                <a:solidFill>
-                  <a:srgbClr val="FFFFFF"/>
-                </a:solidFill>
-                <a:latin typeface="Poppins Light" pitchFamily="34" charset="0"/>
-                <a:ea typeface="Poppins Light" pitchFamily="34" charset="-122"/>
-                <a:cs typeface="Poppins Light" pitchFamily="34" charset="-120"/>
-              </a:rPr>
-              <a:t>Opus 5.5 leads on coding and analyst work, Astra on 3D tools and hard science, and Kimi K3 on cost and self-hosting</a:t>
-            </a:r>
-            <a:endParaRPr lang="en-US" sz="1350" dirty="0"/>
-          </a:p>
-        </p:txBody>
-      </p:sp>
       <p:pic>
         <p:nvPicPr>
           <p:cNvPr id="5" name="Image 0" descr="preencoded.png">    </p:cNvPr>
-          <p:cNvPicPr>
-            <a:picLocks noChangeAspect="1"/>
-          </p:cNvPicPr>
-          <p:nvPr/>
-        </p:nvPicPr>
-        <p:blipFill>
-          <a:blip r:embed="rId1"/>
-          <a:stretch>
-            <a:fillRect/>
-          </a:stretch>
-        </p:blipFill>
-        <p:spPr>
-          <a:xfrm>
-            <a:off x="320040" y="1673352"/>
-            <a:ext cx="3767328" cy="3264408"/>
-          </a:xfrm>
-          <a:prstGeom prst="rect">
-            <a:avLst/>
-          </a:prstGeom>
-        </p:spPr>
-      </p:pic>
-      <p:pic>
-        <p:nvPicPr>
-          <p:cNvPr id="6" name="Image 1" descr="preencoded.png">    </p:cNvPr>
           <p:cNvPicPr>
             <a:picLocks noChangeAspect="1"/>
           </p:cNvPicPr>
@@ -1016,17 +1007,44 @@
         </p:blipFill>
         <p:spPr>
           <a:xfrm>
-            <a:off x="1805940" y="1353312"/>
-            <a:ext cx="731520" cy="731520"/>
+            <a:off x="329184" y="1444752"/>
+            <a:ext cx="3685032" cy="3364992"/>
           </a:xfrm>
           <a:prstGeom prst="rect">
             <a:avLst/>
           </a:prstGeom>
         </p:spPr>
       </p:pic>
+      <p:sp>
+        <p:nvSpPr>
+          <p:cNvPr id="6" name="Shape 5"/>
+          <p:cNvSpPr/>
+          <p:nvPr/>
+        </p:nvSpPr>
+        <p:spPr>
+          <a:xfrm>
+            <a:off x="640080" y="1755648"/>
+            <a:ext cx="566928" cy="566928"/>
+          </a:xfrm>
+          <a:prstGeom prst="roundRect">
+            <a:avLst>
+              <a:gd name="adj" fmla="val 20968"/>
+            </a:avLst>
+          </a:prstGeom>
+          <a:solidFill>
+            <a:srgbClr val="FFFFFF"/>
+          </a:solidFill>
+          <a:ln w="9525">
+            <a:solidFill>
+              <a:srgbClr val="FFFFFF"/>
+            </a:solidFill>
+            <a:prstDash val="solid"/>
+          </a:ln>
+        </p:spPr>
+      </p:sp>
       <p:pic>
         <p:nvPicPr>
-          <p:cNvPr id="7" name="Image 2" descr="preencoded.png">    </p:cNvPr>
+          <p:cNvPr id="7" name="Image 1" descr="preencoded.png">    </p:cNvPr>
           <p:cNvPicPr>
             <a:picLocks noChangeAspect="1"/>
           </p:cNvPicPr>
@@ -1040,8 +1058,8 @@
         </p:blipFill>
         <p:spPr>
           <a:xfrm>
-            <a:off x="1988820" y="1536192"/>
-            <a:ext cx="365760" cy="365760"/>
+            <a:off x="731520" y="1847088"/>
+            <a:ext cx="384048" cy="384048"/>
           </a:xfrm>
           <a:prstGeom prst="rect">
             <a:avLst/>
@@ -1056,8 +1074,8 @@
         </p:nvSpPr>
         <p:spPr>
           <a:xfrm>
-            <a:off x="640080" y="2176272"/>
-            <a:ext cx="3063240" cy="347472"/>
+            <a:off x="1371600" y="1755648"/>
+            <a:ext cx="2423160" cy="329184"/>
           </a:xfrm>
           <a:prstGeom prst="rect">
             <a:avLst/>
@@ -1069,11 +1087,11 @@
           <a:bodyPr wrap="square" lIns="0" tIns="0" rIns="0" bIns="0" rtlCol="0" anchor="t"/>
           <a:lstStyle/>
           <a:p>
-            <a:pPr algn="ctr" indent="0" marL="0">
+            <a:pPr indent="0" marL="0">
               <a:buNone/>
             </a:pPr>
             <a:r>
-              <a:rPr lang="en-US" sz="1800" dirty="0">
+              <a:rPr lang="en-US" sz="1700" dirty="0">
                 <a:solidFill>
                   <a:srgbClr val="FFFFFF"/>
                 </a:solidFill>
@@ -1083,20 +1101,59 @@
               </a:rPr>
               <a:t>Claude Opus 5.5</a:t>
             </a:r>
-            <a:endParaRPr lang="en-US" sz="1800" dirty="0"/>
+            <a:endParaRPr lang="en-US" sz="1700" dirty="0"/>
           </a:p>
         </p:txBody>
       </p:sp>
       <p:sp>
         <p:nvSpPr>
-          <p:cNvPr id="9" name="Straight Connector 8"/>
+          <p:cNvPr id="9" name="TextBox 8"/>
+          <p:cNvSpPr txBox="1"/>
+          <p:nvPr/>
+        </p:nvSpPr>
+        <p:spPr>
+          <a:xfrm>
+            <a:off x="1371600" y="2084832"/>
+            <a:ext cx="2423160" cy="219456"/>
+          </a:xfrm>
+          <a:prstGeom prst="rect">
+            <a:avLst/>
+          </a:prstGeom>
+          <a:noFill/>
+          <a:ln/>
+        </p:spPr>
+        <p:txBody>
+          <a:bodyPr wrap="square" lIns="0" tIns="0" rIns="0" bIns="0" rtlCol="0" anchor="t"/>
+          <a:lstStyle/>
+          <a:p>
+            <a:pPr indent="0" marL="0">
+              <a:buNone/>
+            </a:pPr>
+            <a:r>
+              <a:rPr lang="en-US" sz="1000" i="1" dirty="0">
+                <a:solidFill>
+                  <a:srgbClr val="AEB6DA"/>
+                </a:solidFill>
+                <a:latin typeface="Poppins Light" pitchFamily="34" charset="0"/>
+                <a:ea typeface="Poppins Light" pitchFamily="34" charset="-122"/>
+                <a:cs typeface="Poppins Light" pitchFamily="34" charset="-120"/>
+              </a:rPr>
+              <a:t>Anthropic  |  Released Sep 22, 2026</a:t>
+            </a:r>
+            <a:endParaRPr lang="en-US" sz="1000" dirty="0"/>
+          </a:p>
+        </p:txBody>
+      </p:sp>
+      <p:sp>
+        <p:nvSpPr>
+          <p:cNvPr id="10" name="Straight Connector 9"/>
           <p:cNvSpPr/>
           <p:nvPr/>
         </p:nvSpPr>
         <p:spPr>
           <a:xfrm>
-            <a:off x="914400" y="2569464"/>
-            <a:ext cx="2514600" cy="0"/>
+            <a:off x="640080" y="2505456"/>
+            <a:ext cx="3063240" cy="0"/>
           </a:xfrm>
           <a:prstGeom prst="line">
             <a:avLst/>
@@ -1104,7 +1161,7 @@
           <a:noFill/>
           <a:ln w="9525">
             <a:solidFill>
-              <a:srgbClr val="8A9BB5"/>
+              <a:srgbClr val="34407E"/>
             </a:solidFill>
             <a:prstDash val="solid"/>
           </a:ln>
@@ -1112,14 +1169,14 @@
       </p:sp>
       <p:sp>
         <p:nvSpPr>
-          <p:cNvPr id="10" name="TextBox 9"/>
+          <p:cNvPr id="11" name="TextBox 10"/>
           <p:cNvSpPr txBox="1"/>
           <p:nvPr/>
         </p:nvSpPr>
         <p:spPr>
           <a:xfrm>
-            <a:off x="640080" y="2633472"/>
-            <a:ext cx="3063240" cy="219456"/>
+            <a:off x="621792" y="2670048"/>
+            <a:ext cx="3154680" cy="1920240"/>
           </a:xfrm>
           <a:prstGeom prst="rect">
             <a:avLst/>
@@ -1131,48 +1188,9 @@
           <a:bodyPr wrap="square" lIns="0" tIns="0" rIns="0" bIns="0" rtlCol="0" anchor="t"/>
           <a:lstStyle/>
           <a:p>
-            <a:pPr algn="ctr" indent="0" marL="0">
-              <a:buNone/>
-            </a:pPr>
-            <a:r>
-              <a:rPr lang="en-US" sz="1000" i="1" dirty="0">
-                <a:solidFill>
-                  <a:srgbClr val="C9D3E0"/>
-                </a:solidFill>
-                <a:latin typeface="Poppins Light" pitchFamily="34" charset="0"/>
-                <a:ea typeface="Poppins Light" pitchFamily="34" charset="-122"/>
-                <a:cs typeface="Poppins Light" pitchFamily="34" charset="-120"/>
-              </a:rPr>
-              <a:t>Anthropic  |  Released Sep 22, 2026</a:t>
-            </a:r>
-            <a:endParaRPr lang="en-US" sz="1000" dirty="0"/>
-          </a:p>
-        </p:txBody>
-      </p:sp>
-      <p:sp>
-        <p:nvSpPr>
-          <p:cNvPr id="11" name="TextBox 10"/>
-          <p:cNvSpPr txBox="1"/>
-          <p:nvPr/>
-        </p:nvSpPr>
-        <p:spPr>
-          <a:xfrm>
-            <a:off x="603504" y="2944368"/>
-            <a:ext cx="3191256" cy="1645920"/>
-          </a:xfrm>
-          <a:prstGeom prst="rect">
-            <a:avLst/>
-          </a:prstGeom>
-          <a:noFill/>
-          <a:ln/>
-        </p:spPr>
-        <p:txBody>
-          <a:bodyPr wrap="square" lIns="0" tIns="0" rIns="0" bIns="0" rtlCol="0" anchor="t"/>
-          <a:lstStyle/>
-          <a:p>
             <a:pPr marL="190500" indent="-190500">
               <a:spcAft>
-                <a:spcPts val="700"/>
+                <a:spcPts val="900"/>
               </a:spcAft>
               <a:buClr>
                 <a:srgbClr val="FFFFFF"/>
@@ -1181,7 +1199,7 @@
               <a:buChar char="•"/>
             </a:pPr>
             <a:r>
-              <a:rPr lang="en-US" sz="1150" dirty="0">
+              <a:rPr lang="en-US" sz="1200" dirty="0">
                 <a:solidFill>
                   <a:srgbClr val="FFFFFF"/>
                 </a:solidFill>
@@ -1192,9 +1210,9 @@
               <a:t>Best for </a:t>
             </a:r>
             <a:r>
-              <a:rPr lang="en-US" sz="1150" dirty="0">
-                <a:solidFill>
-                  <a:srgbClr val="5DAAFF"/>
+              <a:rPr lang="en-US" sz="1200" dirty="0">
+                <a:solidFill>
+                  <a:srgbClr val="6FD6FF"/>
                 </a:solidFill>
                 <a:latin typeface="Poppins" pitchFamily="34" charset="0"/>
                 <a:ea typeface="Poppins" pitchFamily="34" charset="-122"/>
@@ -1203,7 +1221,7 @@
               <a:t>coding, agent workflows and analyst work</a:t>
             </a:r>
             <a:r>
-              <a:rPr lang="en-US" sz="1150" dirty="0">
+              <a:rPr lang="en-US" sz="1200" dirty="0">
                 <a:solidFill>
                   <a:srgbClr val="FFFFFF"/>
                 </a:solidFill>
@@ -1213,12 +1231,12 @@
               </a:rPr>
               <a:t> like research and modeling</a:t>
             </a:r>
-            <a:endParaRPr lang="en-US" sz="1150" dirty="0"/>
+            <a:endParaRPr lang="en-US" sz="1200" dirty="0"/>
           </a:p>
           <a:p>
             <a:pPr marL="190500" indent="-190500">
               <a:spcAft>
-                <a:spcPts val="700"/>
+                <a:spcPts val="900"/>
               </a:spcAft>
               <a:buClr>
                 <a:srgbClr val="FFFFFF"/>
@@ -1227,7 +1245,7 @@
               <a:buChar char="•"/>
             </a:pPr>
             <a:r>
-              <a:rPr lang="en-US" sz="1150" dirty="0">
+              <a:rPr lang="en-US" sz="1200" dirty="0">
                 <a:solidFill>
                   <a:srgbClr val="FFFFFF"/>
                 </a:solidFill>
@@ -1238,9 +1256,9 @@
               <a:t>Scored </a:t>
             </a:r>
             <a:r>
-              <a:rPr lang="en-US" sz="1150" dirty="0">
-                <a:solidFill>
-                  <a:srgbClr val="5DAAFF"/>
+              <a:rPr lang="en-US" sz="1200" dirty="0">
+                <a:solidFill>
+                  <a:srgbClr val="6FD6FF"/>
                 </a:solidFill>
                 <a:latin typeface="Poppins" pitchFamily="34" charset="0"/>
                 <a:ea typeface="Poppins" pitchFamily="34" charset="-122"/>
@@ -1249,7 +1267,7 @@
               <a:t>66.4% on Terminal-Bench 4.0</a:t>
             </a:r>
             <a:r>
-              <a:rPr lang="en-US" sz="1150" dirty="0">
+              <a:rPr lang="en-US" sz="1200" dirty="0">
                 <a:solidFill>
                   <a:srgbClr val="FFFFFF"/>
                 </a:solidFill>
@@ -1260,9 +1278,9 @@
               <a:t> vs. 57.9% for Astra; one customer migrated </a:t>
             </a:r>
             <a:r>
-              <a:rPr lang="en-US" sz="1150" dirty="0">
-                <a:solidFill>
-                  <a:srgbClr val="5DAAFF"/>
+              <a:rPr lang="en-US" sz="1200" dirty="0">
+                <a:solidFill>
+                  <a:srgbClr val="6FD6FF"/>
                 </a:solidFill>
                 <a:latin typeface="Poppins" pitchFamily="34" charset="0"/>
                 <a:ea typeface="Poppins" pitchFamily="34" charset="-122"/>
@@ -1270,12 +1288,12 @@
               </a:rPr>
               <a:t>680K lines of code in a day</a:t>
             </a:r>
-            <a:endParaRPr lang="en-US" sz="1150" dirty="0"/>
+            <a:endParaRPr lang="en-US" sz="1200" dirty="0"/>
           </a:p>
           <a:p>
             <a:pPr marL="190500" indent="-190500">
               <a:spcAft>
-                <a:spcPts val="700"/>
+                <a:spcPts val="900"/>
               </a:spcAft>
               <a:buClr>
                 <a:srgbClr val="FFFFFF"/>
@@ -1284,7 +1302,7 @@
               <a:buChar char="•"/>
             </a:pPr>
             <a:r>
-              <a:rPr lang="en-US" sz="1150" dirty="0">
+              <a:rPr lang="en-US" sz="1200" dirty="0">
                 <a:solidFill>
                   <a:srgbClr val="FFFFFF"/>
                 </a:solidFill>
@@ -1295,9 +1313,9 @@
               <a:t>Costs </a:t>
             </a:r>
             <a:r>
-              <a:rPr lang="en-US" sz="1150" dirty="0">
-                <a:solidFill>
-                  <a:srgbClr val="5DAAFF"/>
+              <a:rPr lang="en-US" sz="1200" dirty="0">
+                <a:solidFill>
+                  <a:srgbClr val="6FD6FF"/>
                 </a:solidFill>
                 <a:latin typeface="Poppins" pitchFamily="34" charset="0"/>
                 <a:ea typeface="Poppins" pitchFamily="34" charset="-122"/>
@@ -1306,7 +1324,7 @@
               <a:t>$4 / $20 per 1M tokens</a:t>
             </a:r>
             <a:r>
-              <a:rPr lang="en-US" sz="1150" dirty="0">
+              <a:rPr lang="en-US" sz="1200" dirty="0">
                 <a:solidFill>
                   <a:srgbClr val="FFFFFF"/>
                 </a:solidFill>
@@ -1316,52 +1334,44 @@
               </a:rPr>
               <a:t>, about 60% less than Astra</a:t>
             </a:r>
-            <a:endParaRPr lang="en-US" sz="1150" dirty="0"/>
+            <a:endParaRPr lang="en-US" sz="1200" dirty="0"/>
           </a:p>
         </p:txBody>
       </p:sp>
       <p:sp>
         <p:nvSpPr>
-          <p:cNvPr id="12" name="TextBox 11"/>
-          <p:cNvSpPr txBox="1"/>
-          <p:nvPr/>
-        </p:nvSpPr>
-        <p:spPr>
-          <a:xfrm>
-            <a:off x="3264408" y="4599432"/>
-            <a:ext cx="658368" cy="420624"/>
-          </a:xfrm>
-          <a:prstGeom prst="rect">
-            <a:avLst/>
-          </a:prstGeom>
-          <a:noFill/>
-          <a:ln/>
-        </p:spPr>
-        <p:txBody>
-          <a:bodyPr wrap="square" lIns="0" tIns="0" rIns="0" bIns="0" rtlCol="0" anchor="t"/>
-          <a:lstStyle/>
-          <a:p>
-            <a:pPr algn="ctr" indent="0" marL="0">
-              <a:buNone/>
-            </a:pPr>
-            <a:r>
-              <a:rPr lang="en-US" sz="2400" dirty="0">
-                <a:solidFill>
-                  <a:srgbClr val="FFFFFF"/>
-                </a:solidFill>
-                <a:latin typeface="Poppins" pitchFamily="34" charset="0"/>
-                <a:ea typeface="Poppins" pitchFamily="34" charset="-122"/>
-                <a:cs typeface="Poppins" pitchFamily="34" charset="-120"/>
-              </a:rPr>
-              <a:t>01</a:t>
-            </a:r>
-            <a:endParaRPr lang="en-US" sz="2400" dirty="0"/>
-          </a:p>
-        </p:txBody>
+          <p:cNvPr id="12" name="Shape 11"/>
+          <p:cNvSpPr/>
+          <p:nvPr/>
+        </p:nvSpPr>
+        <p:spPr>
+          <a:xfrm>
+            <a:off x="4270248" y="1481328"/>
+            <a:ext cx="3611880" cy="3291840"/>
+          </a:xfrm>
+          <a:prstGeom prst="roundRect">
+            <a:avLst>
+              <a:gd name="adj" fmla="val 5000"/>
+            </a:avLst>
+          </a:prstGeom>
+          <a:solidFill>
+            <a:srgbClr val="FFFFFF">
+              <a:alpha val="6000"/>
+            </a:srgbClr>
+          </a:solidFill>
+          <a:ln w="6350">
+            <a:solidFill>
+              <a:srgbClr val="FFFFFF">
+                <a:alpha val="10000"/>
+              </a:srgbClr>
+            </a:solidFill>
+            <a:prstDash val="solid"/>
+          </a:ln>
+        </p:spPr>
       </p:sp>
       <p:pic>
         <p:nvPicPr>
-          <p:cNvPr id="13" name="Image 3" descr="preencoded.png">    </p:cNvPr>
+          <p:cNvPr id="13" name="Image 2" descr="preencoded.png">    </p:cNvPr>
           <p:cNvPicPr>
             <a:picLocks noChangeAspect="1"/>
           </p:cNvPicPr>
@@ -1375,17 +1385,44 @@
         </p:blipFill>
         <p:spPr>
           <a:xfrm>
-            <a:off x="4224528" y="1673352"/>
-            <a:ext cx="3767328" cy="3264408"/>
+            <a:off x="4233672" y="1444752"/>
+            <a:ext cx="3685032" cy="3364992"/>
           </a:xfrm>
           <a:prstGeom prst="rect">
             <a:avLst/>
           </a:prstGeom>
         </p:spPr>
       </p:pic>
+      <p:sp>
+        <p:nvSpPr>
+          <p:cNvPr id="14" name="Shape 13"/>
+          <p:cNvSpPr/>
+          <p:nvPr/>
+        </p:nvSpPr>
+        <p:spPr>
+          <a:xfrm>
+            <a:off x="4544568" y="1755648"/>
+            <a:ext cx="566928" cy="566928"/>
+          </a:xfrm>
+          <a:prstGeom prst="roundRect">
+            <a:avLst>
+              <a:gd name="adj" fmla="val 20968"/>
+            </a:avLst>
+          </a:prstGeom>
+          <a:solidFill>
+            <a:srgbClr val="FFFFFF"/>
+          </a:solidFill>
+          <a:ln w="9525">
+            <a:solidFill>
+              <a:srgbClr val="FFFFFF"/>
+            </a:solidFill>
+            <a:prstDash val="solid"/>
+          </a:ln>
+        </p:spPr>
+      </p:sp>
       <p:pic>
         <p:nvPicPr>
-          <p:cNvPr id="14" name="Image 4" descr="preencoded.png">    </p:cNvPr>
+          <p:cNvPr id="15" name="Image 3" descr="preencoded.png">    </p:cNvPr>
           <p:cNvPicPr>
             <a:picLocks noChangeAspect="1"/>
           </p:cNvPicPr>
@@ -1399,17 +1436,331 @@
         </p:blipFill>
         <p:spPr>
           <a:xfrm>
-            <a:off x="5710428" y="1353312"/>
-            <a:ext cx="731520" cy="731520"/>
+            <a:off x="4636008" y="1847088"/>
+            <a:ext cx="384048" cy="384048"/>
           </a:xfrm>
           <a:prstGeom prst="rect">
             <a:avLst/>
           </a:prstGeom>
         </p:spPr>
       </p:pic>
+      <p:sp>
+        <p:nvSpPr>
+          <p:cNvPr id="16" name="TextBox 15"/>
+          <p:cNvSpPr txBox="1"/>
+          <p:nvPr/>
+        </p:nvSpPr>
+        <p:spPr>
+          <a:xfrm>
+            <a:off x="5276088" y="1755648"/>
+            <a:ext cx="2423160" cy="329184"/>
+          </a:xfrm>
+          <a:prstGeom prst="rect">
+            <a:avLst/>
+          </a:prstGeom>
+          <a:noFill/>
+          <a:ln/>
+        </p:spPr>
+        <p:txBody>
+          <a:bodyPr wrap="square" lIns="0" tIns="0" rIns="0" bIns="0" rtlCol="0" anchor="t"/>
+          <a:lstStyle/>
+          <a:p>
+            <a:pPr indent="0" marL="0">
+              <a:buNone/>
+            </a:pPr>
+            <a:r>
+              <a:rPr lang="en-US" sz="1700" dirty="0">
+                <a:solidFill>
+                  <a:srgbClr val="FFFFFF"/>
+                </a:solidFill>
+                <a:latin typeface="Poppins Medium" pitchFamily="34" charset="0"/>
+                <a:ea typeface="Poppins Medium" pitchFamily="34" charset="-122"/>
+                <a:cs typeface="Poppins Medium" pitchFamily="34" charset="-120"/>
+              </a:rPr>
+              <a:t>GPT-6 Astra</a:t>
+            </a:r>
+            <a:endParaRPr lang="en-US" sz="1700" dirty="0"/>
+          </a:p>
+        </p:txBody>
+      </p:sp>
+      <p:sp>
+        <p:nvSpPr>
+          <p:cNvPr id="17" name="TextBox 16"/>
+          <p:cNvSpPr txBox="1"/>
+          <p:nvPr/>
+        </p:nvSpPr>
+        <p:spPr>
+          <a:xfrm>
+            <a:off x="5276088" y="2084832"/>
+            <a:ext cx="2423160" cy="219456"/>
+          </a:xfrm>
+          <a:prstGeom prst="rect">
+            <a:avLst/>
+          </a:prstGeom>
+          <a:noFill/>
+          <a:ln/>
+        </p:spPr>
+        <p:txBody>
+          <a:bodyPr wrap="square" lIns="0" tIns="0" rIns="0" bIns="0" rtlCol="0" anchor="t"/>
+          <a:lstStyle/>
+          <a:p>
+            <a:pPr indent="0" marL="0">
+              <a:buNone/>
+            </a:pPr>
+            <a:r>
+              <a:rPr lang="en-US" sz="1000" i="1" dirty="0">
+                <a:solidFill>
+                  <a:srgbClr val="AEB6DA"/>
+                </a:solidFill>
+                <a:latin typeface="Poppins Light" pitchFamily="34" charset="0"/>
+                <a:ea typeface="Poppins Light" pitchFamily="34" charset="-122"/>
+                <a:cs typeface="Poppins Light" pitchFamily="34" charset="-120"/>
+              </a:rPr>
+              <a:t>OpenAI  |  Released Sep 3, 2026</a:t>
+            </a:r>
+            <a:endParaRPr lang="en-US" sz="1000" dirty="0"/>
+          </a:p>
+        </p:txBody>
+      </p:sp>
+      <p:sp>
+        <p:nvSpPr>
+          <p:cNvPr id="18" name="Straight Connector 17"/>
+          <p:cNvSpPr/>
+          <p:nvPr/>
+        </p:nvSpPr>
+        <p:spPr>
+          <a:xfrm>
+            <a:off x="4544568" y="2505456"/>
+            <a:ext cx="3063240" cy="0"/>
+          </a:xfrm>
+          <a:prstGeom prst="line">
+            <a:avLst/>
+          </a:prstGeom>
+          <a:noFill/>
+          <a:ln w="9525">
+            <a:solidFill>
+              <a:srgbClr val="34407E"/>
+            </a:solidFill>
+            <a:prstDash val="solid"/>
+          </a:ln>
+        </p:spPr>
+      </p:sp>
+      <p:sp>
+        <p:nvSpPr>
+          <p:cNvPr id="19" name="TextBox 18"/>
+          <p:cNvSpPr txBox="1"/>
+          <p:nvPr/>
+        </p:nvSpPr>
+        <p:spPr>
+          <a:xfrm>
+            <a:off x="4526280" y="2670048"/>
+            <a:ext cx="3154680" cy="1920240"/>
+          </a:xfrm>
+          <a:prstGeom prst="rect">
+            <a:avLst/>
+          </a:prstGeom>
+          <a:noFill/>
+          <a:ln/>
+        </p:spPr>
+        <p:txBody>
+          <a:bodyPr wrap="square" lIns="0" tIns="0" rIns="0" bIns="0" rtlCol="0" anchor="t"/>
+          <a:lstStyle/>
+          <a:p>
+            <a:pPr marL="190500" indent="-190500">
+              <a:spcAft>
+                <a:spcPts val="900"/>
+              </a:spcAft>
+              <a:buClr>
+                <a:srgbClr val="FFFFFF"/>
+              </a:buClr>
+              <a:buSzPct val="100000"/>
+              <a:buChar char="•"/>
+            </a:pPr>
+            <a:r>
+              <a:rPr lang="en-US" sz="1200" dirty="0">
+                <a:solidFill>
+                  <a:srgbClr val="FFFFFF"/>
+                </a:solidFill>
+                <a:latin typeface="Poppins" pitchFamily="34" charset="0"/>
+                <a:ea typeface="Poppins" pitchFamily="34" charset="-122"/>
+                <a:cs typeface="Poppins" pitchFamily="34" charset="-120"/>
+              </a:rPr>
+              <a:t>Best for </a:t>
+            </a:r>
+            <a:r>
+              <a:rPr lang="en-US" sz="1200" dirty="0">
+                <a:solidFill>
+                  <a:srgbClr val="6FD6FF"/>
+                </a:solidFill>
+                <a:latin typeface="Poppins" pitchFamily="34" charset="0"/>
+                <a:ea typeface="Poppins" pitchFamily="34" charset="-122"/>
+                <a:cs typeface="Poppins" pitchFamily="34" charset="-120"/>
+              </a:rPr>
+              <a:t>operating desktop software</a:t>
+            </a:r>
+            <a:r>
+              <a:rPr lang="en-US" sz="1200" dirty="0">
+                <a:solidFill>
+                  <a:srgbClr val="FFFFFF"/>
+                </a:solidFill>
+                <a:latin typeface="Poppins" pitchFamily="34" charset="0"/>
+                <a:ea typeface="Poppins" pitchFamily="34" charset="-122"/>
+                <a:cs typeface="Poppins" pitchFamily="34" charset="-120"/>
+              </a:rPr>
+              <a:t>, </a:t>
+            </a:r>
+            <a:r>
+              <a:rPr lang="en-US" sz="1200" dirty="0">
+                <a:solidFill>
+                  <a:srgbClr val="6FD6FF"/>
+                </a:solidFill>
+                <a:latin typeface="Poppins" pitchFamily="34" charset="0"/>
+                <a:ea typeface="Poppins" pitchFamily="34" charset="-122"/>
+                <a:cs typeface="Poppins" pitchFamily="34" charset="-120"/>
+              </a:rPr>
+              <a:t>3D tools like Blender and UE5</a:t>
+            </a:r>
+            <a:r>
+              <a:rPr lang="en-US" sz="1200" dirty="0">
+                <a:solidFill>
+                  <a:srgbClr val="FFFFFF"/>
+                </a:solidFill>
+                <a:latin typeface="Poppins" pitchFamily="34" charset="0"/>
+                <a:ea typeface="Poppins" pitchFamily="34" charset="-122"/>
+                <a:cs typeface="Poppins" pitchFamily="34" charset="-120"/>
+              </a:rPr>
+              <a:t>, and hard math and science</a:t>
+            </a:r>
+            <a:endParaRPr lang="en-US" sz="1200" dirty="0"/>
+          </a:p>
+          <a:p>
+            <a:pPr marL="190500" indent="-190500">
+              <a:spcAft>
+                <a:spcPts val="900"/>
+              </a:spcAft>
+              <a:buClr>
+                <a:srgbClr val="FFFFFF"/>
+              </a:buClr>
+              <a:buSzPct val="100000"/>
+              <a:buChar char="•"/>
+            </a:pPr>
+            <a:r>
+              <a:rPr lang="en-US" sz="1200" dirty="0">
+                <a:solidFill>
+                  <a:srgbClr val="FFFFFF"/>
+                </a:solidFill>
+                <a:latin typeface="Poppins" pitchFamily="34" charset="0"/>
+                <a:ea typeface="Poppins" pitchFamily="34" charset="-122"/>
+                <a:cs typeface="Poppins" pitchFamily="34" charset="-120"/>
+              </a:rPr>
+              <a:t>Scored </a:t>
+            </a:r>
+            <a:r>
+              <a:rPr lang="en-US" sz="1200" dirty="0">
+                <a:solidFill>
+                  <a:srgbClr val="6FD6FF"/>
+                </a:solidFill>
+                <a:latin typeface="Poppins" pitchFamily="34" charset="0"/>
+                <a:ea typeface="Poppins" pitchFamily="34" charset="-122"/>
+                <a:cs typeface="Poppins" pitchFamily="34" charset="-120"/>
+              </a:rPr>
+              <a:t>97.6% on FrontierMath Tier 4</a:t>
+            </a:r>
+            <a:r>
+              <a:rPr lang="en-US" sz="1200" dirty="0">
+                <a:solidFill>
+                  <a:srgbClr val="FFFFFF"/>
+                </a:solidFill>
+                <a:latin typeface="Poppins" pitchFamily="34" charset="0"/>
+                <a:ea typeface="Poppins" pitchFamily="34" charset="-122"/>
+                <a:cs typeface="Poppins" pitchFamily="34" charset="-120"/>
+              </a:rPr>
+              <a:t> and 72.6% on OSWorld 2.0</a:t>
+            </a:r>
+            <a:endParaRPr lang="en-US" sz="1200" dirty="0"/>
+          </a:p>
+          <a:p>
+            <a:pPr marL="190500" indent="-190500">
+              <a:spcAft>
+                <a:spcPts val="900"/>
+              </a:spcAft>
+              <a:buClr>
+                <a:srgbClr val="FFFFFF"/>
+              </a:buClr>
+              <a:buSzPct val="100000"/>
+              <a:buChar char="•"/>
+            </a:pPr>
+            <a:r>
+              <a:rPr lang="en-US" sz="1200" dirty="0">
+                <a:solidFill>
+                  <a:srgbClr val="FFFFFF"/>
+                </a:solidFill>
+                <a:latin typeface="Poppins" pitchFamily="34" charset="0"/>
+                <a:ea typeface="Poppins" pitchFamily="34" charset="-122"/>
+                <a:cs typeface="Poppins" pitchFamily="34" charset="-120"/>
+              </a:rPr>
+              <a:t>Most expensive at </a:t>
+            </a:r>
+            <a:r>
+              <a:rPr lang="en-US" sz="1200" dirty="0">
+                <a:solidFill>
+                  <a:srgbClr val="6FD6FF"/>
+                </a:solidFill>
+                <a:latin typeface="Poppins" pitchFamily="34" charset="0"/>
+                <a:ea typeface="Poppins" pitchFamily="34" charset="-122"/>
+                <a:cs typeface="Poppins" pitchFamily="34" charset="-120"/>
+              </a:rPr>
+              <a:t>$10 / $50 per 1M tokens</a:t>
+            </a:r>
+            <a:r>
+              <a:rPr lang="en-US" sz="1200" dirty="0">
+                <a:solidFill>
+                  <a:srgbClr val="FFFFFF"/>
+                </a:solidFill>
+                <a:latin typeface="Poppins" pitchFamily="34" charset="0"/>
+                <a:ea typeface="Poppins" pitchFamily="34" charset="-122"/>
+                <a:cs typeface="Poppins" pitchFamily="34" charset="-120"/>
+              </a:rPr>
+              <a:t>, with access still rolling out in stages</a:t>
+            </a:r>
+            <a:endParaRPr lang="en-US" sz="1200" dirty="0"/>
+          </a:p>
+        </p:txBody>
+      </p:sp>
+      <p:sp>
+        <p:nvSpPr>
+          <p:cNvPr id="20" name="Shape 19"/>
+          <p:cNvSpPr/>
+          <p:nvPr/>
+        </p:nvSpPr>
+        <p:spPr>
+          <a:xfrm>
+            <a:off x="8174736" y="1481328"/>
+            <a:ext cx="3611880" cy="3291840"/>
+          </a:xfrm>
+          <a:prstGeom prst="roundRect">
+            <a:avLst>
+              <a:gd name="adj" fmla="val 5000"/>
+            </a:avLst>
+          </a:prstGeom>
+          <a:solidFill>
+            <a:srgbClr val="FFFFFF">
+              <a:alpha val="6000"/>
+            </a:srgbClr>
+          </a:solidFill>
+          <a:ln w="6350">
+            <a:solidFill>
+              <a:srgbClr val="FFFFFF">
+                <a:alpha val="10000"/>
+              </a:srgbClr>
+            </a:solidFill>
+            <a:prstDash val="solid"/>
+          </a:ln>
+        </p:spPr>
+      </p:sp>
       <p:pic>
         <p:nvPicPr>
-          <p:cNvPr id="15" name="Image 5" descr="preencoded.png">    </p:cNvPr>
+          <p:cNvPr id="21" name="Image 4" descr="preencoded.png">    </p:cNvPr>
           <p:cNvPicPr>
             <a:picLocks noChangeAspect="1"/>
           </p:cNvPicPr>
@@ -1423,8 +1774,8 @@
         </p:blipFill>
         <p:spPr>
           <a:xfrm>
-            <a:off x="5893308" y="1536192"/>
-            <a:ext cx="365760" cy="365760"/>
+            <a:off x="8138160" y="1444752"/>
+            <a:ext cx="3685032" cy="3364992"/>
           </a:xfrm>
           <a:prstGeom prst="rect">
             <a:avLst/>
@@ -1433,14 +1784,65 @@
       </p:pic>
       <p:sp>
         <p:nvSpPr>
-          <p:cNvPr id="16" name="TextBox 15"/>
+          <p:cNvPr id="22" name="Shape 21"/>
+          <p:cNvSpPr/>
+          <p:nvPr/>
+        </p:nvSpPr>
+        <p:spPr>
+          <a:xfrm>
+            <a:off x="8449056" y="1755648"/>
+            <a:ext cx="566928" cy="566928"/>
+          </a:xfrm>
+          <a:prstGeom prst="roundRect">
+            <a:avLst>
+              <a:gd name="adj" fmla="val 20968"/>
+            </a:avLst>
+          </a:prstGeom>
+          <a:solidFill>
+            <a:srgbClr val="000000"/>
+          </a:solidFill>
+          <a:ln w="9525">
+            <a:solidFill>
+              <a:srgbClr val="4A558F"/>
+            </a:solidFill>
+            <a:prstDash val="solid"/>
+          </a:ln>
+        </p:spPr>
+      </p:sp>
+      <p:pic>
+        <p:nvPicPr>
+          <p:cNvPr id="23" name="Image 5" descr="preencoded.png">    </p:cNvPr>
+          <p:cNvPicPr>
+            <a:picLocks noChangeAspect="1"/>
+          </p:cNvPicPr>
+          <p:nvPr/>
+        </p:nvPicPr>
+        <p:blipFill>
+          <a:blip r:embed="rId7"/>
+          <a:stretch>
+            <a:fillRect/>
+          </a:stretch>
+        </p:blipFill>
+        <p:spPr>
+          <a:xfrm>
+            <a:off x="8540496" y="1847088"/>
+            <a:ext cx="384048" cy="384048"/>
+          </a:xfrm>
+          <a:prstGeom prst="rect">
+            <a:avLst/>
+          </a:prstGeom>
+        </p:spPr>
+      </p:pic>
+      <p:sp>
+        <p:nvSpPr>
+          <p:cNvPr id="24" name="TextBox 23"/>
           <p:cNvSpPr txBox="1"/>
           <p:nvPr/>
         </p:nvSpPr>
         <p:spPr>
           <a:xfrm>
-            <a:off x="4544568" y="2176272"/>
-            <a:ext cx="3063240" cy="347472"/>
+            <a:off x="9180576" y="1755648"/>
+            <a:ext cx="2423160" cy="329184"/>
           </a:xfrm>
           <a:prstGeom prst="rect">
             <a:avLst/>
@@ -1452,11 +1854,11 @@
           <a:bodyPr wrap="square" lIns="0" tIns="0" rIns="0" bIns="0" rtlCol="0" anchor="t"/>
           <a:lstStyle/>
           <a:p>
-            <a:pPr algn="ctr" indent="0" marL="0">
+            <a:pPr indent="0" marL="0">
               <a:buNone/>
             </a:pPr>
             <a:r>
-              <a:rPr lang="en-US" sz="1800" dirty="0">
+              <a:rPr lang="en-US" sz="1700" dirty="0">
                 <a:solidFill>
                   <a:srgbClr val="FFFFFF"/>
                 </a:solidFill>
@@ -1464,22 +1866,61 @@
                 <a:ea typeface="Poppins Medium" pitchFamily="34" charset="-122"/>
                 <a:cs typeface="Poppins Medium" pitchFamily="34" charset="-120"/>
               </a:rPr>
-              <a:t>GPT-6 Astra</a:t>
-            </a:r>
-            <a:endParaRPr lang="en-US" sz="1800" dirty="0"/>
+              <a:t>Kimi K3</a:t>
+            </a:r>
+            <a:endParaRPr lang="en-US" sz="1700" dirty="0"/>
           </a:p>
         </p:txBody>
       </p:sp>
       <p:sp>
         <p:nvSpPr>
-          <p:cNvPr id="17" name="Straight Connector 16"/>
+          <p:cNvPr id="25" name="TextBox 24"/>
+          <p:cNvSpPr txBox="1"/>
+          <p:nvPr/>
+        </p:nvSpPr>
+        <p:spPr>
+          <a:xfrm>
+            <a:off x="9180576" y="2084832"/>
+            <a:ext cx="2423160" cy="219456"/>
+          </a:xfrm>
+          <a:prstGeom prst="rect">
+            <a:avLst/>
+          </a:prstGeom>
+          <a:noFill/>
+          <a:ln/>
+        </p:spPr>
+        <p:txBody>
+          <a:bodyPr wrap="square" lIns="0" tIns="0" rIns="0" bIns="0" rtlCol="0" anchor="t"/>
+          <a:lstStyle/>
+          <a:p>
+            <a:pPr indent="0" marL="0">
+              <a:buNone/>
+            </a:pPr>
+            <a:r>
+              <a:rPr lang="en-US" sz="1000" i="1" dirty="0">
+                <a:solidFill>
+                  <a:srgbClr val="AEB6DA"/>
+                </a:solidFill>
+                <a:latin typeface="Poppins Light" pitchFamily="34" charset="0"/>
+                <a:ea typeface="Poppins Light" pitchFamily="34" charset="-122"/>
+                <a:cs typeface="Poppins Light" pitchFamily="34" charset="-120"/>
+              </a:rPr>
+              <a:t>Moonshot AI  |  Released Jul 16, 2026</a:t>
+            </a:r>
+            <a:endParaRPr lang="en-US" sz="1000" dirty="0"/>
+          </a:p>
+        </p:txBody>
+      </p:sp>
+      <p:sp>
+        <p:nvSpPr>
+          <p:cNvPr id="26" name="Straight Connector 25"/>
           <p:cNvSpPr/>
           <p:nvPr/>
         </p:nvSpPr>
         <p:spPr>
           <a:xfrm>
-            <a:off x="4818888" y="2569464"/>
-            <a:ext cx="2514600" cy="0"/>
+            <a:off x="8449056" y="2505456"/>
+            <a:ext cx="3063240" cy="0"/>
           </a:xfrm>
           <a:prstGeom prst="line">
             <a:avLst/>
@@ -1487,7 +1928,7 @@
           <a:noFill/>
           <a:ln w="9525">
             <a:solidFill>
-              <a:srgbClr val="8A9BB5"/>
+              <a:srgbClr val="34407E"/>
             </a:solidFill>
             <a:prstDash val="solid"/>
           </a:ln>
@@ -1495,14 +1936,14 @@
       </p:sp>
       <p:sp>
         <p:nvSpPr>
-          <p:cNvPr id="18" name="TextBox 17"/>
+          <p:cNvPr id="27" name="TextBox 26"/>
           <p:cNvSpPr txBox="1"/>
           <p:nvPr/>
         </p:nvSpPr>
         <p:spPr>
           <a:xfrm>
-            <a:off x="4544568" y="2633472"/>
-            <a:ext cx="3063240" cy="219456"/>
+            <a:off x="8430768" y="2670048"/>
+            <a:ext cx="3154680" cy="1920240"/>
           </a:xfrm>
           <a:prstGeom prst="rect">
             <a:avLst/>
@@ -1514,48 +1955,9 @@
           <a:bodyPr wrap="square" lIns="0" tIns="0" rIns="0" bIns="0" rtlCol="0" anchor="t"/>
           <a:lstStyle/>
           <a:p>
-            <a:pPr algn="ctr" indent="0" marL="0">
-              <a:buNone/>
-            </a:pPr>
-            <a:r>
-              <a:rPr lang="en-US" sz="1000" i="1" dirty="0">
-                <a:solidFill>
-                  <a:srgbClr val="C9D3E0"/>
-                </a:solidFill>
-                <a:latin typeface="Poppins Light" pitchFamily="34" charset="0"/>
-                <a:ea typeface="Poppins Light" pitchFamily="34" charset="-122"/>
-                <a:cs typeface="Poppins Light" pitchFamily="34" charset="-120"/>
-              </a:rPr>
-              <a:t>OpenAI  |  Released Sep 3, 2026</a:t>
-            </a:r>
-            <a:endParaRPr lang="en-US" sz="1000" dirty="0"/>
-          </a:p>
-        </p:txBody>
-      </p:sp>
-      <p:sp>
-        <p:nvSpPr>
-          <p:cNvPr id="19" name="TextBox 18"/>
-          <p:cNvSpPr txBox="1"/>
-          <p:nvPr/>
-        </p:nvSpPr>
-        <p:spPr>
-          <a:xfrm>
-            <a:off x="4507992" y="2944368"/>
-            <a:ext cx="3191256" cy="1645920"/>
-          </a:xfrm>
-          <a:prstGeom prst="rect">
-            <a:avLst/>
-          </a:prstGeom>
-          <a:noFill/>
-          <a:ln/>
-        </p:spPr>
-        <p:txBody>
-          <a:bodyPr wrap="square" lIns="0" tIns="0" rIns="0" bIns="0" rtlCol="0" anchor="t"/>
-          <a:lstStyle/>
-          <a:p>
             <a:pPr marL="190500" indent="-190500">
               <a:spcAft>
-                <a:spcPts val="700"/>
+                <a:spcPts val="900"/>
               </a:spcAft>
               <a:buClr>
                 <a:srgbClr val="FFFFFF"/>
@@ -1564,7 +1966,7 @@
               <a:buChar char="•"/>
             </a:pPr>
             <a:r>
-              <a:rPr lang="en-US" sz="1150" dirty="0">
+              <a:rPr lang="en-US" sz="1200" dirty="0">
                 <a:solidFill>
                   <a:srgbClr val="FFFFFF"/>
                 </a:solidFill>
@@ -1575,18 +1977,18 @@
               <a:t>Best for </a:t>
             </a:r>
             <a:r>
-              <a:rPr lang="en-US" sz="1150" dirty="0">
-                <a:solidFill>
-                  <a:srgbClr val="5DAAFF"/>
-                </a:solidFill>
-                <a:latin typeface="Poppins" pitchFamily="34" charset="0"/>
-                <a:ea typeface="Poppins" pitchFamily="34" charset="-122"/>
-                <a:cs typeface="Poppins" pitchFamily="34" charset="-120"/>
-              </a:rPr>
-              <a:t>operating desktop software</a:t>
-            </a:r>
-            <a:r>
-              <a:rPr lang="en-US" sz="1150" dirty="0">
+              <a:rPr lang="en-US" sz="1200" dirty="0">
+                <a:solidFill>
+                  <a:srgbClr val="6FD6FF"/>
+                </a:solidFill>
+                <a:latin typeface="Poppins" pitchFamily="34" charset="0"/>
+                <a:ea typeface="Poppins" pitchFamily="34" charset="-122"/>
+                <a:cs typeface="Poppins" pitchFamily="34" charset="-120"/>
+              </a:rPr>
+              <a:t>high-volume, low-cost work</a:t>
+            </a:r>
+            <a:r>
+              <a:rPr lang="en-US" sz="1200" dirty="0">
                 <a:solidFill>
                   <a:srgbClr val="FFFFFF"/>
                 </a:solidFill>
@@ -1594,36 +1996,25 @@
                 <a:ea typeface="Poppins" pitchFamily="34" charset="-122"/>
                 <a:cs typeface="Poppins" pitchFamily="34" charset="-120"/>
               </a:rPr>
-              <a:t>, 3D tools like </a:t>
-            </a:r>
-            <a:r>
-              <a:rPr lang="en-US" sz="1150" dirty="0">
-                <a:solidFill>
-                  <a:srgbClr val="5DAAFF"/>
-                </a:solidFill>
-                <a:latin typeface="Poppins" pitchFamily="34" charset="0"/>
-                <a:ea typeface="Poppins" pitchFamily="34" charset="-122"/>
-                <a:cs typeface="Poppins" pitchFamily="34" charset="-120"/>
-              </a:rPr>
-              <a:t>Blender and Unreal Engine 5</a:t>
-            </a:r>
-            <a:r>
-              <a:rPr lang="en-US" sz="1150" dirty="0">
-                <a:solidFill>
-                  <a:srgbClr val="FFFFFF"/>
-                </a:solidFill>
-                <a:latin typeface="Poppins" pitchFamily="34" charset="0"/>
-                <a:ea typeface="Poppins" pitchFamily="34" charset="-122"/>
-                <a:cs typeface="Poppins" pitchFamily="34" charset="-120"/>
-              </a:rPr>
-              <a:t>, and hard math and science</a:t>
-            </a:r>
-            <a:endParaRPr lang="en-US" sz="1150" dirty="0"/>
+              <a:t> and anything that must be </a:t>
+            </a:r>
+            <a:r>
+              <a:rPr lang="en-US" sz="1200" dirty="0">
+                <a:solidFill>
+                  <a:srgbClr val="6FD6FF"/>
+                </a:solidFill>
+                <a:latin typeface="Poppins" pitchFamily="34" charset="0"/>
+                <a:ea typeface="Poppins" pitchFamily="34" charset="-122"/>
+                <a:cs typeface="Poppins" pitchFamily="34" charset="-120"/>
+              </a:rPr>
+              <a:t>self-hosted</a:t>
+            </a:r>
+            <a:endParaRPr lang="en-US" sz="1200" dirty="0"/>
           </a:p>
           <a:p>
             <a:pPr marL="190500" indent="-190500">
               <a:spcAft>
-                <a:spcPts val="700"/>
+                <a:spcPts val="900"/>
               </a:spcAft>
               <a:buClr>
                 <a:srgbClr val="FFFFFF"/>
@@ -1632,7 +2023,7 @@
               <a:buChar char="•"/>
             </a:pPr>
             <a:r>
-              <a:rPr lang="en-US" sz="1150" dirty="0">
+              <a:rPr lang="en-US" sz="1200" dirty="0">
                 <a:solidFill>
                   <a:srgbClr val="FFFFFF"/>
                 </a:solidFill>
@@ -1640,21 +2031,21 @@
                 <a:ea typeface="Poppins" pitchFamily="34" charset="-122"/>
                 <a:cs typeface="Poppins" pitchFamily="34" charset="-120"/>
               </a:rPr>
-              <a:t>Scored </a:t>
-            </a:r>
-            <a:r>
-              <a:rPr lang="en-US" sz="1150" dirty="0">
-                <a:solidFill>
-                  <a:srgbClr val="5DAAFF"/>
-                </a:solidFill>
-                <a:latin typeface="Poppins" pitchFamily="34" charset="0"/>
-                <a:ea typeface="Poppins" pitchFamily="34" charset="-122"/>
-                <a:cs typeface="Poppins" pitchFamily="34" charset="-120"/>
-              </a:rPr>
-              <a:t>97.6% on FrontierMath Tier 4</a:t>
-            </a:r>
-            <a:r>
-              <a:rPr lang="en-US" sz="1150" dirty="0">
+              <a:t>The </a:t>
+            </a:r>
+            <a:r>
+              <a:rPr lang="en-US" sz="1200" dirty="0">
+                <a:solidFill>
+                  <a:srgbClr val="6FD6FF"/>
+                </a:solidFill>
+                <a:latin typeface="Poppins" pitchFamily="34" charset="0"/>
+                <a:ea typeface="Poppins" pitchFamily="34" charset="-122"/>
+                <a:cs typeface="Poppins" pitchFamily="34" charset="-120"/>
+              </a:rPr>
+              <a:t>only open-weight model</a:t>
+            </a:r>
+            <a:r>
+              <a:rPr lang="en-US" sz="1200" dirty="0">
                 <a:solidFill>
                   <a:srgbClr val="FFFFFF"/>
                 </a:solidFill>
@@ -1662,14 +2053,14 @@
                 <a:ea typeface="Poppins" pitchFamily="34" charset="-122"/>
                 <a:cs typeface="Poppins" pitchFamily="34" charset="-120"/>
               </a:rPr>
-              <a:t> and 72.6% on OSWorld 2.0</a:t>
-            </a:r>
-            <a:endParaRPr lang="en-US" sz="1150" dirty="0"/>
+              <a:t> of the three, with 2.8T parameters</a:t>
+            </a:r>
+            <a:endParaRPr lang="en-US" sz="1200" dirty="0"/>
           </a:p>
           <a:p>
             <a:pPr marL="190500" indent="-190500">
               <a:spcAft>
-                <a:spcPts val="700"/>
+                <a:spcPts val="900"/>
               </a:spcAft>
               <a:buClr>
                 <a:srgbClr val="FFFFFF"/>
@@ -1678,7 +2069,7 @@
               <a:buChar char="•"/>
             </a:pPr>
             <a:r>
-              <a:rPr lang="en-US" sz="1150" dirty="0">
+              <a:rPr lang="en-US" sz="1200" dirty="0">
                 <a:solidFill>
                   <a:srgbClr val="FFFFFF"/>
                 </a:solidFill>
@@ -1686,21 +2077,21 @@
                 <a:ea typeface="Poppins" pitchFamily="34" charset="-122"/>
                 <a:cs typeface="Poppins" pitchFamily="34" charset="-120"/>
               </a:rPr>
-              <a:t>Most expensive at </a:t>
-            </a:r>
-            <a:r>
-              <a:rPr lang="en-US" sz="1150" dirty="0">
-                <a:solidFill>
-                  <a:srgbClr val="5DAAFF"/>
-                </a:solidFill>
-                <a:latin typeface="Poppins" pitchFamily="34" charset="0"/>
-                <a:ea typeface="Poppins" pitchFamily="34" charset="-122"/>
-                <a:cs typeface="Poppins" pitchFamily="34" charset="-120"/>
-              </a:rPr>
-              <a:t>$10 / $50 per 1M tokens</a:t>
-            </a:r>
-            <a:r>
-              <a:rPr lang="en-US" sz="1150" dirty="0">
+              <a:t>Cheapest at </a:t>
+            </a:r>
+            <a:r>
+              <a:rPr lang="en-US" sz="1200" dirty="0">
+                <a:solidFill>
+                  <a:srgbClr val="6FD6FF"/>
+                </a:solidFill>
+                <a:latin typeface="Poppins" pitchFamily="34" charset="0"/>
+                <a:ea typeface="Poppins" pitchFamily="34" charset="-122"/>
+                <a:cs typeface="Poppins" pitchFamily="34" charset="-120"/>
+              </a:rPr>
+              <a:t>$3 / $15 per 1M tokens</a:t>
+            </a:r>
+            <a:r>
+              <a:rPr lang="en-US" sz="1200" dirty="0">
                 <a:solidFill>
                   <a:srgbClr val="FFFFFF"/>
                 </a:solidFill>
@@ -1708,78 +2099,46 @@
                 <a:ea typeface="Poppins" pitchFamily="34" charset="-122"/>
                 <a:cs typeface="Poppins" pitchFamily="34" charset="-120"/>
               </a:rPr>
-              <a:t>, with access still rolling out in stages</a:t>
-            </a:r>
-            <a:endParaRPr lang="en-US" sz="1150" dirty="0"/>
+              <a:t>, but scores 44 vs. 58 for Opus on the Artificial Analysis index</a:t>
+            </a:r>
+            <a:endParaRPr lang="en-US" sz="1200" dirty="0"/>
           </a:p>
         </p:txBody>
       </p:sp>
       <p:sp>
         <p:nvSpPr>
-          <p:cNvPr id="20" name="TextBox 19"/>
-          <p:cNvSpPr txBox="1"/>
-          <p:nvPr/>
-        </p:nvSpPr>
-        <p:spPr>
-          <a:xfrm>
-            <a:off x="7168896" y="4599432"/>
-            <a:ext cx="658368" cy="420624"/>
-          </a:xfrm>
-          <a:prstGeom prst="rect">
-            <a:avLst/>
-          </a:prstGeom>
-          <a:noFill/>
-          <a:ln/>
-        </p:spPr>
-        <p:txBody>
-          <a:bodyPr wrap="square" lIns="0" tIns="0" rIns="0" bIns="0" rtlCol="0" anchor="t"/>
-          <a:lstStyle/>
-          <a:p>
-            <a:pPr algn="ctr" indent="0" marL="0">
-              <a:buNone/>
-            </a:pPr>
-            <a:r>
-              <a:rPr lang="en-US" sz="2400" dirty="0">
-                <a:solidFill>
-                  <a:srgbClr val="FFFFFF"/>
-                </a:solidFill>
-                <a:latin typeface="Poppins" pitchFamily="34" charset="0"/>
-                <a:ea typeface="Poppins" pitchFamily="34" charset="-122"/>
-                <a:cs typeface="Poppins" pitchFamily="34" charset="-120"/>
-              </a:rPr>
-              <a:t>02</a:t>
-            </a:r>
-            <a:endParaRPr lang="en-US" sz="2400" dirty="0"/>
-          </a:p>
-        </p:txBody>
+          <p:cNvPr id="28" name="Shape 27"/>
+          <p:cNvSpPr/>
+          <p:nvPr/>
+        </p:nvSpPr>
+        <p:spPr>
+          <a:xfrm>
+            <a:off x="365760" y="5029200"/>
+            <a:ext cx="11457432" cy="1207008"/>
+          </a:xfrm>
+          <a:prstGeom prst="roundRect">
+            <a:avLst>
+              <a:gd name="adj" fmla="val 13636"/>
+            </a:avLst>
+          </a:prstGeom>
+          <a:solidFill>
+            <a:srgbClr val="FFFFFF">
+              <a:alpha val="6000"/>
+            </a:srgbClr>
+          </a:solidFill>
+          <a:ln w="6350">
+            <a:solidFill>
+              <a:srgbClr val="FFFFFF">
+                <a:alpha val="10000"/>
+              </a:srgbClr>
+            </a:solidFill>
+            <a:prstDash val="solid"/>
+          </a:ln>
+        </p:spPr>
       </p:sp>
       <p:pic>
         <p:nvPicPr>
-          <p:cNvPr id="21" name="Image 6" descr="preencoded.png">    </p:cNvPr>
-          <p:cNvPicPr>
-            <a:picLocks noChangeAspect="1"/>
-          </p:cNvPicPr>
-          <p:nvPr/>
-        </p:nvPicPr>
-        <p:blipFill>
-          <a:blip r:embed="rId7"/>
-          <a:stretch>
-            <a:fillRect/>
-          </a:stretch>
-        </p:blipFill>
-        <p:spPr>
-          <a:xfrm>
-            <a:off x="8129016" y="1673352"/>
-            <a:ext cx="3767328" cy="3264408"/>
-          </a:xfrm>
-          <a:prstGeom prst="rect">
-            <a:avLst/>
-          </a:prstGeom>
-        </p:spPr>
-      </p:pic>
-      <p:pic>
-        <p:nvPicPr>
-          <p:cNvPr id="22" name="Image 7" descr="preencoded.png">    </p:cNvPr>
+          <p:cNvPr id="29" name="Image 6" descr="preencoded.png">    </p:cNvPr>
           <p:cNvPicPr>
             <a:picLocks noChangeAspect="1"/>
           </p:cNvPicPr>
@@ -1793,48 +2152,24 @@
         </p:blipFill>
         <p:spPr>
           <a:xfrm>
-            <a:off x="9614916" y="1353312"/>
-            <a:ext cx="731520" cy="731520"/>
+            <a:off x="329184" y="4992624"/>
+            <a:ext cx="11530584" cy="1280160"/>
           </a:xfrm>
           <a:prstGeom prst="rect">
             <a:avLst/>
           </a:prstGeom>
         </p:spPr>
       </p:pic>
-      <p:pic>
-        <p:nvPicPr>
-          <p:cNvPr id="23" name="Image 8" descr="preencoded.png">    </p:cNvPr>
-          <p:cNvPicPr>
-            <a:picLocks noChangeAspect="1"/>
-          </p:cNvPicPr>
-          <p:nvPr/>
-        </p:nvPicPr>
-        <p:blipFill>
-          <a:blip r:embed="rId9"/>
-          <a:stretch>
-            <a:fillRect/>
-          </a:stretch>
-        </p:blipFill>
-        <p:spPr>
-          <a:xfrm>
-            <a:off x="9797796" y="1536192"/>
-            <a:ext cx="365760" cy="365760"/>
-          </a:xfrm>
-          <a:prstGeom prst="rect">
-            <a:avLst/>
-          </a:prstGeom>
-        </p:spPr>
-      </p:pic>
-      <p:sp>
-        <p:nvSpPr>
-          <p:cNvPr id="24" name="TextBox 23"/>
+      <p:sp>
+        <p:nvSpPr>
+          <p:cNvPr id="30" name="TextBox 29"/>
           <p:cNvSpPr txBox="1"/>
           <p:nvPr/>
         </p:nvSpPr>
         <p:spPr>
           <a:xfrm>
-            <a:off x="8449056" y="2176272"/>
-            <a:ext cx="3063240" cy="347472"/>
+            <a:off x="640080" y="5212080"/>
+            <a:ext cx="3657600" cy="274320"/>
           </a:xfrm>
           <a:prstGeom prst="rect">
             <a:avLst/>
@@ -1846,57 +2181,34 @@
           <a:bodyPr wrap="square" lIns="0" tIns="0" rIns="0" bIns="0" rtlCol="0" anchor="t"/>
           <a:lstStyle/>
           <a:p>
-            <a:pPr algn="ctr" indent="0" marL="0">
+            <a:pPr indent="0" marL="0">
               <a:buNone/>
             </a:pPr>
             <a:r>
-              <a:rPr lang="en-US" sz="1800" dirty="0">
-                <a:solidFill>
-                  <a:srgbClr val="FFFFFF"/>
+              <a:rPr lang="en-US" sz="1300" dirty="0">
+                <a:solidFill>
+                  <a:srgbClr val="6FD6FF"/>
                 </a:solidFill>
                 <a:latin typeface="Poppins Medium" pitchFamily="34" charset="0"/>
                 <a:ea typeface="Poppins Medium" pitchFamily="34" charset="-122"/>
                 <a:cs typeface="Poppins Medium" pitchFamily="34" charset="-120"/>
               </a:rPr>
-              <a:t>Kimi K3</a:t>
-            </a:r>
-            <a:endParaRPr lang="en-US" sz="1800" dirty="0"/>
+              <a:t>Key Takeaways</a:t>
+            </a:r>
+            <a:endParaRPr lang="en-US" sz="1300" dirty="0"/>
           </a:p>
         </p:txBody>
       </p:sp>
       <p:sp>
         <p:nvSpPr>
-          <p:cNvPr id="25" name="Straight Connector 24"/>
-          <p:cNvSpPr/>
-          <p:nvPr/>
-        </p:nvSpPr>
-        <p:spPr>
-          <a:xfrm>
-            <a:off x="8723376" y="2569464"/>
-            <a:ext cx="2514600" cy="0"/>
-          </a:xfrm>
-          <a:prstGeom prst="line">
-            <a:avLst/>
-          </a:prstGeom>
-          <a:noFill/>
-          <a:ln w="9525">
-            <a:solidFill>
-              <a:srgbClr val="8A9BB5"/>
-            </a:solidFill>
-            <a:prstDash val="solid"/>
-          </a:ln>
-        </p:spPr>
-      </p:sp>
-      <p:sp>
-        <p:nvSpPr>
-          <p:cNvPr id="26" name="TextBox 25"/>
+          <p:cNvPr id="31" name="TextBox 30"/>
           <p:cNvSpPr txBox="1"/>
           <p:nvPr/>
         </p:nvSpPr>
         <p:spPr>
           <a:xfrm>
-            <a:off x="8449056" y="2633472"/>
-            <a:ext cx="3063240" cy="219456"/>
+            <a:off x="640080" y="5532120"/>
+            <a:ext cx="10908792" cy="566928"/>
           </a:xfrm>
           <a:prstGeom prst="rect">
             <a:avLst/>
@@ -1906,318 +2218,6 @@
         </p:spPr>
         <p:txBody>
           <a:bodyPr wrap="square" lIns="0" tIns="0" rIns="0" bIns="0" rtlCol="0" anchor="t"/>
-          <a:lstStyle/>
-          <a:p>
-            <a:pPr algn="ctr" indent="0" marL="0">
-              <a:buNone/>
-            </a:pPr>
-            <a:r>
-              <a:rPr lang="en-US" sz="1000" i="1" dirty="0">
-                <a:solidFill>
-                  <a:srgbClr val="C9D3E0"/>
-                </a:solidFill>
-                <a:latin typeface="Poppins Light" pitchFamily="34" charset="0"/>
-                <a:ea typeface="Poppins Light" pitchFamily="34" charset="-122"/>
-                <a:cs typeface="Poppins Light" pitchFamily="34" charset="-120"/>
-              </a:rPr>
-              <a:t>Moonshot AI  |  Released Jul 16, 2026</a:t>
-            </a:r>
-            <a:endParaRPr lang="en-US" sz="1000" dirty="0"/>
-          </a:p>
-        </p:txBody>
-      </p:sp>
-      <p:sp>
-        <p:nvSpPr>
-          <p:cNvPr id="27" name="TextBox 26"/>
-          <p:cNvSpPr txBox="1"/>
-          <p:nvPr/>
-        </p:nvSpPr>
-        <p:spPr>
-          <a:xfrm>
-            <a:off x="8412480" y="2944368"/>
-            <a:ext cx="3191256" cy="1645920"/>
-          </a:xfrm>
-          <a:prstGeom prst="rect">
-            <a:avLst/>
-          </a:prstGeom>
-          <a:noFill/>
-          <a:ln/>
-        </p:spPr>
-        <p:txBody>
-          <a:bodyPr wrap="square" lIns="0" tIns="0" rIns="0" bIns="0" rtlCol="0" anchor="t"/>
-          <a:lstStyle/>
-          <a:p>
-            <a:pPr marL="190500" indent="-190500">
-              <a:spcAft>
-                <a:spcPts val="700"/>
-              </a:spcAft>
-              <a:buClr>
-                <a:srgbClr val="FFFFFF"/>
-              </a:buClr>
-              <a:buSzPct val="100000"/>
-              <a:buChar char="•"/>
-            </a:pPr>
-            <a:r>
-              <a:rPr lang="en-US" sz="1150" dirty="0">
-                <a:solidFill>
-                  <a:srgbClr val="FFFFFF"/>
-                </a:solidFill>
-                <a:latin typeface="Poppins" pitchFamily="34" charset="0"/>
-                <a:ea typeface="Poppins" pitchFamily="34" charset="-122"/>
-                <a:cs typeface="Poppins" pitchFamily="34" charset="-120"/>
-              </a:rPr>
-              <a:t>Best for </a:t>
-            </a:r>
-            <a:r>
-              <a:rPr lang="en-US" sz="1150" dirty="0">
-                <a:solidFill>
-                  <a:srgbClr val="5DAAFF"/>
-                </a:solidFill>
-                <a:latin typeface="Poppins" pitchFamily="34" charset="0"/>
-                <a:ea typeface="Poppins" pitchFamily="34" charset="-122"/>
-                <a:cs typeface="Poppins" pitchFamily="34" charset="-120"/>
-              </a:rPr>
-              <a:t>high-volume, low-cost work</a:t>
-            </a:r>
-            <a:r>
-              <a:rPr lang="en-US" sz="1150" dirty="0">
-                <a:solidFill>
-                  <a:srgbClr val="FFFFFF"/>
-                </a:solidFill>
-                <a:latin typeface="Poppins" pitchFamily="34" charset="0"/>
-                <a:ea typeface="Poppins" pitchFamily="34" charset="-122"/>
-                <a:cs typeface="Poppins" pitchFamily="34" charset="-120"/>
-              </a:rPr>
-              <a:t> and anything that has to be </a:t>
-            </a:r>
-            <a:r>
-              <a:rPr lang="en-US" sz="1150" dirty="0">
-                <a:solidFill>
-                  <a:srgbClr val="5DAAFF"/>
-                </a:solidFill>
-                <a:latin typeface="Poppins" pitchFamily="34" charset="0"/>
-                <a:ea typeface="Poppins" pitchFamily="34" charset="-122"/>
-                <a:cs typeface="Poppins" pitchFamily="34" charset="-120"/>
-              </a:rPr>
-              <a:t>self-hosted</a:t>
-            </a:r>
-            <a:endParaRPr lang="en-US" sz="1150" dirty="0"/>
-          </a:p>
-          <a:p>
-            <a:pPr marL="190500" indent="-190500">
-              <a:spcAft>
-                <a:spcPts val="700"/>
-              </a:spcAft>
-              <a:buClr>
-                <a:srgbClr val="FFFFFF"/>
-              </a:buClr>
-              <a:buSzPct val="100000"/>
-              <a:buChar char="•"/>
-            </a:pPr>
-            <a:r>
-              <a:rPr lang="en-US" sz="1150" dirty="0">
-                <a:solidFill>
-                  <a:srgbClr val="FFFFFF"/>
-                </a:solidFill>
-                <a:latin typeface="Poppins" pitchFamily="34" charset="0"/>
-                <a:ea typeface="Poppins" pitchFamily="34" charset="-122"/>
-                <a:cs typeface="Poppins" pitchFamily="34" charset="-120"/>
-              </a:rPr>
-              <a:t>The </a:t>
-            </a:r>
-            <a:r>
-              <a:rPr lang="en-US" sz="1150" dirty="0">
-                <a:solidFill>
-                  <a:srgbClr val="5DAAFF"/>
-                </a:solidFill>
-                <a:latin typeface="Poppins" pitchFamily="34" charset="0"/>
-                <a:ea typeface="Poppins" pitchFamily="34" charset="-122"/>
-                <a:cs typeface="Poppins" pitchFamily="34" charset="-120"/>
-              </a:rPr>
-              <a:t>only open-weight model</a:t>
-            </a:r>
-            <a:r>
-              <a:rPr lang="en-US" sz="1150" dirty="0">
-                <a:solidFill>
-                  <a:srgbClr val="FFFFFF"/>
-                </a:solidFill>
-                <a:latin typeface="Poppins" pitchFamily="34" charset="0"/>
-                <a:ea typeface="Poppins" pitchFamily="34" charset="-122"/>
-                <a:cs typeface="Poppins" pitchFamily="34" charset="-120"/>
-              </a:rPr>
-              <a:t> of the three, with 2.8T parameters</a:t>
-            </a:r>
-            <a:endParaRPr lang="en-US" sz="1150" dirty="0"/>
-          </a:p>
-          <a:p>
-            <a:pPr marL="190500" indent="-190500">
-              <a:spcAft>
-                <a:spcPts val="700"/>
-              </a:spcAft>
-              <a:buClr>
-                <a:srgbClr val="FFFFFF"/>
-              </a:buClr>
-              <a:buSzPct val="100000"/>
-              <a:buChar char="•"/>
-            </a:pPr>
-            <a:r>
-              <a:rPr lang="en-US" sz="1150" dirty="0">
-                <a:solidFill>
-                  <a:srgbClr val="FFFFFF"/>
-                </a:solidFill>
-                <a:latin typeface="Poppins" pitchFamily="34" charset="0"/>
-                <a:ea typeface="Poppins" pitchFamily="34" charset="-122"/>
-                <a:cs typeface="Poppins" pitchFamily="34" charset="-120"/>
-              </a:rPr>
-              <a:t>Cheapest at </a:t>
-            </a:r>
-            <a:r>
-              <a:rPr lang="en-US" sz="1150" dirty="0">
-                <a:solidFill>
-                  <a:srgbClr val="5DAAFF"/>
-                </a:solidFill>
-                <a:latin typeface="Poppins" pitchFamily="34" charset="0"/>
-                <a:ea typeface="Poppins" pitchFamily="34" charset="-122"/>
-                <a:cs typeface="Poppins" pitchFamily="34" charset="-120"/>
-              </a:rPr>
-              <a:t>$3 / $15 per 1M tokens</a:t>
-            </a:r>
-            <a:r>
-              <a:rPr lang="en-US" sz="1150" dirty="0">
-                <a:solidFill>
-                  <a:srgbClr val="FFFFFF"/>
-                </a:solidFill>
-                <a:latin typeface="Poppins" pitchFamily="34" charset="0"/>
-                <a:ea typeface="Poppins" pitchFamily="34" charset="-122"/>
-                <a:cs typeface="Poppins" pitchFamily="34" charset="-120"/>
-              </a:rPr>
-              <a:t>, but scores 44 vs. 58 for Opus on the Artificial Analysis index</a:t>
-            </a:r>
-            <a:endParaRPr lang="en-US" sz="1150" dirty="0"/>
-          </a:p>
-        </p:txBody>
-      </p:sp>
-      <p:sp>
-        <p:nvSpPr>
-          <p:cNvPr id="28" name="TextBox 27"/>
-          <p:cNvSpPr txBox="1"/>
-          <p:nvPr/>
-        </p:nvSpPr>
-        <p:spPr>
-          <a:xfrm>
-            <a:off x="11073384" y="4599432"/>
-            <a:ext cx="658368" cy="420624"/>
-          </a:xfrm>
-          <a:prstGeom prst="rect">
-            <a:avLst/>
-          </a:prstGeom>
-          <a:noFill/>
-          <a:ln/>
-        </p:spPr>
-        <p:txBody>
-          <a:bodyPr wrap="square" lIns="0" tIns="0" rIns="0" bIns="0" rtlCol="0" anchor="t"/>
-          <a:lstStyle/>
-          <a:p>
-            <a:pPr algn="ctr" indent="0" marL="0">
-              <a:buNone/>
-            </a:pPr>
-            <a:r>
-              <a:rPr lang="en-US" sz="2400" dirty="0">
-                <a:solidFill>
-                  <a:srgbClr val="FFFFFF"/>
-                </a:solidFill>
-                <a:latin typeface="Poppins" pitchFamily="34" charset="0"/>
-                <a:ea typeface="Poppins" pitchFamily="34" charset="-122"/>
-                <a:cs typeface="Poppins" pitchFamily="34" charset="-120"/>
-              </a:rPr>
-              <a:t>03</a:t>
-            </a:r>
-            <a:endParaRPr lang="en-US" sz="2400" dirty="0"/>
-          </a:p>
-        </p:txBody>
-      </p:sp>
-      <p:pic>
-        <p:nvPicPr>
-          <p:cNvPr id="29" name="Image 9" descr="preencoded.png">    </p:cNvPr>
-          <p:cNvPicPr>
-            <a:picLocks noChangeAspect="1"/>
-          </p:cNvPicPr>
-          <p:nvPr/>
-        </p:nvPicPr>
-        <p:blipFill>
-          <a:blip r:embed="rId10"/>
-          <a:stretch>
-            <a:fillRect/>
-          </a:stretch>
-        </p:blipFill>
-        <p:spPr>
-          <a:xfrm>
-            <a:off x="320040" y="5184648"/>
-            <a:ext cx="11612880" cy="1069848"/>
-          </a:xfrm>
-          <a:prstGeom prst="rect">
-            <a:avLst/>
-          </a:prstGeom>
-        </p:spPr>
-      </p:pic>
-      <p:sp>
-        <p:nvSpPr>
-          <p:cNvPr id="30" name="TextBox 29"/>
-          <p:cNvSpPr txBox="1"/>
-          <p:nvPr/>
-        </p:nvSpPr>
-        <p:spPr>
-          <a:xfrm>
-            <a:off x="822960" y="5047488"/>
-            <a:ext cx="2331720" cy="365760"/>
-          </a:xfrm>
-          <a:prstGeom prst="rect">
-            <a:avLst/>
-          </a:prstGeom>
-          <a:noFill/>
-          <a:ln/>
-        </p:spPr>
-        <p:txBody>
-          <a:bodyPr wrap="square" lIns="0" tIns="0" rIns="0" bIns="0" rtlCol="0" anchor="ctr"/>
-          <a:lstStyle/>
-          <a:p>
-            <a:pPr algn="ctr" indent="0" marL="0">
-              <a:buNone/>
-            </a:pPr>
-            <a:r>
-              <a:rPr lang="en-US" sz="1600" dirty="0">
-                <a:solidFill>
-                  <a:srgbClr val="FFFFFF"/>
-                </a:solidFill>
-                <a:latin typeface="Poppins" pitchFamily="34" charset="0"/>
-                <a:ea typeface="Poppins" pitchFamily="34" charset="-122"/>
-                <a:cs typeface="Poppins" pitchFamily="34" charset="-120"/>
-              </a:rPr>
-              <a:t>Key Takeaways</a:t>
-            </a:r>
-            <a:endParaRPr lang="en-US" sz="1600" dirty="0"/>
-          </a:p>
-        </p:txBody>
-      </p:sp>
-      <p:sp>
-        <p:nvSpPr>
-          <p:cNvPr id="31" name="TextBox 30"/>
-          <p:cNvSpPr txBox="1"/>
-          <p:nvPr/>
-        </p:nvSpPr>
-        <p:spPr>
-          <a:xfrm>
-            <a:off x="640080" y="5413248"/>
-            <a:ext cx="10908792" cy="658368"/>
-          </a:xfrm>
-          <a:prstGeom prst="rect">
-            <a:avLst/>
-          </a:prstGeom>
-          <a:noFill/>
-          <a:ln/>
-        </p:spPr>
-        <p:txBody>
-          <a:bodyPr wrap="square" lIns="0" tIns="0" rIns="0" bIns="0" rtlCol="0" anchor="ctr"/>
           <a:lstStyle/>
           <a:p>
             <a:pPr marL="190500" indent="-190500">
@@ -2231,9 +2231,9 @@
               <a:buChar char="•"/>
             </a:pPr>
             <a:r>
-              <a:rPr lang="en-US" sz="1200" dirty="0">
-                <a:solidFill>
-                  <a:srgbClr val="5DAAFF"/>
+              <a:rPr lang="en-US" sz="1250" dirty="0">
+                <a:solidFill>
+                  <a:srgbClr val="6FD6FF"/>
                 </a:solidFill>
                 <a:latin typeface="Poppins" pitchFamily="34" charset="0"/>
                 <a:ea typeface="Poppins" pitchFamily="34" charset="-122"/>
@@ -2242,7 +2242,7 @@
               <a:t>Opus 5.5</a:t>
             </a:r>
             <a:r>
-              <a:rPr lang="en-US" sz="1200" dirty="0">
+              <a:rPr lang="en-US" sz="1250" dirty="0">
                 <a:solidFill>
                   <a:srgbClr val="FFFFFF"/>
                 </a:solidFill>
@@ -2253,9 +2253,9 @@
               <a:t> should be the default for most work, given its lead on coding and knowledge-work benchmarks and its </a:t>
             </a:r>
             <a:r>
-              <a:rPr lang="en-US" sz="1200" dirty="0">
-                <a:solidFill>
-                  <a:srgbClr val="5DAAFF"/>
+              <a:rPr lang="en-US" sz="1250" dirty="0">
+                <a:solidFill>
+                  <a:srgbClr val="6FD6FF"/>
                 </a:solidFill>
                 <a:latin typeface="Poppins" pitchFamily="34" charset="0"/>
                 <a:ea typeface="Poppins" pitchFamily="34" charset="-122"/>
@@ -2263,7 +2263,7 @@
               </a:rPr>
               <a:t>lower price than Astra</a:t>
             </a:r>
-            <a:endParaRPr lang="en-US" sz="1200" dirty="0"/>
+            <a:endParaRPr lang="en-US" sz="1250" dirty="0"/>
           </a:p>
           <a:p>
             <a:pPr marL="190500" indent="-190500">
@@ -2277,9 +2277,9 @@
               <a:buChar char="•"/>
             </a:pPr>
             <a:r>
-              <a:rPr lang="en-US" sz="1200" dirty="0">
-                <a:solidFill>
-                  <a:srgbClr val="5DAAFF"/>
+              <a:rPr lang="en-US" sz="1250" dirty="0">
+                <a:solidFill>
+                  <a:srgbClr val="6FD6FF"/>
                 </a:solidFill>
                 <a:latin typeface="Poppins" pitchFamily="34" charset="0"/>
                 <a:ea typeface="Poppins" pitchFamily="34" charset="-122"/>
@@ -2288,7 +2288,7 @@
               <a:t>Astra</a:t>
             </a:r>
             <a:r>
-              <a:rPr lang="en-US" sz="1200" dirty="0">
+              <a:rPr lang="en-US" sz="1250" dirty="0">
                 <a:solidFill>
                   <a:srgbClr val="FFFFFF"/>
                 </a:solidFill>
@@ -2299,9 +2299,9 @@
               <a:t> is worth the premium for specialist work, while </a:t>
             </a:r>
             <a:r>
-              <a:rPr lang="en-US" sz="1200" dirty="0">
-                <a:solidFill>
-                  <a:srgbClr val="5DAAFF"/>
+              <a:rPr lang="en-US" sz="1250" dirty="0">
+                <a:solidFill>
+                  <a:srgbClr val="6FD6FF"/>
                 </a:solidFill>
                 <a:latin typeface="Poppins" pitchFamily="34" charset="0"/>
                 <a:ea typeface="Poppins" pitchFamily="34" charset="-122"/>
@@ -2310,7 +2310,7 @@
               <a:t>Kimi K3</a:t>
             </a:r>
             <a:r>
-              <a:rPr lang="en-US" sz="1200" dirty="0">
+              <a:rPr lang="en-US" sz="1250" dirty="0">
                 <a:solidFill>
                   <a:srgbClr val="FFFFFF"/>
                 </a:solidFill>
@@ -2320,7 +2320,7 @@
               </a:rPr>
               <a:t> fits teams that need to keep data in-house or cut costs</a:t>
             </a:r>
-            <a:endParaRPr lang="en-US" sz="1200" dirty="0"/>
+            <a:endParaRPr lang="en-US" sz="1250" dirty="0"/>
           </a:p>
         </p:txBody>
       </p:sp>
@@ -2351,7 +2351,7 @@
             <a:r>
               <a:rPr lang="en-US" sz="850" dirty="0">
                 <a:solidFill>
-                  <a:srgbClr val="7F8FA6"/>
+                  <a:srgbClr val="8C95BD"/>
                 </a:solidFill>
                 <a:latin typeface="Poppins" pitchFamily="34" charset="0"/>
                 <a:ea typeface="Poppins" pitchFamily="34" charset="-122"/>

</xml_diff>

<commit_message>
Drop sources line; add PDF export with Poppins embedded
Co-Authored-By: Claude Opus 5.5 <noreply@anthropic.com>
Claude-Session: https://claude.ai/code/session_01ArvvTMQ47fYQzBZA3Mrxmu
</commit_message>
<xml_diff>
--- a/ai-model-comparison/AI-Model-Comparison-Sep-2026.pptx
+++ b/ai-model-comparison/AI-Model-Comparison-Sep-2026.pptx
@@ -2113,12 +2113,12 @@
         </p:nvSpPr>
         <p:spPr>
           <a:xfrm>
-            <a:off x="365760" y="5029200"/>
-            <a:ext cx="11457432" cy="1207008"/>
+            <a:off x="365760" y="5138928"/>
+            <a:ext cx="11457432" cy="1261872"/>
           </a:xfrm>
           <a:prstGeom prst="roundRect">
             <a:avLst>
-              <a:gd name="adj" fmla="val 13636"/>
+              <a:gd name="adj" fmla="val 13043"/>
             </a:avLst>
           </a:prstGeom>
           <a:solidFill>
@@ -2152,8 +2152,8 @@
         </p:blipFill>
         <p:spPr>
           <a:xfrm>
-            <a:off x="329184" y="4992624"/>
-            <a:ext cx="11530584" cy="1280160"/>
+            <a:off x="329184" y="5102352"/>
+            <a:ext cx="11530584" cy="1335024"/>
           </a:xfrm>
           <a:prstGeom prst="rect">
             <a:avLst/>
@@ -2168,7 +2168,7 @@
         </p:nvSpPr>
         <p:spPr>
           <a:xfrm>
-            <a:off x="640080" y="5212080"/>
+            <a:off x="640080" y="5321808"/>
             <a:ext cx="3657600" cy="274320"/>
           </a:xfrm>
           <a:prstGeom prst="rect">
@@ -2207,8 +2207,8 @@
         </p:nvSpPr>
         <p:spPr>
           <a:xfrm>
-            <a:off x="640080" y="5532120"/>
-            <a:ext cx="10908792" cy="566928"/>
+            <a:off x="640080" y="5641848"/>
+            <a:ext cx="10908792" cy="621792"/>
           </a:xfrm>
           <a:prstGeom prst="rect">
             <a:avLst/>
@@ -2321,45 +2321,6 @@
               <a:t> fits teams that need to keep data in-house or cut costs</a:t>
             </a:r>
             <a:endParaRPr lang="en-US" sz="1250" dirty="0"/>
-          </a:p>
-        </p:txBody>
-      </p:sp>
-      <p:sp>
-        <p:nvSpPr>
-          <p:cNvPr id="32" name="TextBox 31"/>
-          <p:cNvSpPr txBox="1"/>
-          <p:nvPr/>
-        </p:nvSpPr>
-        <p:spPr>
-          <a:xfrm>
-            <a:off x="365760" y="6428232"/>
-            <a:ext cx="11430000" cy="201168"/>
-          </a:xfrm>
-          <a:prstGeom prst="rect">
-            <a:avLst/>
-          </a:prstGeom>
-          <a:noFill/>
-          <a:ln/>
-        </p:spPr>
-        <p:txBody>
-          <a:bodyPr wrap="square" lIns="0" tIns="0" rIns="0" bIns="0" rtlCol="0" anchor="t"/>
-          <a:lstStyle/>
-          <a:p>
-            <a:pPr indent="0" marL="0">
-              <a:buNone/>
-            </a:pPr>
-            <a:r>
-              <a:rPr lang="en-US" sz="850" dirty="0">
-                <a:solidFill>
-                  <a:srgbClr val="8C95BD"/>
-                </a:solidFill>
-                <a:latin typeface="Poppins" pitchFamily="34" charset="0"/>
-                <a:ea typeface="Poppins" pitchFamily="34" charset="-122"/>
-                <a:cs typeface="Poppins" pitchFamily="34" charset="-120"/>
-              </a:rPr>
-              <a:t>Sources: Anthropic, OpenAI, Moonshot AI, Artificial Analysis (Sep 2026). Opus vs. Astra benchmarks as reported by Anthropic.</a:t>
-            </a:r>
-            <a:endParaRPr lang="en-US" sz="850" dirty="0"/>
           </a:p>
         </p:txBody>
       </p:sp>

</xml_diff>